<commit_message>
Sync presentation from current working deck
</commit_message>
<xml_diff>
--- a/deliverables/taskflow-case-presentation.pptx
+++ b/deliverables/taskflow-case-presentation.pptx
@@ -534,6 +534,7 @@
           <a:p>
             <a:pPr rtl="0"/>
             <a:r>
+              <a:rPr dirty="0"/>
               <a:t>0:00-0:20</a:t>
             </a:r>
             <a:endParaRPr lang="en-US" b="0" dirty="0">
@@ -542,13 +543,22 @@
           </a:p>
           <a:p>
             <a:r>
+              <a:rPr dirty="0"/>
               <a:t>Hi, my name is Oksana, and today I will briefly present my solution for the TaskFlow case.</a:t>
             </a:r>
           </a:p>
-          <a:p/>
-          <a:p>
-            <a:r>
-              <a:t>I will explain the main reason behind TaskFlow's decline, the market and competitor context, and the strategy I would recommend for the next 12 months.</a:t>
+          <a:p>
+            <a:r>
+              <a:rPr dirty="0"/>
+              <a:t>I will explain the main reason behind </a:t>
+            </a:r>
+            <a:r>
+              <a:rPr dirty="0" err="1"/>
+              <a:t>TaskFlow's</a:t>
+            </a:r>
+            <a:r>
+              <a:rPr dirty="0"/>
+              <a:t> decline, the market and competitor context, and the strategy I would recommend for the next 12 months.</a:t>
             </a:r>
           </a:p>
         </p:txBody>
@@ -590,7 +600,7 @@
 </file>
 
 <file path=ppt/notesSlides/notesSlide10.xml><?xml version="1.0" encoding="utf-8"?>
-<p:notes xmlns:a="http://schemas.openxmlformats.org/drawingml/2006/main" xmlns:p="http://schemas.openxmlformats.org/presentationml/2006/main" xmlns:r="http://schemas.openxmlformats.org/officeDocument/2006/relationships">
+<p:notes xmlns:a="http://schemas.openxmlformats.org/drawingml/2006/main" xmlns:r="http://schemas.openxmlformats.org/officeDocument/2006/relationships" xmlns:p="http://schemas.openxmlformats.org/presentationml/2006/main">
   <p:cSld>
     <p:spTree>
       <p:nvGrpSpPr>
@@ -610,7 +620,7 @@
         <p:nvSpPr>
           <p:cNvPr id="2" name="Slide Image Placeholder 1"/>
           <p:cNvSpPr>
-            <a:spLocks noGrp="1"/>
+            <a:spLocks noGrp="1" noRot="1" noChangeAspect="1"/>
           </p:cNvSpPr>
           <p:nvPr>
             <p:ph type="sldImg" idx="2"/>
@@ -625,7 +635,7 @@
             <a:spLocks noGrp="1"/>
           </p:cNvSpPr>
           <p:nvPr>
-            <p:ph type="body" idx="3" sz="quarter"/>
+            <p:ph type="body" sz="quarter" idx="3"/>
           </p:nvPr>
         </p:nvSpPr>
         <p:spPr/>
@@ -634,16 +644,19 @@
           <a:lstStyle/>
           <a:p>
             <a:r>
+              <a:rPr dirty="0"/>
               <a:t>3:10-3:35</a:t>
             </a:r>
           </a:p>
           <a:p>
             <a:r>
+              <a:rPr dirty="0"/>
               <a:t>My recommendation is a turnaround strategy, not a full pivot.</a:t>
             </a:r>
           </a:p>
           <a:p>
             <a:r>
+              <a:rPr dirty="0"/>
               <a:t>TaskFlow should reposition itself as a calendar-first planner and improve its core workflow, collaboration, packaging, and growth model.</a:t>
             </a:r>
           </a:p>
@@ -656,7 +669,7 @@
             <a:spLocks noGrp="1"/>
           </p:cNvSpPr>
           <p:nvPr>
-            <p:ph type="sldNum" idx="5" sz="quarter"/>
+            <p:ph type="sldNum" sz="quarter" idx="5"/>
           </p:nvPr>
         </p:nvSpPr>
         <p:spPr/>
@@ -670,7 +683,7 @@
 </file>
 
 <file path=ppt/notesSlides/notesSlide11.xml><?xml version="1.0" encoding="utf-8"?>
-<p:notes xmlns:a="http://schemas.openxmlformats.org/drawingml/2006/main" xmlns:p="http://schemas.openxmlformats.org/presentationml/2006/main" xmlns:r="http://schemas.openxmlformats.org/officeDocument/2006/relationships">
+<p:notes xmlns:a="http://schemas.openxmlformats.org/drawingml/2006/main" xmlns:r="http://schemas.openxmlformats.org/officeDocument/2006/relationships" xmlns:p="http://schemas.openxmlformats.org/presentationml/2006/main">
   <p:cSld>
     <p:spTree>
       <p:nvGrpSpPr>
@@ -690,7 +703,7 @@
         <p:nvSpPr>
           <p:cNvPr id="2" name="Slide Image Placeholder 1"/>
           <p:cNvSpPr>
-            <a:spLocks noGrp="1"/>
+            <a:spLocks noGrp="1" noRot="1" noChangeAspect="1"/>
           </p:cNvSpPr>
           <p:nvPr>
             <p:ph type="sldImg" idx="2"/>
@@ -705,7 +718,7 @@
             <a:spLocks noGrp="1"/>
           </p:cNvSpPr>
           <p:nvPr>
-            <p:ph type="body" idx="3" sz="quarter"/>
+            <p:ph type="body" sz="quarter" idx="3"/>
           </p:nvPr>
         </p:nvSpPr>
         <p:spPr/>
@@ -736,7 +749,7 @@
             <a:spLocks noGrp="1"/>
           </p:cNvSpPr>
           <p:nvPr>
-            <p:ph type="sldNum" idx="5" sz="quarter"/>
+            <p:ph type="sldNum" sz="quarter" idx="5"/>
           </p:nvPr>
         </p:nvSpPr>
         <p:spPr/>
@@ -750,7 +763,7 @@
 </file>
 
 <file path=ppt/notesSlides/notesSlide12.xml><?xml version="1.0" encoding="utf-8"?>
-<p:notes xmlns:a="http://schemas.openxmlformats.org/drawingml/2006/main" xmlns:p="http://schemas.openxmlformats.org/presentationml/2006/main" xmlns:r="http://schemas.openxmlformats.org/officeDocument/2006/relationships">
+<p:notes xmlns:a="http://schemas.openxmlformats.org/drawingml/2006/main" xmlns:r="http://schemas.openxmlformats.org/officeDocument/2006/relationships" xmlns:p="http://schemas.openxmlformats.org/presentationml/2006/main">
   <p:cSld>
     <p:spTree>
       <p:nvGrpSpPr>
@@ -770,7 +783,7 @@
         <p:nvSpPr>
           <p:cNvPr id="2" name="Slide Image Placeholder 1"/>
           <p:cNvSpPr>
-            <a:spLocks noGrp="1"/>
+            <a:spLocks noGrp="1" noRot="1" noChangeAspect="1"/>
           </p:cNvSpPr>
           <p:nvPr>
             <p:ph type="sldImg" idx="2"/>
@@ -785,7 +798,7 @@
             <a:spLocks noGrp="1"/>
           </p:cNvSpPr>
           <p:nvPr>
-            <p:ph type="body" idx="3" sz="quarter"/>
+            <p:ph type="body" sz="quarter" idx="3"/>
           </p:nvPr>
         </p:nvSpPr>
         <p:spPr/>
@@ -816,7 +829,7 @@
             <a:spLocks noGrp="1"/>
           </p:cNvSpPr>
           <p:nvPr>
-            <p:ph type="sldNum" idx="5" sz="quarter"/>
+            <p:ph type="sldNum" sz="quarter" idx="5"/>
           </p:nvPr>
         </p:nvSpPr>
         <p:spPr/>
@@ -830,7 +843,7 @@
 </file>
 
 <file path=ppt/notesSlides/notesSlide13.xml><?xml version="1.0" encoding="utf-8"?>
-<p:notes xmlns:a="http://schemas.openxmlformats.org/drawingml/2006/main" xmlns:p="http://schemas.openxmlformats.org/presentationml/2006/main" xmlns:r="http://schemas.openxmlformats.org/officeDocument/2006/relationships">
+<p:notes xmlns:a="http://schemas.openxmlformats.org/drawingml/2006/main" xmlns:r="http://schemas.openxmlformats.org/officeDocument/2006/relationships" xmlns:p="http://schemas.openxmlformats.org/presentationml/2006/main">
   <p:cSld>
     <p:spTree>
       <p:nvGrpSpPr>
@@ -850,7 +863,7 @@
         <p:nvSpPr>
           <p:cNvPr id="2" name="Slide Image Placeholder 1"/>
           <p:cNvSpPr>
-            <a:spLocks noGrp="1"/>
+            <a:spLocks noGrp="1" noRot="1" noChangeAspect="1"/>
           </p:cNvSpPr>
           <p:nvPr>
             <p:ph type="sldImg" idx="2"/>
@@ -865,7 +878,7 @@
             <a:spLocks noGrp="1"/>
           </p:cNvSpPr>
           <p:nvPr>
-            <p:ph type="body" idx="3" sz="quarter"/>
+            <p:ph type="body" sz="quarter" idx="3"/>
           </p:nvPr>
         </p:nvSpPr>
         <p:spPr/>
@@ -891,7 +904,7 @@
             <a:spLocks noGrp="1"/>
           </p:cNvSpPr>
           <p:nvPr>
-            <p:ph type="sldNum" idx="5" sz="quarter"/>
+            <p:ph type="sldNum" sz="quarter" idx="5"/>
           </p:nvPr>
         </p:nvSpPr>
         <p:spPr/>
@@ -905,7 +918,7 @@
 </file>
 
 <file path=ppt/notesSlides/notesSlide14.xml><?xml version="1.0" encoding="utf-8"?>
-<p:notes xmlns:a="http://schemas.openxmlformats.org/drawingml/2006/main" xmlns:p="http://schemas.openxmlformats.org/presentationml/2006/main" xmlns:r="http://schemas.openxmlformats.org/officeDocument/2006/relationships">
+<p:notes xmlns:a="http://schemas.openxmlformats.org/drawingml/2006/main" xmlns:r="http://schemas.openxmlformats.org/officeDocument/2006/relationships" xmlns:p="http://schemas.openxmlformats.org/presentationml/2006/main">
   <p:cSld>
     <p:spTree>
       <p:nvGrpSpPr>
@@ -925,7 +938,7 @@
         <p:nvSpPr>
           <p:cNvPr id="2" name="Slide Image Placeholder 1"/>
           <p:cNvSpPr>
-            <a:spLocks noGrp="1"/>
+            <a:spLocks noGrp="1" noRot="1" noChangeAspect="1"/>
           </p:cNvSpPr>
           <p:nvPr>
             <p:ph type="sldImg" idx="2"/>
@@ -940,7 +953,7 @@
             <a:spLocks noGrp="1"/>
           </p:cNvSpPr>
           <p:nvPr>
-            <p:ph type="body" idx="3" sz="quarter"/>
+            <p:ph type="body" sz="quarter" idx="3"/>
           </p:nvPr>
         </p:nvSpPr>
         <p:spPr/>
@@ -949,22 +962,28 @@
           <a:lstStyle/>
           <a:p>
             <a:r>
+              <a:rPr dirty="0"/>
               <a:t>4:30-4:50</a:t>
             </a:r>
           </a:p>
           <a:p>
             <a:r>
+              <a:rPr dirty="0"/>
               <a:t>So overall, my conclusion is simple:</a:t>
             </a:r>
           </a:p>
           <a:p>
             <a:r>
+              <a:rPr dirty="0"/>
               <a:t>TaskFlow should stay in the productivity category, avoid a risky full pivot for now, and focus on restoring product value, sharper positioning, and more efficient growth.</a:t>
             </a:r>
           </a:p>
-          <a:p/>
-          <a:p>
-            <a:r>
+          <a:p>
+            <a:endParaRPr dirty="0"/>
+          </a:p>
+          <a:p>
+            <a:r>
+              <a:rPr dirty="0"/>
               <a:t>Thank you.</a:t>
             </a:r>
           </a:p>
@@ -977,7 +996,7 @@
             <a:spLocks noGrp="1"/>
           </p:cNvSpPr>
           <p:nvPr>
-            <p:ph type="sldNum" idx="5" sz="quarter"/>
+            <p:ph type="sldNum" sz="quarter" idx="5"/>
           </p:nvPr>
         </p:nvSpPr>
         <p:spPr/>
@@ -991,7 +1010,7 @@
 </file>
 
 <file path=ppt/notesSlides/notesSlide2.xml><?xml version="1.0" encoding="utf-8"?>
-<p:notes xmlns:a="http://schemas.openxmlformats.org/drawingml/2006/main" xmlns:p="http://schemas.openxmlformats.org/presentationml/2006/main" xmlns:r="http://schemas.openxmlformats.org/officeDocument/2006/relationships">
+<p:notes xmlns:a="http://schemas.openxmlformats.org/drawingml/2006/main" xmlns:r="http://schemas.openxmlformats.org/officeDocument/2006/relationships" xmlns:p="http://schemas.openxmlformats.org/presentationml/2006/main">
   <p:cSld>
     <p:spTree>
       <p:nvGrpSpPr>
@@ -1011,7 +1030,7 @@
         <p:nvSpPr>
           <p:cNvPr id="2" name="Slide Image Placeholder 1"/>
           <p:cNvSpPr>
-            <a:spLocks noGrp="1"/>
+            <a:spLocks noGrp="1" noRot="1" noChangeAspect="1"/>
           </p:cNvSpPr>
           <p:nvPr>
             <p:ph type="sldImg" idx="2"/>
@@ -1026,7 +1045,7 @@
             <a:spLocks noGrp="1"/>
           </p:cNvSpPr>
           <p:nvPr>
-            <p:ph type="body" idx="3" sz="quarter"/>
+            <p:ph type="body" sz="quarter" idx="3"/>
           </p:nvPr>
         </p:nvSpPr>
         <p:spPr/>
@@ -1057,7 +1076,7 @@
             <a:spLocks noGrp="1"/>
           </p:cNvSpPr>
           <p:nvPr>
-            <p:ph type="sldNum" idx="5" sz="quarter"/>
+            <p:ph type="sldNum" sz="quarter" idx="5"/>
           </p:nvPr>
         </p:nvSpPr>
         <p:spPr/>
@@ -1071,7 +1090,7 @@
 </file>
 
 <file path=ppt/notesSlides/notesSlide3.xml><?xml version="1.0" encoding="utf-8"?>
-<p:notes xmlns:a="http://schemas.openxmlformats.org/drawingml/2006/main" xmlns:p="http://schemas.openxmlformats.org/presentationml/2006/main" xmlns:r="http://schemas.openxmlformats.org/officeDocument/2006/relationships">
+<p:notes xmlns:a="http://schemas.openxmlformats.org/drawingml/2006/main" xmlns:r="http://schemas.openxmlformats.org/officeDocument/2006/relationships" xmlns:p="http://schemas.openxmlformats.org/presentationml/2006/main">
   <p:cSld>
     <p:spTree>
       <p:nvGrpSpPr>
@@ -1091,7 +1110,7 @@
         <p:nvSpPr>
           <p:cNvPr id="2" name="Slide Image Placeholder 1"/>
           <p:cNvSpPr>
-            <a:spLocks noGrp="1"/>
+            <a:spLocks noGrp="1" noRot="1" noChangeAspect="1"/>
           </p:cNvSpPr>
           <p:nvPr>
             <p:ph type="sldImg" idx="2"/>
@@ -1106,7 +1125,7 @@
             <a:spLocks noGrp="1"/>
           </p:cNvSpPr>
           <p:nvPr>
-            <p:ph type="body" idx="3" sz="quarter"/>
+            <p:ph type="body" sz="quarter" idx="3"/>
           </p:nvPr>
         </p:nvSpPr>
         <p:spPr/>
@@ -1137,7 +1156,7 @@
             <a:spLocks noGrp="1"/>
           </p:cNvSpPr>
           <p:nvPr>
-            <p:ph type="sldNum" idx="5" sz="quarter"/>
+            <p:ph type="sldNum" sz="quarter" idx="5"/>
           </p:nvPr>
         </p:nvSpPr>
         <p:spPr/>
@@ -1151,7 +1170,7 @@
 </file>
 
 <file path=ppt/notesSlides/notesSlide4.xml><?xml version="1.0" encoding="utf-8"?>
-<p:notes xmlns:a="http://schemas.openxmlformats.org/drawingml/2006/main" xmlns:p="http://schemas.openxmlformats.org/presentationml/2006/main" xmlns:r="http://schemas.openxmlformats.org/officeDocument/2006/relationships">
+<p:notes xmlns:a="http://schemas.openxmlformats.org/drawingml/2006/main" xmlns:r="http://schemas.openxmlformats.org/officeDocument/2006/relationships" xmlns:p="http://schemas.openxmlformats.org/presentationml/2006/main">
   <p:cSld>
     <p:spTree>
       <p:nvGrpSpPr>
@@ -1171,7 +1190,7 @@
         <p:nvSpPr>
           <p:cNvPr id="2" name="Slide Image Placeholder 1"/>
           <p:cNvSpPr>
-            <a:spLocks noGrp="1"/>
+            <a:spLocks noGrp="1" noRot="1" noChangeAspect="1"/>
           </p:cNvSpPr>
           <p:nvPr>
             <p:ph type="sldImg" idx="2"/>
@@ -1186,7 +1205,7 @@
             <a:spLocks noGrp="1"/>
           </p:cNvSpPr>
           <p:nvPr>
-            <p:ph type="body" idx="3" sz="quarter"/>
+            <p:ph type="body" sz="quarter" idx="3"/>
           </p:nvPr>
         </p:nvSpPr>
         <p:spPr/>
@@ -1217,7 +1236,7 @@
             <a:spLocks noGrp="1"/>
           </p:cNvSpPr>
           <p:nvPr>
-            <p:ph type="sldNum" idx="5" sz="quarter"/>
+            <p:ph type="sldNum" sz="quarter" idx="5"/>
           </p:nvPr>
         </p:nvSpPr>
         <p:spPr/>
@@ -1231,7 +1250,7 @@
 </file>
 
 <file path=ppt/notesSlides/notesSlide5.xml><?xml version="1.0" encoding="utf-8"?>
-<p:notes xmlns:a="http://schemas.openxmlformats.org/drawingml/2006/main" xmlns:p="http://schemas.openxmlformats.org/presentationml/2006/main" xmlns:r="http://schemas.openxmlformats.org/officeDocument/2006/relationships">
+<p:notes xmlns:a="http://schemas.openxmlformats.org/drawingml/2006/main" xmlns:r="http://schemas.openxmlformats.org/officeDocument/2006/relationships" xmlns:p="http://schemas.openxmlformats.org/presentationml/2006/main">
   <p:cSld>
     <p:spTree>
       <p:nvGrpSpPr>
@@ -1251,7 +1270,7 @@
         <p:nvSpPr>
           <p:cNvPr id="2" name="Slide Image Placeholder 1"/>
           <p:cNvSpPr>
-            <a:spLocks noGrp="1"/>
+            <a:spLocks noGrp="1" noRot="1" noChangeAspect="1"/>
           </p:cNvSpPr>
           <p:nvPr>
             <p:ph type="sldImg" idx="2"/>
@@ -1266,7 +1285,7 @@
             <a:spLocks noGrp="1"/>
           </p:cNvSpPr>
           <p:nvPr>
-            <p:ph type="body" idx="3" sz="quarter"/>
+            <p:ph type="body" sz="quarter" idx="3"/>
           </p:nvPr>
         </p:nvSpPr>
         <p:spPr/>
@@ -1297,7 +1316,7 @@
             <a:spLocks noGrp="1"/>
           </p:cNvSpPr>
           <p:nvPr>
-            <p:ph type="sldNum" idx="5" sz="quarter"/>
+            <p:ph type="sldNum" sz="quarter" idx="5"/>
           </p:nvPr>
         </p:nvSpPr>
         <p:spPr/>
@@ -1311,7 +1330,7 @@
 </file>
 
 <file path=ppt/notesSlides/notesSlide6.xml><?xml version="1.0" encoding="utf-8"?>
-<p:notes xmlns:a="http://schemas.openxmlformats.org/drawingml/2006/main" xmlns:p="http://schemas.openxmlformats.org/presentationml/2006/main" xmlns:r="http://schemas.openxmlformats.org/officeDocument/2006/relationships">
+<p:notes xmlns:a="http://schemas.openxmlformats.org/drawingml/2006/main" xmlns:r="http://schemas.openxmlformats.org/officeDocument/2006/relationships" xmlns:p="http://schemas.openxmlformats.org/presentationml/2006/main">
   <p:cSld>
     <p:spTree>
       <p:nvGrpSpPr>
@@ -1331,7 +1350,7 @@
         <p:nvSpPr>
           <p:cNvPr id="2" name="Slide Image Placeholder 1"/>
           <p:cNvSpPr>
-            <a:spLocks noGrp="1"/>
+            <a:spLocks noGrp="1" noRot="1" noChangeAspect="1"/>
           </p:cNvSpPr>
           <p:nvPr>
             <p:ph type="sldImg" idx="2"/>
@@ -1346,7 +1365,7 @@
             <a:spLocks noGrp="1"/>
           </p:cNvSpPr>
           <p:nvPr>
-            <p:ph type="body" idx="3" sz="quarter"/>
+            <p:ph type="body" sz="quarter" idx="3"/>
           </p:nvPr>
         </p:nvSpPr>
         <p:spPr/>
@@ -1355,16 +1374,19 @@
           <a:lstStyle/>
           <a:p>
             <a:r>
+              <a:rPr dirty="0"/>
               <a:t>1:45-2:05</a:t>
             </a:r>
           </a:p>
           <a:p>
             <a:r>
+              <a:rPr dirty="0"/>
               <a:t>The market is still attractive, so I would not recommend leaving productivity.</a:t>
             </a:r>
           </a:p>
           <a:p>
             <a:r>
+              <a:rPr dirty="0"/>
               <a:t>However, TaskFlow needs a sharper niche, and the strongest fit is calendar-first planning for young professionals, freelancers, and duos.</a:t>
             </a:r>
           </a:p>
@@ -1377,7 +1399,7 @@
             <a:spLocks noGrp="1"/>
           </p:cNvSpPr>
           <p:nvPr>
-            <p:ph type="sldNum" idx="5" sz="quarter"/>
+            <p:ph type="sldNum" sz="quarter" idx="5"/>
           </p:nvPr>
         </p:nvSpPr>
         <p:spPr/>
@@ -1391,7 +1413,7 @@
 </file>
 
 <file path=ppt/notesSlides/notesSlide7.xml><?xml version="1.0" encoding="utf-8"?>
-<p:notes xmlns:a="http://schemas.openxmlformats.org/drawingml/2006/main" xmlns:p="http://schemas.openxmlformats.org/presentationml/2006/main" xmlns:r="http://schemas.openxmlformats.org/officeDocument/2006/relationships">
+<p:notes xmlns:a="http://schemas.openxmlformats.org/drawingml/2006/main" xmlns:r="http://schemas.openxmlformats.org/officeDocument/2006/relationships" xmlns:p="http://schemas.openxmlformats.org/presentationml/2006/main">
   <p:cSld>
     <p:spTree>
       <p:nvGrpSpPr>
@@ -1411,7 +1433,7 @@
         <p:nvSpPr>
           <p:cNvPr id="2" name="Slide Image Placeholder 1"/>
           <p:cNvSpPr>
-            <a:spLocks noGrp="1"/>
+            <a:spLocks noGrp="1" noRot="1" noChangeAspect="1"/>
           </p:cNvSpPr>
           <p:nvPr>
             <p:ph type="sldImg" idx="2"/>
@@ -1426,7 +1448,7 @@
             <a:spLocks noGrp="1"/>
           </p:cNvSpPr>
           <p:nvPr>
-            <p:ph type="body" idx="3" sz="quarter"/>
+            <p:ph type="body" sz="quarter" idx="3"/>
           </p:nvPr>
         </p:nvSpPr>
         <p:spPr/>
@@ -1435,16 +1457,35 @@
           <a:lstStyle/>
           <a:p>
             <a:r>
+              <a:rPr dirty="0"/>
               <a:t>2:05-2:25</a:t>
             </a:r>
           </a:p>
           <a:p>
             <a:r>
-              <a:t>Here I compare TaskFlow with Todoist, TickTick, Any.do, and Microsoft To Do.</a:t>
-            </a:r>
-          </a:p>
-          <a:p>
-            <a:r>
+              <a:rPr dirty="0"/>
+              <a:t>Here I compare TaskFlow with </a:t>
+            </a:r>
+            <a:r>
+              <a:rPr dirty="0" err="1"/>
+              <a:t>Todoist</a:t>
+            </a:r>
+            <a:r>
+              <a:rPr dirty="0"/>
+              <a:t>, </a:t>
+            </a:r>
+            <a:r>
+              <a:rPr dirty="0" err="1"/>
+              <a:t>TickTick</a:t>
+            </a:r>
+            <a:r>
+              <a:rPr dirty="0"/>
+              <a:t>, Any.do, and Microsoft To Do.</a:t>
+            </a:r>
+          </a:p>
+          <a:p>
+            <a:r>
+              <a:rPr dirty="0"/>
               <a:t>The benchmark shows that competitors are stronger in collaboration, product maturity, and distribution.</a:t>
             </a:r>
           </a:p>
@@ -1457,7 +1498,7 @@
             <a:spLocks noGrp="1"/>
           </p:cNvSpPr>
           <p:nvPr>
-            <p:ph type="sldNum" idx="5" sz="quarter"/>
+            <p:ph type="sldNum" sz="quarter" idx="5"/>
           </p:nvPr>
         </p:nvSpPr>
         <p:spPr/>
@@ -1471,7 +1512,7 @@
 </file>
 
 <file path=ppt/notesSlides/notesSlide8.xml><?xml version="1.0" encoding="utf-8"?>
-<p:notes xmlns:a="http://schemas.openxmlformats.org/drawingml/2006/main" xmlns:p="http://schemas.openxmlformats.org/presentationml/2006/main" xmlns:r="http://schemas.openxmlformats.org/officeDocument/2006/relationships">
+<p:notes xmlns:a="http://schemas.openxmlformats.org/drawingml/2006/main" xmlns:r="http://schemas.openxmlformats.org/officeDocument/2006/relationships" xmlns:p="http://schemas.openxmlformats.org/presentationml/2006/main">
   <p:cSld>
     <p:spTree>
       <p:nvGrpSpPr>
@@ -1491,7 +1532,7 @@
         <p:nvSpPr>
           <p:cNvPr id="2" name="Slide Image Placeholder 1"/>
           <p:cNvSpPr>
-            <a:spLocks noGrp="1"/>
+            <a:spLocks noGrp="1" noRot="1" noChangeAspect="1"/>
           </p:cNvSpPr>
           <p:nvPr>
             <p:ph type="sldImg" idx="2"/>
@@ -1506,7 +1547,7 @@
             <a:spLocks noGrp="1"/>
           </p:cNvSpPr>
           <p:nvPr>
-            <p:ph type="body" idx="3" sz="quarter"/>
+            <p:ph type="body" sz="quarter" idx="3"/>
           </p:nvPr>
         </p:nvSpPr>
         <p:spPr/>
@@ -1515,16 +1556,19 @@
           <a:lstStyle/>
           <a:p>
             <a:r>
+              <a:rPr dirty="0"/>
               <a:t>2:25-2:45</a:t>
             </a:r>
           </a:p>
           <a:p>
             <a:r>
+              <a:rPr dirty="0"/>
               <a:t>TaskFlow should not try to out-feature everyone.</a:t>
             </a:r>
           </a:p>
           <a:p>
             <a:r>
+              <a:rPr dirty="0"/>
               <a:t>Instead, it should focus on a narrower and cleaner use case where it can realistically compete.</a:t>
             </a:r>
           </a:p>
@@ -1537,7 +1581,7 @@
             <a:spLocks noGrp="1"/>
           </p:cNvSpPr>
           <p:nvPr>
-            <p:ph type="sldNum" idx="5" sz="quarter"/>
+            <p:ph type="sldNum" sz="quarter" idx="5"/>
           </p:nvPr>
         </p:nvSpPr>
         <p:spPr/>
@@ -1551,7 +1595,7 @@
 </file>
 
 <file path=ppt/notesSlides/notesSlide9.xml><?xml version="1.0" encoding="utf-8"?>
-<p:notes xmlns:a="http://schemas.openxmlformats.org/drawingml/2006/main" xmlns:p="http://schemas.openxmlformats.org/presentationml/2006/main" xmlns:r="http://schemas.openxmlformats.org/officeDocument/2006/relationships">
+<p:notes xmlns:a="http://schemas.openxmlformats.org/drawingml/2006/main" xmlns:r="http://schemas.openxmlformats.org/officeDocument/2006/relationships" xmlns:p="http://schemas.openxmlformats.org/presentationml/2006/main">
   <p:cSld>
     <p:spTree>
       <p:nvGrpSpPr>
@@ -1571,7 +1615,7 @@
         <p:nvSpPr>
           <p:cNvPr id="2" name="Slide Image Placeholder 1"/>
           <p:cNvSpPr>
-            <a:spLocks noGrp="1"/>
+            <a:spLocks noGrp="1" noRot="1" noChangeAspect="1"/>
           </p:cNvSpPr>
           <p:nvPr>
             <p:ph type="sldImg" idx="2"/>
@@ -1586,7 +1630,7 @@
             <a:spLocks noGrp="1"/>
           </p:cNvSpPr>
           <p:nvPr>
-            <p:ph type="body" idx="3" sz="quarter"/>
+            <p:ph type="body" sz="quarter" idx="3"/>
           </p:nvPr>
         </p:nvSpPr>
         <p:spPr/>
@@ -1617,7 +1661,7 @@
             <a:spLocks noGrp="1"/>
           </p:cNvSpPr>
           <p:nvPr>
-            <p:ph type="sldNum" idx="5" sz="quarter"/>
+            <p:ph type="sldNum" sz="quarter" idx="5"/>
           </p:nvPr>
         </p:nvSpPr>
         <p:spPr/>
@@ -4675,12 +4719,15 @@
               <a:rPr sz="3600" b="1" dirty="0" err="1"/>
               <a:t>TaskFlow</a:t>
             </a:r>
-            <a:br>
-              <a:rPr lang="uk-UA" b="1" dirty="0"/>
-            </a:br>
+            <a:endParaRPr lang="en-US" sz="3600" b="1" dirty="0"/>
+          </a:p>
+          <a:p>
+            <a:r>
+              <a:t>how </a:t>
+            </a:r>
             <a:r>
               <a:rPr dirty="0"/>
-              <a:t>how to stop the decline and restore growth</a:t>
+              <a:t>to stop the decline and restore growth</a:t>
             </a:r>
           </a:p>
         </p:txBody>
@@ -4979,7 +5026,7 @@
         <p:spPr>
           <a:xfrm>
             <a:off x="786384" y="4864608"/>
-            <a:ext cx="5455920" cy="369332"/>
+            <a:ext cx="5455920" cy="646331"/>
           </a:xfrm>
           <a:prstGeom prst="rect">
             <a:avLst/>
@@ -4993,9 +5040,12 @@
           <a:lstStyle/>
           <a:p>
             <a:r>
-              <a:rPr dirty="0"/>
-              <a:t>https://www.loom.com/share/</a:t>
-            </a:r>
+              <a:rPr lang="en-US" dirty="0">
+                <a:hlinkClick r:id="rId3"/>
+              </a:rPr>
+              <a:t>https://www.loom.com/share/ec723b4fa73542679c644feae340f941</a:t>
+            </a:r>
+            <a:endParaRPr dirty="0"/>
           </a:p>
         </p:txBody>
       </p:sp>
@@ -5080,7 +5130,7 @@
         <p:spPr>
           <a:xfrm>
             <a:off x="9235440" y="2286000"/>
-            <a:ext cx="2560320" cy="1554480"/>
+            <a:ext cx="2560320" cy="1181862"/>
           </a:xfrm>
           <a:prstGeom prst="rect">
             <a:avLst/>
@@ -5093,7 +5143,7 @@
           </a:bodyPr>
           <a:lstStyle/>
           <a:p>
-            <a:pPr algn="l">
+            <a:pPr>
               <a:defRPr sz="1200" b="0">
                 <a:solidFill>
                   <a:srgbClr val="FFFDFC"/>
@@ -5102,11 +5152,12 @@
               </a:defRPr>
             </a:pPr>
             <a:r>
-              <a:t>Included in folder:</a:t>
-            </a:r>
-          </a:p>
-          <a:p>
-            <a:pPr algn="l">
+              <a:rPr lang="en-US" dirty="0"/>
+              <a:t>Included in research:</a:t>
+            </a:r>
+          </a:p>
+          <a:p>
+            <a:pPr>
               <a:defRPr sz="1200" b="0">
                 <a:solidFill>
                   <a:srgbClr val="FFFDFC"/>
@@ -5115,11 +5166,12 @@
               </a:defRPr>
             </a:pPr>
             <a:r>
+              <a:rPr lang="en-US" dirty="0"/>
               <a:t>- ready PPTX</a:t>
             </a:r>
           </a:p>
           <a:p>
-            <a:pPr algn="l">
+            <a:pPr>
               <a:defRPr sz="1200" b="0">
                 <a:solidFill>
                   <a:srgbClr val="FFFDFC"/>
@@ -5128,11 +5180,12 @@
               </a:defRPr>
             </a:pPr>
             <a:r>
+              <a:rPr lang="en-US" dirty="0"/>
               <a:t>- XLSX with calculations</a:t>
             </a:r>
           </a:p>
           <a:p>
-            <a:pPr algn="l">
+            <a:pPr>
               <a:defRPr sz="1200" b="0">
                 <a:solidFill>
                   <a:srgbClr val="FFFDFC"/>
@@ -5141,11 +5194,12 @@
               </a:defRPr>
             </a:pPr>
             <a:r>
+              <a:rPr lang="en-US" dirty="0"/>
               <a:t>- sources log</a:t>
             </a:r>
           </a:p>
           <a:p>
-            <a:pPr algn="l">
+            <a:pPr>
               <a:defRPr sz="1200" b="0">
                 <a:solidFill>
                   <a:srgbClr val="FFFDFC"/>
@@ -5154,6 +5208,7 @@
               </a:defRPr>
             </a:pPr>
             <a:r>
+              <a:rPr lang="en-US" dirty="0"/>
               <a:t>- 5-minute Loom talk track</a:t>
             </a:r>
           </a:p>
@@ -9657,6 +9712,7 @@
               </a:defRPr>
             </a:pPr>
             <a:r>
+              <a:rPr dirty="0"/>
               <a:t>If churn normalizes and organic share recovers, TaskFlow can grow MRR without going back to heavy, low-quality paid social.</a:t>
             </a:r>
           </a:p>
@@ -11438,7 +11494,7 @@
             </a:pPr>
             <a:r>
               <a:rPr dirty="0">
-                <a:hlinkClick r:id="rId2"/>
+                <a:hlinkClick r:id="rId3"/>
               </a:rPr>
               <a:t>https://www.mordorintelligence.com/industry-reports/task-management-software-market</a:t>
             </a:r>
@@ -11461,7 +11517,7 @@
             </a:pPr>
             <a:r>
               <a:rPr dirty="0">
-                <a:hlinkClick r:id="rId3"/>
+                <a:hlinkClick r:id="rId4"/>
               </a:rPr>
               <a:t>https://techcrunch.com/2026/01/21/consumers-spent-more-on-mobile-apps-than-games-in-2025-driven-by-ai-app-adoption/</a:t>
             </a:r>
@@ -11484,7 +11540,7 @@
             </a:pPr>
             <a:r>
               <a:rPr dirty="0">
-                <a:hlinkClick r:id="rId4"/>
+                <a:hlinkClick r:id="rId5"/>
               </a:rPr>
               <a:t>https://www.gartner.com/en/newsroom/press-releases/2025-01-15-gartner-predicts-mobile-app-usage-will-decrease-25-percent-due-to-ai-assistants-by-2027</a:t>
             </a:r>
@@ -11507,7 +11563,7 @@
             </a:pPr>
             <a:r>
               <a:rPr dirty="0">
-                <a:hlinkClick r:id="rId5"/>
+                <a:hlinkClick r:id="rId6"/>
               </a:rPr>
               <a:t>https://www.gartner.com/en/newsroom/press-releases/2025-08-26-gartner-predicts-40-percent-of-enterprise-apps-will-feature-task-specific-ai-agents-by-2026-up-from-less-than-5-percent-in-2025</a:t>
             </a:r>
@@ -11530,7 +11586,7 @@
             </a:pPr>
             <a:r>
               <a:rPr dirty="0">
-                <a:hlinkClick r:id="rId6"/>
+                <a:hlinkClick r:id="rId7"/>
               </a:rPr>
               <a:t>https://www.todoist.com/pricing</a:t>
             </a:r>
@@ -11553,7 +11609,7 @@
             </a:pPr>
             <a:r>
               <a:rPr dirty="0">
-                <a:hlinkClick r:id="rId7"/>
+                <a:hlinkClick r:id="rId8"/>
               </a:rPr>
               <a:t>https://www.todoist.com/help/articles/todoist-pro-plan-pricing-update-bxBvHZuJZ</a:t>
             </a:r>
@@ -11576,7 +11632,7 @@
             </a:pPr>
             <a:r>
               <a:rPr dirty="0">
-                <a:hlinkClick r:id="rId8"/>
+                <a:hlinkClick r:id="rId9"/>
               </a:rPr>
               <a:t>https://play.google.com/store/apps/details?id=com.todoist&amp;hl=en&amp;gl=US</a:t>
             </a:r>
@@ -11599,7 +11655,7 @@
             </a:pPr>
             <a:r>
               <a:rPr dirty="0">
-                <a:hlinkClick r:id="rId9"/>
+                <a:hlinkClick r:id="rId10"/>
               </a:rPr>
               <a:t>https://ticktick.com/upgrade</a:t>
             </a:r>
@@ -11768,12 +11824,8 @@
               </a:defRPr>
             </a:pPr>
             <a:r>
-              <a:rPr lang="en-US" dirty="0" err="1"/>
-              <a:t>TaskFlow</a:t>
-            </a:r>
-            <a:r>
               <a:rPr lang="en-US" dirty="0"/>
-              <a:t> should stay in the productivity category, avoid a risky full pivot for now, and focus on restoring product value, </a:t>
+              <a:t>TaskFlow should stay in the productivity category, avoid a risky full pivot for now, and focus on restoring product value, </a:t>
             </a:r>
           </a:p>
           <a:p>
@@ -11823,7 +11875,7 @@
         <p:spPr>
           <a:xfrm>
             <a:off x="640080" y="6446520"/>
-            <a:ext cx="10058400" cy="228600"/>
+            <a:ext cx="8414483" cy="215444"/>
           </a:xfrm>
           <a:prstGeom prst="rect">
             <a:avLst/>
@@ -11846,8 +11898,47 @@
             </a:pPr>
             <a:r>
               <a:rPr dirty="0"/>
-              <a:t>Sources: Full source log is also included in the workbook and sources.md.</a:t>
-            </a:r>
+              <a:t>Sources: Full source log</a:t>
+            </a:r>
+            <a:r>
+              <a:rPr lang="en-US" dirty="0"/>
+              <a:t> will </a:t>
+            </a:r>
+            <a:r>
+              <a:rPr dirty="0"/>
+              <a:t>also</a:t>
+            </a:r>
+            <a:r>
+              <a:rPr lang="en-US" dirty="0"/>
+              <a:t> be</a:t>
+            </a:r>
+            <a:r>
+              <a:rPr dirty="0"/>
+              <a:t> included</a:t>
+            </a:r>
+            <a:r>
+              <a:rPr lang="en-US" dirty="0"/>
+              <a:t> later</a:t>
+            </a:r>
+            <a:r>
+              <a:rPr dirty="0"/>
+              <a:t> in the workbook and sources.md</a:t>
+            </a:r>
+            <a:r>
+              <a:rPr lang="en-US" dirty="0"/>
+              <a:t>: </a:t>
+            </a:r>
+            <a:r>
+              <a:rPr lang="en-US" dirty="0">
+                <a:hlinkClick r:id="rId11"/>
+              </a:rPr>
+              <a:t>https://github.com/TEZv/Genesis-Academy_Strategy-Operations-School-2.0-Case-Task/tree/main</a:t>
+            </a:r>
+            <a:r>
+              <a:rPr lang="en-US" dirty="0"/>
+              <a:t> </a:t>
+            </a:r>
+            <a:endParaRPr dirty="0"/>
           </a:p>
         </p:txBody>
       </p:sp>
@@ -12031,6 +12122,7 @@
               </a:defRPr>
             </a:pPr>
             <a:r>
+              <a:rPr dirty="0"/>
               <a:t>The market is still growing. TaskFlow is losing relevance inside that market.</a:t>
             </a:r>
           </a:p>
@@ -12679,6 +12771,7 @@
               </a:defRPr>
             </a:pPr>
             <a:r>
+              <a:rPr dirty="0"/>
               <a:t>Reposition TaskFlow as a calendar-first planner for young professionals, freelancers and duos. Fix core workflow first, add lightweight AI second, and reduce inefficient paid UA until retention improves.</a:t>
             </a:r>
           </a:p>
@@ -12914,7 +13007,7 @@
           <p:nvPr/>
         </p:nvPicPr>
         <p:blipFill>
-          <a:blip r:embed="rId2"/>
+          <a:blip r:embed="rId3"/>
           <a:stretch>
             <a:fillRect/>
           </a:stretch>
@@ -14761,7 +14854,7 @@
           <p:nvPr/>
         </p:nvPicPr>
         <p:blipFill>
-          <a:blip r:embed="rId2"/>
+          <a:blip r:embed="rId3"/>
           <a:stretch>
             <a:fillRect/>
           </a:stretch>
@@ -14785,7 +14878,7 @@
           <p:nvPr/>
         </p:nvPicPr>
         <p:blipFill>
-          <a:blip r:embed="rId3"/>
+          <a:blip r:embed="rId4"/>
           <a:stretch>
             <a:fillRect/>
           </a:stretch>
@@ -16142,6 +16235,7 @@
               </a:defRPr>
             </a:pPr>
             <a:r>
+              <a:rPr dirty="0"/>
               <a:t>The right move is not to leave productivity. It is to choose a sharper niche where TaskFlow can win with its current team and runway.</a:t>
             </a:r>
           </a:p>
@@ -16156,7 +16250,7 @@
           <p:nvPr/>
         </p:nvPicPr>
         <p:blipFill>
-          <a:blip r:embed="rId2"/>
+          <a:blip r:embed="rId3"/>
           <a:stretch>
             <a:fillRect/>
           </a:stretch>
@@ -16477,6 +16571,7 @@
               </a:defRPr>
             </a:pPr>
             <a:r>
+              <a:rPr dirty="0"/>
               <a:t>TaskFlow today</a:t>
             </a:r>
           </a:p>
@@ -17483,15 +17578,7 @@
             </a:pPr>
             <a:r>
               <a:rPr dirty="0"/>
-              <a:t>What competitors do better - and where </a:t>
-            </a:r>
-            <a:r>
-              <a:rPr dirty="0" err="1"/>
-              <a:t>TaskFlow</a:t>
-            </a:r>
-            <a:r>
-              <a:rPr dirty="0"/>
-              <a:t> still has whitespace</a:t>
+              <a:t>What competitors do better - and where TaskFlow still has whitespace</a:t>
             </a:r>
           </a:p>
         </p:txBody>
@@ -18021,6 +18108,7 @@
               </a:defRPr>
             </a:pPr>
             <a:r>
+              <a:rPr dirty="0"/>
               <a:t>Leaders lean on SEO, templates, ecosystems, app-store scale and integrations. TaskFlow depends too heavily on paid social.</a:t>
             </a:r>
           </a:p>
@@ -18345,6 +18433,7 @@
               </a:defRPr>
             </a:pPr>
             <a:r>
+              <a:rPr dirty="0"/>
               <a:t>TaskFlow should not try to out-feature everyone. The most credible opening is a lightweight, calendar-first planner for solo professionals, freelancers and duos that is faster, cleaner, offline-capable and better for micro-collaboration.</a:t>
             </a:r>
           </a:p>

</xml_diff>

<commit_message>
Rework case deck with operator-style turnaround framing
</commit_message>
<xml_diff>
--- a/deliverables/taskflow-case-presentation.pptx
+++ b/deliverables/taskflow-case-presentation.pptx
@@ -4715,20 +4715,16 @@
           </a:bodyPr>
           <a:lstStyle/>
           <a:p>
-            <a:r>
-              <a:rPr sz="3600" b="1" dirty="0" err="1"/>
-              <a:t>TaskFlow</a:t>
+            <a:pPr>
+              <a:defRPr>
+                <a:solidFill/>
+                <a:latin typeface="Segoe UI"/>
+              </a:defRPr>
+            </a:pPr>
+            <a:r>
+              <a:t>TaskFlow | fix the leak before buying more growth</a:t>
             </a:r>
             <a:endParaRPr lang="en-US" sz="3600" b="1" dirty="0"/>
-          </a:p>
-          <a:p>
-            <a:r>
-              <a:t>how </a:t>
-            </a:r>
-            <a:r>
-              <a:rPr dirty="0"/>
-              <a:t>to stop the decline and restore growth</a:t>
-            </a:r>
           </a:p>
         </p:txBody>
       </p:sp>
@@ -4878,15 +4874,24 @@
           </a:bodyPr>
           <a:lstStyle/>
           <a:p>
-            <a:r>
-              <a:rPr dirty="0"/>
-              <a:t>Do not run a full pivot now.</a:t>
-            </a:r>
-          </a:p>
-          <a:p>
-            <a:r>
-              <a:rPr dirty="0"/>
-              <a:t>Narrow the positioning, fix retention, and build around calendar-first planning plus micro-collaboration.</a:t>
+            <a:pPr>
+              <a:defRPr>
+                <a:solidFill/>
+                <a:latin typeface="Segoe UI"/>
+              </a:defRPr>
+            </a:pPr>
+            <a:r>
+              <a:t>Do a focused turnaround.</a:t>
+            </a:r>
+          </a:p>
+          <a:p>
+            <a:pPr>
+              <a:defRPr>
+                <a:latin typeface="Segoe UI"/>
+              </a:defRPr>
+            </a:pPr>
+            <a:r>
+              <a:t>The category still works; the value engine does not.</a:t>
             </a:r>
           </a:p>
         </p:txBody>
@@ -5152,8 +5157,7 @@
               </a:defRPr>
             </a:pPr>
             <a:r>
-              <a:rPr lang="en-US" dirty="0"/>
-              <a:t>Included in research:</a:t>
+              <a:t>Included:</a:t>
             </a:r>
           </a:p>
           <a:p>
@@ -5166,8 +5170,7 @@
               </a:defRPr>
             </a:pPr>
             <a:r>
-              <a:rPr lang="en-US" dirty="0"/>
-              <a:t>- ready PPTX</a:t>
+              <a:t>- deck</a:t>
             </a:r>
           </a:p>
           <a:p>
@@ -5180,8 +5183,7 @@
               </a:defRPr>
             </a:pPr>
             <a:r>
-              <a:rPr lang="en-US" dirty="0"/>
-              <a:t>- XLSX with calculations</a:t>
+              <a:t>- PDF</a:t>
             </a:r>
           </a:p>
           <a:p>
@@ -5194,8 +5196,7 @@
               </a:defRPr>
             </a:pPr>
             <a:r>
-              <a:rPr lang="en-US" dirty="0"/>
-              <a:t>- sources log</a:t>
+              <a:t>- calculations</a:t>
             </a:r>
           </a:p>
           <a:p>
@@ -5208,8 +5209,7 @@
               </a:defRPr>
             </a:pPr>
             <a:r>
-              <a:rPr lang="en-US" dirty="0"/>
-              <a:t>- 5-minute Loom talk track</a:t>
+              <a:t>- source log</a:t>
             </a:r>
           </a:p>
         </p:txBody>
@@ -5245,7 +5245,7 @@
               </a:defRPr>
             </a:pPr>
             <a:r>
-              <a:t>Main recommendation:</a:t>
+              <a:t>Operating rule:</a:t>
             </a:r>
           </a:p>
           <a:p>
@@ -5258,7 +5258,7 @@
               </a:defRPr>
             </a:pPr>
             <a:r>
-              <a:t>Turnaround, not full pivot.</a:t>
+              <a:t>No scale before D30 &gt; 7% and paid churn &lt; 14%.</a:t>
             </a:r>
           </a:p>
         </p:txBody>
@@ -5399,7 +5399,7 @@
               </a:defRPr>
             </a:pPr>
             <a:r>
-              <a:t>Recommended strategy: narrow and modernize the core product</a:t>
+              <a:t>What turnaround means in practice</a:t>
             </a:r>
           </a:p>
         </p:txBody>
@@ -5605,6 +5605,19 @@
               </a:defRPr>
             </a:pPr>
             <a:r>
+              <a:t>Rebuild the activation funnel.</a:t>
+            </a:r>
+          </a:p>
+          <a:p>
+            <a:pPr>
+              <a:defRPr sz="1050">
+                <a:solidFill>
+                  <a:srgbClr val="1F2937"/>
+                </a:solidFill>
+                <a:latin typeface="Segoe UI"/>
+              </a:defRPr>
+            </a:pPr>
+            <a:r>
               <a:t>Ship offline mode.</a:t>
             </a:r>
           </a:p>
@@ -5618,46 +5631,20 @@
               </a:defRPr>
             </a:pPr>
             <a:r>
+              <a:t>Tighten calendar parity.</a:t>
+            </a:r>
+          </a:p>
+          <a:p>
+            <a:pPr>
+              <a:defRPr sz="1050">
+                <a:solidFill>
+                  <a:srgbClr val="1F2937"/>
+                </a:solidFill>
+                <a:latin typeface="Segoe UI"/>
+              </a:defRPr>
+            </a:pPr>
+            <a:r>
               <a:t>Improve onboarding by use case.</a:t>
-            </a:r>
-          </a:p>
-          <a:p>
-            <a:pPr>
-              <a:defRPr sz="1050">
-                <a:solidFill>
-                  <a:srgbClr val="1F2937"/>
-                </a:solidFill>
-                <a:latin typeface="Segoe UI"/>
-              </a:defRPr>
-            </a:pPr>
-            <a:r>
-              <a:t>Refresh UI.</a:t>
-            </a:r>
-          </a:p>
-          <a:p>
-            <a:pPr>
-              <a:defRPr sz="1050">
-                <a:solidFill>
-                  <a:srgbClr val="1F2937"/>
-                </a:solidFill>
-                <a:latin typeface="Segoe UI"/>
-              </a:defRPr>
-            </a:pPr>
-            <a:r>
-              <a:t>Upgrade recurring tasks and calendar parity.</a:t>
-            </a:r>
-          </a:p>
-          <a:p>
-            <a:pPr>
-              <a:defRPr sz="1050">
-                <a:solidFill>
-                  <a:srgbClr val="1F2937"/>
-                </a:solidFill>
-                <a:latin typeface="Segoe UI"/>
-              </a:defRPr>
-            </a:pPr>
-            <a:r>
-              <a:t>Expand collaboration from 3 to 5 users with comments + attachments.</a:t>
             </a:r>
           </a:p>
         </p:txBody>
@@ -5783,7 +5770,7 @@
               </a:defRPr>
             </a:pPr>
             <a:r>
-              <a:t>Positioning</a:t>
+              <a:t>Growth</a:t>
             </a:r>
           </a:p>
         </p:txBody>
@@ -5819,7 +5806,7 @@
               </a:defRPr>
             </a:pPr>
             <a:r>
-              <a:t>Move from generic to-do app to:</a:t>
+              <a:t>Pause weak paid social.</a:t>
             </a:r>
           </a:p>
           <a:p>
@@ -5832,7 +5819,7 @@
               </a:defRPr>
             </a:pPr>
             <a:r>
-              <a:t>calendar-first planner for young professionals, freelancers and duos.</a:t>
+              <a:t>Rewrite the store listing and landing page.</a:t>
             </a:r>
           </a:p>
           <a:p>
@@ -5845,7 +5832,7 @@
               </a:defRPr>
             </a:pPr>
             <a:r>
-              <a:t>That is narrower, more defensible and closer to current strengths.</a:t>
+              <a:t>Build templates and creator pilots.</a:t>
             </a:r>
           </a:p>
         </p:txBody>
@@ -5971,7 +5958,7 @@
               </a:defRPr>
             </a:pPr>
             <a:r>
-              <a:t>Packaging</a:t>
+              <a:t>Customer insight</a:t>
             </a:r>
           </a:p>
         </p:txBody>
@@ -6007,7 +5994,7 @@
               </a:defRPr>
             </a:pPr>
             <a:r>
-              <a:t>Keep pricing broadly stable.</a:t>
+              <a:t>Run churn interviews.</a:t>
             </a:r>
           </a:p>
           <a:p>
@@ -6020,7 +6007,7 @@
               </a:defRPr>
             </a:pPr>
             <a:r>
-              <a:t>Relax free limits so users can form a habit.</a:t>
+              <a:t>Tag support tickets by reason.</a:t>
             </a:r>
           </a:p>
           <a:p>
@@ -6033,7 +6020,20 @@
               </a:defRPr>
             </a:pPr>
             <a:r>
-              <a:t>Test 14-day trial, annual-first CTA and win-back offers instead of a blanket price cut.</a:t>
+              <a:t>Add cancellation survey.</a:t>
+            </a:r>
+          </a:p>
+          <a:p>
+            <a:pPr>
+              <a:defRPr sz="1050">
+                <a:solidFill>
+                  <a:srgbClr val="1F2937"/>
+                </a:solidFill>
+                <a:latin typeface="Segoe UI"/>
+              </a:defRPr>
+            </a:pPr>
+            <a:r>
+              <a:t>Track D7 and D30 by cohort.</a:t>
             </a:r>
           </a:p>
         </p:txBody>
@@ -6159,7 +6159,7 @@
               </a:defRPr>
             </a:pPr>
             <a:r>
-              <a:t>Growth</a:t>
+              <a:t>Support / success</a:t>
             </a:r>
           </a:p>
         </p:txBody>
@@ -6195,7 +6195,7 @@
               </a:defRPr>
             </a:pPr>
             <a:r>
-              <a:t>Pause or cut underperforming paid social.</a:t>
+              <a:t>Use lifecycle nudges for stuck trial users.</a:t>
             </a:r>
           </a:p>
           <a:p>
@@ -6208,7 +6208,7 @@
               </a:defRPr>
             </a:pPr>
             <a:r>
-              <a:t>Rebuild ASO.</a:t>
+              <a:t>Build a self-serve help layer.</a:t>
             </a:r>
           </a:p>
           <a:p>
@@ -6221,7 +6221,7 @@
               </a:defRPr>
             </a:pPr>
             <a:r>
-              <a:t>Launch templates, referral loops and creator partnerships in the productivity niche.</a:t>
+              <a:t>Turn support into a feedback loop, not only ticket handling.</a:t>
             </a:r>
           </a:p>
         </p:txBody>
@@ -6347,7 +6347,7 @@
               </a:defRPr>
             </a:pPr>
             <a:r>
-              <a:t>Markets</a:t>
+              <a:t>Ops / finance</a:t>
             </a:r>
           </a:p>
         </p:txBody>
@@ -6383,7 +6383,7 @@
               </a:defRPr>
             </a:pPr>
             <a:r>
-              <a:t>Prioritize US, UK, Canada and Australia first.</a:t>
+              <a:t>Freeze non-core work.</a:t>
             </a:r>
           </a:p>
           <a:p>
@@ -6396,7 +6396,7 @@
               </a:defRPr>
             </a:pPr>
             <a:r>
-              <a:t>Germany can be wave 2.</a:t>
+              <a:t>Use weekly stop-loss rules on paid.</a:t>
             </a:r>
           </a:p>
           <a:p>
@@ -6409,7 +6409,7 @@
               </a:defRPr>
             </a:pPr>
             <a:r>
-              <a:t>Do not chase cheap low-monetization volume before retention recovers.</a:t>
+              <a:t>Limit the team to 3 core bets at a time.</a:t>
             </a:r>
           </a:p>
         </p:txBody>
@@ -6445,7 +6445,7 @@
               </a:defRPr>
             </a:pPr>
             <a:r>
-              <a:t>This is a turnaround strategy with a lightweight AI layer, not a risky full pivot into a brand-new product.</a:t>
+              <a:t>The point is not to do more work. It is to do fewer bets with tighter operating discipline.</a:t>
             </a:r>
           </a:p>
         </p:txBody>
@@ -6586,7 +6586,7 @@
               </a:defRPr>
             </a:pPr>
             <a:r>
-              <a:t>12-month roadmap</a:t>
+              <a:t>90 days to stop the bleed, 12 months to scale winners</a:t>
             </a:r>
           </a:p>
         </p:txBody>
@@ -6756,7 +6756,7 @@
               </a:defRPr>
             </a:pPr>
             <a:r>
-              <a:t>Q2 2026 | Stabilize</a:t>
+              <a:t>Q2 2026 | Stop the bleed</a:t>
             </a:r>
           </a:p>
         </p:txBody>
@@ -6792,7 +6792,7 @@
               </a:defRPr>
             </a:pPr>
             <a:r>
-              <a:t>Cut inefficient paid UA</a:t>
+              <a:t>Activation funnel</a:t>
             </a:r>
           </a:p>
           <a:p>
@@ -6818,7 +6818,7 @@
               </a:defRPr>
             </a:pPr>
             <a:r>
-              <a:t>Onboarding by use case</a:t>
+              <a:t>Store listing rewrite</a:t>
             </a:r>
           </a:p>
           <a:p>
@@ -6831,20 +6831,7 @@
               </a:defRPr>
             </a:pPr>
             <a:r>
-              <a:t>Design refresh</a:t>
-            </a:r>
-          </a:p>
-          <a:p>
-            <a:pPr>
-              <a:defRPr sz="1050">
-                <a:solidFill>
-                  <a:srgbClr val="1F2937"/>
-                </a:solidFill>
-                <a:latin typeface="Segoe UI"/>
-              </a:defRPr>
-            </a:pPr>
-            <a:r>
-              <a:t>Review-response program</a:t>
+              <a:t>Paid stop-loss rules</a:t>
             </a:r>
           </a:p>
         </p:txBody>
@@ -6970,7 +6957,7 @@
               </a:defRPr>
             </a:pPr>
             <a:r>
-              <a:t>Q3 2026 | Differentiate</a:t>
+              <a:t>Q3 2026 | Prove the core</a:t>
             </a:r>
           </a:p>
         </p:txBody>
@@ -7019,7 +7006,7 @@
               </a:defRPr>
             </a:pPr>
             <a:r>
-              <a:t>Web + calendar parity</a:t>
+              <a:t>Calendar parity</a:t>
             </a:r>
           </a:p>
           <a:p>
@@ -7032,7 +7019,7 @@
               </a:defRPr>
             </a:pPr>
             <a:r>
-              <a:t>Recurring task improvements</a:t>
+              <a:t>Templates</a:t>
             </a:r>
           </a:p>
           <a:p>
@@ -7045,7 +7032,7 @@
               </a:defRPr>
             </a:pPr>
             <a:r>
-              <a:t>Free tier / trial experiments</a:t>
+              <a:t>Free / trial experiments</a:t>
             </a:r>
           </a:p>
         </p:txBody>
@@ -7207,7 +7194,7 @@
               </a:defRPr>
             </a:pPr>
             <a:r>
-              <a:t>AI smart scheduling</a:t>
+              <a:t>Smart scheduling</a:t>
             </a:r>
           </a:p>
           <a:p>
@@ -7234,19 +7221,6 @@
             </a:pPr>
             <a:r>
               <a:t>Weekly planning summary</a:t>
-            </a:r>
-          </a:p>
-          <a:p>
-            <a:pPr>
-              <a:defRPr sz="1050">
-                <a:solidFill>
-                  <a:srgbClr val="1F2937"/>
-                </a:solidFill>
-                <a:latin typeface="Segoe UI"/>
-              </a:defRPr>
-            </a:pPr>
-            <a:r>
-              <a:t>ASO + SEO landing pages</a:t>
             </a:r>
           </a:p>
         </p:txBody>
@@ -7408,7 +7382,7 @@
               </a:defRPr>
             </a:pPr>
             <a:r>
-              <a:t>Increase spend only on positive-payback channels</a:t>
+              <a:t>Increase spend only on green channels</a:t>
             </a:r>
           </a:p>
           <a:p>
@@ -7421,7 +7395,7 @@
               </a:defRPr>
             </a:pPr>
             <a:r>
-              <a:t>Referral / ambassador engine</a:t>
+              <a:t>Referral engine</a:t>
             </a:r>
           </a:p>
           <a:p>
@@ -7434,7 +7408,7 @@
               </a:defRPr>
             </a:pPr>
             <a:r>
-              <a:t>Wave-2 localization if KPIs hold</a:t>
+              <a:t>Wave-2 market tests</a:t>
             </a:r>
           </a:p>
         </p:txBody>
@@ -7470,7 +7444,7 @@
               </a:defRPr>
             </a:pPr>
             <a:r>
-              <a:t>Decision gate: if D30 retention is still below 7% after Q3 2026, revisit a larger pivot instead of scaling spend.</a:t>
+              <a:t>Hard checkpoint: if D30 is still below 7% by the end of Q3, revisit a broader pivot instead of raising spend.</a:t>
             </a:r>
           </a:p>
         </p:txBody>
@@ -7611,7 +7585,7 @@
               </a:defRPr>
             </a:pPr>
             <a:r>
-              <a:t>What success should look like after 12 months</a:t>
+              <a:t>Do not scale again until these thresholds are met</a:t>
             </a:r>
           </a:p>
         </p:txBody>
@@ -7657,1739 +7631,6 @@
           <a:p>
             <a:pPr algn="ctr"/>
             <a:endParaRPr/>
-          </a:p>
-        </p:txBody>
-      </p:sp>
-      <p:sp>
-        <p:nvSpPr>
-          <p:cNvPr id="4" name="Rectangle 3"/>
-          <p:cNvSpPr/>
-          <p:nvPr/>
-        </p:nvSpPr>
-        <p:spPr>
-          <a:xfrm>
-            <a:off x="713232" y="1572768"/>
-            <a:ext cx="5669280" cy="4041648"/>
-          </a:xfrm>
-          <a:prstGeom prst="rect">
-            <a:avLst/>
-          </a:prstGeom>
-          <a:solidFill>
-            <a:srgbClr val="FFFDFC"/>
-          </a:solidFill>
-          <a:ln>
-            <a:solidFill>
-              <a:srgbClr val="E5DDD4"/>
-            </a:solidFill>
-          </a:ln>
-        </p:spPr>
-        <p:style>
-          <a:lnRef idx="1">
-            <a:schemeClr val="accent1"/>
-          </a:lnRef>
-          <a:fillRef idx="3">
-            <a:schemeClr val="accent1"/>
-          </a:fillRef>
-          <a:effectRef idx="2">
-            <a:schemeClr val="accent1"/>
-          </a:effectRef>
-          <a:fontRef idx="minor">
-            <a:schemeClr val="lt1"/>
-          </a:fontRef>
-        </p:style>
-        <p:txBody>
-          <a:bodyPr rtlCol="0" anchor="ctr"/>
-          <a:lstStyle/>
-          <a:p>
-            <a:pPr algn="ctr"/>
-            <a:endParaRPr/>
-          </a:p>
-        </p:txBody>
-      </p:sp>
-      <p:sp>
-        <p:nvSpPr>
-          <p:cNvPr id="5" name="Rectangle 4"/>
-          <p:cNvSpPr/>
-          <p:nvPr/>
-        </p:nvSpPr>
-        <p:spPr>
-          <a:xfrm>
-            <a:off x="841248" y="1810512"/>
-            <a:ext cx="2286000" cy="420624"/>
-          </a:xfrm>
-          <a:prstGeom prst="rect">
-            <a:avLst/>
-          </a:prstGeom>
-          <a:solidFill>
-            <a:srgbClr val="F26B3A"/>
-          </a:solidFill>
-          <a:ln>
-            <a:solidFill>
-              <a:srgbClr val="FFFDFC"/>
-            </a:solidFill>
-          </a:ln>
-        </p:spPr>
-        <p:style>
-          <a:lnRef idx="1">
-            <a:schemeClr val="accent1"/>
-          </a:lnRef>
-          <a:fillRef idx="3">
-            <a:schemeClr val="accent1"/>
-          </a:fillRef>
-          <a:effectRef idx="2">
-            <a:schemeClr val="accent1"/>
-          </a:effectRef>
-          <a:fontRef idx="minor">
-            <a:schemeClr val="lt1"/>
-          </a:fontRef>
-        </p:style>
-        <p:txBody>
-          <a:bodyPr rtlCol="0" anchor="ctr"/>
-          <a:lstStyle/>
-          <a:p>
-            <a:pPr algn="ctr"/>
-            <a:endParaRPr/>
-          </a:p>
-        </p:txBody>
-      </p:sp>
-      <p:sp>
-        <p:nvSpPr>
-          <p:cNvPr id="6" name="TextBox 5"/>
-          <p:cNvSpPr txBox="1"/>
-          <p:nvPr/>
-        </p:nvSpPr>
-        <p:spPr>
-          <a:xfrm>
-            <a:off x="896112" y="1847088"/>
-            <a:ext cx="2212848" cy="256032"/>
-          </a:xfrm>
-          <a:prstGeom prst="rect">
-            <a:avLst/>
-          </a:prstGeom>
-          <a:noFill/>
-        </p:spPr>
-        <p:txBody>
-          <a:bodyPr wrap="square" lIns="128016" tIns="128016" rIns="128016" bIns="128016" anchor="t">
-            <a:spAutoFit/>
-          </a:bodyPr>
-          <a:lstStyle/>
-          <a:p>
-            <a:pPr algn="l">
-              <a:defRPr sz="1050" b="1">
-                <a:solidFill>
-                  <a:srgbClr val="FFFDFC"/>
-                </a:solidFill>
-                <a:latin typeface="Segoe UI"/>
-              </a:defRPr>
-            </a:pPr>
-            <a:r>
-              <a:t>Metric</a:t>
-            </a:r>
-          </a:p>
-        </p:txBody>
-      </p:sp>
-      <p:sp>
-        <p:nvSpPr>
-          <p:cNvPr id="7" name="Rectangle 6"/>
-          <p:cNvSpPr/>
-          <p:nvPr/>
-        </p:nvSpPr>
-        <p:spPr>
-          <a:xfrm>
-            <a:off x="3127248" y="1810512"/>
-            <a:ext cx="1463040" cy="420624"/>
-          </a:xfrm>
-          <a:prstGeom prst="rect">
-            <a:avLst/>
-          </a:prstGeom>
-          <a:solidFill>
-            <a:srgbClr val="F26B3A"/>
-          </a:solidFill>
-          <a:ln>
-            <a:solidFill>
-              <a:srgbClr val="FFFDFC"/>
-            </a:solidFill>
-          </a:ln>
-        </p:spPr>
-        <p:style>
-          <a:lnRef idx="1">
-            <a:schemeClr val="accent1"/>
-          </a:lnRef>
-          <a:fillRef idx="3">
-            <a:schemeClr val="accent1"/>
-          </a:fillRef>
-          <a:effectRef idx="2">
-            <a:schemeClr val="accent1"/>
-          </a:effectRef>
-          <a:fontRef idx="minor">
-            <a:schemeClr val="lt1"/>
-          </a:fontRef>
-        </p:style>
-        <p:txBody>
-          <a:bodyPr rtlCol="0" anchor="ctr"/>
-          <a:lstStyle/>
-          <a:p>
-            <a:pPr algn="ctr"/>
-            <a:endParaRPr/>
-          </a:p>
-        </p:txBody>
-      </p:sp>
-      <p:sp>
-        <p:nvSpPr>
-          <p:cNvPr id="9" name="Rectangle 8"/>
-          <p:cNvSpPr/>
-          <p:nvPr/>
-        </p:nvSpPr>
-        <p:spPr>
-          <a:xfrm>
-            <a:off x="4590288" y="1810512"/>
-            <a:ext cx="1463040" cy="420624"/>
-          </a:xfrm>
-          <a:prstGeom prst="rect">
-            <a:avLst/>
-          </a:prstGeom>
-          <a:solidFill>
-            <a:srgbClr val="F26B3A"/>
-          </a:solidFill>
-          <a:ln>
-            <a:solidFill>
-              <a:srgbClr val="FFFDFC"/>
-            </a:solidFill>
-          </a:ln>
-        </p:spPr>
-        <p:style>
-          <a:lnRef idx="1">
-            <a:schemeClr val="accent1"/>
-          </a:lnRef>
-          <a:fillRef idx="3">
-            <a:schemeClr val="accent1"/>
-          </a:fillRef>
-          <a:effectRef idx="2">
-            <a:schemeClr val="accent1"/>
-          </a:effectRef>
-          <a:fontRef idx="minor">
-            <a:schemeClr val="lt1"/>
-          </a:fontRef>
-        </p:style>
-        <p:txBody>
-          <a:bodyPr rtlCol="0" anchor="ctr"/>
-          <a:lstStyle/>
-          <a:p>
-            <a:pPr algn="ctr"/>
-            <a:endParaRPr/>
-          </a:p>
-        </p:txBody>
-      </p:sp>
-      <p:sp>
-        <p:nvSpPr>
-          <p:cNvPr id="10" name="TextBox 9"/>
-          <p:cNvSpPr txBox="1"/>
-          <p:nvPr/>
-        </p:nvSpPr>
-        <p:spPr>
-          <a:xfrm>
-            <a:off x="4645152" y="1847088"/>
-            <a:ext cx="1389888" cy="256032"/>
-          </a:xfrm>
-          <a:prstGeom prst="rect">
-            <a:avLst/>
-          </a:prstGeom>
-          <a:noFill/>
-        </p:spPr>
-        <p:txBody>
-          <a:bodyPr wrap="square" lIns="128016" tIns="128016" rIns="128016" bIns="128016" anchor="t">
-            <a:spAutoFit/>
-          </a:bodyPr>
-          <a:lstStyle/>
-          <a:p>
-            <a:pPr algn="l">
-              <a:defRPr sz="1050" b="1">
-                <a:solidFill>
-                  <a:srgbClr val="FFFDFC"/>
-                </a:solidFill>
-                <a:latin typeface="Segoe UI"/>
-              </a:defRPr>
-            </a:pPr>
-            <a:r>
-              <a:rPr dirty="0"/>
-              <a:t>12M target</a:t>
-            </a:r>
-          </a:p>
-        </p:txBody>
-      </p:sp>
-      <p:sp>
-        <p:nvSpPr>
-          <p:cNvPr id="11" name="Rectangle 10"/>
-          <p:cNvSpPr/>
-          <p:nvPr/>
-        </p:nvSpPr>
-        <p:spPr>
-          <a:xfrm>
-            <a:off x="841248" y="2231136"/>
-            <a:ext cx="2286000" cy="457200"/>
-          </a:xfrm>
-          <a:prstGeom prst="rect">
-            <a:avLst/>
-          </a:prstGeom>
-          <a:solidFill>
-            <a:srgbClr val="FFF0E8"/>
-          </a:solidFill>
-          <a:ln>
-            <a:solidFill>
-              <a:srgbClr val="E5DDD4"/>
-            </a:solidFill>
-          </a:ln>
-        </p:spPr>
-        <p:style>
-          <a:lnRef idx="1">
-            <a:schemeClr val="accent1"/>
-          </a:lnRef>
-          <a:fillRef idx="3">
-            <a:schemeClr val="accent1"/>
-          </a:fillRef>
-          <a:effectRef idx="2">
-            <a:schemeClr val="accent1"/>
-          </a:effectRef>
-          <a:fontRef idx="minor">
-            <a:schemeClr val="lt1"/>
-          </a:fontRef>
-        </p:style>
-        <p:txBody>
-          <a:bodyPr rtlCol="0" anchor="ctr"/>
-          <a:lstStyle/>
-          <a:p>
-            <a:pPr algn="ctr"/>
-            <a:endParaRPr/>
-          </a:p>
-        </p:txBody>
-      </p:sp>
-      <p:sp>
-        <p:nvSpPr>
-          <p:cNvPr id="12" name="TextBox 11"/>
-          <p:cNvSpPr txBox="1"/>
-          <p:nvPr/>
-        </p:nvSpPr>
-        <p:spPr>
-          <a:xfrm>
-            <a:off x="914400" y="2304288"/>
-            <a:ext cx="2194560" cy="237744"/>
-          </a:xfrm>
-          <a:prstGeom prst="rect">
-            <a:avLst/>
-          </a:prstGeom>
-          <a:noFill/>
-        </p:spPr>
-        <p:txBody>
-          <a:bodyPr wrap="square" lIns="128016" tIns="128016" rIns="128016" bIns="128016" anchor="t">
-            <a:spAutoFit/>
-          </a:bodyPr>
-          <a:lstStyle/>
-          <a:p>
-            <a:pPr algn="l">
-              <a:defRPr sz="1200" b="1">
-                <a:solidFill>
-                  <a:srgbClr val="1F2937"/>
-                </a:solidFill>
-                <a:latin typeface="Segoe UI"/>
-              </a:defRPr>
-            </a:pPr>
-            <a:r>
-              <a:t>D30 retention</a:t>
-            </a:r>
-          </a:p>
-        </p:txBody>
-      </p:sp>
-      <p:sp>
-        <p:nvSpPr>
-          <p:cNvPr id="13" name="Rectangle 12"/>
-          <p:cNvSpPr/>
-          <p:nvPr/>
-        </p:nvSpPr>
-        <p:spPr>
-          <a:xfrm>
-            <a:off x="3127248" y="2231136"/>
-            <a:ext cx="1463040" cy="457200"/>
-          </a:xfrm>
-          <a:prstGeom prst="rect">
-            <a:avLst/>
-          </a:prstGeom>
-          <a:solidFill>
-            <a:srgbClr val="FFF0E8"/>
-          </a:solidFill>
-          <a:ln>
-            <a:solidFill>
-              <a:srgbClr val="E5DDD4"/>
-            </a:solidFill>
-          </a:ln>
-        </p:spPr>
-        <p:style>
-          <a:lnRef idx="1">
-            <a:schemeClr val="accent1"/>
-          </a:lnRef>
-          <a:fillRef idx="3">
-            <a:schemeClr val="accent1"/>
-          </a:fillRef>
-          <a:effectRef idx="2">
-            <a:schemeClr val="accent1"/>
-          </a:effectRef>
-          <a:fontRef idx="minor">
-            <a:schemeClr val="lt1"/>
-          </a:fontRef>
-        </p:style>
-        <p:txBody>
-          <a:bodyPr rtlCol="0" anchor="ctr"/>
-          <a:lstStyle/>
-          <a:p>
-            <a:pPr algn="ctr"/>
-            <a:endParaRPr/>
-          </a:p>
-        </p:txBody>
-      </p:sp>
-      <p:sp>
-        <p:nvSpPr>
-          <p:cNvPr id="14" name="TextBox 13"/>
-          <p:cNvSpPr txBox="1"/>
-          <p:nvPr/>
-        </p:nvSpPr>
-        <p:spPr>
-          <a:xfrm>
-            <a:off x="3200400" y="2304288"/>
-            <a:ext cx="1371600" cy="237744"/>
-          </a:xfrm>
-          <a:prstGeom prst="rect">
-            <a:avLst/>
-          </a:prstGeom>
-          <a:noFill/>
-        </p:spPr>
-        <p:txBody>
-          <a:bodyPr wrap="square" lIns="128016" tIns="128016" rIns="128016" bIns="128016" anchor="t">
-            <a:spAutoFit/>
-          </a:bodyPr>
-          <a:lstStyle/>
-          <a:p>
-            <a:pPr algn="l">
-              <a:defRPr sz="1200" b="0">
-                <a:solidFill>
-                  <a:srgbClr val="1F2937"/>
-                </a:solidFill>
-                <a:latin typeface="Segoe UI"/>
-              </a:defRPr>
-            </a:pPr>
-            <a:r>
-              <a:t>5.0%</a:t>
-            </a:r>
-          </a:p>
-        </p:txBody>
-      </p:sp>
-      <p:sp>
-        <p:nvSpPr>
-          <p:cNvPr id="15" name="Rectangle 14"/>
-          <p:cNvSpPr/>
-          <p:nvPr/>
-        </p:nvSpPr>
-        <p:spPr>
-          <a:xfrm>
-            <a:off x="4590288" y="2231136"/>
-            <a:ext cx="1463040" cy="457200"/>
-          </a:xfrm>
-          <a:prstGeom prst="rect">
-            <a:avLst/>
-          </a:prstGeom>
-          <a:solidFill>
-            <a:srgbClr val="FFF0E8"/>
-          </a:solidFill>
-          <a:ln>
-            <a:solidFill>
-              <a:srgbClr val="E5DDD4"/>
-            </a:solidFill>
-          </a:ln>
-        </p:spPr>
-        <p:style>
-          <a:lnRef idx="1">
-            <a:schemeClr val="accent1"/>
-          </a:lnRef>
-          <a:fillRef idx="3">
-            <a:schemeClr val="accent1"/>
-          </a:fillRef>
-          <a:effectRef idx="2">
-            <a:schemeClr val="accent1"/>
-          </a:effectRef>
-          <a:fontRef idx="minor">
-            <a:schemeClr val="lt1"/>
-          </a:fontRef>
-        </p:style>
-        <p:txBody>
-          <a:bodyPr rtlCol="0" anchor="ctr"/>
-          <a:lstStyle/>
-          <a:p>
-            <a:pPr algn="ctr"/>
-            <a:endParaRPr/>
-          </a:p>
-        </p:txBody>
-      </p:sp>
-      <p:sp>
-        <p:nvSpPr>
-          <p:cNvPr id="16" name="TextBox 15"/>
-          <p:cNvSpPr txBox="1"/>
-          <p:nvPr/>
-        </p:nvSpPr>
-        <p:spPr>
-          <a:xfrm>
-            <a:off x="4663440" y="2304288"/>
-            <a:ext cx="1371600" cy="237744"/>
-          </a:xfrm>
-          <a:prstGeom prst="rect">
-            <a:avLst/>
-          </a:prstGeom>
-          <a:noFill/>
-        </p:spPr>
-        <p:txBody>
-          <a:bodyPr wrap="square" lIns="128016" tIns="128016" rIns="128016" bIns="128016" anchor="t">
-            <a:spAutoFit/>
-          </a:bodyPr>
-          <a:lstStyle/>
-          <a:p>
-            <a:pPr algn="l">
-              <a:defRPr sz="1200" b="0">
-                <a:solidFill>
-                  <a:srgbClr val="1F2937"/>
-                </a:solidFill>
-                <a:latin typeface="Segoe UI"/>
-              </a:defRPr>
-            </a:pPr>
-            <a:r>
-              <a:t>8.0%-9.0%</a:t>
-            </a:r>
-          </a:p>
-        </p:txBody>
-      </p:sp>
-      <p:sp>
-        <p:nvSpPr>
-          <p:cNvPr id="17" name="Rectangle 16"/>
-          <p:cNvSpPr/>
-          <p:nvPr/>
-        </p:nvSpPr>
-        <p:spPr>
-          <a:xfrm>
-            <a:off x="841248" y="2688336"/>
-            <a:ext cx="2286000" cy="457200"/>
-          </a:xfrm>
-          <a:prstGeom prst="rect">
-            <a:avLst/>
-          </a:prstGeom>
-          <a:solidFill>
-            <a:srgbClr val="FFFDFC"/>
-          </a:solidFill>
-          <a:ln>
-            <a:solidFill>
-              <a:srgbClr val="E5DDD4"/>
-            </a:solidFill>
-          </a:ln>
-        </p:spPr>
-        <p:style>
-          <a:lnRef idx="1">
-            <a:schemeClr val="accent1"/>
-          </a:lnRef>
-          <a:fillRef idx="3">
-            <a:schemeClr val="accent1"/>
-          </a:fillRef>
-          <a:effectRef idx="2">
-            <a:schemeClr val="accent1"/>
-          </a:effectRef>
-          <a:fontRef idx="minor">
-            <a:schemeClr val="lt1"/>
-          </a:fontRef>
-        </p:style>
-        <p:txBody>
-          <a:bodyPr rtlCol="0" anchor="ctr"/>
-          <a:lstStyle/>
-          <a:p>
-            <a:pPr algn="ctr"/>
-            <a:endParaRPr/>
-          </a:p>
-        </p:txBody>
-      </p:sp>
-      <p:sp>
-        <p:nvSpPr>
-          <p:cNvPr id="18" name="TextBox 17"/>
-          <p:cNvSpPr txBox="1"/>
-          <p:nvPr/>
-        </p:nvSpPr>
-        <p:spPr>
-          <a:xfrm>
-            <a:off x="914400" y="2761488"/>
-            <a:ext cx="2194560" cy="237744"/>
-          </a:xfrm>
-          <a:prstGeom prst="rect">
-            <a:avLst/>
-          </a:prstGeom>
-          <a:noFill/>
-        </p:spPr>
-        <p:txBody>
-          <a:bodyPr wrap="square" lIns="128016" tIns="128016" rIns="128016" bIns="128016" anchor="t">
-            <a:spAutoFit/>
-          </a:bodyPr>
-          <a:lstStyle/>
-          <a:p>
-            <a:pPr algn="l">
-              <a:defRPr sz="1200" b="0">
-                <a:solidFill>
-                  <a:srgbClr val="1F2937"/>
-                </a:solidFill>
-                <a:latin typeface="Segoe UI"/>
-              </a:defRPr>
-            </a:pPr>
-            <a:r>
-              <a:t>Paid churn</a:t>
-            </a:r>
-          </a:p>
-        </p:txBody>
-      </p:sp>
-      <p:sp>
-        <p:nvSpPr>
-          <p:cNvPr id="19" name="Rectangle 18"/>
-          <p:cNvSpPr/>
-          <p:nvPr/>
-        </p:nvSpPr>
-        <p:spPr>
-          <a:xfrm>
-            <a:off x="3127248" y="2688336"/>
-            <a:ext cx="1463040" cy="457200"/>
-          </a:xfrm>
-          <a:prstGeom prst="rect">
-            <a:avLst/>
-          </a:prstGeom>
-          <a:solidFill>
-            <a:srgbClr val="FFFDFC"/>
-          </a:solidFill>
-          <a:ln>
-            <a:solidFill>
-              <a:srgbClr val="E5DDD4"/>
-            </a:solidFill>
-          </a:ln>
-        </p:spPr>
-        <p:style>
-          <a:lnRef idx="1">
-            <a:schemeClr val="accent1"/>
-          </a:lnRef>
-          <a:fillRef idx="3">
-            <a:schemeClr val="accent1"/>
-          </a:fillRef>
-          <a:effectRef idx="2">
-            <a:schemeClr val="accent1"/>
-          </a:effectRef>
-          <a:fontRef idx="minor">
-            <a:schemeClr val="lt1"/>
-          </a:fontRef>
-        </p:style>
-        <p:txBody>
-          <a:bodyPr rtlCol="0" anchor="ctr"/>
-          <a:lstStyle/>
-          <a:p>
-            <a:pPr algn="ctr"/>
-            <a:endParaRPr/>
-          </a:p>
-        </p:txBody>
-      </p:sp>
-      <p:sp>
-        <p:nvSpPr>
-          <p:cNvPr id="20" name="TextBox 19"/>
-          <p:cNvSpPr txBox="1"/>
-          <p:nvPr/>
-        </p:nvSpPr>
-        <p:spPr>
-          <a:xfrm>
-            <a:off x="3200400" y="2761488"/>
-            <a:ext cx="1371600" cy="237744"/>
-          </a:xfrm>
-          <a:prstGeom prst="rect">
-            <a:avLst/>
-          </a:prstGeom>
-          <a:noFill/>
-        </p:spPr>
-        <p:txBody>
-          <a:bodyPr wrap="square" lIns="128016" tIns="128016" rIns="128016" bIns="128016" anchor="t">
-            <a:spAutoFit/>
-          </a:bodyPr>
-          <a:lstStyle/>
-          <a:p>
-            <a:pPr algn="l">
-              <a:defRPr sz="1200" b="0">
-                <a:solidFill>
-                  <a:srgbClr val="1F2937"/>
-                </a:solidFill>
-                <a:latin typeface="Segoe UI"/>
-              </a:defRPr>
-            </a:pPr>
-            <a:r>
-              <a:t>18%</a:t>
-            </a:r>
-          </a:p>
-        </p:txBody>
-      </p:sp>
-      <p:sp>
-        <p:nvSpPr>
-          <p:cNvPr id="21" name="Rectangle 20"/>
-          <p:cNvSpPr/>
-          <p:nvPr/>
-        </p:nvSpPr>
-        <p:spPr>
-          <a:xfrm>
-            <a:off x="4590288" y="2688336"/>
-            <a:ext cx="1463040" cy="457200"/>
-          </a:xfrm>
-          <a:prstGeom prst="rect">
-            <a:avLst/>
-          </a:prstGeom>
-          <a:solidFill>
-            <a:srgbClr val="FFFDFC"/>
-          </a:solidFill>
-          <a:ln>
-            <a:solidFill>
-              <a:srgbClr val="E5DDD4"/>
-            </a:solidFill>
-          </a:ln>
-        </p:spPr>
-        <p:style>
-          <a:lnRef idx="1">
-            <a:schemeClr val="accent1"/>
-          </a:lnRef>
-          <a:fillRef idx="3">
-            <a:schemeClr val="accent1"/>
-          </a:fillRef>
-          <a:effectRef idx="2">
-            <a:schemeClr val="accent1"/>
-          </a:effectRef>
-          <a:fontRef idx="minor">
-            <a:schemeClr val="lt1"/>
-          </a:fontRef>
-        </p:style>
-        <p:txBody>
-          <a:bodyPr rtlCol="0" anchor="ctr"/>
-          <a:lstStyle/>
-          <a:p>
-            <a:pPr algn="ctr"/>
-            <a:endParaRPr/>
-          </a:p>
-        </p:txBody>
-      </p:sp>
-      <p:sp>
-        <p:nvSpPr>
-          <p:cNvPr id="22" name="TextBox 21"/>
-          <p:cNvSpPr txBox="1"/>
-          <p:nvPr/>
-        </p:nvSpPr>
-        <p:spPr>
-          <a:xfrm>
-            <a:off x="4663440" y="2761488"/>
-            <a:ext cx="1371600" cy="237744"/>
-          </a:xfrm>
-          <a:prstGeom prst="rect">
-            <a:avLst/>
-          </a:prstGeom>
-          <a:noFill/>
-        </p:spPr>
-        <p:txBody>
-          <a:bodyPr wrap="square" lIns="128016" tIns="128016" rIns="128016" bIns="128016" anchor="t">
-            <a:spAutoFit/>
-          </a:bodyPr>
-          <a:lstStyle/>
-          <a:p>
-            <a:pPr algn="l">
-              <a:defRPr sz="1200" b="0">
-                <a:solidFill>
-                  <a:srgbClr val="1F2937"/>
-                </a:solidFill>
-                <a:latin typeface="Segoe UI"/>
-              </a:defRPr>
-            </a:pPr>
-            <a:r>
-              <a:t>11%-12%</a:t>
-            </a:r>
-          </a:p>
-        </p:txBody>
-      </p:sp>
-      <p:sp>
-        <p:nvSpPr>
-          <p:cNvPr id="23" name="Rectangle 22"/>
-          <p:cNvSpPr/>
-          <p:nvPr/>
-        </p:nvSpPr>
-        <p:spPr>
-          <a:xfrm>
-            <a:off x="841248" y="3145536"/>
-            <a:ext cx="2286000" cy="457200"/>
-          </a:xfrm>
-          <a:prstGeom prst="rect">
-            <a:avLst/>
-          </a:prstGeom>
-          <a:solidFill>
-            <a:srgbClr val="FFFDFC"/>
-          </a:solidFill>
-          <a:ln>
-            <a:solidFill>
-              <a:srgbClr val="E5DDD4"/>
-            </a:solidFill>
-          </a:ln>
-        </p:spPr>
-        <p:style>
-          <a:lnRef idx="1">
-            <a:schemeClr val="accent1"/>
-          </a:lnRef>
-          <a:fillRef idx="3">
-            <a:schemeClr val="accent1"/>
-          </a:fillRef>
-          <a:effectRef idx="2">
-            <a:schemeClr val="accent1"/>
-          </a:effectRef>
-          <a:fontRef idx="minor">
-            <a:schemeClr val="lt1"/>
-          </a:fontRef>
-        </p:style>
-        <p:txBody>
-          <a:bodyPr rtlCol="0" anchor="ctr"/>
-          <a:lstStyle/>
-          <a:p>
-            <a:pPr algn="ctr"/>
-            <a:endParaRPr/>
-          </a:p>
-        </p:txBody>
-      </p:sp>
-      <p:sp>
-        <p:nvSpPr>
-          <p:cNvPr id="24" name="TextBox 23"/>
-          <p:cNvSpPr txBox="1"/>
-          <p:nvPr/>
-        </p:nvSpPr>
-        <p:spPr>
-          <a:xfrm>
-            <a:off x="914400" y="3218688"/>
-            <a:ext cx="2194560" cy="237744"/>
-          </a:xfrm>
-          <a:prstGeom prst="rect">
-            <a:avLst/>
-          </a:prstGeom>
-          <a:noFill/>
-        </p:spPr>
-        <p:txBody>
-          <a:bodyPr wrap="square" lIns="128016" tIns="128016" rIns="128016" bIns="128016" anchor="t">
-            <a:spAutoFit/>
-          </a:bodyPr>
-          <a:lstStyle/>
-          <a:p>
-            <a:pPr algn="l">
-              <a:defRPr sz="1200" b="0">
-                <a:solidFill>
-                  <a:srgbClr val="1F2937"/>
-                </a:solidFill>
-                <a:latin typeface="Segoe UI"/>
-              </a:defRPr>
-            </a:pPr>
-            <a:r>
-              <a:t>Trial-to-paid</a:t>
-            </a:r>
-          </a:p>
-        </p:txBody>
-      </p:sp>
-      <p:sp>
-        <p:nvSpPr>
-          <p:cNvPr id="25" name="Rectangle 24"/>
-          <p:cNvSpPr/>
-          <p:nvPr/>
-        </p:nvSpPr>
-        <p:spPr>
-          <a:xfrm>
-            <a:off x="3127248" y="3145536"/>
-            <a:ext cx="1463040" cy="457200"/>
-          </a:xfrm>
-          <a:prstGeom prst="rect">
-            <a:avLst/>
-          </a:prstGeom>
-          <a:solidFill>
-            <a:srgbClr val="FFFDFC"/>
-          </a:solidFill>
-          <a:ln>
-            <a:solidFill>
-              <a:srgbClr val="E5DDD4"/>
-            </a:solidFill>
-          </a:ln>
-        </p:spPr>
-        <p:style>
-          <a:lnRef idx="1">
-            <a:schemeClr val="accent1"/>
-          </a:lnRef>
-          <a:fillRef idx="3">
-            <a:schemeClr val="accent1"/>
-          </a:fillRef>
-          <a:effectRef idx="2">
-            <a:schemeClr val="accent1"/>
-          </a:effectRef>
-          <a:fontRef idx="minor">
-            <a:schemeClr val="lt1"/>
-          </a:fontRef>
-        </p:style>
-        <p:txBody>
-          <a:bodyPr rtlCol="0" anchor="ctr"/>
-          <a:lstStyle/>
-          <a:p>
-            <a:pPr algn="ctr"/>
-            <a:endParaRPr/>
-          </a:p>
-        </p:txBody>
-      </p:sp>
-      <p:sp>
-        <p:nvSpPr>
-          <p:cNvPr id="26" name="TextBox 25"/>
-          <p:cNvSpPr txBox="1"/>
-          <p:nvPr/>
-        </p:nvSpPr>
-        <p:spPr>
-          <a:xfrm>
-            <a:off x="3200400" y="3218688"/>
-            <a:ext cx="1371600" cy="237744"/>
-          </a:xfrm>
-          <a:prstGeom prst="rect">
-            <a:avLst/>
-          </a:prstGeom>
-          <a:noFill/>
-        </p:spPr>
-        <p:txBody>
-          <a:bodyPr wrap="square" lIns="128016" tIns="128016" rIns="128016" bIns="128016" anchor="t">
-            <a:spAutoFit/>
-          </a:bodyPr>
-          <a:lstStyle/>
-          <a:p>
-            <a:pPr algn="l">
-              <a:defRPr sz="1200" b="0">
-                <a:solidFill>
-                  <a:srgbClr val="1F2937"/>
-                </a:solidFill>
-                <a:latin typeface="Segoe UI"/>
-              </a:defRPr>
-            </a:pPr>
-            <a:r>
-              <a:t>18%</a:t>
-            </a:r>
-          </a:p>
-        </p:txBody>
-      </p:sp>
-      <p:sp>
-        <p:nvSpPr>
-          <p:cNvPr id="27" name="Rectangle 26"/>
-          <p:cNvSpPr/>
-          <p:nvPr/>
-        </p:nvSpPr>
-        <p:spPr>
-          <a:xfrm>
-            <a:off x="4590288" y="3145536"/>
-            <a:ext cx="1463040" cy="457200"/>
-          </a:xfrm>
-          <a:prstGeom prst="rect">
-            <a:avLst/>
-          </a:prstGeom>
-          <a:solidFill>
-            <a:srgbClr val="FFFDFC"/>
-          </a:solidFill>
-          <a:ln>
-            <a:solidFill>
-              <a:srgbClr val="E5DDD4"/>
-            </a:solidFill>
-          </a:ln>
-        </p:spPr>
-        <p:style>
-          <a:lnRef idx="1">
-            <a:schemeClr val="accent1"/>
-          </a:lnRef>
-          <a:fillRef idx="3">
-            <a:schemeClr val="accent1"/>
-          </a:fillRef>
-          <a:effectRef idx="2">
-            <a:schemeClr val="accent1"/>
-          </a:effectRef>
-          <a:fontRef idx="minor">
-            <a:schemeClr val="lt1"/>
-          </a:fontRef>
-        </p:style>
-        <p:txBody>
-          <a:bodyPr rtlCol="0" anchor="ctr"/>
-          <a:lstStyle/>
-          <a:p>
-            <a:pPr algn="ctr"/>
-            <a:endParaRPr/>
-          </a:p>
-        </p:txBody>
-      </p:sp>
-      <p:sp>
-        <p:nvSpPr>
-          <p:cNvPr id="28" name="TextBox 27"/>
-          <p:cNvSpPr txBox="1"/>
-          <p:nvPr/>
-        </p:nvSpPr>
-        <p:spPr>
-          <a:xfrm>
-            <a:off x="4663440" y="3218688"/>
-            <a:ext cx="1371600" cy="237744"/>
-          </a:xfrm>
-          <a:prstGeom prst="rect">
-            <a:avLst/>
-          </a:prstGeom>
-          <a:noFill/>
-        </p:spPr>
-        <p:txBody>
-          <a:bodyPr wrap="square" lIns="128016" tIns="128016" rIns="128016" bIns="128016" anchor="t">
-            <a:spAutoFit/>
-          </a:bodyPr>
-          <a:lstStyle/>
-          <a:p>
-            <a:pPr algn="l">
-              <a:defRPr sz="1200" b="0">
-                <a:solidFill>
-                  <a:srgbClr val="1F2937"/>
-                </a:solidFill>
-                <a:latin typeface="Segoe UI"/>
-              </a:defRPr>
-            </a:pPr>
-            <a:r>
-              <a:t>24%-26%</a:t>
-            </a:r>
-          </a:p>
-        </p:txBody>
-      </p:sp>
-      <p:sp>
-        <p:nvSpPr>
-          <p:cNvPr id="29" name="Rectangle 28"/>
-          <p:cNvSpPr/>
-          <p:nvPr/>
-        </p:nvSpPr>
-        <p:spPr>
-          <a:xfrm>
-            <a:off x="841248" y="3602736"/>
-            <a:ext cx="2286000" cy="457200"/>
-          </a:xfrm>
-          <a:prstGeom prst="rect">
-            <a:avLst/>
-          </a:prstGeom>
-          <a:solidFill>
-            <a:srgbClr val="FFFDFC"/>
-          </a:solidFill>
-          <a:ln>
-            <a:solidFill>
-              <a:srgbClr val="E5DDD4"/>
-            </a:solidFill>
-          </a:ln>
-        </p:spPr>
-        <p:style>
-          <a:lnRef idx="1">
-            <a:schemeClr val="accent1"/>
-          </a:lnRef>
-          <a:fillRef idx="3">
-            <a:schemeClr val="accent1"/>
-          </a:fillRef>
-          <a:effectRef idx="2">
-            <a:schemeClr val="accent1"/>
-          </a:effectRef>
-          <a:fontRef idx="minor">
-            <a:schemeClr val="lt1"/>
-          </a:fontRef>
-        </p:style>
-        <p:txBody>
-          <a:bodyPr rtlCol="0" anchor="ctr"/>
-          <a:lstStyle/>
-          <a:p>
-            <a:pPr algn="ctr"/>
-            <a:endParaRPr/>
-          </a:p>
-        </p:txBody>
-      </p:sp>
-      <p:sp>
-        <p:nvSpPr>
-          <p:cNvPr id="30" name="TextBox 29"/>
-          <p:cNvSpPr txBox="1"/>
-          <p:nvPr/>
-        </p:nvSpPr>
-        <p:spPr>
-          <a:xfrm>
-            <a:off x="914400" y="3675887"/>
-            <a:ext cx="2194560" cy="237744"/>
-          </a:xfrm>
-          <a:prstGeom prst="rect">
-            <a:avLst/>
-          </a:prstGeom>
-          <a:noFill/>
-        </p:spPr>
-        <p:txBody>
-          <a:bodyPr wrap="square" lIns="128016" tIns="128016" rIns="128016" bIns="128016" anchor="t">
-            <a:spAutoFit/>
-          </a:bodyPr>
-          <a:lstStyle/>
-          <a:p>
-            <a:pPr algn="l">
-              <a:defRPr sz="1200" b="0">
-                <a:solidFill>
-                  <a:srgbClr val="1F2937"/>
-                </a:solidFill>
-                <a:latin typeface="Segoe UI"/>
-              </a:defRPr>
-            </a:pPr>
-            <a:r>
-              <a:t>Organic share of installs</a:t>
-            </a:r>
-          </a:p>
-        </p:txBody>
-      </p:sp>
-      <p:sp>
-        <p:nvSpPr>
-          <p:cNvPr id="31" name="Rectangle 30"/>
-          <p:cNvSpPr/>
-          <p:nvPr/>
-        </p:nvSpPr>
-        <p:spPr>
-          <a:xfrm>
-            <a:off x="3127248" y="3602736"/>
-            <a:ext cx="1463040" cy="457200"/>
-          </a:xfrm>
-          <a:prstGeom prst="rect">
-            <a:avLst/>
-          </a:prstGeom>
-          <a:solidFill>
-            <a:srgbClr val="FFFDFC"/>
-          </a:solidFill>
-          <a:ln>
-            <a:solidFill>
-              <a:srgbClr val="E5DDD4"/>
-            </a:solidFill>
-          </a:ln>
-        </p:spPr>
-        <p:style>
-          <a:lnRef idx="1">
-            <a:schemeClr val="accent1"/>
-          </a:lnRef>
-          <a:fillRef idx="3">
-            <a:schemeClr val="accent1"/>
-          </a:fillRef>
-          <a:effectRef idx="2">
-            <a:schemeClr val="accent1"/>
-          </a:effectRef>
-          <a:fontRef idx="minor">
-            <a:schemeClr val="lt1"/>
-          </a:fontRef>
-        </p:style>
-        <p:txBody>
-          <a:bodyPr rtlCol="0" anchor="ctr"/>
-          <a:lstStyle/>
-          <a:p>
-            <a:pPr algn="ctr"/>
-            <a:endParaRPr/>
-          </a:p>
-        </p:txBody>
-      </p:sp>
-      <p:sp>
-        <p:nvSpPr>
-          <p:cNvPr id="32" name="TextBox 31"/>
-          <p:cNvSpPr txBox="1"/>
-          <p:nvPr/>
-        </p:nvSpPr>
-        <p:spPr>
-          <a:xfrm>
-            <a:off x="3200400" y="3675887"/>
-            <a:ext cx="1371600" cy="237744"/>
-          </a:xfrm>
-          <a:prstGeom prst="rect">
-            <a:avLst/>
-          </a:prstGeom>
-          <a:noFill/>
-        </p:spPr>
-        <p:txBody>
-          <a:bodyPr wrap="square" lIns="128016" tIns="128016" rIns="128016" bIns="128016" anchor="t">
-            <a:spAutoFit/>
-          </a:bodyPr>
-          <a:lstStyle/>
-          <a:p>
-            <a:pPr algn="l">
-              <a:defRPr sz="1200" b="0">
-                <a:solidFill>
-                  <a:srgbClr val="1F2937"/>
-                </a:solidFill>
-                <a:latin typeface="Segoe UI"/>
-              </a:defRPr>
-            </a:pPr>
-            <a:r>
-              <a:t>15%</a:t>
-            </a:r>
-          </a:p>
-        </p:txBody>
-      </p:sp>
-      <p:sp>
-        <p:nvSpPr>
-          <p:cNvPr id="33" name="Rectangle 32"/>
-          <p:cNvSpPr/>
-          <p:nvPr/>
-        </p:nvSpPr>
-        <p:spPr>
-          <a:xfrm>
-            <a:off x="4590288" y="3602736"/>
-            <a:ext cx="1463040" cy="457200"/>
-          </a:xfrm>
-          <a:prstGeom prst="rect">
-            <a:avLst/>
-          </a:prstGeom>
-          <a:solidFill>
-            <a:srgbClr val="FFFDFC"/>
-          </a:solidFill>
-          <a:ln>
-            <a:solidFill>
-              <a:srgbClr val="E5DDD4"/>
-            </a:solidFill>
-          </a:ln>
-        </p:spPr>
-        <p:style>
-          <a:lnRef idx="1">
-            <a:schemeClr val="accent1"/>
-          </a:lnRef>
-          <a:fillRef idx="3">
-            <a:schemeClr val="accent1"/>
-          </a:fillRef>
-          <a:effectRef idx="2">
-            <a:schemeClr val="accent1"/>
-          </a:effectRef>
-          <a:fontRef idx="minor">
-            <a:schemeClr val="lt1"/>
-          </a:fontRef>
-        </p:style>
-        <p:txBody>
-          <a:bodyPr rtlCol="0" anchor="ctr"/>
-          <a:lstStyle/>
-          <a:p>
-            <a:pPr algn="ctr"/>
-            <a:endParaRPr/>
-          </a:p>
-        </p:txBody>
-      </p:sp>
-      <p:sp>
-        <p:nvSpPr>
-          <p:cNvPr id="34" name="TextBox 33"/>
-          <p:cNvSpPr txBox="1"/>
-          <p:nvPr/>
-        </p:nvSpPr>
-        <p:spPr>
-          <a:xfrm>
-            <a:off x="4663440" y="3675887"/>
-            <a:ext cx="1371600" cy="237744"/>
-          </a:xfrm>
-          <a:prstGeom prst="rect">
-            <a:avLst/>
-          </a:prstGeom>
-          <a:noFill/>
-        </p:spPr>
-        <p:txBody>
-          <a:bodyPr wrap="square" lIns="128016" tIns="128016" rIns="128016" bIns="128016" anchor="t">
-            <a:spAutoFit/>
-          </a:bodyPr>
-          <a:lstStyle/>
-          <a:p>
-            <a:pPr algn="l">
-              <a:defRPr sz="1200" b="0">
-                <a:solidFill>
-                  <a:srgbClr val="1F2937"/>
-                </a:solidFill>
-                <a:latin typeface="Segoe UI"/>
-              </a:defRPr>
-            </a:pPr>
-            <a:r>
-              <a:t>25%</a:t>
-            </a:r>
-          </a:p>
-        </p:txBody>
-      </p:sp>
-      <p:sp>
-        <p:nvSpPr>
-          <p:cNvPr id="35" name="Rectangle 34"/>
-          <p:cNvSpPr/>
-          <p:nvPr/>
-        </p:nvSpPr>
-        <p:spPr>
-          <a:xfrm>
-            <a:off x="841248" y="4059935"/>
-            <a:ext cx="2286000" cy="457200"/>
-          </a:xfrm>
-          <a:prstGeom prst="rect">
-            <a:avLst/>
-          </a:prstGeom>
-          <a:solidFill>
-            <a:srgbClr val="FFFDFC"/>
-          </a:solidFill>
-          <a:ln>
-            <a:solidFill>
-              <a:srgbClr val="E5DDD4"/>
-            </a:solidFill>
-          </a:ln>
-        </p:spPr>
-        <p:style>
-          <a:lnRef idx="1">
-            <a:schemeClr val="accent1"/>
-          </a:lnRef>
-          <a:fillRef idx="3">
-            <a:schemeClr val="accent1"/>
-          </a:fillRef>
-          <a:effectRef idx="2">
-            <a:schemeClr val="accent1"/>
-          </a:effectRef>
-          <a:fontRef idx="minor">
-            <a:schemeClr val="lt1"/>
-          </a:fontRef>
-        </p:style>
-        <p:txBody>
-          <a:bodyPr rtlCol="0" anchor="ctr"/>
-          <a:lstStyle/>
-          <a:p>
-            <a:pPr algn="ctr"/>
-            <a:endParaRPr/>
-          </a:p>
-        </p:txBody>
-      </p:sp>
-      <p:sp>
-        <p:nvSpPr>
-          <p:cNvPr id="36" name="TextBox 35"/>
-          <p:cNvSpPr txBox="1"/>
-          <p:nvPr/>
-        </p:nvSpPr>
-        <p:spPr>
-          <a:xfrm>
-            <a:off x="914400" y="4133087"/>
-            <a:ext cx="2194560" cy="237744"/>
-          </a:xfrm>
-          <a:prstGeom prst="rect">
-            <a:avLst/>
-          </a:prstGeom>
-          <a:noFill/>
-        </p:spPr>
-        <p:txBody>
-          <a:bodyPr wrap="square" lIns="128016" tIns="128016" rIns="128016" bIns="128016" anchor="t">
-            <a:spAutoFit/>
-          </a:bodyPr>
-          <a:lstStyle/>
-          <a:p>
-            <a:pPr algn="l">
-              <a:defRPr sz="1200" b="0">
-                <a:solidFill>
-                  <a:srgbClr val="1F2937"/>
-                </a:solidFill>
-                <a:latin typeface="Segoe UI"/>
-              </a:defRPr>
-            </a:pPr>
-            <a:r>
-              <a:t>MAU</a:t>
-            </a:r>
-          </a:p>
-        </p:txBody>
-      </p:sp>
-      <p:sp>
-        <p:nvSpPr>
-          <p:cNvPr id="37" name="Rectangle 36"/>
-          <p:cNvSpPr/>
-          <p:nvPr/>
-        </p:nvSpPr>
-        <p:spPr>
-          <a:xfrm>
-            <a:off x="3127248" y="4059935"/>
-            <a:ext cx="1463040" cy="457200"/>
-          </a:xfrm>
-          <a:prstGeom prst="rect">
-            <a:avLst/>
-          </a:prstGeom>
-          <a:solidFill>
-            <a:srgbClr val="FFFDFC"/>
-          </a:solidFill>
-          <a:ln>
-            <a:solidFill>
-              <a:srgbClr val="E5DDD4"/>
-            </a:solidFill>
-          </a:ln>
-        </p:spPr>
-        <p:style>
-          <a:lnRef idx="1">
-            <a:schemeClr val="accent1"/>
-          </a:lnRef>
-          <a:fillRef idx="3">
-            <a:schemeClr val="accent1"/>
-          </a:fillRef>
-          <a:effectRef idx="2">
-            <a:schemeClr val="accent1"/>
-          </a:effectRef>
-          <a:fontRef idx="minor">
-            <a:schemeClr val="lt1"/>
-          </a:fontRef>
-        </p:style>
-        <p:txBody>
-          <a:bodyPr rtlCol="0" anchor="ctr"/>
-          <a:lstStyle/>
-          <a:p>
-            <a:pPr algn="ctr"/>
-            <a:endParaRPr/>
-          </a:p>
-        </p:txBody>
-      </p:sp>
-      <p:sp>
-        <p:nvSpPr>
-          <p:cNvPr id="38" name="TextBox 37"/>
-          <p:cNvSpPr txBox="1"/>
-          <p:nvPr/>
-        </p:nvSpPr>
-        <p:spPr>
-          <a:xfrm>
-            <a:off x="3200400" y="4133087"/>
-            <a:ext cx="1371600" cy="237744"/>
-          </a:xfrm>
-          <a:prstGeom prst="rect">
-            <a:avLst/>
-          </a:prstGeom>
-          <a:noFill/>
-        </p:spPr>
-        <p:txBody>
-          <a:bodyPr wrap="square" lIns="128016" tIns="128016" rIns="128016" bIns="128016" anchor="t">
-            <a:spAutoFit/>
-          </a:bodyPr>
-          <a:lstStyle/>
-          <a:p>
-            <a:pPr algn="l">
-              <a:defRPr sz="1200" b="0">
-                <a:solidFill>
-                  <a:srgbClr val="1F2937"/>
-                </a:solidFill>
-                <a:latin typeface="Segoe UI"/>
-              </a:defRPr>
-            </a:pPr>
-            <a:r>
-              <a:t>105k</a:t>
-            </a:r>
-          </a:p>
-        </p:txBody>
-      </p:sp>
-      <p:sp>
-        <p:nvSpPr>
-          <p:cNvPr id="39" name="Rectangle 38"/>
-          <p:cNvSpPr/>
-          <p:nvPr/>
-        </p:nvSpPr>
-        <p:spPr>
-          <a:xfrm>
-            <a:off x="4590288" y="4059935"/>
-            <a:ext cx="1463040" cy="457200"/>
-          </a:xfrm>
-          <a:prstGeom prst="rect">
-            <a:avLst/>
-          </a:prstGeom>
-          <a:solidFill>
-            <a:srgbClr val="FFFDFC"/>
-          </a:solidFill>
-          <a:ln>
-            <a:solidFill>
-              <a:srgbClr val="E5DDD4"/>
-            </a:solidFill>
-          </a:ln>
-        </p:spPr>
-        <p:style>
-          <a:lnRef idx="1">
-            <a:schemeClr val="accent1"/>
-          </a:lnRef>
-          <a:fillRef idx="3">
-            <a:schemeClr val="accent1"/>
-          </a:fillRef>
-          <a:effectRef idx="2">
-            <a:schemeClr val="accent1"/>
-          </a:effectRef>
-          <a:fontRef idx="minor">
-            <a:schemeClr val="lt1"/>
-          </a:fontRef>
-        </p:style>
-        <p:txBody>
-          <a:bodyPr rtlCol="0" anchor="ctr"/>
-          <a:lstStyle/>
-          <a:p>
-            <a:pPr algn="ctr"/>
-            <a:endParaRPr/>
-          </a:p>
-        </p:txBody>
-      </p:sp>
-      <p:sp>
-        <p:nvSpPr>
-          <p:cNvPr id="40" name="TextBox 39"/>
-          <p:cNvSpPr txBox="1"/>
-          <p:nvPr/>
-        </p:nvSpPr>
-        <p:spPr>
-          <a:xfrm>
-            <a:off x="4663440" y="4133087"/>
-            <a:ext cx="1371600" cy="237744"/>
-          </a:xfrm>
-          <a:prstGeom prst="rect">
-            <a:avLst/>
-          </a:prstGeom>
-          <a:noFill/>
-        </p:spPr>
-        <p:txBody>
-          <a:bodyPr wrap="square" lIns="128016" tIns="128016" rIns="128016" bIns="128016" anchor="t">
-            <a:spAutoFit/>
-          </a:bodyPr>
-          <a:lstStyle/>
-          <a:p>
-            <a:pPr algn="l">
-              <a:defRPr sz="1200" b="0">
-                <a:solidFill>
-                  <a:srgbClr val="1F2937"/>
-                </a:solidFill>
-                <a:latin typeface="Segoe UI"/>
-              </a:defRPr>
-            </a:pPr>
-            <a:r>
-              <a:t>120k-130k</a:t>
-            </a:r>
-          </a:p>
-        </p:txBody>
-      </p:sp>
-      <p:sp>
-        <p:nvSpPr>
-          <p:cNvPr id="41" name="Rectangle 40"/>
-          <p:cNvSpPr/>
-          <p:nvPr/>
-        </p:nvSpPr>
-        <p:spPr>
-          <a:xfrm>
-            <a:off x="841248" y="4517136"/>
-            <a:ext cx="2286000" cy="457200"/>
-          </a:xfrm>
-          <a:prstGeom prst="rect">
-            <a:avLst/>
-          </a:prstGeom>
-          <a:solidFill>
-            <a:srgbClr val="FFFDFC"/>
-          </a:solidFill>
-          <a:ln>
-            <a:solidFill>
-              <a:srgbClr val="E5DDD4"/>
-            </a:solidFill>
-          </a:ln>
-        </p:spPr>
-        <p:style>
-          <a:lnRef idx="1">
-            <a:schemeClr val="accent1"/>
-          </a:lnRef>
-          <a:fillRef idx="3">
-            <a:schemeClr val="accent1"/>
-          </a:fillRef>
-          <a:effectRef idx="2">
-            <a:schemeClr val="accent1"/>
-          </a:effectRef>
-          <a:fontRef idx="minor">
-            <a:schemeClr val="lt1"/>
-          </a:fontRef>
-        </p:style>
-        <p:txBody>
-          <a:bodyPr rtlCol="0" anchor="ctr"/>
-          <a:lstStyle/>
-          <a:p>
-            <a:pPr algn="ctr"/>
-            <a:endParaRPr/>
-          </a:p>
-        </p:txBody>
-      </p:sp>
-      <p:sp>
-        <p:nvSpPr>
-          <p:cNvPr id="42" name="TextBox 41"/>
-          <p:cNvSpPr txBox="1"/>
-          <p:nvPr/>
-        </p:nvSpPr>
-        <p:spPr>
-          <a:xfrm>
-            <a:off x="914400" y="4590288"/>
-            <a:ext cx="2194560" cy="237744"/>
-          </a:xfrm>
-          <a:prstGeom prst="rect">
-            <a:avLst/>
-          </a:prstGeom>
-          <a:noFill/>
-        </p:spPr>
-        <p:txBody>
-          <a:bodyPr wrap="square" lIns="128016" tIns="128016" rIns="128016" bIns="128016" anchor="t">
-            <a:spAutoFit/>
-          </a:bodyPr>
-          <a:lstStyle/>
-          <a:p>
-            <a:pPr algn="l">
-              <a:defRPr sz="1200" b="0">
-                <a:solidFill>
-                  <a:srgbClr val="1F2937"/>
-                </a:solidFill>
-                <a:latin typeface="Segoe UI"/>
-              </a:defRPr>
-            </a:pPr>
-            <a:r>
-              <a:t>MRR</a:t>
-            </a:r>
-          </a:p>
-        </p:txBody>
-      </p:sp>
-      <p:sp>
-        <p:nvSpPr>
-          <p:cNvPr id="43" name="Rectangle 42"/>
-          <p:cNvSpPr/>
-          <p:nvPr/>
-        </p:nvSpPr>
-        <p:spPr>
-          <a:xfrm>
-            <a:off x="3127248" y="4517136"/>
-            <a:ext cx="1463040" cy="457200"/>
-          </a:xfrm>
-          <a:prstGeom prst="rect">
-            <a:avLst/>
-          </a:prstGeom>
-          <a:solidFill>
-            <a:srgbClr val="FFFDFC"/>
-          </a:solidFill>
-          <a:ln>
-            <a:solidFill>
-              <a:srgbClr val="E5DDD4"/>
-            </a:solidFill>
-          </a:ln>
-        </p:spPr>
-        <p:style>
-          <a:lnRef idx="1">
-            <a:schemeClr val="accent1"/>
-          </a:lnRef>
-          <a:fillRef idx="3">
-            <a:schemeClr val="accent1"/>
-          </a:fillRef>
-          <a:effectRef idx="2">
-            <a:schemeClr val="accent1"/>
-          </a:effectRef>
-          <a:fontRef idx="minor">
-            <a:schemeClr val="lt1"/>
-          </a:fontRef>
-        </p:style>
-        <p:txBody>
-          <a:bodyPr rtlCol="0" anchor="ctr"/>
-          <a:lstStyle/>
-          <a:p>
-            <a:pPr algn="ctr"/>
-            <a:endParaRPr/>
-          </a:p>
-        </p:txBody>
-      </p:sp>
-      <p:sp>
-        <p:nvSpPr>
-          <p:cNvPr id="44" name="TextBox 43"/>
-          <p:cNvSpPr txBox="1"/>
-          <p:nvPr/>
-        </p:nvSpPr>
-        <p:spPr>
-          <a:xfrm>
-            <a:off x="3200400" y="4590288"/>
-            <a:ext cx="1371600" cy="237744"/>
-          </a:xfrm>
-          <a:prstGeom prst="rect">
-            <a:avLst/>
-          </a:prstGeom>
-          <a:noFill/>
-        </p:spPr>
-        <p:txBody>
-          <a:bodyPr wrap="square" lIns="128016" tIns="128016" rIns="128016" bIns="128016" anchor="t">
-            <a:spAutoFit/>
-          </a:bodyPr>
-          <a:lstStyle/>
-          <a:p>
-            <a:pPr algn="l">
-              <a:defRPr sz="1200" b="0">
-                <a:solidFill>
-                  <a:srgbClr val="1F2937"/>
-                </a:solidFill>
-                <a:latin typeface="Segoe UI"/>
-              </a:defRPr>
-            </a:pPr>
-            <a:r>
-              <a:t>$60k</a:t>
-            </a:r>
-          </a:p>
-        </p:txBody>
-      </p:sp>
-      <p:sp>
-        <p:nvSpPr>
-          <p:cNvPr id="45" name="Rectangle 44"/>
-          <p:cNvSpPr/>
-          <p:nvPr/>
-        </p:nvSpPr>
-        <p:spPr>
-          <a:xfrm>
-            <a:off x="4590288" y="4517136"/>
-            <a:ext cx="1463040" cy="457200"/>
-          </a:xfrm>
-          <a:prstGeom prst="rect">
-            <a:avLst/>
-          </a:prstGeom>
-          <a:solidFill>
-            <a:srgbClr val="FFFDFC"/>
-          </a:solidFill>
-          <a:ln>
-            <a:solidFill>
-              <a:srgbClr val="E5DDD4"/>
-            </a:solidFill>
-          </a:ln>
-        </p:spPr>
-        <p:style>
-          <a:lnRef idx="1">
-            <a:schemeClr val="accent1"/>
-          </a:lnRef>
-          <a:fillRef idx="3">
-            <a:schemeClr val="accent1"/>
-          </a:fillRef>
-          <a:effectRef idx="2">
-            <a:schemeClr val="accent1"/>
-          </a:effectRef>
-          <a:fontRef idx="minor">
-            <a:schemeClr val="lt1"/>
-          </a:fontRef>
-        </p:style>
-        <p:txBody>
-          <a:bodyPr rtlCol="0" anchor="ctr"/>
-          <a:lstStyle/>
-          <a:p>
-            <a:pPr algn="ctr"/>
-            <a:endParaRPr/>
-          </a:p>
-        </p:txBody>
-      </p:sp>
-      <p:sp>
-        <p:nvSpPr>
-          <p:cNvPr id="46" name="TextBox 45"/>
-          <p:cNvSpPr txBox="1"/>
-          <p:nvPr/>
-        </p:nvSpPr>
-        <p:spPr>
-          <a:xfrm>
-            <a:off x="4663440" y="4590288"/>
-            <a:ext cx="1371600" cy="237744"/>
-          </a:xfrm>
-          <a:prstGeom prst="rect">
-            <a:avLst/>
-          </a:prstGeom>
-          <a:noFill/>
-        </p:spPr>
-        <p:txBody>
-          <a:bodyPr wrap="square" lIns="128016" tIns="128016" rIns="128016" bIns="128016" anchor="t">
-            <a:spAutoFit/>
-          </a:bodyPr>
-          <a:lstStyle/>
-          <a:p>
-            <a:pPr algn="l">
-              <a:defRPr sz="1200" b="0">
-                <a:solidFill>
-                  <a:srgbClr val="1F2937"/>
-                </a:solidFill>
-                <a:latin typeface="Segoe UI"/>
-              </a:defRPr>
-            </a:pPr>
-            <a:r>
-              <a:t>$78k-$85k</a:t>
-            </a:r>
           </a:p>
         </p:txBody>
       </p:sp>
@@ -9514,7 +7755,7 @@
               </a:defRPr>
             </a:pPr>
             <a:r>
-              <a:t>Why these targets matter</a:t>
+              <a:t>Why these gates matter</a:t>
             </a:r>
           </a:p>
         </p:txBody>
@@ -9550,7 +7791,7 @@
               </a:defRPr>
             </a:pPr>
             <a:r>
-              <a:t>They focus on proving product value first, then monetization and efficient growth. MAU alone is not enough.</a:t>
+              <a:t>They force the team to prove product value before buying more top-of-funnel volume.</a:t>
             </a:r>
           </a:p>
         </p:txBody>
@@ -9676,7 +7917,7 @@
               </a:defRPr>
             </a:pPr>
             <a:r>
-              <a:t>Financial logic</a:t>
+              <a:t>Minimum economic rule</a:t>
             </a:r>
           </a:p>
         </p:txBody>
@@ -9712,8 +7953,7 @@
               </a:defRPr>
             </a:pPr>
             <a:r>
-              <a:rPr dirty="0"/>
-              <a:t>If churn normalizes and organic share recovers, TaskFlow can grow MRR without going back to heavy, low-quality paid social.</a:t>
+              <a:t>Paid LTV / CAC should move above about 1.3x before spend increases materially; healthy state is 1.5x or better.</a:t>
             </a:r>
           </a:p>
         </p:txBody>
@@ -9839,7 +8079,7 @@
               </a:defRPr>
             </a:pPr>
             <a:r>
-              <a:t>Operating rule</a:t>
+              <a:t>Scale rule</a:t>
             </a:r>
           </a:p>
         </p:txBody>
@@ -9875,7 +8115,7 @@
               </a:defRPr>
             </a:pPr>
             <a:r>
-              <a:t>Do not scale any channel unless it shows positive payback under the new retention baseline.</a:t>
+              <a:t>All operating gates should clear for 2 consecutive months before paid budgets go back up.</a:t>
             </a:r>
           </a:p>
         </p:txBody>
@@ -9911,7 +8151,7 @@
               </a:defRPr>
             </a:pPr>
             <a:r>
-              <a:t>Sources: Own KPI targets built from current baseline and recommended roadmap.</a:t>
+              <a:t>Sources: Own thresholds built from current baselines and simplified unit economics.</a:t>
             </a:r>
           </a:p>
         </p:txBody>
@@ -9952,50 +8192,30 @@
           </a:p>
         </p:txBody>
       </p:sp>
-      <p:sp>
-        <p:nvSpPr>
-          <p:cNvPr id="61" name="TextBox 60">
-            <a:extLst>
-              <a:ext uri="{FF2B5EF4-FFF2-40B4-BE49-F238E27FC236}">
-                <a16:creationId xmlns:a16="http://schemas.microsoft.com/office/drawing/2014/main" id="{FE81F99F-F0EF-413C-B314-83028A4BFC9E}"/>
-              </a:ext>
-            </a:extLst>
-          </p:cNvPr>
-          <p:cNvSpPr txBox="1"/>
-          <p:nvPr/>
-        </p:nvSpPr>
-        <p:spPr>
-          <a:xfrm>
-            <a:off x="3108960" y="1839538"/>
-            <a:ext cx="1517904" cy="420115"/>
-          </a:xfrm>
-          <a:prstGeom prst="rect">
-            <a:avLst/>
-          </a:prstGeom>
-          <a:noFill/>
-        </p:spPr>
-        <p:txBody>
-          <a:bodyPr wrap="square" lIns="128016" tIns="128016" rIns="128016" bIns="128016" anchor="t">
-            <a:spAutoFit/>
-          </a:bodyPr>
-          <a:lstStyle/>
-          <a:p>
-            <a:pPr algn="l">
-              <a:defRPr sz="1050" b="1">
-                <a:solidFill>
-                  <a:srgbClr val="FFFDFC"/>
-                </a:solidFill>
-                <a:latin typeface="Segoe UI"/>
-              </a:defRPr>
-            </a:pPr>
-            <a:r>
-              <a:rPr lang="en-US" dirty="0"/>
-              <a:t>Baseline (Dec 2025)</a:t>
-            </a:r>
-            <a:endParaRPr dirty="0"/>
-          </a:p>
-        </p:txBody>
-      </p:sp>
+      <p:pic>
+        <p:nvPicPr>
+          <p:cNvPr id="61" name="Picture 60" descr="threshold_gates.png"/>
+          <p:cNvPicPr>
+            <a:picLocks noChangeAspect="1"/>
+          </p:cNvPicPr>
+          <p:nvPr/>
+        </p:nvPicPr>
+        <p:blipFill>
+          <a:blip r:embed="rId3"/>
+          <a:stretch>
+            <a:fillRect/>
+          </a:stretch>
+        </p:blipFill>
+        <p:spPr>
+          <a:xfrm>
+            <a:off x="685800" y="1627632"/>
+            <a:ext cx="5897880" cy="2881829"/>
+          </a:xfrm>
+          <a:prstGeom prst="rect">
+            <a:avLst/>
+          </a:prstGeom>
+        </p:spPr>
+      </p:pic>
     </p:spTree>
   </p:cSld>
   <p:clrMapOvr>
@@ -10060,7 +8280,7 @@
               </a:defRPr>
             </a:pPr>
             <a:r>
-              <a:t>Key risks and mitigations</a:t>
+              <a:t>If the plan works, the business should feel different</a:t>
             </a:r>
           </a:p>
         </p:txBody>
@@ -10230,7 +8450,7 @@
               </a:defRPr>
             </a:pPr>
             <a:r>
-              <a:t>Execution bandwidth</a:t>
+              <a:t>User value</a:t>
             </a:r>
           </a:p>
         </p:txBody>
@@ -10266,20 +8486,7 @@
               </a:defRPr>
             </a:pPr>
             <a:r>
-              <a:t>Risk: A 12-person team cannot run five major bets at once.</a:t>
-            </a:r>
-          </a:p>
-          <a:p>
-            <a:pPr>
-              <a:defRPr sz="1050">
-                <a:solidFill>
-                  <a:srgbClr val="1F2937"/>
-                </a:solidFill>
-                <a:latin typeface="Segoe UI"/>
-              </a:defRPr>
-            </a:pPr>
-            <a:r>
-              <a:t>Mitigation: Freeze non-core work and focus on 3 product bets max: offline, collaboration, onboarding.</a:t>
+              <a:t>D30 is back above 8%, ratings recover, and complaints about missing basics start fading.</a:t>
             </a:r>
           </a:p>
         </p:txBody>
@@ -10405,7 +8612,7 @@
               </a:defRPr>
             </a:pPr>
             <a:r>
-              <a:t>Competitive response</a:t>
+              <a:t>Growth quality</a:t>
             </a:r>
           </a:p>
         </p:txBody>
@@ -10441,20 +8648,7 @@
               </a:defRPr>
             </a:pPr>
             <a:r>
-              <a:t>Risk: Leaders can copy surface features quickly.</a:t>
-            </a:r>
-          </a:p>
-          <a:p>
-            <a:pPr>
-              <a:defRPr sz="1050">
-                <a:solidFill>
-                  <a:srgbClr val="1F2937"/>
-                </a:solidFill>
-                <a:latin typeface="Segoe UI"/>
-              </a:defRPr>
-            </a:pPr>
-            <a:r>
-              <a:t>Mitigation: Compete on a sharper use case and workflow simplicity, not feature count.</a:t>
+              <a:t>Organic share rises, paid dependence falls, and channel decisions get cleaner.</a:t>
             </a:r>
           </a:p>
         </p:txBody>
@@ -10580,7 +8774,7 @@
               </a:defRPr>
             </a:pPr>
             <a:r>
-              <a:t>AI cost / hype risk</a:t>
+              <a:t>Revenue quality</a:t>
             </a:r>
           </a:p>
         </p:txBody>
@@ -10616,20 +8810,7 @@
               </a:defRPr>
             </a:pPr>
             <a:r>
-              <a:t>Risk: AI can burn time and cash without improving retention.</a:t>
-            </a:r>
-          </a:p>
-          <a:p>
-            <a:pPr>
-              <a:defRPr sz="1050">
-                <a:solidFill>
-                  <a:srgbClr val="1F2937"/>
-                </a:solidFill>
-                <a:latin typeface="Segoe UI"/>
-              </a:defRPr>
-            </a:pPr>
-            <a:r>
-              <a:t>Mitigation: Add lightweight AI only after core workflow fixes land; use opt-in features first.</a:t>
+              <a:t>Lower churn and better trial conversion lift MRR without forcing a risky price cut.</a:t>
             </a:r>
           </a:p>
         </p:txBody>
@@ -10755,7 +8936,7 @@
               </a:defRPr>
             </a:pPr>
             <a:r>
-              <a:t>Runway pressure</a:t>
+              <a:t>Team cadence</a:t>
             </a:r>
           </a:p>
         </p:txBody>
@@ -10791,20 +8972,7 @@
               </a:defRPr>
             </a:pPr>
             <a:r>
-              <a:t>Risk: Burn is high relative to MRR.</a:t>
-            </a:r>
-          </a:p>
-          <a:p>
-            <a:pPr>
-              <a:defRPr sz="1050">
-                <a:solidFill>
-                  <a:srgbClr val="1F2937"/>
-                </a:solidFill>
-                <a:latin typeface="Segoe UI"/>
-              </a:defRPr>
-            </a:pPr>
-            <a:r>
-              <a:t>Mitigation: Cut inefficient paid UA immediately and gate later spend behind retention milestones.</a:t>
+              <a:t>Product, growth and support work from the same weekly scorecard instead of chasing disconnected fixes.</a:t>
             </a:r>
           </a:p>
         </p:txBody>
@@ -10930,7 +9098,7 @@
               </a:defRPr>
             </a:pPr>
             <a:r>
-              <a:t>Geo distraction</a:t>
+              <a:t>Strategic option value</a:t>
             </a:r>
           </a:p>
         </p:txBody>
@@ -10966,20 +9134,7 @@
               </a:defRPr>
             </a:pPr>
             <a:r>
-              <a:t>Risk: Cheap installs in low-value markets can create false confidence.</a:t>
-            </a:r>
-          </a:p>
-          <a:p>
-            <a:pPr>
-              <a:defRPr sz="1050">
-                <a:solidFill>
-                  <a:srgbClr val="1F2937"/>
-                </a:solidFill>
-                <a:latin typeface="Segoe UI"/>
-              </a:defRPr>
-            </a:pPr>
-            <a:r>
-              <a:t>Mitigation: Prioritize high-ARPU English markets until the model stabilizes.</a:t>
+              <a:t>Management can either keep compounding the recovery or pivot later from a position of strength, not panic.</a:t>
             </a:r>
           </a:p>
         </p:txBody>
@@ -11120,7 +9275,7 @@
               </a:defRPr>
             </a:pPr>
             <a:r>
-              <a:t>Selected sources and submission note</a:t>
+              <a:t>Selected sources</a:t>
             </a:r>
           </a:p>
         </p:txBody>
@@ -11273,107 +9428,43 @@
           </a:bodyPr>
           <a:lstStyle/>
           <a:p>
-            <a:pPr>
-              <a:defRPr sz="1050">
-                <a:solidFill>
-                  <a:srgbClr val="1F2937"/>
-                </a:solidFill>
-                <a:latin typeface="Segoe UI"/>
-              </a:defRPr>
-            </a:pPr>
-            <a:r>
-              <a:t>1. Mordor Intelligence - Task Management Software Market</a:t>
-            </a:r>
-          </a:p>
-          <a:p>
-            <a:pPr>
-              <a:defRPr sz="1050">
-                <a:solidFill>
-                  <a:srgbClr val="1F2937"/>
-                </a:solidFill>
-                <a:latin typeface="Segoe UI"/>
-              </a:defRPr>
-            </a:pPr>
+            <a:r>
+              <a:t>1. Mordor Intelligence - task management market</a:t>
+            </a:r>
+          </a:p>
+          <a:p>
             <a:r>
               <a:t>2. TechCrunch on Sensor Tower State of Mobile 2026</a:t>
             </a:r>
           </a:p>
           <a:p>
-            <a:pPr>
-              <a:defRPr sz="1050">
-                <a:solidFill>
-                  <a:srgbClr val="1F2937"/>
-                </a:solidFill>
-                <a:latin typeface="Segoe UI"/>
-              </a:defRPr>
-            </a:pPr>
-            <a:r>
-              <a:t>3. Gartner - mobile app usage to decrease 25% by 2027</a:t>
-            </a:r>
-          </a:p>
-          <a:p>
-            <a:pPr>
-              <a:defRPr sz="1050">
-                <a:solidFill>
-                  <a:srgbClr val="1F2937"/>
-                </a:solidFill>
-                <a:latin typeface="Segoe UI"/>
-              </a:defRPr>
-            </a:pPr>
-            <a:r>
-              <a:t>4. Gartner - 40% of enterprise apps to feature AI agents by 2026</a:t>
-            </a:r>
-          </a:p>
-          <a:p>
-            <a:pPr>
-              <a:defRPr sz="1050">
-                <a:solidFill>
-                  <a:srgbClr val="1F2937"/>
-                </a:solidFill>
-                <a:latin typeface="Segoe UI"/>
-              </a:defRPr>
-            </a:pPr>
-            <a:r>
-              <a:t>5. Todoist pricing update + Google Play</a:t>
-            </a:r>
-          </a:p>
-          <a:p>
-            <a:pPr>
-              <a:defRPr sz="1050">
-                <a:solidFill>
-                  <a:srgbClr val="1F2937"/>
-                </a:solidFill>
-                <a:latin typeface="Segoe UI"/>
-              </a:defRPr>
-            </a:pPr>
-            <a:r>
-              <a:t>6. TickTick upgrade + Google Play</a:t>
-            </a:r>
-          </a:p>
-          <a:p>
-            <a:pPr>
-              <a:defRPr sz="1050">
-                <a:solidFill>
-                  <a:srgbClr val="1F2937"/>
-                </a:solidFill>
-                <a:latin typeface="Segoe UI"/>
-              </a:defRPr>
-            </a:pPr>
-            <a:r>
-              <a:t>7. Any.do pricing/help/blog + Google Play</a:t>
-            </a:r>
-          </a:p>
-          <a:p>
-            <a:pPr>
-              <a:defRPr sz="1050">
-                <a:solidFill>
-                  <a:srgbClr val="1F2937"/>
-                </a:solidFill>
-                <a:latin typeface="Segoe UI"/>
-              </a:defRPr>
-            </a:pPr>
-            <a:r>
-              <a:t>8. Microsoft To Do official page + Google Play</a:t>
+            <a:r>
+              <a:t>3. Todoist template gallery</a:t>
+            </a:r>
+          </a:p>
+          <a:p>
+            <a:r>
+              <a:t>4. Todoist pricing update 2025</a:t>
+            </a:r>
+          </a:p>
+          <a:p>
+            <a:r>
+              <a:t>5. TickTick upgrade page</a:t>
+            </a:r>
+          </a:p>
+          <a:p>
+            <a:r>
+              <a:t>6. TickTick ambassador program</a:t>
+            </a:r>
+          </a:p>
+          <a:p>
+            <a:r>
+              <a:t>7. Any.do pricing and Spaces</a:t>
+            </a:r>
+          </a:p>
+          <a:p>
+            <a:r>
+              <a:t>8. Microsoft To Do with Outlook Tasks</a:t>
             </a:r>
           </a:p>
         </p:txBody>
@@ -11482,188 +9573,44 @@
           </a:bodyPr>
           <a:lstStyle/>
           <a:p>
-            <a:pPr marL="171450" indent="-171450">
-              <a:buFont typeface="Arial" panose="020B0604020202020204" pitchFamily="34" charset="0"/>
-              <a:buChar char="•"/>
-              <a:defRPr sz="1050">
-                <a:solidFill>
-                  <a:srgbClr val="1F2937"/>
-                </a:solidFill>
-                <a:latin typeface="Segoe UI"/>
-              </a:defRPr>
-            </a:pPr>
-            <a:r>
-              <a:rPr dirty="0">
-                <a:hlinkClick r:id="rId3"/>
-              </a:rPr>
+            <a:r>
               <a:t>https://www.mordorintelligence.com/industry-reports/task-management-software-market</a:t>
             </a:r>
-            <a:r>
-              <a:rPr lang="en-US" dirty="0"/>
-              <a:t> </a:t>
-            </a:r>
-            <a:endParaRPr dirty="0"/>
-          </a:p>
-          <a:p>
-            <a:pPr marL="171450" indent="-171450">
-              <a:buFont typeface="Arial" panose="020B0604020202020204" pitchFamily="34" charset="0"/>
-              <a:buChar char="•"/>
-              <a:defRPr sz="1050">
-                <a:solidFill>
-                  <a:srgbClr val="1F2937"/>
-                </a:solidFill>
-                <a:latin typeface="Segoe UI"/>
-              </a:defRPr>
-            </a:pPr>
-            <a:r>
-              <a:rPr dirty="0">
-                <a:hlinkClick r:id="rId4"/>
-              </a:rPr>
+          </a:p>
+          <a:p>
+            <a:r>
               <a:t>https://techcrunch.com/2026/01/21/consumers-spent-more-on-mobile-apps-than-games-in-2025-driven-by-ai-app-adoption/</a:t>
             </a:r>
-            <a:r>
-              <a:rPr lang="en-US" dirty="0"/>
-              <a:t> </a:t>
-            </a:r>
-            <a:endParaRPr dirty="0"/>
-          </a:p>
-          <a:p>
-            <a:pPr marL="171450" indent="-171450">
-              <a:buFont typeface="Arial" panose="020B0604020202020204" pitchFamily="34" charset="0"/>
-              <a:buChar char="•"/>
-              <a:defRPr sz="1050">
-                <a:solidFill>
-                  <a:srgbClr val="1F2937"/>
-                </a:solidFill>
-                <a:latin typeface="Segoe UI"/>
-              </a:defRPr>
-            </a:pPr>
-            <a:r>
-              <a:rPr dirty="0">
-                <a:hlinkClick r:id="rId5"/>
-              </a:rPr>
-              <a:t>https://www.gartner.com/en/newsroom/press-releases/2025-01-15-gartner-predicts-mobile-app-usage-will-decrease-25-percent-due-to-ai-assistants-by-2027</a:t>
-            </a:r>
-            <a:r>
-              <a:rPr lang="en-US" dirty="0"/>
-              <a:t> </a:t>
-            </a:r>
-            <a:endParaRPr dirty="0"/>
-          </a:p>
-          <a:p>
-            <a:pPr marL="171450" indent="-171450">
-              <a:buFont typeface="Arial" panose="020B0604020202020204" pitchFamily="34" charset="0"/>
-              <a:buChar char="•"/>
-              <a:defRPr sz="1050">
-                <a:solidFill>
-                  <a:srgbClr val="1F2937"/>
-                </a:solidFill>
-                <a:latin typeface="Segoe UI"/>
-              </a:defRPr>
-            </a:pPr>
-            <a:r>
-              <a:rPr dirty="0">
-                <a:hlinkClick r:id="rId6"/>
-              </a:rPr>
-              <a:t>https://www.gartner.com/en/newsroom/press-releases/2025-08-26-gartner-predicts-40-percent-of-enterprise-apps-will-feature-task-specific-ai-agents-by-2026-up-from-less-than-5-percent-in-2025</a:t>
-            </a:r>
-            <a:r>
-              <a:rPr lang="en-US" dirty="0"/>
-              <a:t> </a:t>
-            </a:r>
-            <a:endParaRPr dirty="0"/>
-          </a:p>
-          <a:p>
-            <a:pPr marL="171450" indent="-171450">
-              <a:buFont typeface="Arial" panose="020B0604020202020204" pitchFamily="34" charset="0"/>
-              <a:buChar char="•"/>
-              <a:defRPr sz="1050">
-                <a:solidFill>
-                  <a:srgbClr val="1F2937"/>
-                </a:solidFill>
-                <a:latin typeface="Segoe UI"/>
-              </a:defRPr>
-            </a:pPr>
-            <a:r>
-              <a:rPr dirty="0">
-                <a:hlinkClick r:id="rId7"/>
-              </a:rPr>
-              <a:t>https://www.todoist.com/pricing</a:t>
-            </a:r>
-            <a:r>
-              <a:rPr lang="en-US" dirty="0"/>
-              <a:t> </a:t>
-            </a:r>
-            <a:endParaRPr dirty="0"/>
-          </a:p>
-          <a:p>
-            <a:pPr marL="171450" indent="-171450">
-              <a:buFont typeface="Arial" panose="020B0604020202020204" pitchFamily="34" charset="0"/>
-              <a:buChar char="•"/>
-              <a:defRPr sz="1050">
-                <a:solidFill>
-                  <a:srgbClr val="1F2937"/>
-                </a:solidFill>
-                <a:latin typeface="Segoe UI"/>
-              </a:defRPr>
-            </a:pPr>
-            <a:r>
-              <a:rPr dirty="0">
-                <a:hlinkClick r:id="rId8"/>
-              </a:rPr>
-              <a:t>https://www.todoist.com/help/articles/todoist-pro-plan-pricing-update-bxBvHZuJZ</a:t>
-            </a:r>
-            <a:r>
-              <a:rPr lang="en-US" dirty="0"/>
-              <a:t> </a:t>
-            </a:r>
-            <a:endParaRPr dirty="0"/>
-          </a:p>
-          <a:p>
-            <a:pPr marL="171450" indent="-171450">
-              <a:buFont typeface="Arial" panose="020B0604020202020204" pitchFamily="34" charset="0"/>
-              <a:buChar char="•"/>
-              <a:defRPr sz="1050">
-                <a:solidFill>
-                  <a:srgbClr val="1F2937"/>
-                </a:solidFill>
-                <a:latin typeface="Segoe UI"/>
-              </a:defRPr>
-            </a:pPr>
-            <a:r>
-              <a:rPr dirty="0">
-                <a:hlinkClick r:id="rId9"/>
-              </a:rPr>
-              <a:t>https://play.google.com/store/apps/details?id=com.todoist&amp;hl=en&amp;gl=US</a:t>
-            </a:r>
-            <a:r>
-              <a:rPr lang="en-US" dirty="0"/>
-              <a:t> </a:t>
-            </a:r>
-            <a:endParaRPr dirty="0"/>
-          </a:p>
-          <a:p>
-            <a:pPr marL="171450" indent="-171450">
-              <a:buFont typeface="Arial" panose="020B0604020202020204" pitchFamily="34" charset="0"/>
-              <a:buChar char="•"/>
-              <a:defRPr sz="1050">
-                <a:solidFill>
-                  <a:srgbClr val="1F2937"/>
-                </a:solidFill>
-                <a:latin typeface="Segoe UI"/>
-              </a:defRPr>
-            </a:pPr>
-            <a:r>
-              <a:rPr dirty="0">
-                <a:hlinkClick r:id="rId10"/>
-              </a:rPr>
+          </a:p>
+          <a:p>
+            <a:r>
+              <a:t>https://www.todoist.com/templates/getting-things-done</a:t>
+            </a:r>
+          </a:p>
+          <a:p>
+            <a:r>
+              <a:t>https://www.todoist.com/help/articles/todoist-pricing-and-plans-update-2025-everything-you-need-to-know-Tn6Pg1JKI</a:t>
+            </a:r>
+          </a:p>
+          <a:p>
+            <a:r>
               <a:t>https://ticktick.com/upgrade</a:t>
             </a:r>
-            <a:r>
-              <a:rPr lang="en-US" dirty="0"/>
-              <a:t> </a:t>
-            </a:r>
-            <a:endParaRPr dirty="0"/>
+          </a:p>
+          <a:p>
+            <a:r>
+              <a:t>https://ticktick.com/ambassador_program</a:t>
+            </a:r>
+          </a:p>
+          <a:p>
+            <a:r>
+              <a:t>https://www.any.do/pricing</a:t>
+            </a:r>
+          </a:p>
+          <a:p>
+            <a:r>
+              <a:t>https://support.microsoft.com/en-us/office/using-microsoft-to-do-with-outlook-tasks-c7a0253d-b8cc-4054-b94b-c194e0e5308a</a:t>
+            </a:r>
           </a:p>
         </p:txBody>
       </p:sp>
@@ -11779,17 +9726,16 @@
           </a:bodyPr>
           <a:lstStyle/>
           <a:p>
-            <a:r>
-              <a:rPr lang="en-US" b="1" dirty="0"/>
-              <a:t>How to act</a:t>
+            <a:pPr>
+              <a:defRPr>
+                <a:solidFill/>
+                <a:latin typeface="Segoe UI"/>
+              </a:defRPr>
+            </a:pPr>
+            <a:r>
+              <a:t>Closing thought</a:t>
             </a:r>
             <a:endParaRPr lang="en-US" dirty="0"/>
-          </a:p>
-          <a:p>
-            <a:br>
-              <a:rPr lang="en-US" dirty="0"/>
-            </a:br>
-            <a:endParaRPr dirty="0"/>
           </a:p>
         </p:txBody>
       </p:sp>
@@ -11824,45 +9770,8 @@
               </a:defRPr>
             </a:pPr>
             <a:r>
-              <a:rPr lang="en-US" dirty="0"/>
-              <a:t>TaskFlow should stay in the productivity category, avoid a risky full pivot for now, and focus on restoring product value, </a:t>
-            </a:r>
-          </a:p>
-          <a:p>
-            <a:pPr>
-              <a:defRPr sz="1050">
-                <a:solidFill>
-                  <a:srgbClr val="1F2937"/>
-                </a:solidFill>
-                <a:latin typeface="Segoe UI"/>
-              </a:defRPr>
-            </a:pPr>
-            <a:r>
-              <a:rPr lang="en-US" dirty="0"/>
-              <a:t>sharper positioning, and more efficient growth.</a:t>
-            </a:r>
-          </a:p>
-          <a:p>
-            <a:pPr>
-              <a:defRPr sz="1050">
-                <a:solidFill>
-                  <a:srgbClr val="1F2937"/>
-                </a:solidFill>
-                <a:latin typeface="Segoe UI"/>
-              </a:defRPr>
-            </a:pPr>
-            <a:endParaRPr lang="en-US" dirty="0"/>
-          </a:p>
-          <a:p>
-            <a:pPr>
-              <a:defRPr sz="1050">
-                <a:solidFill>
-                  <a:srgbClr val="1F2937"/>
-                </a:solidFill>
-                <a:latin typeface="Segoe UI"/>
-              </a:defRPr>
-            </a:pPr>
-            <a:endParaRPr dirty="0"/>
+              <a:t>This version is intentionally more operator-style: what to fix, where growth can come from, and what thresholds need to move before scaling again.</a:t>
+            </a:r>
           </a:p>
         </p:txBody>
       </p:sp>
@@ -11888,57 +9797,9 @@
           </a:bodyPr>
           <a:lstStyle/>
           <a:p>
-            <a:pPr>
-              <a:defRPr sz="800">
-                <a:solidFill>
-                  <a:srgbClr val="6B7280"/>
-                </a:solidFill>
-                <a:latin typeface="Segoe UI"/>
-              </a:defRPr>
-            </a:pPr>
-            <a:r>
-              <a:rPr dirty="0"/>
-              <a:t>Sources: Full source log</a:t>
-            </a:r>
-            <a:r>
-              <a:rPr lang="en-US" dirty="0"/>
-              <a:t> will </a:t>
-            </a:r>
-            <a:r>
-              <a:rPr dirty="0"/>
-              <a:t>also</a:t>
-            </a:r>
-            <a:r>
-              <a:rPr lang="en-US" dirty="0"/>
-              <a:t> be</a:t>
-            </a:r>
-            <a:r>
-              <a:rPr dirty="0"/>
-              <a:t> included</a:t>
-            </a:r>
-            <a:r>
-              <a:rPr lang="en-US" dirty="0"/>
-              <a:t> later</a:t>
-            </a:r>
-            <a:r>
-              <a:rPr dirty="0"/>
-              <a:t> in the workbook and sources.md</a:t>
-            </a:r>
-            <a:r>
-              <a:rPr lang="en-US" dirty="0"/>
-              <a:t>: </a:t>
-            </a:r>
-            <a:r>
-              <a:rPr lang="en-US" dirty="0">
-                <a:hlinkClick r:id="rId11"/>
-              </a:rPr>
-              <a:t>https://github.com/TEZv/Genesis-Academy_Strategy-Operations-School-2.0-Case-Task/tree/main</a:t>
-            </a:r>
-            <a:r>
-              <a:rPr lang="en-US" dirty="0"/>
-              <a:t> </a:t>
-            </a:r>
-            <a:endParaRPr dirty="0"/>
+            <a:r>
+              <a:t>Sources: Official market and competitor pages used in the revised deck.</a:t>
+            </a:r>
           </a:p>
         </p:txBody>
       </p:sp>
@@ -12042,7 +9903,7 @@
               </a:defRPr>
             </a:pPr>
             <a:r>
-              <a:t>Executive summary</a:t>
+              <a:t>My read: this is a value leakage problem</a:t>
             </a:r>
           </a:p>
         </p:txBody>
@@ -12122,8 +9983,7 @@
               </a:defRPr>
             </a:pPr>
             <a:r>
-              <a:rPr dirty="0"/>
-              <a:t>The market is still growing. TaskFlow is losing relevance inside that market.</a:t>
+              <a:t>The category is alive. TaskFlow stopped earning repeat usage.</a:t>
             </a:r>
           </a:p>
         </p:txBody>
@@ -12285,7 +10145,7 @@
               </a:defRPr>
             </a:pPr>
             <a:r>
-              <a:t>The strongest signal is retention erosion: D30 fell from 12.0% to 5.0%, D90 from 6.5% to 2.3%, and paid churn rose to 18%. Acquisition can no longer cover weak product value.</a:t>
+              <a:t>Retention is the clearest signal: D30 fell from 12% to 5%, D90 from 6.5% to 2.3%, and paid churn rose to 18%.</a:t>
             </a:r>
           </a:p>
         </p:txBody>
@@ -12411,7 +10271,7 @@
               </a:defRPr>
             </a:pPr>
             <a:r>
-              <a:t>What caused it</a:t>
+              <a:t>Why it broke</a:t>
             </a:r>
           </a:p>
         </p:txBody>
@@ -12447,7 +10307,7 @@
               </a:defRPr>
             </a:pPr>
             <a:r>
-              <a:t>No major feature release in 8 months, declining store rating, weak collaboration, no offline mode, repetitive UI, and limited web parity while competitors kept shipping.</a:t>
+              <a:t>The product feels stale: no major release in 8 months, worse ratings, weak collaboration, no offline mode, repetitive UI.</a:t>
             </a:r>
           </a:p>
         </p:txBody>
@@ -12573,7 +10433,7 @@
               </a:defRPr>
             </a:pPr>
             <a:r>
-              <a:t>Why urgency matters</a:t>
+              <a:t>Why this matters</a:t>
             </a:r>
           </a:p>
         </p:txBody>
@@ -12609,7 +10469,7 @@
               </a:defRPr>
             </a:pPr>
             <a:r>
-              <a:t>Downloads and MAU fell 42% in 2025, CPI rose 44%, and burn is ~$150k per month vs $60k MRR.</a:t>
+              <a:t>Downloads and MAU fell 42%, CPI rose 44%, and burn is still about $150k a month against $60k MRR.</a:t>
             </a:r>
           </a:p>
         </p:txBody>
@@ -12735,7 +10595,7 @@
               </a:defRPr>
             </a:pPr>
             <a:r>
-              <a:t>Recommendation</a:t>
+              <a:t>What management should do</a:t>
             </a:r>
           </a:p>
         </p:txBody>
@@ -12771,8 +10631,7 @@
               </a:defRPr>
             </a:pPr>
             <a:r>
-              <a:rPr dirty="0"/>
-              <a:t>Reposition TaskFlow as a calendar-first planner for young professionals, freelancers and duos. Fix core workflow first, add lightweight AI second, and reduce inefficient paid UA until retention improves.</a:t>
+              <a:t>Do not fund a full pivot yet. Narrow the promise, fix first-session value, and scale only after the core numbers move.</a:t>
             </a:r>
           </a:p>
         </p:txBody>
@@ -12808,7 +10667,7 @@
               </a:defRPr>
             </a:pPr>
             <a:r>
-              <a:t>12-month objective: stabilize MAU by month 6, recover organic share, and bring MRR back to $78k-$85k without a full-scale pivot.</a:t>
+              <a:t>12-month objective: clear the retention gates, recover organic share, and reopen growth options.</a:t>
             </a:r>
           </a:p>
         </p:txBody>
@@ -12949,7 +10808,7 @@
               </a:defRPr>
             </a:pPr>
             <a:r>
-              <a:t>2025 performance collapsed across every core metric</a:t>
+              <a:t>The whole model bent in the same direction</a:t>
             </a:r>
           </a:p>
         </p:txBody>
@@ -13858,7 +11717,7 @@
               </a:defRPr>
             </a:pPr>
             <a:r>
-              <a:t>Diagnosis: this is primarily a product + positioning problem</a:t>
+              <a:t>The leak starts after install</a:t>
             </a:r>
           </a:p>
         </p:txBody>
@@ -14064,33 +11923,7 @@
               </a:defRPr>
             </a:pPr>
             <a:r>
-              <a:t>Every cohort got weaker.</a:t>
-            </a:r>
-          </a:p>
-          <a:p>
-            <a:pPr>
-              <a:defRPr sz="1050">
-                <a:solidFill>
-                  <a:srgbClr val="1F2937"/>
-                </a:solidFill>
-                <a:latin typeface="Segoe UI"/>
-              </a:defRPr>
-            </a:pPr>
-            <a:r>
-              <a:t>D30 fell 58% and D90 fell 65% vs Q1 2024.</a:t>
-            </a:r>
-          </a:p>
-          <a:p>
-            <a:pPr>
-              <a:defRPr sz="1050">
-                <a:solidFill>
-                  <a:srgbClr val="1F2937"/>
-                </a:solidFill>
-                <a:latin typeface="Segoe UI"/>
-              </a:defRPr>
-            </a:pPr>
-            <a:r>
-              <a:t>That points to lower repeat value, not just weaker top-of-funnel.</a:t>
+              <a:t>Every cohort got weaker. D30 fell 58% and D90 fell 65% vs Q1 2024. That is what a value leak looks like.</a:t>
             </a:r>
           </a:p>
         </p:txBody>
@@ -14216,7 +12049,7 @@
               </a:defRPr>
             </a:pPr>
             <a:r>
-              <a:t>2. Product freshness is weak</a:t>
+              <a:t>2. The product stopped feeling fresh</a:t>
             </a:r>
           </a:p>
         </p:txBody>
@@ -14252,33 +12085,7 @@
               </a:defRPr>
             </a:pPr>
             <a:r>
-              <a:t>Store rating dropped from 4.6 to 4.2.</a:t>
-            </a:r>
-          </a:p>
-          <a:p>
-            <a:pPr>
-              <a:defRPr sz="1050">
-                <a:solidFill>
-                  <a:srgbClr val="1F2937"/>
-                </a:solidFill>
-                <a:latin typeface="Segoe UI"/>
-              </a:defRPr>
-            </a:pPr>
-            <a:r>
-              <a:t>Public complaints: limited collaboration, no offline mode, repetitive UI.</a:t>
-            </a:r>
-          </a:p>
-          <a:p>
-            <a:pPr>
-              <a:defRPr sz="1050">
-                <a:solidFill>
-                  <a:srgbClr val="1F2937"/>
-                </a:solidFill>
-                <a:latin typeface="Segoe UI"/>
-              </a:defRPr>
-            </a:pPr>
-            <a:r>
-              <a:t>Last major feature release was 8 months ago.</a:t>
+              <a:t>Ratings fell from 4.6 to 4.2. Complaints repeat the same basics: weak collaboration, no offline mode, repetitive UI.</a:t>
             </a:r>
           </a:p>
         </p:txBody>
@@ -14404,7 +12211,7 @@
               </a:defRPr>
             </a:pPr>
             <a:r>
-              <a:t>3. UA became inefficient</a:t>
+              <a:t>3. Paid growth became a patch</a:t>
             </a:r>
           </a:p>
         </p:txBody>
@@ -14440,33 +12247,7 @@
               </a:defRPr>
             </a:pPr>
             <a:r>
-              <a:t>81% of installs come from paid channels.</a:t>
-            </a:r>
-          </a:p>
-          <a:p>
-            <a:pPr>
-              <a:defRPr sz="1050">
-                <a:solidFill>
-                  <a:srgbClr val="1F2937"/>
-                </a:solidFill>
-                <a:latin typeface="Segoe UI"/>
-              </a:defRPr>
-            </a:pPr>
-            <a:r>
-              <a:t>62% come from Meta alone.</a:t>
-            </a:r>
-          </a:p>
-          <a:p>
-            <a:pPr>
-              <a:defRPr sz="1050">
-                <a:solidFill>
-                  <a:srgbClr val="1F2937"/>
-                </a:solidFill>
-                <a:latin typeface="Segoe UI"/>
-              </a:defRPr>
-            </a:pPr>
-            <a:r>
-              <a:t>Organic share is shrinking while paid CPI rises.</a:t>
+              <a:t>81% of installs are paid, and 62% come from Meta. That is too much dependence for a product with weakening retention.</a:t>
             </a:r>
           </a:p>
         </p:txBody>
@@ -14592,7 +12373,7 @@
               </a:defRPr>
             </a:pPr>
             <a:r>
-              <a:t>4. Geo mix hurts scale</a:t>
+              <a:t>4. Cheap volume will not save it</a:t>
             </a:r>
           </a:p>
         </p:txBody>
@@ -14628,33 +12409,7 @@
               </a:defRPr>
             </a:pPr>
             <a:r>
-              <a:t>Best-monetizing markets are shrinking.</a:t>
-            </a:r>
-          </a:p>
-          <a:p>
-            <a:pPr>
-              <a:defRPr sz="1050">
-                <a:solidFill>
-                  <a:srgbClr val="1F2937"/>
-                </a:solidFill>
-                <a:latin typeface="Segoe UI"/>
-              </a:defRPr>
-            </a:pPr>
-            <a:r>
-              <a:t>Other markets are 29% of MAU but only 10% of revenue.</a:t>
-            </a:r>
-          </a:p>
-          <a:p>
-            <a:pPr>
-              <a:defRPr sz="1050">
-                <a:solidFill>
-                  <a:srgbClr val="1F2937"/>
-                </a:solidFill>
-                <a:latin typeface="Segoe UI"/>
-              </a:defRPr>
-            </a:pPr>
-            <a:r>
-              <a:t>Cheap growth there will not offset value loss in the US.</a:t>
+              <a:t>Other markets are 29% of MAU but only 10% of revenue. Cheaper installs there do not repair the model.</a:t>
             </a:r>
           </a:p>
         </p:txBody>
@@ -14795,8 +12550,7 @@
               </a:defRPr>
             </a:pPr>
             <a:r>
-              <a:rPr dirty="0"/>
-              <a:t>Unit economics show why scaling paid UA now is dangerous</a:t>
+              <a:t>Paid growth is now almost a breakeven habit</a:t>
             </a:r>
           </a:p>
         </p:txBody>
@@ -15364,7 +13118,7 @@
               </a:defRPr>
             </a:pPr>
             <a:r>
-              <a:t>Implication</a:t>
+              <a:t>So what?</a:t>
             </a:r>
           </a:p>
         </p:txBody>
@@ -15400,7 +13154,7 @@
               </a:defRPr>
             </a:pPr>
             <a:r>
-              <a:t>At current conversion and churn, a newly acquired payer barely covers expected subscription value before platform fees, fixed costs and reactivation spend.</a:t>
+              <a:t>At today's conversion and churn, a newly acquired payer barely covers expected subscription value.</a:t>
             </a:r>
           </a:p>
         </p:txBody>
@@ -15526,7 +13280,7 @@
               </a:defRPr>
             </a:pPr>
             <a:r>
-              <a:t>Secondary insight</a:t>
+              <a:t>Operator rule</a:t>
             </a:r>
           </a:p>
         </p:txBody>
@@ -15562,7 +13316,7 @@
               </a:defRPr>
             </a:pPr>
             <a:r>
-              <a:t>LTV fell from roughly $48 in Q1 2024 to about $26.7 in Dec 2025. The monetization engine weakened because users churn faster.</a:t>
+              <a:t>Cap weak paid social. Shift energy into activation, retention, ASO and content until the model improves.</a:t>
             </a:r>
           </a:p>
         </p:txBody>
@@ -15704,8 +13458,7 @@
               </a:defRPr>
             </a:pPr>
             <a:r>
-              <a:rPr dirty="0"/>
-              <a:t>The market is still attractive, but generic to-do apps are under pressure</a:t>
+              <a:t>Three places where real growth still exists</a:t>
             </a:r>
           </a:p>
         </p:txBody>
@@ -15875,7 +13628,7 @@
               </a:defRPr>
             </a:pPr>
             <a:r>
-              <a:t>Task management market</a:t>
+              <a:t>The category is still real</a:t>
             </a:r>
           </a:p>
         </p:txBody>
@@ -15911,7 +13664,7 @@
               </a:defRPr>
             </a:pPr>
             <a:r>
-              <a:t>Mordor estimates the task management software market at $1.27B in 2025, growing to $2.66B by 2031 (13.1% CAGR).</a:t>
+              <a:t>Task management is still growing. The question is not whether demand exists, but where TaskFlow can still win.</a:t>
             </a:r>
           </a:p>
         </p:txBody>
@@ -16037,7 +13790,7 @@
               </a:defRPr>
             </a:pPr>
             <a:r>
-              <a:t>Mobile monetization trend</a:t>
+              <a:t>The best growth pocket</a:t>
             </a:r>
           </a:p>
         </p:txBody>
@@ -16073,7 +13826,7 @@
               </a:defRPr>
             </a:pPr>
             <a:r>
-              <a:t>Sensor Tower says non-game app spend reached about $85B in 2025, up 21% YoY. GenAI apps drove a large share of that growth.</a:t>
+              <a:t>A narrower calendar-first planning use case fits the product better than generic to-do positioning.</a:t>
             </a:r>
           </a:p>
         </p:txBody>
@@ -16199,7 +13952,7 @@
               </a:defRPr>
             </a:pPr>
             <a:r>
-              <a:t>Strategic implication</a:t>
+              <a:t>Where to focus first</a:t>
             </a:r>
           </a:p>
         </p:txBody>
@@ -16235,8 +13988,7 @@
               </a:defRPr>
             </a:pPr>
             <a:r>
-              <a:rPr dirty="0"/>
-              <a:t>The right move is not to leave productivity. It is to choose a sharper niche where TaskFlow can win with its current team and runway.</a:t>
+              <a:t>US, UK, Canada and Australia already drive most revenue. I would fix the product there before chasing cheaper installs elsewhere.</a:t>
             </a:r>
           </a:p>
         </p:txBody>
@@ -16401,7 +14153,7 @@
               </a:defRPr>
             </a:pPr>
             <a:r>
-              <a:t>Competitor benchmark</a:t>
+              <a:t>What stronger players do differently</a:t>
             </a:r>
           </a:p>
         </p:txBody>
@@ -16571,7 +14323,6 @@
               </a:defRPr>
             </a:pPr>
             <a:r>
-              <a:rPr dirty="0"/>
               <a:t>TaskFlow today</a:t>
             </a:r>
           </a:p>
@@ -16608,46 +14359,7 @@
               </a:defRPr>
             </a:pPr>
             <a:r>
-              <a:t>Price: $5.99/mo or $39.99/yr</a:t>
-            </a:r>
-          </a:p>
-          <a:p>
-            <a:pPr>
-              <a:defRPr sz="1050">
-                <a:solidFill>
-                  <a:srgbClr val="1F2937"/>
-                </a:solidFill>
-                <a:latin typeface="Segoe UI"/>
-              </a:defRPr>
-            </a:pPr>
-            <a:r>
-              <a:t>Positioning: generic personal productivity</a:t>
-            </a:r>
-          </a:p>
-          <a:p>
-            <a:pPr>
-              <a:defRPr sz="1050">
-                <a:solidFill>
-                  <a:srgbClr val="1F2937"/>
-                </a:solidFill>
-                <a:latin typeface="Segoe UI"/>
-              </a:defRPr>
-            </a:pPr>
-            <a:r>
-              <a:t>Main gaps: weak collaboration, no offline mode, stale UX, weak web parity</a:t>
-            </a:r>
-          </a:p>
-          <a:p>
-            <a:pPr>
-              <a:defRPr sz="1050">
-                <a:solidFill>
-                  <a:srgbClr val="1F2937"/>
-                </a:solidFill>
-                <a:latin typeface="Segoe UI"/>
-              </a:defRPr>
-            </a:pPr>
-            <a:r>
-              <a:t>Signal: 105k MAU, 4.2 rating, no major release in 8 months</a:t>
+              <a:t>Generic promise, weak collaboration, no offline mode, stale UX, too much paid dependence.</a:t>
             </a:r>
           </a:p>
         </p:txBody>
@@ -16809,33 +14521,7 @@
               </a:defRPr>
             </a:pPr>
             <a:r>
-              <a:t>Price: $7/mo or $60/yr</a:t>
-            </a:r>
-          </a:p>
-          <a:p>
-            <a:pPr>
-              <a:defRPr sz="1050">
-                <a:solidFill>
-                  <a:srgbClr val="1F2937"/>
-                </a:solidFill>
-                <a:latin typeface="Segoe UI"/>
-              </a:defRPr>
-            </a:pPr>
-            <a:r>
-              <a:t>Why stronger: templates, AI assist, calendar layout, deep integrations</a:t>
-            </a:r>
-          </a:p>
-          <a:p>
-            <a:pPr>
-              <a:defRPr sz="1050">
-                <a:solidFill>
-                  <a:srgbClr val="1F2937"/>
-                </a:solidFill>
-                <a:latin typeface="Segoe UI"/>
-              </a:defRPr>
-            </a:pPr>
-            <a:r>
-              <a:t>Public signal: 4.6 rating, 297K reviews, 10M+ downloads</a:t>
+              <a:t>Wins on templates, content and integrations. It feels easier to start for a concrete job to be done.</a:t>
             </a:r>
           </a:p>
         </p:txBody>
@@ -16997,33 +14683,7 @@
               </a:defRPr>
             </a:pPr>
             <a:r>
-              <a:t>Price: $35.99/yr</a:t>
-            </a:r>
-          </a:p>
-          <a:p>
-            <a:pPr>
-              <a:defRPr sz="1050">
-                <a:solidFill>
-                  <a:srgbClr val="1F2937"/>
-                </a:solidFill>
-                <a:latin typeface="Segoe UI"/>
-              </a:defRPr>
-            </a:pPr>
-            <a:r>
-              <a:t>Why stronger: calendar + tasks + habits + Pomodoro in one product</a:t>
-            </a:r>
-          </a:p>
-          <a:p>
-            <a:pPr>
-              <a:defRPr sz="1050">
-                <a:solidFill>
-                  <a:srgbClr val="1F2937"/>
-                </a:solidFill>
-                <a:latin typeface="Segoe UI"/>
-              </a:defRPr>
-            </a:pPr>
-            <a:r>
-              <a:t>Public signal: 4.6 rating, 157K reviews, 5M+ downloads</a:t>
+              <a:t>Wins on bundled value: tasks, calendar, habits, focus tools and strong annual pricing.</a:t>
             </a:r>
           </a:p>
         </p:txBody>
@@ -17185,33 +14845,7 @@
               </a:defRPr>
             </a:pPr>
             <a:r>
-              <a:t>Price: about $4.99 annual / $7.99 monthly</a:t>
-            </a:r>
-          </a:p>
-          <a:p>
-            <a:pPr>
-              <a:defRPr sz="1050">
-                <a:solidFill>
-                  <a:srgbClr val="1F2937"/>
-                </a:solidFill>
-                <a:latin typeface="Segoe UI"/>
-              </a:defRPr>
-            </a:pPr>
-            <a:r>
-              <a:t>Why stronger: family + workspace flows, integrations, collaboration depth</a:t>
-            </a:r>
-          </a:p>
-          <a:p>
-            <a:pPr>
-              <a:defRPr sz="1050">
-                <a:solidFill>
-                  <a:srgbClr val="1F2937"/>
-                </a:solidFill>
-                <a:latin typeface="Segoe UI"/>
-              </a:defRPr>
-            </a:pPr>
-            <a:r>
-              <a:t>Public signal: 4.4 rating, 503K reviews, 10M+ downloads</a:t>
+              <a:t>Wins on clearer shared-planning packaging through Family and Workspace flows.</a:t>
             </a:r>
           </a:p>
         </p:txBody>
@@ -17373,33 +15007,7 @@
               </a:defRPr>
             </a:pPr>
             <a:r>
-              <a:t>Price: free</a:t>
-            </a:r>
-          </a:p>
-          <a:p>
-            <a:pPr>
-              <a:defRPr sz="1050">
-                <a:solidFill>
-                  <a:srgbClr val="1F2937"/>
-                </a:solidFill>
-                <a:latin typeface="Segoe UI"/>
-              </a:defRPr>
-            </a:pPr>
-            <a:r>
-              <a:t>Why stronger: ecosystem bundling with Microsoft / Outlook and zero-price entry</a:t>
-            </a:r>
-          </a:p>
-          <a:p>
-            <a:pPr>
-              <a:defRPr sz="1050">
-                <a:solidFill>
-                  <a:srgbClr val="1F2937"/>
-                </a:solidFill>
-                <a:latin typeface="Segoe UI"/>
-              </a:defRPr>
-            </a:pPr>
-            <a:r>
-              <a:t>Public signal: 4.6 rating, 468K reviews, 10M+ downloads</a:t>
+              <a:t>Wins distribution through Outlook and the Microsoft ecosystem, not just paid UA.</a:t>
             </a:r>
           </a:p>
         </p:txBody>
@@ -17435,8 +15043,7 @@
               </a:defRPr>
             </a:pPr>
             <a:r>
-              <a:rPr dirty="0"/>
-              <a:t>Observed GTM is an informed inference from pricing pages, store traction, integrations, templates and ecosystem distribution.</a:t>
+              <a:t>Lesson: TaskFlow does not need feature parity. It needs one sharper promise and fewer missing basics.</a:t>
             </a:r>
           </a:p>
         </p:txBody>
@@ -17577,8 +15184,7 @@
               </a:defRPr>
             </a:pPr>
             <a:r>
-              <a:rPr dirty="0"/>
-              <a:t>What competitors do better - and where TaskFlow still has whitespace</a:t>
+              <a:t>Where TaskFlow still has room to win</a:t>
             </a:r>
           </a:p>
         </p:txBody>
@@ -17748,7 +15354,7 @@
               </a:defRPr>
             </a:pPr>
             <a:r>
-              <a:t>More complete workflow</a:t>
+              <a:t>1. Faster first value</a:t>
             </a:r>
           </a:p>
         </p:txBody>
@@ -17784,7 +15390,7 @@
               </a:defRPr>
             </a:pPr>
             <a:r>
-              <a:t>Todoist and TickTick cover capture, planning, reminders, comments, templates and advanced views inside one product.</a:t>
+              <a:t>Onboarding, templates and calendar setup can make the product useful in the first session.</a:t>
             </a:r>
           </a:p>
         </p:txBody>
@@ -17910,7 +15516,7 @@
               </a:defRPr>
             </a:pPr>
             <a:r>
-              <a:t>Deeper collaboration</a:t>
+              <a:t>2. Better micro-collaboration</a:t>
             </a:r>
           </a:p>
         </p:txBody>
@@ -17946,7 +15552,7 @@
               </a:defRPr>
             </a:pPr>
             <a:r>
-              <a:t>Any.do teams, TickTick shared lists and Todoist workspaces all go beyond TaskFlow's cap of 3 collaborators and limited assignment model.</a:t>
+              <a:t>The opening is 2-5 person planning, not complex team workflows.</a:t>
             </a:r>
           </a:p>
         </p:txBody>
@@ -18072,7 +15678,7 @@
               </a:defRPr>
             </a:pPr>
             <a:r>
-              <a:t>Stronger distribution</a:t>
+              <a:t>3. Less paid dependence</a:t>
             </a:r>
           </a:p>
         </p:txBody>
@@ -18108,8 +15714,7 @@
               </a:defRPr>
             </a:pPr>
             <a:r>
-              <a:rPr dirty="0"/>
-              <a:t>Leaders lean on SEO, templates, ecosystems, app-store scale and integrations. TaskFlow depends too heavily on paid social.</a:t>
+              <a:t>Competitors use templates, content, referrals and ecosystems. TaskFlow over-relies on paid social.</a:t>
             </a:r>
           </a:p>
         </p:txBody>
@@ -18235,7 +15840,7 @@
               </a:defRPr>
             </a:pPr>
             <a:r>
-              <a:t>Fresher product</a:t>
+              <a:t>4. Product freshness</a:t>
             </a:r>
           </a:p>
         </p:txBody>
@@ -18271,7 +15876,7 @@
               </a:defRPr>
             </a:pPr>
             <a:r>
-              <a:t>Competitors were updated in March 2026 or late February 2026. TaskFlow's last major launch was 8 months ago.</a:t>
+              <a:t>Shipping visible basics matters. Reviews suggest users no longer trust the product to keep improving.</a:t>
             </a:r>
           </a:p>
         </p:txBody>
@@ -18397,7 +16002,7 @@
               </a:defRPr>
             </a:pPr>
             <a:r>
-              <a:t>Whitespace to pursue</a:t>
+              <a:t>The growth thesis</a:t>
             </a:r>
           </a:p>
         </p:txBody>
@@ -18433,8 +16038,7 @@
               </a:defRPr>
             </a:pPr>
             <a:r>
-              <a:rPr dirty="0"/>
-              <a:t>TaskFlow should not try to out-feature everyone. The most credible opening is a lightweight, calendar-first planner for solo professionals, freelancers and duos that is faster, cleaner, offline-capable and better for micro-collaboration.</a:t>
+              <a:t>TaskFlow should not try to out-feature everyone. The opening is a cleaner calendar-first planner for solo professionals, freelancers and very small shared workflows.</a:t>
             </a:r>
           </a:p>
         </p:txBody>
@@ -18575,7 +16179,7 @@
               </a:defRPr>
             </a:pPr>
             <a:r>
-              <a:t>Strategic options</a:t>
+              <a:t>The strategic choice</a:t>
             </a:r>
           </a:p>
         </p:txBody>
@@ -18745,7 +16349,7 @@
               </a:defRPr>
             </a:pPr>
             <a:r>
-              <a:t>1. Core turnaround + sharper positioning</a:t>
+              <a:t>Option A | Fix and narrow</a:t>
             </a:r>
           </a:p>
         </p:txBody>
@@ -18781,8 +16385,7 @@
               </a:defRPr>
             </a:pPr>
             <a:r>
-              <a:rPr dirty="0"/>
-              <a:t>Why it could work</a:t>
+              <a:t>Why I would say yes</a:t>
             </a:r>
           </a:p>
           <a:p>
@@ -18795,8 +16398,7 @@
               </a:defRPr>
             </a:pPr>
             <a:r>
-              <a:rPr dirty="0"/>
-              <a:t>Fixes the actual problem: retention, stale UX, weak collaboration and packaging.</a:t>
+              <a:t>Attacks the real leak, fits the current team, and can show progress inside 2-3 quarters.</a:t>
             </a:r>
           </a:p>
           <a:p>
@@ -18808,7 +16410,6 @@
                 <a:latin typeface="Segoe UI"/>
               </a:defRPr>
             </a:pPr>
-            <a:endParaRPr dirty="0"/>
           </a:p>
           <a:p>
             <a:pPr>
@@ -18820,8 +16421,7 @@
               </a:defRPr>
             </a:pPr>
             <a:r>
-              <a:rPr dirty="0"/>
-              <a:t>Main risk</a:t>
+              <a:t>Main downside</a:t>
             </a:r>
           </a:p>
           <a:p>
@@ -18834,47 +16434,7 @@
               </a:defRPr>
             </a:pPr>
             <a:r>
-              <a:rPr dirty="0"/>
-              <a:t>Still a crowded category. Requires focus and scope discipline.</a:t>
-            </a:r>
-          </a:p>
-          <a:p>
-            <a:pPr>
-              <a:defRPr sz="1050">
-                <a:solidFill>
-                  <a:srgbClr val="1F2937"/>
-                </a:solidFill>
-                <a:latin typeface="Segoe UI"/>
-              </a:defRPr>
-            </a:pPr>
-            <a:endParaRPr dirty="0"/>
-          </a:p>
-          <a:p>
-            <a:pPr>
-              <a:defRPr sz="1050">
-                <a:solidFill>
-                  <a:srgbClr val="1F2937"/>
-                </a:solidFill>
-                <a:latin typeface="Segoe UI"/>
-              </a:defRPr>
-            </a:pPr>
-            <a:r>
-              <a:rPr dirty="0"/>
-              <a:t>Investment / impact</a:t>
-            </a:r>
-          </a:p>
-          <a:p>
-            <a:pPr>
-              <a:defRPr sz="1050">
-                <a:solidFill>
-                  <a:srgbClr val="1F2937"/>
-                </a:solidFill>
-                <a:latin typeface="Segoe UI"/>
-              </a:defRPr>
-            </a:pPr>
-            <a:r>
-              <a:rPr dirty="0"/>
-              <a:t>Medium investment, medium-high impact.</a:t>
+              <a:t>Requires discipline to stay narrow.</a:t>
             </a:r>
           </a:p>
         </p:txBody>
@@ -19000,7 +16560,7 @@
               </a:defRPr>
             </a:pPr>
             <a:r>
-              <a:t>2. Pivot to AI-first planning assistant</a:t>
+              <a:t>Option B | Full AI pivot</a:t>
             </a:r>
           </a:p>
         </p:txBody>
@@ -19036,8 +16596,7 @@
               </a:defRPr>
             </a:pPr>
             <a:r>
-              <a:rPr dirty="0"/>
-              <a:t>Why it could work</a:t>
+              <a:t>Why I would hesitate</a:t>
             </a:r>
           </a:p>
           <a:p>
@@ -19050,8 +16609,7 @@
               </a:defRPr>
             </a:pPr>
             <a:r>
-              <a:rPr dirty="0"/>
-              <a:t>Aligns with the fastest growth theme in productivity and could create stronger differentiation.</a:t>
+              <a:t>Attractive theme, but it is a much bigger repositioning with higher product risk, stronger incumbents and extra cost.</a:t>
             </a:r>
           </a:p>
           <a:p>
@@ -19063,7 +16621,6 @@
                 <a:latin typeface="Segoe UI"/>
               </a:defRPr>
             </a:pPr>
-            <a:endParaRPr dirty="0"/>
           </a:p>
           <a:p>
             <a:pPr>
@@ -19075,8 +16632,7 @@
               </a:defRPr>
             </a:pPr>
             <a:r>
-              <a:rPr dirty="0"/>
-              <a:t>Main risk</a:t>
+              <a:t>Main downside</a:t>
             </a:r>
           </a:p>
           <a:p>
@@ -19089,47 +16645,7 @@
               </a:defRPr>
             </a:pPr>
             <a:r>
-              <a:rPr dirty="0"/>
-              <a:t>High execution risk, AI cost and stronger incumbents.</a:t>
-            </a:r>
-          </a:p>
-          <a:p>
-            <a:pPr>
-              <a:defRPr sz="1050">
-                <a:solidFill>
-                  <a:srgbClr val="1F2937"/>
-                </a:solidFill>
-                <a:latin typeface="Segoe UI"/>
-              </a:defRPr>
-            </a:pPr>
-            <a:endParaRPr dirty="0"/>
-          </a:p>
-          <a:p>
-            <a:pPr>
-              <a:defRPr sz="1050">
-                <a:solidFill>
-                  <a:srgbClr val="1F2937"/>
-                </a:solidFill>
-                <a:latin typeface="Segoe UI"/>
-              </a:defRPr>
-            </a:pPr>
-            <a:r>
-              <a:rPr dirty="0"/>
-              <a:t>Investment / impact</a:t>
-            </a:r>
-          </a:p>
-          <a:p>
-            <a:pPr>
-              <a:defRPr sz="1050">
-                <a:solidFill>
-                  <a:srgbClr val="1F2937"/>
-                </a:solidFill>
-                <a:latin typeface="Segoe UI"/>
-              </a:defRPr>
-            </a:pPr>
-            <a:r>
-              <a:rPr dirty="0"/>
-              <a:t>High investment, high but uncertain upside.</a:t>
+              <a:t>Too much uncertainty for the current runway.</a:t>
             </a:r>
           </a:p>
         </p:txBody>
@@ -19255,8 +16771,7 @@
               </a:defRPr>
             </a:pPr>
             <a:r>
-              <a:rPr dirty="0"/>
-              <a:t>3. Growth-first expansion to lower-cost segments</a:t>
+              <a:t>Option C | Chase cheaper users</a:t>
             </a:r>
           </a:p>
         </p:txBody>
@@ -19292,8 +16807,7 @@
               </a:defRPr>
             </a:pPr>
             <a:r>
-              <a:rPr dirty="0"/>
-              <a:t>Why it could work</a:t>
+              <a:t>Why I would say no for now</a:t>
             </a:r>
           </a:p>
           <a:p>
@@ -19306,8 +16820,7 @@
               </a:defRPr>
             </a:pPr>
             <a:r>
-              <a:rPr dirty="0"/>
-              <a:t>Can restore top-of-funnel volume and reduce headline CPI.</a:t>
+              <a:t>It may improve install volume and headline CPI, but it does not solve retention and can weaken the revenue mix.</a:t>
             </a:r>
           </a:p>
           <a:p>
@@ -19319,7 +16832,6 @@
                 <a:latin typeface="Segoe UI"/>
               </a:defRPr>
             </a:pPr>
-            <a:endParaRPr dirty="0"/>
           </a:p>
           <a:p>
             <a:pPr>
@@ -19331,8 +16843,7 @@
               </a:defRPr>
             </a:pPr>
             <a:r>
-              <a:rPr dirty="0"/>
-              <a:t>Main risk</a:t>
+              <a:t>Main downside</a:t>
             </a:r>
           </a:p>
           <a:p>
@@ -19345,47 +16856,7 @@
               </a:defRPr>
             </a:pPr>
             <a:r>
-              <a:rPr dirty="0"/>
-              <a:t>Does not solve retention and may worsen monetization mix.</a:t>
-            </a:r>
-          </a:p>
-          <a:p>
-            <a:pPr>
-              <a:defRPr sz="1050">
-                <a:solidFill>
-                  <a:srgbClr val="1F2937"/>
-                </a:solidFill>
-                <a:latin typeface="Segoe UI"/>
-              </a:defRPr>
-            </a:pPr>
-            <a:endParaRPr dirty="0"/>
-          </a:p>
-          <a:p>
-            <a:pPr>
-              <a:defRPr sz="1050">
-                <a:solidFill>
-                  <a:srgbClr val="1F2937"/>
-                </a:solidFill>
-                <a:latin typeface="Segoe UI"/>
-              </a:defRPr>
-            </a:pPr>
-            <a:r>
-              <a:rPr dirty="0"/>
-              <a:t>Investment / impact</a:t>
-            </a:r>
-          </a:p>
-          <a:p>
-            <a:pPr>
-              <a:defRPr sz="1050">
-                <a:solidFill>
-                  <a:srgbClr val="1F2937"/>
-                </a:solidFill>
-                <a:latin typeface="Segoe UI"/>
-              </a:defRPr>
-            </a:pPr>
-            <a:r>
-              <a:rPr dirty="0"/>
-              <a:t>Medium investment, low-medium impact.</a:t>
+              <a:t>Looks like growth without value.</a:t>
             </a:r>
           </a:p>
         </p:txBody>
@@ -19511,7 +16982,7 @@
               </a:defRPr>
             </a:pPr>
             <a:r>
-              <a:t>Why option 1 wins</a:t>
+              <a:t>Why I would pick A</a:t>
             </a:r>
           </a:p>
         </p:txBody>
@@ -19547,8 +17018,7 @@
               </a:defRPr>
             </a:pPr>
             <a:r>
-              <a:rPr dirty="0"/>
-              <a:t>It addresses the real problem fastest, fits the 12-person team, and preserves strategic flexibility if the product still underperforms after 2-3 quarters.</a:t>
+              <a:t>It attacks the real leak fastest, fits the 12-person team, and preserves the option to pivot later if the recovery stalls.</a:t>
             </a:r>
           </a:p>
         </p:txBody>

</xml_diff>

<commit_message>
Refine deck visual style and export
</commit_message>
<xml_diff>
--- a/deliverables/taskflow-case-presentation.pptx
+++ b/deliverables/taskflow-case-presentation.pptx
@@ -4630,7 +4630,7 @@
     <p:bg>
       <p:bgPr>
         <a:solidFill>
-          <a:srgbClr val="F7F3EE"/>
+          <a:srgbClr val="FBF8F3"/>
         </a:solidFill>
         <a:effectLst/>
       </p:bgPr>
@@ -4664,7 +4664,7 @@
             <a:avLst/>
           </a:prstGeom>
           <a:solidFill>
-            <a:srgbClr val="F26B3A"/>
+            <a:srgbClr val="243140"/>
           </a:solidFill>
           <a:ln>
             <a:noFill/>
@@ -4722,6 +4722,12 @@
               </a:defRPr>
             </a:pPr>
             <a:r>
+              <a:rPr>
+                <a:solidFill>
+                  <a:srgbClr val="1F2937"/>
+                </a:solidFill>
+                <a:latin typeface="Aptos"/>
+              </a:rPr>
               <a:t>TaskFlow | fix the leak before buying more growth</a:t>
             </a:r>
             <a:endParaRPr lang="en-US" sz="3600" b="1" dirty="0"/>
@@ -4759,6 +4765,12 @@
               </a:defRPr>
             </a:pPr>
             <a:r>
+              <a:rPr>
+                <a:solidFill>
+                  <a:srgbClr val="1F2937"/>
+                </a:solidFill>
+                <a:latin typeface="Aptos"/>
+              </a:rPr>
               <a:t>Genesis Strategy &amp; Operations School 2.0</a:t>
             </a:r>
           </a:p>
@@ -4772,6 +4784,12 @@
               </a:defRPr>
             </a:pPr>
             <a:r>
+              <a:rPr>
+                <a:solidFill>
+                  <a:srgbClr val="1F2937"/>
+                </a:solidFill>
+                <a:latin typeface="Aptos"/>
+              </a:rPr>
               <a:t>Case Task | March 2026</a:t>
             </a:r>
           </a:p>
@@ -4792,11 +4810,11 @@
             <a:avLst/>
           </a:prstGeom>
           <a:solidFill>
-            <a:srgbClr val="FFFDFC"/>
+            <a:srgbClr val="F7EFE6"/>
           </a:solidFill>
           <a:ln>
             <a:solidFill>
-              <a:srgbClr val="E5DDD4"/>
+              <a:srgbClr val="B65A34"/>
             </a:solidFill>
           </a:ln>
         </p:spPr>
@@ -4846,7 +4864,12 @@
           <a:lstStyle/>
           <a:p>
             <a:r>
-              <a:rPr b="1" dirty="0"/>
+              <a:rPr b="1" dirty="0">
+                <a:solidFill>
+                  <a:srgbClr val="1F2937"/>
+                </a:solidFill>
+                <a:latin typeface="Aptos"/>
+              </a:rPr>
               <a:t>Recommendation</a:t>
             </a:r>
           </a:p>
@@ -4881,6 +4904,12 @@
               </a:defRPr>
             </a:pPr>
             <a:r>
+              <a:rPr>
+                <a:solidFill>
+                  <a:srgbClr val="1F2937"/>
+                </a:solidFill>
+                <a:latin typeface="Aptos"/>
+              </a:rPr>
               <a:t>Do a focused turnaround.</a:t>
             </a:r>
           </a:p>
@@ -4891,6 +4920,12 @@
               </a:defRPr>
             </a:pPr>
             <a:r>
+              <a:rPr>
+                <a:solidFill>
+                  <a:srgbClr val="1F2937"/>
+                </a:solidFill>
+                <a:latin typeface="Aptos"/>
+              </a:rPr>
               <a:t>The category still works; the value engine does not.</a:t>
             </a:r>
           </a:p>
@@ -4911,11 +4946,11 @@
             <a:avLst/>
           </a:prstGeom>
           <a:solidFill>
-            <a:srgbClr val="FFF0E8"/>
+            <a:srgbClr val="F7EFE6"/>
           </a:solidFill>
           <a:ln>
             <a:solidFill>
-              <a:srgbClr val="F26B3A"/>
+              <a:srgbClr val="B65A34"/>
             </a:solidFill>
           </a:ln>
         </p:spPr>
@@ -4957,7 +4992,7 @@
             <a:avLst/>
           </a:prstGeom>
           <a:solidFill>
-            <a:srgbClr val="F26B3A"/>
+            <a:srgbClr val="B65A34"/>
           </a:solidFill>
           <a:ln>
             <a:noFill/>
@@ -5017,6 +5052,12 @@
               </a:defRPr>
             </a:pPr>
             <a:r>
+              <a:rPr>
+                <a:solidFill>
+                  <a:srgbClr val="1F2937"/>
+                </a:solidFill>
+                <a:latin typeface="Aptos"/>
+              </a:rPr>
               <a:t>Loom</a:t>
             </a:r>
           </a:p>
@@ -5046,6 +5087,10 @@
           <a:p>
             <a:r>
               <a:rPr lang="en-US" dirty="0">
+                <a:solidFill>
+                  <a:srgbClr val="1F2937"/>
+                </a:solidFill>
+                <a:latin typeface="Aptos"/>
                 <a:hlinkClick r:id="rId3"/>
               </a:rPr>
               <a:t>https://www.loom.com/share/ec723b4fa73542679c644feae340f941</a:t>
@@ -5085,6 +5130,12 @@
               </a:defRPr>
             </a:pPr>
             <a:r>
+              <a:rPr>
+                <a:solidFill>
+                  <a:srgbClr val="F5D7C9"/>
+                </a:solidFill>
+                <a:latin typeface="Aptos"/>
+              </a:rPr>
               <a:t>Prepared by</a:t>
             </a:r>
           </a:p>
@@ -5121,6 +5172,12 @@
               </a:defRPr>
             </a:pPr>
             <a:r>
+              <a:rPr>
+                <a:solidFill>
+                  <a:srgbClr val="FFFDF9"/>
+                </a:solidFill>
+                <a:latin typeface="Aptos"/>
+              </a:rPr>
               <a:t>Oksana Kolisnyk</a:t>
             </a:r>
           </a:p>
@@ -5157,6 +5214,12 @@
               </a:defRPr>
             </a:pPr>
             <a:r>
+              <a:rPr>
+                <a:solidFill>
+                  <a:srgbClr val="FFFDF9"/>
+                </a:solidFill>
+                <a:latin typeface="Aptos"/>
+              </a:rPr>
               <a:t>Included:</a:t>
             </a:r>
           </a:p>
@@ -5170,6 +5233,12 @@
               </a:defRPr>
             </a:pPr>
             <a:r>
+              <a:rPr>
+                <a:solidFill>
+                  <a:srgbClr val="FFFDF9"/>
+                </a:solidFill>
+                <a:latin typeface="Aptos"/>
+              </a:rPr>
               <a:t>- deck</a:t>
             </a:r>
           </a:p>
@@ -5183,6 +5252,12 @@
               </a:defRPr>
             </a:pPr>
             <a:r>
+              <a:rPr>
+                <a:solidFill>
+                  <a:srgbClr val="FFFDF9"/>
+                </a:solidFill>
+                <a:latin typeface="Aptos"/>
+              </a:rPr>
               <a:t>- PDF</a:t>
             </a:r>
           </a:p>
@@ -5196,6 +5271,12 @@
               </a:defRPr>
             </a:pPr>
             <a:r>
+              <a:rPr>
+                <a:solidFill>
+                  <a:srgbClr val="FFFDF9"/>
+                </a:solidFill>
+                <a:latin typeface="Aptos"/>
+              </a:rPr>
               <a:t>- calculations</a:t>
             </a:r>
           </a:p>
@@ -5209,6 +5290,12 @@
               </a:defRPr>
             </a:pPr>
             <a:r>
+              <a:rPr>
+                <a:solidFill>
+                  <a:srgbClr val="FFFDF9"/>
+                </a:solidFill>
+                <a:latin typeface="Aptos"/>
+              </a:rPr>
               <a:t>- source log</a:t>
             </a:r>
           </a:p>
@@ -5245,6 +5332,12 @@
               </a:defRPr>
             </a:pPr>
             <a:r>
+              <a:rPr>
+                <a:solidFill>
+                  <a:srgbClr val="FFFDF9"/>
+                </a:solidFill>
+                <a:latin typeface="Aptos"/>
+              </a:rPr>
               <a:t>Operating rule:</a:t>
             </a:r>
           </a:p>
@@ -5258,6 +5351,12 @@
               </a:defRPr>
             </a:pPr>
             <a:r>
+              <a:rPr>
+                <a:solidFill>
+                  <a:srgbClr val="FFFDF9"/>
+                </a:solidFill>
+                <a:latin typeface="Aptos"/>
+              </a:rPr>
               <a:t>No scale before D30 &gt; 7% and paid churn &lt; 14%.</a:t>
             </a:r>
           </a:p>
@@ -5294,6 +5393,12 @@
               </a:defRPr>
             </a:pPr>
             <a:r>
+              <a:rPr>
+                <a:solidFill>
+                  <a:srgbClr val="667085"/>
+                </a:solidFill>
+                <a:latin typeface="Aptos"/>
+              </a:rPr>
               <a:t>Sources: Task brief and own analysis.</a:t>
             </a:r>
           </a:p>
@@ -5330,6 +5435,12 @@
               </a:defRPr>
             </a:pPr>
             <a:r>
+              <a:rPr>
+                <a:solidFill>
+                  <a:srgbClr val="FFFDF9"/>
+                </a:solidFill>
+                <a:latin typeface="Aptos"/>
+              </a:rPr>
               <a:t>1</a:t>
             </a:r>
           </a:p>
@@ -5349,7 +5460,7 @@
     <p:bg>
       <p:bgPr>
         <a:solidFill>
-          <a:srgbClr val="F7F3EE"/>
+          <a:srgbClr val="FBF8F3"/>
         </a:solidFill>
         <a:effectLst/>
       </p:bgPr>
@@ -5399,6 +5510,12 @@
               </a:defRPr>
             </a:pPr>
             <a:r>
+              <a:rPr>
+                <a:solidFill>
+                  <a:srgbClr val="1F2937"/>
+                </a:solidFill>
+                <a:latin typeface="Aptos"/>
+              </a:rPr>
               <a:t>What turnaround means in practice</a:t>
             </a:r>
           </a:p>
@@ -5419,7 +5536,7 @@
             <a:avLst/>
           </a:prstGeom>
           <a:solidFill>
-            <a:srgbClr val="F26B3A"/>
+            <a:srgbClr val="B65A34"/>
           </a:solidFill>
           <a:ln>
             <a:noFill/>
@@ -5463,11 +5580,11 @@
             <a:avLst/>
           </a:prstGeom>
           <a:solidFill>
-            <a:srgbClr val="FFF0E8"/>
+            <a:srgbClr val="FFFDF9"/>
           </a:solidFill>
           <a:ln>
             <a:solidFill>
-              <a:srgbClr val="F26B3A"/>
+              <a:srgbClr val="D9D1C7"/>
             </a:solidFill>
           </a:ln>
         </p:spPr>
@@ -5509,7 +5626,7 @@
             <a:avLst/>
           </a:prstGeom>
           <a:solidFill>
-            <a:srgbClr val="F26B3A"/>
+            <a:srgbClr val="B65A34"/>
           </a:solidFill>
           <a:ln>
             <a:noFill/>
@@ -5569,6 +5686,12 @@
               </a:defRPr>
             </a:pPr>
             <a:r>
+              <a:rPr>
+                <a:solidFill>
+                  <a:srgbClr val="1F2937"/>
+                </a:solidFill>
+                <a:latin typeface="Aptos"/>
+              </a:rPr>
               <a:t>Product</a:t>
             </a:r>
           </a:p>
@@ -5605,6 +5728,12 @@
               </a:defRPr>
             </a:pPr>
             <a:r>
+              <a:rPr>
+                <a:solidFill>
+                  <a:srgbClr val="1F2937"/>
+                </a:solidFill>
+                <a:latin typeface="Aptos"/>
+              </a:rPr>
               <a:t>Rebuild the activation funnel.</a:t>
             </a:r>
           </a:p>
@@ -5618,6 +5747,12 @@
               </a:defRPr>
             </a:pPr>
             <a:r>
+              <a:rPr>
+                <a:solidFill>
+                  <a:srgbClr val="1F2937"/>
+                </a:solidFill>
+                <a:latin typeface="Aptos"/>
+              </a:rPr>
               <a:t>Ship offline mode.</a:t>
             </a:r>
           </a:p>
@@ -5631,6 +5766,12 @@
               </a:defRPr>
             </a:pPr>
             <a:r>
+              <a:rPr>
+                <a:solidFill>
+                  <a:srgbClr val="1F2937"/>
+                </a:solidFill>
+                <a:latin typeface="Aptos"/>
+              </a:rPr>
               <a:t>Tighten calendar parity.</a:t>
             </a:r>
           </a:p>
@@ -5644,6 +5785,12 @@
               </a:defRPr>
             </a:pPr>
             <a:r>
+              <a:rPr>
+                <a:solidFill>
+                  <a:srgbClr val="1F2937"/>
+                </a:solidFill>
+                <a:latin typeface="Aptos"/>
+              </a:rPr>
               <a:t>Improve onboarding by use case.</a:t>
             </a:r>
           </a:p>
@@ -5664,11 +5811,11 @@
             <a:avLst/>
           </a:prstGeom>
           <a:solidFill>
-            <a:srgbClr val="E8F0FF"/>
+            <a:srgbClr val="FFFDF9"/>
           </a:solidFill>
           <a:ln>
             <a:solidFill>
-              <a:srgbClr val="2563EB"/>
+              <a:srgbClr val="D9D1C7"/>
             </a:solidFill>
           </a:ln>
         </p:spPr>
@@ -5710,7 +5857,7 @@
             <a:avLst/>
           </a:prstGeom>
           <a:solidFill>
-            <a:srgbClr val="2563EB"/>
+            <a:srgbClr val="B65A34"/>
           </a:solidFill>
           <a:ln>
             <a:noFill/>
@@ -5770,6 +5917,12 @@
               </a:defRPr>
             </a:pPr>
             <a:r>
+              <a:rPr>
+                <a:solidFill>
+                  <a:srgbClr val="1F2937"/>
+                </a:solidFill>
+                <a:latin typeface="Aptos"/>
+              </a:rPr>
               <a:t>Growth</a:t>
             </a:r>
           </a:p>
@@ -5806,6 +5959,12 @@
               </a:defRPr>
             </a:pPr>
             <a:r>
+              <a:rPr>
+                <a:solidFill>
+                  <a:srgbClr val="1F2937"/>
+                </a:solidFill>
+                <a:latin typeface="Aptos"/>
+              </a:rPr>
               <a:t>Pause weak paid social.</a:t>
             </a:r>
           </a:p>
@@ -5819,6 +5978,12 @@
               </a:defRPr>
             </a:pPr>
             <a:r>
+              <a:rPr>
+                <a:solidFill>
+                  <a:srgbClr val="1F2937"/>
+                </a:solidFill>
+                <a:latin typeface="Aptos"/>
+              </a:rPr>
               <a:t>Rewrite the store listing and landing page.</a:t>
             </a:r>
           </a:p>
@@ -5832,6 +5997,12 @@
               </a:defRPr>
             </a:pPr>
             <a:r>
+              <a:rPr>
+                <a:solidFill>
+                  <a:srgbClr val="1F2937"/>
+                </a:solidFill>
+                <a:latin typeface="Aptos"/>
+              </a:rPr>
               <a:t>Build templates and creator pilots.</a:t>
             </a:r>
           </a:p>
@@ -5852,11 +6023,11 @@
             <a:avLst/>
           </a:prstGeom>
           <a:solidFill>
-            <a:srgbClr val="E9F8EE"/>
+            <a:srgbClr val="FFFDF9"/>
           </a:solidFill>
           <a:ln>
             <a:solidFill>
-              <a:srgbClr val="15803D"/>
+              <a:srgbClr val="D9D1C7"/>
             </a:solidFill>
           </a:ln>
         </p:spPr>
@@ -5898,7 +6069,7 @@
             <a:avLst/>
           </a:prstGeom>
           <a:solidFill>
-            <a:srgbClr val="15803D"/>
+            <a:srgbClr val="B65A34"/>
           </a:solidFill>
           <a:ln>
             <a:noFill/>
@@ -5958,6 +6129,12 @@
               </a:defRPr>
             </a:pPr>
             <a:r>
+              <a:rPr>
+                <a:solidFill>
+                  <a:srgbClr val="1F2937"/>
+                </a:solidFill>
+                <a:latin typeface="Aptos"/>
+              </a:rPr>
               <a:t>Customer insight</a:t>
             </a:r>
           </a:p>
@@ -5994,6 +6171,12 @@
               </a:defRPr>
             </a:pPr>
             <a:r>
+              <a:rPr>
+                <a:solidFill>
+                  <a:srgbClr val="1F2937"/>
+                </a:solidFill>
+                <a:latin typeface="Aptos"/>
+              </a:rPr>
               <a:t>Run churn interviews.</a:t>
             </a:r>
           </a:p>
@@ -6007,6 +6190,12 @@
               </a:defRPr>
             </a:pPr>
             <a:r>
+              <a:rPr>
+                <a:solidFill>
+                  <a:srgbClr val="1F2937"/>
+                </a:solidFill>
+                <a:latin typeface="Aptos"/>
+              </a:rPr>
               <a:t>Tag support tickets by reason.</a:t>
             </a:r>
           </a:p>
@@ -6020,6 +6209,12 @@
               </a:defRPr>
             </a:pPr>
             <a:r>
+              <a:rPr>
+                <a:solidFill>
+                  <a:srgbClr val="1F2937"/>
+                </a:solidFill>
+                <a:latin typeface="Aptos"/>
+              </a:rPr>
               <a:t>Add cancellation survey.</a:t>
             </a:r>
           </a:p>
@@ -6033,6 +6228,12 @@
               </a:defRPr>
             </a:pPr>
             <a:r>
+              <a:rPr>
+                <a:solidFill>
+                  <a:srgbClr val="1F2937"/>
+                </a:solidFill>
+                <a:latin typeface="Aptos"/>
+              </a:rPr>
               <a:t>Track D7 and D30 by cohort.</a:t>
             </a:r>
           </a:p>
@@ -6053,11 +6254,11 @@
             <a:avLst/>
           </a:prstGeom>
           <a:solidFill>
-            <a:srgbClr val="FFF7D6"/>
+            <a:srgbClr val="FFFDF9"/>
           </a:solidFill>
           <a:ln>
             <a:solidFill>
-              <a:srgbClr val="CA8A04"/>
+              <a:srgbClr val="D9D1C7"/>
             </a:solidFill>
           </a:ln>
         </p:spPr>
@@ -6099,7 +6300,7 @@
             <a:avLst/>
           </a:prstGeom>
           <a:solidFill>
-            <a:srgbClr val="CA8A04"/>
+            <a:srgbClr val="B65A34"/>
           </a:solidFill>
           <a:ln>
             <a:noFill/>
@@ -6159,6 +6360,12 @@
               </a:defRPr>
             </a:pPr>
             <a:r>
+              <a:rPr>
+                <a:solidFill>
+                  <a:srgbClr val="1F2937"/>
+                </a:solidFill>
+                <a:latin typeface="Aptos"/>
+              </a:rPr>
               <a:t>Support / success</a:t>
             </a:r>
           </a:p>
@@ -6195,6 +6402,12 @@
               </a:defRPr>
             </a:pPr>
             <a:r>
+              <a:rPr>
+                <a:solidFill>
+                  <a:srgbClr val="1F2937"/>
+                </a:solidFill>
+                <a:latin typeface="Aptos"/>
+              </a:rPr>
               <a:t>Use lifecycle nudges for stuck trial users.</a:t>
             </a:r>
           </a:p>
@@ -6208,6 +6421,12 @@
               </a:defRPr>
             </a:pPr>
             <a:r>
+              <a:rPr>
+                <a:solidFill>
+                  <a:srgbClr val="1F2937"/>
+                </a:solidFill>
+                <a:latin typeface="Aptos"/>
+              </a:rPr>
               <a:t>Build a self-serve help layer.</a:t>
             </a:r>
           </a:p>
@@ -6221,6 +6440,12 @@
               </a:defRPr>
             </a:pPr>
             <a:r>
+              <a:rPr>
+                <a:solidFill>
+                  <a:srgbClr val="1F2937"/>
+                </a:solidFill>
+                <a:latin typeface="Aptos"/>
+              </a:rPr>
               <a:t>Turn support into a feedback loop, not only ticket handling.</a:t>
             </a:r>
           </a:p>
@@ -6241,11 +6466,11 @@
             <a:avLst/>
           </a:prstGeom>
           <a:solidFill>
-            <a:srgbClr val="FEECEC"/>
+            <a:srgbClr val="FFFDF9"/>
           </a:solidFill>
           <a:ln>
             <a:solidFill>
-              <a:srgbClr val="B42318"/>
+              <a:srgbClr val="D9D1C7"/>
             </a:solidFill>
           </a:ln>
         </p:spPr>
@@ -6287,7 +6512,7 @@
             <a:avLst/>
           </a:prstGeom>
           <a:solidFill>
-            <a:srgbClr val="B42318"/>
+            <a:srgbClr val="B65A34"/>
           </a:solidFill>
           <a:ln>
             <a:noFill/>
@@ -6347,6 +6572,12 @@
               </a:defRPr>
             </a:pPr>
             <a:r>
+              <a:rPr>
+                <a:solidFill>
+                  <a:srgbClr val="1F2937"/>
+                </a:solidFill>
+                <a:latin typeface="Aptos"/>
+              </a:rPr>
               <a:t>Ops / finance</a:t>
             </a:r>
           </a:p>
@@ -6383,6 +6614,12 @@
               </a:defRPr>
             </a:pPr>
             <a:r>
+              <a:rPr>
+                <a:solidFill>
+                  <a:srgbClr val="1F2937"/>
+                </a:solidFill>
+                <a:latin typeface="Aptos"/>
+              </a:rPr>
               <a:t>Freeze non-core work.</a:t>
             </a:r>
           </a:p>
@@ -6396,6 +6633,12 @@
               </a:defRPr>
             </a:pPr>
             <a:r>
+              <a:rPr>
+                <a:solidFill>
+                  <a:srgbClr val="1F2937"/>
+                </a:solidFill>
+                <a:latin typeface="Aptos"/>
+              </a:rPr>
               <a:t>Use weekly stop-loss rules on paid.</a:t>
             </a:r>
           </a:p>
@@ -6409,6 +6652,12 @@
               </a:defRPr>
             </a:pPr>
             <a:r>
+              <a:rPr>
+                <a:solidFill>
+                  <a:srgbClr val="1F2937"/>
+                </a:solidFill>
+                <a:latin typeface="Aptos"/>
+              </a:rPr>
               <a:t>Limit the team to 3 core bets at a time.</a:t>
             </a:r>
           </a:p>
@@ -6445,6 +6694,12 @@
               </a:defRPr>
             </a:pPr>
             <a:r>
+              <a:rPr>
+                <a:solidFill>
+                  <a:srgbClr val="1F2937"/>
+                </a:solidFill>
+                <a:latin typeface="Aptos"/>
+              </a:rPr>
               <a:t>The point is not to do more work. It is to do fewer bets with tighter operating discipline.</a:t>
             </a:r>
           </a:p>
@@ -6481,6 +6736,12 @@
               </a:defRPr>
             </a:pPr>
             <a:r>
+              <a:rPr>
+                <a:solidFill>
+                  <a:srgbClr val="667085"/>
+                </a:solidFill>
+                <a:latin typeface="Aptos"/>
+              </a:rPr>
               <a:t>Sources: Own recommendation based on brief, benchmark and market research.</a:t>
             </a:r>
           </a:p>
@@ -6517,6 +6778,12 @@
               </a:defRPr>
             </a:pPr>
             <a:r>
+              <a:rPr>
+                <a:solidFill>
+                  <a:srgbClr val="667085"/>
+                </a:solidFill>
+                <a:latin typeface="Aptos"/>
+              </a:rPr>
               <a:t>10</a:t>
             </a:r>
           </a:p>
@@ -6536,7 +6803,7 @@
     <p:bg>
       <p:bgPr>
         <a:solidFill>
-          <a:srgbClr val="F7F3EE"/>
+          <a:srgbClr val="FBF8F3"/>
         </a:solidFill>
         <a:effectLst/>
       </p:bgPr>
@@ -6586,6 +6853,12 @@
               </a:defRPr>
             </a:pPr>
             <a:r>
+              <a:rPr>
+                <a:solidFill>
+                  <a:srgbClr val="1F2937"/>
+                </a:solidFill>
+                <a:latin typeface="Aptos"/>
+              </a:rPr>
               <a:t>90 days to stop the bleed, 12 months to scale winners</a:t>
             </a:r>
           </a:p>
@@ -6606,7 +6879,7 @@
             <a:avLst/>
           </a:prstGeom>
           <a:solidFill>
-            <a:srgbClr val="F26B3A"/>
+            <a:srgbClr val="B65A34"/>
           </a:solidFill>
           <a:ln>
             <a:noFill/>
@@ -6650,11 +6923,11 @@
             <a:avLst/>
           </a:prstGeom>
           <a:solidFill>
-            <a:srgbClr val="FFFDFC"/>
+            <a:srgbClr val="FFFDF9"/>
           </a:solidFill>
           <a:ln>
             <a:solidFill>
-              <a:srgbClr val="E5DDD4"/>
+              <a:srgbClr val="D9D1C7"/>
             </a:solidFill>
           </a:ln>
         </p:spPr>
@@ -6696,7 +6969,7 @@
             <a:avLst/>
           </a:prstGeom>
           <a:solidFill>
-            <a:srgbClr val="F26B3A"/>
+            <a:srgbClr val="B65A34"/>
           </a:solidFill>
           <a:ln>
             <a:noFill/>
@@ -6756,6 +7029,12 @@
               </a:defRPr>
             </a:pPr>
             <a:r>
+              <a:rPr>
+                <a:solidFill>
+                  <a:srgbClr val="1F2937"/>
+                </a:solidFill>
+                <a:latin typeface="Aptos"/>
+              </a:rPr>
               <a:t>Q2 2026 | Stop the bleed</a:t>
             </a:r>
           </a:p>
@@ -6792,6 +7071,12 @@
               </a:defRPr>
             </a:pPr>
             <a:r>
+              <a:rPr>
+                <a:solidFill>
+                  <a:srgbClr val="1F2937"/>
+                </a:solidFill>
+                <a:latin typeface="Aptos"/>
+              </a:rPr>
               <a:t>Activation funnel</a:t>
             </a:r>
           </a:p>
@@ -6805,6 +7090,12 @@
               </a:defRPr>
             </a:pPr>
             <a:r>
+              <a:rPr>
+                <a:solidFill>
+                  <a:srgbClr val="1F2937"/>
+                </a:solidFill>
+                <a:latin typeface="Aptos"/>
+              </a:rPr>
               <a:t>Offline mode MVP</a:t>
             </a:r>
           </a:p>
@@ -6818,6 +7109,12 @@
               </a:defRPr>
             </a:pPr>
             <a:r>
+              <a:rPr>
+                <a:solidFill>
+                  <a:srgbClr val="1F2937"/>
+                </a:solidFill>
+                <a:latin typeface="Aptos"/>
+              </a:rPr>
               <a:t>Store listing rewrite</a:t>
             </a:r>
           </a:p>
@@ -6831,6 +7128,12 @@
               </a:defRPr>
             </a:pPr>
             <a:r>
+              <a:rPr>
+                <a:solidFill>
+                  <a:srgbClr val="1F2937"/>
+                </a:solidFill>
+                <a:latin typeface="Aptos"/>
+              </a:rPr>
               <a:t>Paid stop-loss rules</a:t>
             </a:r>
           </a:p>
@@ -6851,11 +7154,11 @@
             <a:avLst/>
           </a:prstGeom>
           <a:solidFill>
-            <a:srgbClr val="FFFDFC"/>
+            <a:srgbClr val="FFFDF9"/>
           </a:solidFill>
           <a:ln>
             <a:solidFill>
-              <a:srgbClr val="E5DDD4"/>
+              <a:srgbClr val="D9D1C7"/>
             </a:solidFill>
           </a:ln>
         </p:spPr>
@@ -6897,7 +7200,7 @@
             <a:avLst/>
           </a:prstGeom>
           <a:solidFill>
-            <a:srgbClr val="2563EB"/>
+            <a:srgbClr val="B65A34"/>
           </a:solidFill>
           <a:ln>
             <a:noFill/>
@@ -6957,6 +7260,12 @@
               </a:defRPr>
             </a:pPr>
             <a:r>
+              <a:rPr>
+                <a:solidFill>
+                  <a:srgbClr val="1F2937"/>
+                </a:solidFill>
+                <a:latin typeface="Aptos"/>
+              </a:rPr>
               <a:t>Q3 2026 | Prove the core</a:t>
             </a:r>
           </a:p>
@@ -6993,6 +7302,12 @@
               </a:defRPr>
             </a:pPr>
             <a:r>
+              <a:rPr>
+                <a:solidFill>
+                  <a:srgbClr val="1F2937"/>
+                </a:solidFill>
+                <a:latin typeface="Aptos"/>
+              </a:rPr>
               <a:t>Collaboration 2.0</a:t>
             </a:r>
           </a:p>
@@ -7006,6 +7321,12 @@
               </a:defRPr>
             </a:pPr>
             <a:r>
+              <a:rPr>
+                <a:solidFill>
+                  <a:srgbClr val="1F2937"/>
+                </a:solidFill>
+                <a:latin typeface="Aptos"/>
+              </a:rPr>
               <a:t>Calendar parity</a:t>
             </a:r>
           </a:p>
@@ -7019,6 +7340,12 @@
               </a:defRPr>
             </a:pPr>
             <a:r>
+              <a:rPr>
+                <a:solidFill>
+                  <a:srgbClr val="1F2937"/>
+                </a:solidFill>
+                <a:latin typeface="Aptos"/>
+              </a:rPr>
               <a:t>Templates</a:t>
             </a:r>
           </a:p>
@@ -7032,6 +7359,12 @@
               </a:defRPr>
             </a:pPr>
             <a:r>
+              <a:rPr>
+                <a:solidFill>
+                  <a:srgbClr val="1F2937"/>
+                </a:solidFill>
+                <a:latin typeface="Aptos"/>
+              </a:rPr>
               <a:t>Free / trial experiments</a:t>
             </a:r>
           </a:p>
@@ -7052,11 +7385,11 @@
             <a:avLst/>
           </a:prstGeom>
           <a:solidFill>
-            <a:srgbClr val="FFFDFC"/>
+            <a:srgbClr val="FFFDF9"/>
           </a:solidFill>
           <a:ln>
             <a:solidFill>
-              <a:srgbClr val="E5DDD4"/>
+              <a:srgbClr val="D9D1C7"/>
             </a:solidFill>
           </a:ln>
         </p:spPr>
@@ -7098,7 +7431,7 @@
             <a:avLst/>
           </a:prstGeom>
           <a:solidFill>
-            <a:srgbClr val="15803D"/>
+            <a:srgbClr val="B65A34"/>
           </a:solidFill>
           <a:ln>
             <a:noFill/>
@@ -7158,6 +7491,12 @@
               </a:defRPr>
             </a:pPr>
             <a:r>
+              <a:rPr>
+                <a:solidFill>
+                  <a:srgbClr val="1F2937"/>
+                </a:solidFill>
+                <a:latin typeface="Aptos"/>
+              </a:rPr>
               <a:t>Q4 2026 | Add AI selectively</a:t>
             </a:r>
           </a:p>
@@ -7194,6 +7533,12 @@
               </a:defRPr>
             </a:pPr>
             <a:r>
+              <a:rPr>
+                <a:solidFill>
+                  <a:srgbClr val="1F2937"/>
+                </a:solidFill>
+                <a:latin typeface="Aptos"/>
+              </a:rPr>
               <a:t>Smart scheduling</a:t>
             </a:r>
           </a:p>
@@ -7207,6 +7552,12 @@
               </a:defRPr>
             </a:pPr>
             <a:r>
+              <a:rPr>
+                <a:solidFill>
+                  <a:srgbClr val="1F2937"/>
+                </a:solidFill>
+                <a:latin typeface="Aptos"/>
+              </a:rPr>
               <a:t>Natural-language capture</a:t>
             </a:r>
           </a:p>
@@ -7220,6 +7571,12 @@
               </a:defRPr>
             </a:pPr>
             <a:r>
+              <a:rPr>
+                <a:solidFill>
+                  <a:srgbClr val="1F2937"/>
+                </a:solidFill>
+                <a:latin typeface="Aptos"/>
+              </a:rPr>
               <a:t>Weekly planning summary</a:t>
             </a:r>
           </a:p>
@@ -7240,11 +7597,11 @@
             <a:avLst/>
           </a:prstGeom>
           <a:solidFill>
-            <a:srgbClr val="FFFDFC"/>
+            <a:srgbClr val="FFFDF9"/>
           </a:solidFill>
           <a:ln>
             <a:solidFill>
-              <a:srgbClr val="E5DDD4"/>
+              <a:srgbClr val="D9D1C7"/>
             </a:solidFill>
           </a:ln>
         </p:spPr>
@@ -7286,7 +7643,7 @@
             <a:avLst/>
           </a:prstGeom>
           <a:solidFill>
-            <a:srgbClr val="CA8A04"/>
+            <a:srgbClr val="B65A34"/>
           </a:solidFill>
           <a:ln>
             <a:noFill/>
@@ -7346,6 +7703,12 @@
               </a:defRPr>
             </a:pPr>
             <a:r>
+              <a:rPr>
+                <a:solidFill>
+                  <a:srgbClr val="1F2937"/>
+                </a:solidFill>
+                <a:latin typeface="Aptos"/>
+              </a:rPr>
               <a:t>Q1 2027 | Scale winners</a:t>
             </a:r>
           </a:p>
@@ -7382,6 +7745,12 @@
               </a:defRPr>
             </a:pPr>
             <a:r>
+              <a:rPr>
+                <a:solidFill>
+                  <a:srgbClr val="1F2937"/>
+                </a:solidFill>
+                <a:latin typeface="Aptos"/>
+              </a:rPr>
               <a:t>Increase spend only on green channels</a:t>
             </a:r>
           </a:p>
@@ -7395,6 +7764,12 @@
               </a:defRPr>
             </a:pPr>
             <a:r>
+              <a:rPr>
+                <a:solidFill>
+                  <a:srgbClr val="1F2937"/>
+                </a:solidFill>
+                <a:latin typeface="Aptos"/>
+              </a:rPr>
               <a:t>Referral engine</a:t>
             </a:r>
           </a:p>
@@ -7408,6 +7783,12 @@
               </a:defRPr>
             </a:pPr>
             <a:r>
+              <a:rPr>
+                <a:solidFill>
+                  <a:srgbClr val="1F2937"/>
+                </a:solidFill>
+                <a:latin typeface="Aptos"/>
+              </a:rPr>
               <a:t>Wave-2 market tests</a:t>
             </a:r>
           </a:p>
@@ -7427,7 +7808,14 @@
           <a:prstGeom prst="rect">
             <a:avLst/>
           </a:prstGeom>
-          <a:noFill/>
+          <a:solidFill>
+            <a:srgbClr val="F7EFE6"/>
+          </a:solidFill>
+          <a:ln>
+            <a:solidFill>
+              <a:srgbClr val="B65A34"/>
+            </a:solidFill>
+          </a:ln>
         </p:spPr>
         <p:txBody>
           <a:bodyPr wrap="square" lIns="128016" tIns="128016" rIns="128016" bIns="128016" anchor="t">
@@ -7444,6 +7832,12 @@
               </a:defRPr>
             </a:pPr>
             <a:r>
+              <a:rPr>
+                <a:solidFill>
+                  <a:srgbClr val="1F2937"/>
+                </a:solidFill>
+                <a:latin typeface="Aptos"/>
+              </a:rPr>
               <a:t>Hard checkpoint: if D30 is still below 7% by the end of Q3, revisit a broader pivot instead of raising spend.</a:t>
             </a:r>
           </a:p>
@@ -7480,6 +7874,12 @@
               </a:defRPr>
             </a:pPr>
             <a:r>
+              <a:rPr>
+                <a:solidFill>
+                  <a:srgbClr val="667085"/>
+                </a:solidFill>
+                <a:latin typeface="Aptos"/>
+              </a:rPr>
               <a:t>Sources: Own roadmap recommendation.</a:t>
             </a:r>
           </a:p>
@@ -7516,6 +7916,12 @@
               </a:defRPr>
             </a:pPr>
             <a:r>
+              <a:rPr>
+                <a:solidFill>
+                  <a:srgbClr val="667085"/>
+                </a:solidFill>
+                <a:latin typeface="Aptos"/>
+              </a:rPr>
               <a:t>11</a:t>
             </a:r>
           </a:p>
@@ -7535,7 +7941,7 @@
     <p:bg>
       <p:bgPr>
         <a:solidFill>
-          <a:srgbClr val="F7F3EE"/>
+          <a:srgbClr val="FBF8F3"/>
         </a:solidFill>
         <a:effectLst/>
       </p:bgPr>
@@ -7585,6 +7991,12 @@
               </a:defRPr>
             </a:pPr>
             <a:r>
+              <a:rPr>
+                <a:solidFill>
+                  <a:srgbClr val="1F2937"/>
+                </a:solidFill>
+                <a:latin typeface="Aptos"/>
+              </a:rPr>
               <a:t>Do not scale again until these thresholds are met</a:t>
             </a:r>
           </a:p>
@@ -7605,10 +8017,12 @@
             <a:avLst/>
           </a:prstGeom>
           <a:solidFill>
-            <a:srgbClr val="F26B3A"/>
+            <a:srgbClr val="FFFDF9"/>
           </a:solidFill>
           <a:ln>
-            <a:noFill/>
+            <a:solidFill>
+              <a:srgbClr val="D9D1C7"/>
+            </a:solidFill>
           </a:ln>
         </p:spPr>
         <p:style>
@@ -7649,11 +8063,11 @@
             <a:avLst/>
           </a:prstGeom>
           <a:solidFill>
-            <a:srgbClr val="E8F0FF"/>
+            <a:srgbClr val="FFFDF9"/>
           </a:solidFill>
           <a:ln>
             <a:solidFill>
-              <a:srgbClr val="2563EB"/>
+              <a:srgbClr val="D9D1C7"/>
             </a:solidFill>
           </a:ln>
         </p:spPr>
@@ -7695,7 +8109,7 @@
             <a:avLst/>
           </a:prstGeom>
           <a:solidFill>
-            <a:srgbClr val="2563EB"/>
+            <a:srgbClr val="B65A34"/>
           </a:solidFill>
           <a:ln>
             <a:noFill/>
@@ -7755,6 +8169,12 @@
               </a:defRPr>
             </a:pPr>
             <a:r>
+              <a:rPr>
+                <a:solidFill>
+                  <a:srgbClr val="1F2937"/>
+                </a:solidFill>
+                <a:latin typeface="Aptos"/>
+              </a:rPr>
               <a:t>Why these gates matter</a:t>
             </a:r>
           </a:p>
@@ -7791,6 +8211,12 @@
               </a:defRPr>
             </a:pPr>
             <a:r>
+              <a:rPr>
+                <a:solidFill>
+                  <a:srgbClr val="1F2937"/>
+                </a:solidFill>
+                <a:latin typeface="Aptos"/>
+              </a:rPr>
               <a:t>They force the team to prove product value before buying more top-of-funnel volume.</a:t>
             </a:r>
           </a:p>
@@ -7811,11 +8237,11 @@
             <a:avLst/>
           </a:prstGeom>
           <a:solidFill>
-            <a:srgbClr val="E9F8EE"/>
+            <a:srgbClr val="FFFDF9"/>
           </a:solidFill>
           <a:ln>
             <a:solidFill>
-              <a:srgbClr val="15803D"/>
+              <a:srgbClr val="D9D1C7"/>
             </a:solidFill>
           </a:ln>
         </p:spPr>
@@ -7857,7 +8283,7 @@
             <a:avLst/>
           </a:prstGeom>
           <a:solidFill>
-            <a:srgbClr val="15803D"/>
+            <a:srgbClr val="B65A34"/>
           </a:solidFill>
           <a:ln>
             <a:noFill/>
@@ -7917,6 +8343,12 @@
               </a:defRPr>
             </a:pPr>
             <a:r>
+              <a:rPr>
+                <a:solidFill>
+                  <a:srgbClr val="1F2937"/>
+                </a:solidFill>
+                <a:latin typeface="Aptos"/>
+              </a:rPr>
               <a:t>Minimum economic rule</a:t>
             </a:r>
           </a:p>
@@ -7953,6 +8385,12 @@
               </a:defRPr>
             </a:pPr>
             <a:r>
+              <a:rPr>
+                <a:solidFill>
+                  <a:srgbClr val="1F2937"/>
+                </a:solidFill>
+                <a:latin typeface="Aptos"/>
+              </a:rPr>
               <a:t>Paid LTV / CAC should move above about 1.3x before spend increases materially; healthy state is 1.5x or better.</a:t>
             </a:r>
           </a:p>
@@ -7973,11 +8411,11 @@
             <a:avLst/>
           </a:prstGeom>
           <a:solidFill>
-            <a:srgbClr val="FFF0E8"/>
+            <a:srgbClr val="FFFDF9"/>
           </a:solidFill>
           <a:ln>
             <a:solidFill>
-              <a:srgbClr val="F26B3A"/>
+              <a:srgbClr val="D9D1C7"/>
             </a:solidFill>
           </a:ln>
         </p:spPr>
@@ -8019,7 +8457,7 @@
             <a:avLst/>
           </a:prstGeom>
           <a:solidFill>
-            <a:srgbClr val="F26B3A"/>
+            <a:srgbClr val="B65A34"/>
           </a:solidFill>
           <a:ln>
             <a:noFill/>
@@ -8079,6 +8517,12 @@
               </a:defRPr>
             </a:pPr>
             <a:r>
+              <a:rPr>
+                <a:solidFill>
+                  <a:srgbClr val="1F2937"/>
+                </a:solidFill>
+                <a:latin typeface="Aptos"/>
+              </a:rPr>
               <a:t>Scale rule</a:t>
             </a:r>
           </a:p>
@@ -8115,6 +8559,12 @@
               </a:defRPr>
             </a:pPr>
             <a:r>
+              <a:rPr>
+                <a:solidFill>
+                  <a:srgbClr val="1F2937"/>
+                </a:solidFill>
+                <a:latin typeface="Aptos"/>
+              </a:rPr>
               <a:t>All operating gates should clear for 2 consecutive months before paid budgets go back up.</a:t>
             </a:r>
           </a:p>
@@ -8151,6 +8601,12 @@
               </a:defRPr>
             </a:pPr>
             <a:r>
+              <a:rPr>
+                <a:solidFill>
+                  <a:srgbClr val="667085"/>
+                </a:solidFill>
+                <a:latin typeface="Aptos"/>
+              </a:rPr>
               <a:t>Sources: Own thresholds built from current baselines and simplified unit economics.</a:t>
             </a:r>
           </a:p>
@@ -8187,6 +8643,12 @@
               </a:defRPr>
             </a:pPr>
             <a:r>
+              <a:rPr>
+                <a:solidFill>
+                  <a:srgbClr val="667085"/>
+                </a:solidFill>
+                <a:latin typeface="Aptos"/>
+              </a:rPr>
               <a:t>12</a:t>
             </a:r>
           </a:p>
@@ -8230,7 +8692,7 @@
     <p:bg>
       <p:bgPr>
         <a:solidFill>
-          <a:srgbClr val="F7F3EE"/>
+          <a:srgbClr val="FBF8F3"/>
         </a:solidFill>
         <a:effectLst/>
       </p:bgPr>
@@ -8280,6 +8742,12 @@
               </a:defRPr>
             </a:pPr>
             <a:r>
+              <a:rPr>
+                <a:solidFill>
+                  <a:srgbClr val="1F2937"/>
+                </a:solidFill>
+                <a:latin typeface="Aptos"/>
+              </a:rPr>
               <a:t>If the plan works, the business should feel different</a:t>
             </a:r>
           </a:p>
@@ -8300,7 +8768,7 @@
             <a:avLst/>
           </a:prstGeom>
           <a:solidFill>
-            <a:srgbClr val="F26B3A"/>
+            <a:srgbClr val="B65A34"/>
           </a:solidFill>
           <a:ln>
             <a:noFill/>
@@ -8344,11 +8812,11 @@
             <a:avLst/>
           </a:prstGeom>
           <a:solidFill>
-            <a:srgbClr val="FFFDFC"/>
+            <a:srgbClr val="FFFDF9"/>
           </a:solidFill>
           <a:ln>
             <a:solidFill>
-              <a:srgbClr val="E5DDD4"/>
+              <a:srgbClr val="D9D1C7"/>
             </a:solidFill>
           </a:ln>
         </p:spPr>
@@ -8390,7 +8858,7 @@
             <a:avLst/>
           </a:prstGeom>
           <a:solidFill>
-            <a:srgbClr val="B42318"/>
+            <a:srgbClr val="B65A34"/>
           </a:solidFill>
           <a:ln>
             <a:noFill/>
@@ -8450,6 +8918,12 @@
               </a:defRPr>
             </a:pPr>
             <a:r>
+              <a:rPr>
+                <a:solidFill>
+                  <a:srgbClr val="1F2937"/>
+                </a:solidFill>
+                <a:latin typeface="Aptos"/>
+              </a:rPr>
               <a:t>User value</a:t>
             </a:r>
           </a:p>
@@ -8486,6 +8960,12 @@
               </a:defRPr>
             </a:pPr>
             <a:r>
+              <a:rPr>
+                <a:solidFill>
+                  <a:srgbClr val="1F2937"/>
+                </a:solidFill>
+                <a:latin typeface="Aptos"/>
+              </a:rPr>
               <a:t>D30 is back above 8%, ratings recover, and complaints about missing basics start fading.</a:t>
             </a:r>
           </a:p>
@@ -8506,11 +8986,11 @@
             <a:avLst/>
           </a:prstGeom>
           <a:solidFill>
-            <a:srgbClr val="FFFDFC"/>
+            <a:srgbClr val="FFFDF9"/>
           </a:solidFill>
           <a:ln>
             <a:solidFill>
-              <a:srgbClr val="E5DDD4"/>
+              <a:srgbClr val="D9D1C7"/>
             </a:solidFill>
           </a:ln>
         </p:spPr>
@@ -8552,7 +9032,7 @@
             <a:avLst/>
           </a:prstGeom>
           <a:solidFill>
-            <a:srgbClr val="B42318"/>
+            <a:srgbClr val="B65A34"/>
           </a:solidFill>
           <a:ln>
             <a:noFill/>
@@ -8612,6 +9092,12 @@
               </a:defRPr>
             </a:pPr>
             <a:r>
+              <a:rPr>
+                <a:solidFill>
+                  <a:srgbClr val="1F2937"/>
+                </a:solidFill>
+                <a:latin typeface="Aptos"/>
+              </a:rPr>
               <a:t>Growth quality</a:t>
             </a:r>
           </a:p>
@@ -8648,6 +9134,12 @@
               </a:defRPr>
             </a:pPr>
             <a:r>
+              <a:rPr>
+                <a:solidFill>
+                  <a:srgbClr val="1F2937"/>
+                </a:solidFill>
+                <a:latin typeface="Aptos"/>
+              </a:rPr>
               <a:t>Organic share rises, paid dependence falls, and channel decisions get cleaner.</a:t>
             </a:r>
           </a:p>
@@ -8668,11 +9160,11 @@
             <a:avLst/>
           </a:prstGeom>
           <a:solidFill>
-            <a:srgbClr val="FFFDFC"/>
+            <a:srgbClr val="FFFDF9"/>
           </a:solidFill>
           <a:ln>
             <a:solidFill>
-              <a:srgbClr val="E5DDD4"/>
+              <a:srgbClr val="D9D1C7"/>
             </a:solidFill>
           </a:ln>
         </p:spPr>
@@ -8714,7 +9206,7 @@
             <a:avLst/>
           </a:prstGeom>
           <a:solidFill>
-            <a:srgbClr val="B42318"/>
+            <a:srgbClr val="B65A34"/>
           </a:solidFill>
           <a:ln>
             <a:noFill/>
@@ -8774,6 +9266,12 @@
               </a:defRPr>
             </a:pPr>
             <a:r>
+              <a:rPr>
+                <a:solidFill>
+                  <a:srgbClr val="1F2937"/>
+                </a:solidFill>
+                <a:latin typeface="Aptos"/>
+              </a:rPr>
               <a:t>Revenue quality</a:t>
             </a:r>
           </a:p>
@@ -8810,6 +9308,12 @@
               </a:defRPr>
             </a:pPr>
             <a:r>
+              <a:rPr>
+                <a:solidFill>
+                  <a:srgbClr val="1F2937"/>
+                </a:solidFill>
+                <a:latin typeface="Aptos"/>
+              </a:rPr>
               <a:t>Lower churn and better trial conversion lift MRR without forcing a risky price cut.</a:t>
             </a:r>
           </a:p>
@@ -8830,11 +9334,11 @@
             <a:avLst/>
           </a:prstGeom>
           <a:solidFill>
-            <a:srgbClr val="FFFDFC"/>
+            <a:srgbClr val="FFFDF9"/>
           </a:solidFill>
           <a:ln>
             <a:solidFill>
-              <a:srgbClr val="E5DDD4"/>
+              <a:srgbClr val="D9D1C7"/>
             </a:solidFill>
           </a:ln>
         </p:spPr>
@@ -8876,7 +9380,7 @@
             <a:avLst/>
           </a:prstGeom>
           <a:solidFill>
-            <a:srgbClr val="B42318"/>
+            <a:srgbClr val="B65A34"/>
           </a:solidFill>
           <a:ln>
             <a:noFill/>
@@ -8936,6 +9440,12 @@
               </a:defRPr>
             </a:pPr>
             <a:r>
+              <a:rPr>
+                <a:solidFill>
+                  <a:srgbClr val="1F2937"/>
+                </a:solidFill>
+                <a:latin typeface="Aptos"/>
+              </a:rPr>
               <a:t>Team cadence</a:t>
             </a:r>
           </a:p>
@@ -8972,6 +9482,12 @@
               </a:defRPr>
             </a:pPr>
             <a:r>
+              <a:rPr>
+                <a:solidFill>
+                  <a:srgbClr val="1F2937"/>
+                </a:solidFill>
+                <a:latin typeface="Aptos"/>
+              </a:rPr>
               <a:t>Product, growth and support work from the same weekly scorecard instead of chasing disconnected fixes.</a:t>
             </a:r>
           </a:p>
@@ -8992,11 +9508,11 @@
             <a:avLst/>
           </a:prstGeom>
           <a:solidFill>
-            <a:srgbClr val="FFFDFC"/>
+            <a:srgbClr val="FFFDF9"/>
           </a:solidFill>
           <a:ln>
             <a:solidFill>
-              <a:srgbClr val="E5DDD4"/>
+              <a:srgbClr val="D9D1C7"/>
             </a:solidFill>
           </a:ln>
         </p:spPr>
@@ -9038,7 +9554,7 @@
             <a:avLst/>
           </a:prstGeom>
           <a:solidFill>
-            <a:srgbClr val="B42318"/>
+            <a:srgbClr val="B65A34"/>
           </a:solidFill>
           <a:ln>
             <a:noFill/>
@@ -9098,6 +9614,12 @@
               </a:defRPr>
             </a:pPr>
             <a:r>
+              <a:rPr>
+                <a:solidFill>
+                  <a:srgbClr val="1F2937"/>
+                </a:solidFill>
+                <a:latin typeface="Aptos"/>
+              </a:rPr>
               <a:t>Strategic option value</a:t>
             </a:r>
           </a:p>
@@ -9134,6 +9656,12 @@
               </a:defRPr>
             </a:pPr>
             <a:r>
+              <a:rPr>
+                <a:solidFill>
+                  <a:srgbClr val="1F2937"/>
+                </a:solidFill>
+                <a:latin typeface="Aptos"/>
+              </a:rPr>
               <a:t>Management can either keep compounding the recovery or pivot later from a position of strength, not panic.</a:t>
             </a:r>
           </a:p>
@@ -9170,6 +9698,12 @@
               </a:defRPr>
             </a:pPr>
             <a:r>
+              <a:rPr>
+                <a:solidFill>
+                  <a:srgbClr val="667085"/>
+                </a:solidFill>
+                <a:latin typeface="Aptos"/>
+              </a:rPr>
               <a:t>Sources: Own risk assessment.</a:t>
             </a:r>
           </a:p>
@@ -9206,6 +9740,12 @@
               </a:defRPr>
             </a:pPr>
             <a:r>
+              <a:rPr>
+                <a:solidFill>
+                  <a:srgbClr val="667085"/>
+                </a:solidFill>
+                <a:latin typeface="Aptos"/>
+              </a:rPr>
               <a:t>13</a:t>
             </a:r>
           </a:p>
@@ -9225,7 +9765,7 @@
     <p:bg>
       <p:bgPr>
         <a:solidFill>
-          <a:srgbClr val="F7F3EE"/>
+          <a:srgbClr val="FBF8F3"/>
         </a:solidFill>
         <a:effectLst/>
       </p:bgPr>
@@ -9275,6 +9815,12 @@
               </a:defRPr>
             </a:pPr>
             <a:r>
+              <a:rPr>
+                <a:solidFill>
+                  <a:srgbClr val="1F2937"/>
+                </a:solidFill>
+                <a:latin typeface="Aptos"/>
+              </a:rPr>
               <a:t>Selected sources</a:t>
             </a:r>
           </a:p>
@@ -9295,7 +9841,7 @@
             <a:avLst/>
           </a:prstGeom>
           <a:solidFill>
-            <a:srgbClr val="F26B3A"/>
+            <a:srgbClr val="B65A34"/>
           </a:solidFill>
           <a:ln>
             <a:noFill/>
@@ -9339,11 +9885,11 @@
             <a:avLst/>
           </a:prstGeom>
           <a:solidFill>
-            <a:srgbClr val="FFFDFC"/>
+            <a:srgbClr val="FFFDF9"/>
           </a:solidFill>
           <a:ln>
             <a:solidFill>
-              <a:srgbClr val="E5DDD4"/>
+              <a:srgbClr val="D9D1C7"/>
             </a:solidFill>
           </a:ln>
         </p:spPr>
@@ -9401,6 +9947,12 @@
               </a:defRPr>
             </a:pPr>
             <a:r>
+              <a:rPr>
+                <a:solidFill>
+                  <a:srgbClr val="1F2937"/>
+                </a:solidFill>
+                <a:latin typeface="Aptos"/>
+              </a:rPr>
               <a:t>Sources (titles)</a:t>
             </a:r>
           </a:p>
@@ -9429,41 +9981,89 @@
           <a:lstStyle/>
           <a:p>
             <a:r>
+              <a:rPr>
+                <a:solidFill>
+                  <a:srgbClr val="1F2937"/>
+                </a:solidFill>
+                <a:latin typeface="Aptos"/>
+              </a:rPr>
               <a:t>1. Mordor Intelligence - task management market</a:t>
             </a:r>
           </a:p>
           <a:p>
             <a:r>
+              <a:rPr>
+                <a:solidFill>
+                  <a:srgbClr val="1F2937"/>
+                </a:solidFill>
+                <a:latin typeface="Aptos"/>
+              </a:rPr>
               <a:t>2. TechCrunch on Sensor Tower State of Mobile 2026</a:t>
             </a:r>
           </a:p>
           <a:p>
             <a:r>
+              <a:rPr>
+                <a:solidFill>
+                  <a:srgbClr val="1F2937"/>
+                </a:solidFill>
+                <a:latin typeface="Aptos"/>
+              </a:rPr>
               <a:t>3. Todoist template gallery</a:t>
             </a:r>
           </a:p>
           <a:p>
             <a:r>
+              <a:rPr>
+                <a:solidFill>
+                  <a:srgbClr val="1F2937"/>
+                </a:solidFill>
+                <a:latin typeface="Aptos"/>
+              </a:rPr>
               <a:t>4. Todoist pricing update 2025</a:t>
             </a:r>
           </a:p>
           <a:p>
             <a:r>
+              <a:rPr>
+                <a:solidFill>
+                  <a:srgbClr val="1F2937"/>
+                </a:solidFill>
+                <a:latin typeface="Aptos"/>
+              </a:rPr>
               <a:t>5. TickTick upgrade page</a:t>
             </a:r>
           </a:p>
           <a:p>
             <a:r>
+              <a:rPr>
+                <a:solidFill>
+                  <a:srgbClr val="1F2937"/>
+                </a:solidFill>
+                <a:latin typeface="Aptos"/>
+              </a:rPr>
               <a:t>6. TickTick ambassador program</a:t>
             </a:r>
           </a:p>
           <a:p>
             <a:r>
+              <a:rPr>
+                <a:solidFill>
+                  <a:srgbClr val="1F2937"/>
+                </a:solidFill>
+                <a:latin typeface="Aptos"/>
+              </a:rPr>
               <a:t>7. Any.do pricing and Spaces</a:t>
             </a:r>
           </a:p>
           <a:p>
             <a:r>
+              <a:rPr>
+                <a:solidFill>
+                  <a:srgbClr val="1F2937"/>
+                </a:solidFill>
+                <a:latin typeface="Aptos"/>
+              </a:rPr>
               <a:t>8. Microsoft To Do with Outlook Tasks</a:t>
             </a:r>
           </a:p>
@@ -9484,11 +10084,11 @@
             <a:avLst/>
           </a:prstGeom>
           <a:solidFill>
-            <a:srgbClr val="FFFDFC"/>
+            <a:srgbClr val="FFFDF9"/>
           </a:solidFill>
           <a:ln>
             <a:solidFill>
-              <a:srgbClr val="E5DDD4"/>
+              <a:srgbClr val="D9D1C7"/>
             </a:solidFill>
           </a:ln>
         </p:spPr>
@@ -9546,6 +10146,12 @@
               </a:defRPr>
             </a:pPr>
             <a:r>
+              <a:rPr>
+                <a:solidFill>
+                  <a:srgbClr val="1F2937"/>
+                </a:solidFill>
+                <a:latin typeface="Aptos"/>
+              </a:rPr>
               <a:t>Links</a:t>
             </a:r>
           </a:p>
@@ -9574,41 +10180,89 @@
           <a:lstStyle/>
           <a:p>
             <a:r>
+              <a:rPr>
+                <a:solidFill>
+                  <a:srgbClr val="1F2937"/>
+                </a:solidFill>
+                <a:latin typeface="Aptos"/>
+              </a:rPr>
               <a:t>https://www.mordorintelligence.com/industry-reports/task-management-software-market</a:t>
             </a:r>
           </a:p>
           <a:p>
             <a:r>
+              <a:rPr>
+                <a:solidFill>
+                  <a:srgbClr val="1F2937"/>
+                </a:solidFill>
+                <a:latin typeface="Aptos"/>
+              </a:rPr>
               <a:t>https://techcrunch.com/2026/01/21/consumers-spent-more-on-mobile-apps-than-games-in-2025-driven-by-ai-app-adoption/</a:t>
             </a:r>
           </a:p>
           <a:p>
             <a:r>
+              <a:rPr>
+                <a:solidFill>
+                  <a:srgbClr val="1F2937"/>
+                </a:solidFill>
+                <a:latin typeface="Aptos"/>
+              </a:rPr>
               <a:t>https://www.todoist.com/templates/getting-things-done</a:t>
             </a:r>
           </a:p>
           <a:p>
             <a:r>
+              <a:rPr>
+                <a:solidFill>
+                  <a:srgbClr val="1F2937"/>
+                </a:solidFill>
+                <a:latin typeface="Aptos"/>
+              </a:rPr>
               <a:t>https://www.todoist.com/help/articles/todoist-pricing-and-plans-update-2025-everything-you-need-to-know-Tn6Pg1JKI</a:t>
             </a:r>
           </a:p>
           <a:p>
             <a:r>
+              <a:rPr>
+                <a:solidFill>
+                  <a:srgbClr val="1F2937"/>
+                </a:solidFill>
+                <a:latin typeface="Aptos"/>
+              </a:rPr>
               <a:t>https://ticktick.com/upgrade</a:t>
             </a:r>
           </a:p>
           <a:p>
             <a:r>
+              <a:rPr>
+                <a:solidFill>
+                  <a:srgbClr val="1F2937"/>
+                </a:solidFill>
+                <a:latin typeface="Aptos"/>
+              </a:rPr>
               <a:t>https://ticktick.com/ambassador_program</a:t>
             </a:r>
           </a:p>
           <a:p>
             <a:r>
+              <a:rPr>
+                <a:solidFill>
+                  <a:srgbClr val="1F2937"/>
+                </a:solidFill>
+                <a:latin typeface="Aptos"/>
+              </a:rPr>
               <a:t>https://www.any.do/pricing</a:t>
             </a:r>
           </a:p>
           <a:p>
             <a:r>
+              <a:rPr>
+                <a:solidFill>
+                  <a:srgbClr val="1F2937"/>
+                </a:solidFill>
+                <a:latin typeface="Aptos"/>
+              </a:rPr>
               <a:t>https://support.microsoft.com/en-us/office/using-microsoft-to-do-with-outlook-tasks-c7a0253d-b8cc-4054-b94b-c194e0e5308a</a:t>
             </a:r>
           </a:p>
@@ -9629,11 +10283,11 @@
             <a:avLst/>
           </a:prstGeom>
           <a:solidFill>
-            <a:srgbClr val="FFF0E8"/>
+            <a:srgbClr val="F7EFE6"/>
           </a:solidFill>
           <a:ln>
             <a:solidFill>
-              <a:srgbClr val="F26B3A"/>
+              <a:srgbClr val="B65A34"/>
             </a:solidFill>
           </a:ln>
         </p:spPr>
@@ -9675,7 +10329,7 @@
             <a:avLst/>
           </a:prstGeom>
           <a:solidFill>
-            <a:srgbClr val="F26B3A"/>
+            <a:srgbClr val="B65A34"/>
           </a:solidFill>
           <a:ln>
             <a:noFill/>
@@ -9733,6 +10387,12 @@
               </a:defRPr>
             </a:pPr>
             <a:r>
+              <a:rPr>
+                <a:solidFill>
+                  <a:srgbClr val="1F2937"/>
+                </a:solidFill>
+                <a:latin typeface="Aptos"/>
+              </a:rPr>
               <a:t>Closing thought</a:t>
             </a:r>
             <a:endParaRPr lang="en-US" dirty="0"/>
@@ -9770,6 +10430,12 @@
               </a:defRPr>
             </a:pPr>
             <a:r>
+              <a:rPr>
+                <a:solidFill>
+                  <a:srgbClr val="1F2937"/>
+                </a:solidFill>
+                <a:latin typeface="Aptos"/>
+              </a:rPr>
               <a:t>This version is intentionally more operator-style: what to fix, where growth can come from, and what thresholds need to move before scaling again.</a:t>
             </a:r>
           </a:p>
@@ -9798,6 +10464,12 @@
           <a:lstStyle/>
           <a:p>
             <a:r>
+              <a:rPr>
+                <a:solidFill>
+                  <a:srgbClr val="667085"/>
+                </a:solidFill>
+                <a:latin typeface="Aptos"/>
+              </a:rPr>
               <a:t>Sources: Official market and competitor pages used in the revised deck.</a:t>
             </a:r>
           </a:p>
@@ -9834,6 +10506,12 @@
               </a:defRPr>
             </a:pPr>
             <a:r>
+              <a:rPr>
+                <a:solidFill>
+                  <a:srgbClr val="667085"/>
+                </a:solidFill>
+                <a:latin typeface="Aptos"/>
+              </a:rPr>
               <a:t>14</a:t>
             </a:r>
           </a:p>
@@ -9853,7 +10531,7 @@
     <p:bg>
       <p:bgPr>
         <a:solidFill>
-          <a:srgbClr val="F7F3EE"/>
+          <a:srgbClr val="FBF8F3"/>
         </a:solidFill>
         <a:effectLst/>
       </p:bgPr>
@@ -9903,6 +10581,12 @@
               </a:defRPr>
             </a:pPr>
             <a:r>
+              <a:rPr>
+                <a:solidFill>
+                  <a:srgbClr val="1F2937"/>
+                </a:solidFill>
+                <a:latin typeface="Aptos"/>
+              </a:rPr>
               <a:t>My read: this is a value leakage problem</a:t>
             </a:r>
           </a:p>
@@ -9923,7 +10607,7 @@
             <a:avLst/>
           </a:prstGeom>
           <a:solidFill>
-            <a:srgbClr val="F26B3A"/>
+            <a:srgbClr val="B65A34"/>
           </a:solidFill>
           <a:ln>
             <a:noFill/>
@@ -9983,6 +10667,12 @@
               </a:defRPr>
             </a:pPr>
             <a:r>
+              <a:rPr>
+                <a:solidFill>
+                  <a:srgbClr val="1F2937"/>
+                </a:solidFill>
+                <a:latin typeface="Aptos"/>
+              </a:rPr>
               <a:t>The category is alive. TaskFlow stopped earning repeat usage.</a:t>
             </a:r>
           </a:p>
@@ -10003,11 +10693,11 @@
             <a:avLst/>
           </a:prstGeom>
           <a:solidFill>
-            <a:srgbClr val="FFFDFC"/>
+            <a:srgbClr val="FFFDF9"/>
           </a:solidFill>
           <a:ln>
             <a:solidFill>
-              <a:srgbClr val="E5DDD4"/>
+              <a:srgbClr val="D9D1C7"/>
             </a:solidFill>
           </a:ln>
         </p:spPr>
@@ -10049,7 +10739,7 @@
             <a:avLst/>
           </a:prstGeom>
           <a:solidFill>
-            <a:srgbClr val="B42318"/>
+            <a:srgbClr val="B65A34"/>
           </a:solidFill>
           <a:ln>
             <a:noFill/>
@@ -10109,6 +10799,12 @@
               </a:defRPr>
             </a:pPr>
             <a:r>
+              <a:rPr>
+                <a:solidFill>
+                  <a:srgbClr val="1F2937"/>
+                </a:solidFill>
+                <a:latin typeface="Aptos"/>
+              </a:rPr>
               <a:t>What is broken</a:t>
             </a:r>
           </a:p>
@@ -10145,6 +10841,12 @@
               </a:defRPr>
             </a:pPr>
             <a:r>
+              <a:rPr>
+                <a:solidFill>
+                  <a:srgbClr val="1F2937"/>
+                </a:solidFill>
+                <a:latin typeface="Aptos"/>
+              </a:rPr>
               <a:t>Retention is the clearest signal: D30 fell from 12% to 5%, D90 from 6.5% to 2.3%, and paid churn rose to 18%.</a:t>
             </a:r>
           </a:p>
@@ -10165,11 +10867,11 @@
             <a:avLst/>
           </a:prstGeom>
           <a:solidFill>
-            <a:srgbClr val="FFFDFC"/>
+            <a:srgbClr val="FFFDF9"/>
           </a:solidFill>
           <a:ln>
             <a:solidFill>
-              <a:srgbClr val="E5DDD4"/>
+              <a:srgbClr val="D9D1C7"/>
             </a:solidFill>
           </a:ln>
         </p:spPr>
@@ -10211,7 +10913,7 @@
             <a:avLst/>
           </a:prstGeom>
           <a:solidFill>
-            <a:srgbClr val="CA8A04"/>
+            <a:srgbClr val="B65A34"/>
           </a:solidFill>
           <a:ln>
             <a:noFill/>
@@ -10271,6 +10973,12 @@
               </a:defRPr>
             </a:pPr>
             <a:r>
+              <a:rPr>
+                <a:solidFill>
+                  <a:srgbClr val="1F2937"/>
+                </a:solidFill>
+                <a:latin typeface="Aptos"/>
+              </a:rPr>
               <a:t>Why it broke</a:t>
             </a:r>
           </a:p>
@@ -10307,6 +11015,12 @@
               </a:defRPr>
             </a:pPr>
             <a:r>
+              <a:rPr>
+                <a:solidFill>
+                  <a:srgbClr val="1F2937"/>
+                </a:solidFill>
+                <a:latin typeface="Aptos"/>
+              </a:rPr>
               <a:t>The product feels stale: no major release in 8 months, worse ratings, weak collaboration, no offline mode, repetitive UI.</a:t>
             </a:r>
           </a:p>
@@ -10327,11 +11041,11 @@
             <a:avLst/>
           </a:prstGeom>
           <a:solidFill>
-            <a:srgbClr val="FFFDFC"/>
+            <a:srgbClr val="FFFDF9"/>
           </a:solidFill>
           <a:ln>
             <a:solidFill>
-              <a:srgbClr val="E5DDD4"/>
+              <a:srgbClr val="D9D1C7"/>
             </a:solidFill>
           </a:ln>
         </p:spPr>
@@ -10373,7 +11087,7 @@
             <a:avLst/>
           </a:prstGeom>
           <a:solidFill>
-            <a:srgbClr val="F26B3A"/>
+            <a:srgbClr val="B65A34"/>
           </a:solidFill>
           <a:ln>
             <a:noFill/>
@@ -10433,6 +11147,12 @@
               </a:defRPr>
             </a:pPr>
             <a:r>
+              <a:rPr>
+                <a:solidFill>
+                  <a:srgbClr val="1F2937"/>
+                </a:solidFill>
+                <a:latin typeface="Aptos"/>
+              </a:rPr>
               <a:t>Why this matters</a:t>
             </a:r>
           </a:p>
@@ -10469,6 +11189,12 @@
               </a:defRPr>
             </a:pPr>
             <a:r>
+              <a:rPr>
+                <a:solidFill>
+                  <a:srgbClr val="1F2937"/>
+                </a:solidFill>
+                <a:latin typeface="Aptos"/>
+              </a:rPr>
               <a:t>Downloads and MAU fell 42%, CPI rose 44%, and burn is still about $150k a month against $60k MRR.</a:t>
             </a:r>
           </a:p>
@@ -10489,11 +11215,11 @@
             <a:avLst/>
           </a:prstGeom>
           <a:solidFill>
-            <a:srgbClr val="E9F8EE"/>
+            <a:srgbClr val="F7EFE6"/>
           </a:solidFill>
           <a:ln>
             <a:solidFill>
-              <a:srgbClr val="15803D"/>
+              <a:srgbClr val="B65A34"/>
             </a:solidFill>
           </a:ln>
         </p:spPr>
@@ -10535,7 +11261,7 @@
             <a:avLst/>
           </a:prstGeom>
           <a:solidFill>
-            <a:srgbClr val="15803D"/>
+            <a:srgbClr val="B65A34"/>
           </a:solidFill>
           <a:ln>
             <a:noFill/>
@@ -10595,6 +11321,12 @@
               </a:defRPr>
             </a:pPr>
             <a:r>
+              <a:rPr>
+                <a:solidFill>
+                  <a:srgbClr val="1F2937"/>
+                </a:solidFill>
+                <a:latin typeface="Aptos"/>
+              </a:rPr>
               <a:t>What management should do</a:t>
             </a:r>
           </a:p>
@@ -10631,6 +11363,12 @@
               </a:defRPr>
             </a:pPr>
             <a:r>
+              <a:rPr>
+                <a:solidFill>
+                  <a:srgbClr val="1F2937"/>
+                </a:solidFill>
+                <a:latin typeface="Aptos"/>
+              </a:rPr>
               <a:t>Do not fund a full pivot yet. Narrow the promise, fix first-session value, and scale only after the core numbers move.</a:t>
             </a:r>
           </a:p>
@@ -10667,6 +11405,12 @@
               </a:defRPr>
             </a:pPr>
             <a:r>
+              <a:rPr>
+                <a:solidFill>
+                  <a:srgbClr val="1F2937"/>
+                </a:solidFill>
+                <a:latin typeface="Aptos"/>
+              </a:rPr>
               <a:t>12-month objective: clear the retention gates, recover organic share, and reopen growth options.</a:t>
             </a:r>
           </a:p>
@@ -10703,6 +11447,12 @@
               </a:defRPr>
             </a:pPr>
             <a:r>
+              <a:rPr>
+                <a:solidFill>
+                  <a:srgbClr val="667085"/>
+                </a:solidFill>
+                <a:latin typeface="Aptos"/>
+              </a:rPr>
               <a:t>Sources: Task brief; own calculations; Mordor; Gartner; competitor public pages.</a:t>
             </a:r>
           </a:p>
@@ -10739,6 +11489,12 @@
               </a:defRPr>
             </a:pPr>
             <a:r>
+              <a:rPr>
+                <a:solidFill>
+                  <a:srgbClr val="667085"/>
+                </a:solidFill>
+                <a:latin typeface="Aptos"/>
+              </a:rPr>
               <a:t>2</a:t>
             </a:r>
           </a:p>
@@ -10758,7 +11514,7 @@
     <p:bg>
       <p:bgPr>
         <a:solidFill>
-          <a:srgbClr val="F7F3EE"/>
+          <a:srgbClr val="FBF8F3"/>
         </a:solidFill>
         <a:effectLst/>
       </p:bgPr>
@@ -10808,6 +11564,12 @@
               </a:defRPr>
             </a:pPr>
             <a:r>
+              <a:rPr>
+                <a:solidFill>
+                  <a:srgbClr val="1F2937"/>
+                </a:solidFill>
+                <a:latin typeface="Aptos"/>
+              </a:rPr>
               <a:t>The whole model bent in the same direction</a:t>
             </a:r>
           </a:p>
@@ -10828,7 +11590,7 @@
             <a:avLst/>
           </a:prstGeom>
           <a:solidFill>
-            <a:srgbClr val="F26B3A"/>
+            <a:srgbClr val="B65A34"/>
           </a:solidFill>
           <a:ln>
             <a:noFill/>
@@ -10896,11 +11658,11 @@
             <a:avLst/>
           </a:prstGeom>
           <a:solidFill>
-            <a:srgbClr val="FEECEC"/>
+            <a:srgbClr val="FFFDF9"/>
           </a:solidFill>
           <a:ln>
             <a:solidFill>
-              <a:srgbClr val="B42318"/>
+              <a:srgbClr val="D9D1C7"/>
             </a:solidFill>
           </a:ln>
         </p:spPr>
@@ -10942,7 +11704,7 @@
             <a:avLst/>
           </a:prstGeom>
           <a:solidFill>
-            <a:srgbClr val="B42318"/>
+            <a:srgbClr val="B65A34"/>
           </a:solidFill>
           <a:ln>
             <a:noFill/>
@@ -11002,6 +11764,12 @@
               </a:defRPr>
             </a:pPr>
             <a:r>
+              <a:rPr>
+                <a:solidFill>
+                  <a:srgbClr val="1F2937"/>
+                </a:solidFill>
+                <a:latin typeface="Aptos"/>
+              </a:rPr>
               <a:t>Downloads</a:t>
             </a:r>
           </a:p>
@@ -11038,6 +11806,12 @@
               </a:defRPr>
             </a:pPr>
             <a:r>
+              <a:rPr>
+                <a:solidFill>
+                  <a:srgbClr val="1F2937"/>
+                </a:solidFill>
+                <a:latin typeface="Aptos"/>
+              </a:rPr>
               <a:t>48k -&gt; 28k</a:t>
             </a:r>
           </a:p>
@@ -11051,6 +11825,12 @@
               </a:defRPr>
             </a:pPr>
             <a:r>
+              <a:rPr>
+                <a:solidFill>
+                  <a:srgbClr val="1F2937"/>
+                </a:solidFill>
+                <a:latin typeface="Aptos"/>
+              </a:rPr>
               <a:t>-42%</a:t>
             </a:r>
           </a:p>
@@ -11071,11 +11851,11 @@
             <a:avLst/>
           </a:prstGeom>
           <a:solidFill>
-            <a:srgbClr val="FEECEC"/>
+            <a:srgbClr val="FFFDF9"/>
           </a:solidFill>
           <a:ln>
             <a:solidFill>
-              <a:srgbClr val="B42318"/>
+              <a:srgbClr val="D9D1C7"/>
             </a:solidFill>
           </a:ln>
         </p:spPr>
@@ -11117,7 +11897,7 @@
             <a:avLst/>
           </a:prstGeom>
           <a:solidFill>
-            <a:srgbClr val="B42318"/>
+            <a:srgbClr val="B65A34"/>
           </a:solidFill>
           <a:ln>
             <a:noFill/>
@@ -11177,6 +11957,12 @@
               </a:defRPr>
             </a:pPr>
             <a:r>
+              <a:rPr>
+                <a:solidFill>
+                  <a:srgbClr val="1F2937"/>
+                </a:solidFill>
+                <a:latin typeface="Aptos"/>
+              </a:rPr>
               <a:t>MAU</a:t>
             </a:r>
           </a:p>
@@ -11213,6 +11999,12 @@
               </a:defRPr>
             </a:pPr>
             <a:r>
+              <a:rPr>
+                <a:solidFill>
+                  <a:srgbClr val="1F2937"/>
+                </a:solidFill>
+                <a:latin typeface="Aptos"/>
+              </a:rPr>
               <a:t>180k -&gt; 105k</a:t>
             </a:r>
           </a:p>
@@ -11226,6 +12018,12 @@
               </a:defRPr>
             </a:pPr>
             <a:r>
+              <a:rPr>
+                <a:solidFill>
+                  <a:srgbClr val="1F2937"/>
+                </a:solidFill>
+                <a:latin typeface="Aptos"/>
+              </a:rPr>
               <a:t>-42%</a:t>
             </a:r>
           </a:p>
@@ -11246,11 +12044,11 @@
             <a:avLst/>
           </a:prstGeom>
           <a:solidFill>
-            <a:srgbClr val="FFF7D6"/>
+            <a:srgbClr val="FFFDF9"/>
           </a:solidFill>
           <a:ln>
             <a:solidFill>
-              <a:srgbClr val="CA8A04"/>
+              <a:srgbClr val="D9D1C7"/>
             </a:solidFill>
           </a:ln>
         </p:spPr>
@@ -11292,7 +12090,7 @@
             <a:avLst/>
           </a:prstGeom>
           <a:solidFill>
-            <a:srgbClr val="CA8A04"/>
+            <a:srgbClr val="B65A34"/>
           </a:solidFill>
           <a:ln>
             <a:noFill/>
@@ -11352,6 +12150,12 @@
               </a:defRPr>
             </a:pPr>
             <a:r>
+              <a:rPr>
+                <a:solidFill>
+                  <a:srgbClr val="1F2937"/>
+                </a:solidFill>
+                <a:latin typeface="Aptos"/>
+              </a:rPr>
               <a:t>MRR</a:t>
             </a:r>
           </a:p>
@@ -11388,6 +12192,12 @@
               </a:defRPr>
             </a:pPr>
             <a:r>
+              <a:rPr>
+                <a:solidFill>
+                  <a:srgbClr val="1F2937"/>
+                </a:solidFill>
+                <a:latin typeface="Aptos"/>
+              </a:rPr>
               <a:t>$86.4k -&gt; $60.0k</a:t>
             </a:r>
           </a:p>
@@ -11401,6 +12211,12 @@
               </a:defRPr>
             </a:pPr>
             <a:r>
+              <a:rPr>
+                <a:solidFill>
+                  <a:srgbClr val="1F2937"/>
+                </a:solidFill>
+                <a:latin typeface="Aptos"/>
+              </a:rPr>
               <a:t>-31%</a:t>
             </a:r>
           </a:p>
@@ -11421,11 +12237,11 @@
             <a:avLst/>
           </a:prstGeom>
           <a:solidFill>
-            <a:srgbClr val="FFF0E8"/>
+            <a:srgbClr val="FFFDF9"/>
           </a:solidFill>
           <a:ln>
             <a:solidFill>
-              <a:srgbClr val="F26B3A"/>
+              <a:srgbClr val="D9D1C7"/>
             </a:solidFill>
           </a:ln>
         </p:spPr>
@@ -11467,7 +12283,7 @@
             <a:avLst/>
           </a:prstGeom>
           <a:solidFill>
-            <a:srgbClr val="F26B3A"/>
+            <a:srgbClr val="B65A34"/>
           </a:solidFill>
           <a:ln>
             <a:noFill/>
@@ -11527,6 +12343,12 @@
               </a:defRPr>
             </a:pPr>
             <a:r>
+              <a:rPr>
+                <a:solidFill>
+                  <a:srgbClr val="1F2937"/>
+                </a:solidFill>
+                <a:latin typeface="Aptos"/>
+              </a:rPr>
               <a:t>Avg CPI</a:t>
             </a:r>
           </a:p>
@@ -11563,6 +12385,12 @@
               </a:defRPr>
             </a:pPr>
             <a:r>
+              <a:rPr>
+                <a:solidFill>
+                  <a:srgbClr val="1F2937"/>
+                </a:solidFill>
+                <a:latin typeface="Aptos"/>
+              </a:rPr>
               <a:t>$1.80 -&gt; $2.60</a:t>
             </a:r>
           </a:p>
@@ -11576,6 +12404,12 @@
               </a:defRPr>
             </a:pPr>
             <a:r>
+              <a:rPr>
+                <a:solidFill>
+                  <a:srgbClr val="1F2937"/>
+                </a:solidFill>
+                <a:latin typeface="Aptos"/>
+              </a:rPr>
               <a:t>+44%</a:t>
             </a:r>
           </a:p>
@@ -11612,6 +12446,12 @@
               </a:defRPr>
             </a:pPr>
             <a:r>
+              <a:rPr>
+                <a:solidFill>
+                  <a:srgbClr val="667085"/>
+                </a:solidFill>
+                <a:latin typeface="Aptos"/>
+              </a:rPr>
               <a:t>Sources: Task brief dataset; own calculations.</a:t>
             </a:r>
           </a:p>
@@ -11648,6 +12488,12 @@
               </a:defRPr>
             </a:pPr>
             <a:r>
+              <a:rPr>
+                <a:solidFill>
+                  <a:srgbClr val="667085"/>
+                </a:solidFill>
+                <a:latin typeface="Aptos"/>
+              </a:rPr>
               <a:t>3</a:t>
             </a:r>
           </a:p>
@@ -11667,7 +12513,7 @@
     <p:bg>
       <p:bgPr>
         <a:solidFill>
-          <a:srgbClr val="F7F3EE"/>
+          <a:srgbClr val="FBF8F3"/>
         </a:solidFill>
         <a:effectLst/>
       </p:bgPr>
@@ -11717,6 +12563,12 @@
               </a:defRPr>
             </a:pPr>
             <a:r>
+              <a:rPr>
+                <a:solidFill>
+                  <a:srgbClr val="1F2937"/>
+                </a:solidFill>
+                <a:latin typeface="Aptos"/>
+              </a:rPr>
               <a:t>The leak starts after install</a:t>
             </a:r>
           </a:p>
@@ -11737,7 +12589,7 @@
             <a:avLst/>
           </a:prstGeom>
           <a:solidFill>
-            <a:srgbClr val="F26B3A"/>
+            <a:srgbClr val="B65A34"/>
           </a:solidFill>
           <a:ln>
             <a:noFill/>
@@ -11781,11 +12633,11 @@
             <a:avLst/>
           </a:prstGeom>
           <a:solidFill>
-            <a:srgbClr val="FEECEC"/>
+            <a:srgbClr val="FFFDF9"/>
           </a:solidFill>
           <a:ln>
             <a:solidFill>
-              <a:srgbClr val="B42318"/>
+              <a:srgbClr val="D9D1C7"/>
             </a:solidFill>
           </a:ln>
         </p:spPr>
@@ -11827,7 +12679,7 @@
             <a:avLst/>
           </a:prstGeom>
           <a:solidFill>
-            <a:srgbClr val="B42318"/>
+            <a:srgbClr val="B65A34"/>
           </a:solidFill>
           <a:ln>
             <a:noFill/>
@@ -11887,6 +12739,12 @@
               </a:defRPr>
             </a:pPr>
             <a:r>
+              <a:rPr>
+                <a:solidFill>
+                  <a:srgbClr val="1F2937"/>
+                </a:solidFill>
+                <a:latin typeface="Aptos"/>
+              </a:rPr>
               <a:t>1. Retention broke first</a:t>
             </a:r>
           </a:p>
@@ -11923,6 +12781,12 @@
               </a:defRPr>
             </a:pPr>
             <a:r>
+              <a:rPr>
+                <a:solidFill>
+                  <a:srgbClr val="1F2937"/>
+                </a:solidFill>
+                <a:latin typeface="Aptos"/>
+              </a:rPr>
               <a:t>Every cohort got weaker. D30 fell 58% and D90 fell 65% vs Q1 2024. That is what a value leak looks like.</a:t>
             </a:r>
           </a:p>
@@ -11943,11 +12807,11 @@
             <a:avLst/>
           </a:prstGeom>
           <a:solidFill>
-            <a:srgbClr val="FFF7D6"/>
+            <a:srgbClr val="FFFDF9"/>
           </a:solidFill>
           <a:ln>
             <a:solidFill>
-              <a:srgbClr val="CA8A04"/>
+              <a:srgbClr val="D9D1C7"/>
             </a:solidFill>
           </a:ln>
         </p:spPr>
@@ -11989,7 +12853,7 @@
             <a:avLst/>
           </a:prstGeom>
           <a:solidFill>
-            <a:srgbClr val="CA8A04"/>
+            <a:srgbClr val="B65A34"/>
           </a:solidFill>
           <a:ln>
             <a:noFill/>
@@ -12049,6 +12913,12 @@
               </a:defRPr>
             </a:pPr>
             <a:r>
+              <a:rPr>
+                <a:solidFill>
+                  <a:srgbClr val="1F2937"/>
+                </a:solidFill>
+                <a:latin typeface="Aptos"/>
+              </a:rPr>
               <a:t>2. The product stopped feeling fresh</a:t>
             </a:r>
           </a:p>
@@ -12085,6 +12955,12 @@
               </a:defRPr>
             </a:pPr>
             <a:r>
+              <a:rPr>
+                <a:solidFill>
+                  <a:srgbClr val="1F2937"/>
+                </a:solidFill>
+                <a:latin typeface="Aptos"/>
+              </a:rPr>
               <a:t>Ratings fell from 4.6 to 4.2. Complaints repeat the same basics: weak collaboration, no offline mode, repetitive UI.</a:t>
             </a:r>
           </a:p>
@@ -12105,11 +12981,11 @@
             <a:avLst/>
           </a:prstGeom>
           <a:solidFill>
-            <a:srgbClr val="FFF0E8"/>
+            <a:srgbClr val="FFFDF9"/>
           </a:solidFill>
           <a:ln>
             <a:solidFill>
-              <a:srgbClr val="F26B3A"/>
+              <a:srgbClr val="D9D1C7"/>
             </a:solidFill>
           </a:ln>
         </p:spPr>
@@ -12151,7 +13027,7 @@
             <a:avLst/>
           </a:prstGeom>
           <a:solidFill>
-            <a:srgbClr val="F26B3A"/>
+            <a:srgbClr val="B65A34"/>
           </a:solidFill>
           <a:ln>
             <a:noFill/>
@@ -12211,6 +13087,12 @@
               </a:defRPr>
             </a:pPr>
             <a:r>
+              <a:rPr>
+                <a:solidFill>
+                  <a:srgbClr val="1F2937"/>
+                </a:solidFill>
+                <a:latin typeface="Aptos"/>
+              </a:rPr>
               <a:t>3. Paid growth became a patch</a:t>
             </a:r>
           </a:p>
@@ -12247,6 +13129,12 @@
               </a:defRPr>
             </a:pPr>
             <a:r>
+              <a:rPr>
+                <a:solidFill>
+                  <a:srgbClr val="1F2937"/>
+                </a:solidFill>
+                <a:latin typeface="Aptos"/>
+              </a:rPr>
               <a:t>81% of installs are paid, and 62% come from Meta. That is too much dependence for a product with weakening retention.</a:t>
             </a:r>
           </a:p>
@@ -12267,11 +13155,11 @@
             <a:avLst/>
           </a:prstGeom>
           <a:solidFill>
-            <a:srgbClr val="E8F0FF"/>
+            <a:srgbClr val="FFFDF9"/>
           </a:solidFill>
           <a:ln>
             <a:solidFill>
-              <a:srgbClr val="2563EB"/>
+              <a:srgbClr val="D9D1C7"/>
             </a:solidFill>
           </a:ln>
         </p:spPr>
@@ -12313,7 +13201,7 @@
             <a:avLst/>
           </a:prstGeom>
           <a:solidFill>
-            <a:srgbClr val="2563EB"/>
+            <a:srgbClr val="B65A34"/>
           </a:solidFill>
           <a:ln>
             <a:noFill/>
@@ -12373,6 +13261,12 @@
               </a:defRPr>
             </a:pPr>
             <a:r>
+              <a:rPr>
+                <a:solidFill>
+                  <a:srgbClr val="1F2937"/>
+                </a:solidFill>
+                <a:latin typeface="Aptos"/>
+              </a:rPr>
               <a:t>4. Cheap volume will not save it</a:t>
             </a:r>
           </a:p>
@@ -12409,6 +13303,12 @@
               </a:defRPr>
             </a:pPr>
             <a:r>
+              <a:rPr>
+                <a:solidFill>
+                  <a:srgbClr val="1F2937"/>
+                </a:solidFill>
+                <a:latin typeface="Aptos"/>
+              </a:rPr>
               <a:t>Other markets are 29% of MAU but only 10% of revenue. Cheaper installs there do not repair the model.</a:t>
             </a:r>
           </a:p>
@@ -12445,6 +13345,12 @@
               </a:defRPr>
             </a:pPr>
             <a:r>
+              <a:rPr>
+                <a:solidFill>
+                  <a:srgbClr val="667085"/>
+                </a:solidFill>
+                <a:latin typeface="Aptos"/>
+              </a:rPr>
               <a:t>Sources: Task brief dataset; public review themes from case prompt.</a:t>
             </a:r>
           </a:p>
@@ -12481,6 +13387,12 @@
               </a:defRPr>
             </a:pPr>
             <a:r>
+              <a:rPr>
+                <a:solidFill>
+                  <a:srgbClr val="667085"/>
+                </a:solidFill>
+                <a:latin typeface="Aptos"/>
+              </a:rPr>
               <a:t>4</a:t>
             </a:r>
           </a:p>
@@ -12500,7 +13412,7 @@
     <p:bg>
       <p:bgPr>
         <a:solidFill>
-          <a:srgbClr val="F7F3EE"/>
+          <a:srgbClr val="FBF8F3"/>
         </a:solidFill>
         <a:effectLst/>
       </p:bgPr>
@@ -12550,6 +13462,12 @@
               </a:defRPr>
             </a:pPr>
             <a:r>
+              <a:rPr>
+                <a:solidFill>
+                  <a:srgbClr val="1F2937"/>
+                </a:solidFill>
+                <a:latin typeface="Aptos"/>
+              </a:rPr>
               <a:t>Paid growth is now almost a breakeven habit</a:t>
             </a:r>
           </a:p>
@@ -12570,7 +13488,7 @@
             <a:avLst/>
           </a:prstGeom>
           <a:solidFill>
-            <a:srgbClr val="F26B3A"/>
+            <a:srgbClr val="B65A34"/>
           </a:solidFill>
           <a:ln>
             <a:noFill/>
@@ -12662,11 +13580,11 @@
             <a:avLst/>
           </a:prstGeom>
           <a:solidFill>
-            <a:srgbClr val="FFF0E8"/>
+            <a:srgbClr val="FFFDF9"/>
           </a:solidFill>
           <a:ln>
             <a:solidFill>
-              <a:srgbClr val="F26B3A"/>
+              <a:srgbClr val="D9D1C7"/>
             </a:solidFill>
           </a:ln>
         </p:spPr>
@@ -12708,7 +13626,7 @@
             <a:avLst/>
           </a:prstGeom>
           <a:solidFill>
-            <a:srgbClr val="F26B3A"/>
+            <a:srgbClr val="B65A34"/>
           </a:solidFill>
           <a:ln>
             <a:noFill/>
@@ -12768,6 +13686,12 @@
               </a:defRPr>
             </a:pPr>
             <a:r>
+              <a:rPr>
+                <a:solidFill>
+                  <a:srgbClr val="1F2937"/>
+                </a:solidFill>
+                <a:latin typeface="Aptos"/>
+              </a:rPr>
               <a:t>Approx. paid CAC</a:t>
             </a:r>
           </a:p>
@@ -12804,6 +13728,12 @@
               </a:defRPr>
             </a:pPr>
             <a:r>
+              <a:rPr>
+                <a:solidFill>
+                  <a:srgbClr val="1F2937"/>
+                </a:solidFill>
+                <a:latin typeface="Aptos"/>
+              </a:rPr>
               <a:t>$26.5</a:t>
             </a:r>
           </a:p>
@@ -12817,6 +13747,12 @@
               </a:defRPr>
             </a:pPr>
             <a:r>
+              <a:rPr>
+                <a:solidFill>
+                  <a:srgbClr val="1F2937"/>
+                </a:solidFill>
+                <a:latin typeface="Aptos"/>
+              </a:rPr>
               <a:t>= $2.60 / 9.8%</a:t>
             </a:r>
           </a:p>
@@ -12837,11 +13773,11 @@
             <a:avLst/>
           </a:prstGeom>
           <a:solidFill>
-            <a:srgbClr val="E9F8EE"/>
+            <a:srgbClr val="FFFDF9"/>
           </a:solidFill>
           <a:ln>
             <a:solidFill>
-              <a:srgbClr val="15803D"/>
+              <a:srgbClr val="D9D1C7"/>
             </a:solidFill>
           </a:ln>
         </p:spPr>
@@ -12883,7 +13819,7 @@
             <a:avLst/>
           </a:prstGeom>
           <a:solidFill>
-            <a:srgbClr val="15803D"/>
+            <a:srgbClr val="B65A34"/>
           </a:solidFill>
           <a:ln>
             <a:noFill/>
@@ -12943,6 +13879,12 @@
               </a:defRPr>
             </a:pPr>
             <a:r>
+              <a:rPr>
+                <a:solidFill>
+                  <a:srgbClr val="1F2937"/>
+                </a:solidFill>
+                <a:latin typeface="Aptos"/>
+              </a:rPr>
               <a:t>Approx. paid LTV</a:t>
             </a:r>
           </a:p>
@@ -12979,6 +13921,12 @@
               </a:defRPr>
             </a:pPr>
             <a:r>
+              <a:rPr>
+                <a:solidFill>
+                  <a:srgbClr val="1F2937"/>
+                </a:solidFill>
+                <a:latin typeface="Aptos"/>
+              </a:rPr>
               <a:t>$26.7</a:t>
             </a:r>
           </a:p>
@@ -12992,6 +13940,12 @@
               </a:defRPr>
             </a:pPr>
             <a:r>
+              <a:rPr>
+                <a:solidFill>
+                  <a:srgbClr val="1F2937"/>
+                </a:solidFill>
+                <a:latin typeface="Aptos"/>
+              </a:rPr>
               <a:t>= $4.80 / 18%</a:t>
             </a:r>
           </a:p>
@@ -13012,11 +13966,11 @@
             <a:avLst/>
           </a:prstGeom>
           <a:solidFill>
-            <a:srgbClr val="FEECEC"/>
+            <a:srgbClr val="FFFDF9"/>
           </a:solidFill>
           <a:ln>
             <a:solidFill>
-              <a:srgbClr val="B42318"/>
+              <a:srgbClr val="D9D1C7"/>
             </a:solidFill>
           </a:ln>
         </p:spPr>
@@ -13058,7 +14012,7 @@
             <a:avLst/>
           </a:prstGeom>
           <a:solidFill>
-            <a:srgbClr val="B42318"/>
+            <a:srgbClr val="B65A34"/>
           </a:solidFill>
           <a:ln>
             <a:noFill/>
@@ -13118,6 +14072,12 @@
               </a:defRPr>
             </a:pPr>
             <a:r>
+              <a:rPr>
+                <a:solidFill>
+                  <a:srgbClr val="1F2937"/>
+                </a:solidFill>
+                <a:latin typeface="Aptos"/>
+              </a:rPr>
               <a:t>So what?</a:t>
             </a:r>
           </a:p>
@@ -13154,6 +14114,12 @@
               </a:defRPr>
             </a:pPr>
             <a:r>
+              <a:rPr>
+                <a:solidFill>
+                  <a:srgbClr val="1F2937"/>
+                </a:solidFill>
+                <a:latin typeface="Aptos"/>
+              </a:rPr>
               <a:t>At today's conversion and churn, a newly acquired payer barely covers expected subscription value.</a:t>
             </a:r>
           </a:p>
@@ -13174,11 +14140,11 @@
             <a:avLst/>
           </a:prstGeom>
           <a:solidFill>
-            <a:srgbClr val="FFF7D6"/>
+            <a:srgbClr val="FFFDF9"/>
           </a:solidFill>
           <a:ln>
             <a:solidFill>
-              <a:srgbClr val="CA8A04"/>
+              <a:srgbClr val="D9D1C7"/>
             </a:solidFill>
           </a:ln>
         </p:spPr>
@@ -13220,7 +14186,7 @@
             <a:avLst/>
           </a:prstGeom>
           <a:solidFill>
-            <a:srgbClr val="CA8A04"/>
+            <a:srgbClr val="B65A34"/>
           </a:solidFill>
           <a:ln>
             <a:noFill/>
@@ -13280,6 +14246,12 @@
               </a:defRPr>
             </a:pPr>
             <a:r>
+              <a:rPr>
+                <a:solidFill>
+                  <a:srgbClr val="1F2937"/>
+                </a:solidFill>
+                <a:latin typeface="Aptos"/>
+              </a:rPr>
               <a:t>Operator rule</a:t>
             </a:r>
           </a:p>
@@ -13316,6 +14288,12 @@
               </a:defRPr>
             </a:pPr>
             <a:r>
+              <a:rPr>
+                <a:solidFill>
+                  <a:srgbClr val="1F2937"/>
+                </a:solidFill>
+                <a:latin typeface="Aptos"/>
+              </a:rPr>
               <a:t>Cap weak paid social. Shift energy into activation, retention, ASO and content until the model improves.</a:t>
             </a:r>
           </a:p>
@@ -13352,7 +14330,12 @@
               </a:defRPr>
             </a:pPr>
             <a:r>
-              <a:rPr dirty="0"/>
+              <a:rPr dirty="0">
+                <a:solidFill>
+                  <a:srgbClr val="667085"/>
+                </a:solidFill>
+                <a:latin typeface="Aptos"/>
+              </a:rPr>
               <a:t>Sources: Task brief dataset; simplified LTV/CAC estimates using provided ARPPU, churn, CPI and free-to-paid conversion.</a:t>
             </a:r>
           </a:p>
@@ -13389,6 +14372,12 @@
               </a:defRPr>
             </a:pPr>
             <a:r>
+              <a:rPr>
+                <a:solidFill>
+                  <a:srgbClr val="667085"/>
+                </a:solidFill>
+                <a:latin typeface="Aptos"/>
+              </a:rPr>
               <a:t>5</a:t>
             </a:r>
           </a:p>
@@ -13408,7 +14397,7 @@
     <p:bg>
       <p:bgPr>
         <a:solidFill>
-          <a:srgbClr val="F7F3EE"/>
+          <a:srgbClr val="FBF8F3"/>
         </a:solidFill>
         <a:effectLst/>
       </p:bgPr>
@@ -13458,6 +14447,12 @@
               </a:defRPr>
             </a:pPr>
             <a:r>
+              <a:rPr>
+                <a:solidFill>
+                  <a:srgbClr val="1F2937"/>
+                </a:solidFill>
+                <a:latin typeface="Aptos"/>
+              </a:rPr>
               <a:t>Three places where real growth still exists</a:t>
             </a:r>
           </a:p>
@@ -13478,7 +14473,7 @@
             <a:avLst/>
           </a:prstGeom>
           <a:solidFill>
-            <a:srgbClr val="F26B3A"/>
+            <a:srgbClr val="B65A34"/>
           </a:solidFill>
           <a:ln>
             <a:noFill/>
@@ -13522,11 +14517,11 @@
             <a:avLst/>
           </a:prstGeom>
           <a:solidFill>
-            <a:srgbClr val="E9F8EE"/>
+            <a:srgbClr val="FFFDF9"/>
           </a:solidFill>
           <a:ln>
             <a:solidFill>
-              <a:srgbClr val="15803D"/>
+              <a:srgbClr val="D9D1C7"/>
             </a:solidFill>
           </a:ln>
         </p:spPr>
@@ -13568,7 +14563,7 @@
             <a:avLst/>
           </a:prstGeom>
           <a:solidFill>
-            <a:srgbClr val="15803D"/>
+            <a:srgbClr val="B65A34"/>
           </a:solidFill>
           <a:ln>
             <a:noFill/>
@@ -13628,6 +14623,12 @@
               </a:defRPr>
             </a:pPr>
             <a:r>
+              <a:rPr>
+                <a:solidFill>
+                  <a:srgbClr val="1F2937"/>
+                </a:solidFill>
+                <a:latin typeface="Aptos"/>
+              </a:rPr>
               <a:t>The category is still real</a:t>
             </a:r>
           </a:p>
@@ -13664,6 +14665,12 @@
               </a:defRPr>
             </a:pPr>
             <a:r>
+              <a:rPr>
+                <a:solidFill>
+                  <a:srgbClr val="1F2937"/>
+                </a:solidFill>
+                <a:latin typeface="Aptos"/>
+              </a:rPr>
               <a:t>Task management is still growing. The question is not whether demand exists, but where TaskFlow can still win.</a:t>
             </a:r>
           </a:p>
@@ -13684,11 +14691,11 @@
             <a:avLst/>
           </a:prstGeom>
           <a:solidFill>
-            <a:srgbClr val="FFF0E8"/>
+            <a:srgbClr val="FFFDF9"/>
           </a:solidFill>
           <a:ln>
             <a:solidFill>
-              <a:srgbClr val="F26B3A"/>
+              <a:srgbClr val="D9D1C7"/>
             </a:solidFill>
           </a:ln>
         </p:spPr>
@@ -13730,7 +14737,7 @@
             <a:avLst/>
           </a:prstGeom>
           <a:solidFill>
-            <a:srgbClr val="F26B3A"/>
+            <a:srgbClr val="B65A34"/>
           </a:solidFill>
           <a:ln>
             <a:noFill/>
@@ -13790,6 +14797,12 @@
               </a:defRPr>
             </a:pPr>
             <a:r>
+              <a:rPr>
+                <a:solidFill>
+                  <a:srgbClr val="1F2937"/>
+                </a:solidFill>
+                <a:latin typeface="Aptos"/>
+              </a:rPr>
               <a:t>The best growth pocket</a:t>
             </a:r>
           </a:p>
@@ -13826,6 +14839,12 @@
               </a:defRPr>
             </a:pPr>
             <a:r>
+              <a:rPr>
+                <a:solidFill>
+                  <a:srgbClr val="1F2937"/>
+                </a:solidFill>
+                <a:latin typeface="Aptos"/>
+              </a:rPr>
               <a:t>A narrower calendar-first planning use case fits the product better than generic to-do positioning.</a:t>
             </a:r>
           </a:p>
@@ -13846,11 +14865,11 @@
             <a:avLst/>
           </a:prstGeom>
           <a:solidFill>
-            <a:srgbClr val="E8F0FF"/>
+            <a:srgbClr val="FFFDF9"/>
           </a:solidFill>
           <a:ln>
             <a:solidFill>
-              <a:srgbClr val="2563EB"/>
+              <a:srgbClr val="D9D1C7"/>
             </a:solidFill>
           </a:ln>
         </p:spPr>
@@ -13892,7 +14911,7 @@
             <a:avLst/>
           </a:prstGeom>
           <a:solidFill>
-            <a:srgbClr val="2563EB"/>
+            <a:srgbClr val="B65A34"/>
           </a:solidFill>
           <a:ln>
             <a:noFill/>
@@ -13952,6 +14971,12 @@
               </a:defRPr>
             </a:pPr>
             <a:r>
+              <a:rPr>
+                <a:solidFill>
+                  <a:srgbClr val="1F2937"/>
+                </a:solidFill>
+                <a:latin typeface="Aptos"/>
+              </a:rPr>
               <a:t>Where to focus first</a:t>
             </a:r>
           </a:p>
@@ -13988,6 +15013,12 @@
               </a:defRPr>
             </a:pPr>
             <a:r>
+              <a:rPr>
+                <a:solidFill>
+                  <a:srgbClr val="1F2937"/>
+                </a:solidFill>
+                <a:latin typeface="Aptos"/>
+              </a:rPr>
               <a:t>US, UK, Canada and Australia already drive most revenue. I would fix the product there before chasing cheaper installs elsewhere.</a:t>
             </a:r>
           </a:p>
@@ -14048,6 +15079,12 @@
               </a:defRPr>
             </a:pPr>
             <a:r>
+              <a:rPr>
+                <a:solidFill>
+                  <a:srgbClr val="667085"/>
+                </a:solidFill>
+                <a:latin typeface="Aptos"/>
+              </a:rPr>
               <a:t>Sources: Mordor Intelligence; TechCrunch on Sensor Tower State of Mobile 2026; Gartner AI predictions.</a:t>
             </a:r>
           </a:p>
@@ -14084,6 +15121,12 @@
               </a:defRPr>
             </a:pPr>
             <a:r>
+              <a:rPr>
+                <a:solidFill>
+                  <a:srgbClr val="667085"/>
+                </a:solidFill>
+                <a:latin typeface="Aptos"/>
+              </a:rPr>
               <a:t>6</a:t>
             </a:r>
           </a:p>
@@ -14103,7 +15146,7 @@
     <p:bg>
       <p:bgPr>
         <a:solidFill>
-          <a:srgbClr val="F7F3EE"/>
+          <a:srgbClr val="FBF8F3"/>
         </a:solidFill>
         <a:effectLst/>
       </p:bgPr>
@@ -14153,6 +15196,12 @@
               </a:defRPr>
             </a:pPr>
             <a:r>
+              <a:rPr>
+                <a:solidFill>
+                  <a:srgbClr val="1F2937"/>
+                </a:solidFill>
+                <a:latin typeface="Aptos"/>
+              </a:rPr>
               <a:t>What stronger players do differently</a:t>
             </a:r>
           </a:p>
@@ -14173,7 +15222,7 @@
             <a:avLst/>
           </a:prstGeom>
           <a:solidFill>
-            <a:srgbClr val="F26B3A"/>
+            <a:srgbClr val="B65A34"/>
           </a:solidFill>
           <a:ln>
             <a:noFill/>
@@ -14217,11 +15266,11 @@
             <a:avLst/>
           </a:prstGeom>
           <a:solidFill>
-            <a:srgbClr val="FEECEC"/>
+            <a:srgbClr val="FFFDF9"/>
           </a:solidFill>
           <a:ln>
             <a:solidFill>
-              <a:srgbClr val="B42318"/>
+              <a:srgbClr val="D9D1C7"/>
             </a:solidFill>
           </a:ln>
         </p:spPr>
@@ -14263,7 +15312,7 @@
             <a:avLst/>
           </a:prstGeom>
           <a:solidFill>
-            <a:srgbClr val="B42318"/>
+            <a:srgbClr val="B65A34"/>
           </a:solidFill>
           <a:ln>
             <a:noFill/>
@@ -14323,6 +15372,12 @@
               </a:defRPr>
             </a:pPr>
             <a:r>
+              <a:rPr>
+                <a:solidFill>
+                  <a:srgbClr val="1F2937"/>
+                </a:solidFill>
+                <a:latin typeface="Aptos"/>
+              </a:rPr>
               <a:t>TaskFlow today</a:t>
             </a:r>
           </a:p>
@@ -14359,6 +15414,12 @@
               </a:defRPr>
             </a:pPr>
             <a:r>
+              <a:rPr>
+                <a:solidFill>
+                  <a:srgbClr val="1F2937"/>
+                </a:solidFill>
+                <a:latin typeface="Aptos"/>
+              </a:rPr>
               <a:t>Generic promise, weak collaboration, no offline mode, stale UX, too much paid dependence.</a:t>
             </a:r>
           </a:p>
@@ -14379,11 +15440,11 @@
             <a:avLst/>
           </a:prstGeom>
           <a:solidFill>
-            <a:srgbClr val="E8F0FF"/>
+            <a:srgbClr val="FFFDF9"/>
           </a:solidFill>
           <a:ln>
             <a:solidFill>
-              <a:srgbClr val="2563EB"/>
+              <a:srgbClr val="D9D1C7"/>
             </a:solidFill>
           </a:ln>
         </p:spPr>
@@ -14425,7 +15486,7 @@
             <a:avLst/>
           </a:prstGeom>
           <a:solidFill>
-            <a:srgbClr val="2563EB"/>
+            <a:srgbClr val="B65A34"/>
           </a:solidFill>
           <a:ln>
             <a:noFill/>
@@ -14485,6 +15546,12 @@
               </a:defRPr>
             </a:pPr>
             <a:r>
+              <a:rPr>
+                <a:solidFill>
+                  <a:srgbClr val="1F2937"/>
+                </a:solidFill>
+                <a:latin typeface="Aptos"/>
+              </a:rPr>
               <a:t>Todoist</a:t>
             </a:r>
           </a:p>
@@ -14521,6 +15588,12 @@
               </a:defRPr>
             </a:pPr>
             <a:r>
+              <a:rPr>
+                <a:solidFill>
+                  <a:srgbClr val="1F2937"/>
+                </a:solidFill>
+                <a:latin typeface="Aptos"/>
+              </a:rPr>
               <a:t>Wins on templates, content and integrations. It feels easier to start for a concrete job to be done.</a:t>
             </a:r>
           </a:p>
@@ -14541,11 +15614,11 @@
             <a:avLst/>
           </a:prstGeom>
           <a:solidFill>
-            <a:srgbClr val="E9F8EE"/>
+            <a:srgbClr val="FFFDF9"/>
           </a:solidFill>
           <a:ln>
             <a:solidFill>
-              <a:srgbClr val="15803D"/>
+              <a:srgbClr val="D9D1C7"/>
             </a:solidFill>
           </a:ln>
         </p:spPr>
@@ -14587,7 +15660,7 @@
             <a:avLst/>
           </a:prstGeom>
           <a:solidFill>
-            <a:srgbClr val="15803D"/>
+            <a:srgbClr val="B65A34"/>
           </a:solidFill>
           <a:ln>
             <a:noFill/>
@@ -14647,6 +15720,12 @@
               </a:defRPr>
             </a:pPr>
             <a:r>
+              <a:rPr>
+                <a:solidFill>
+                  <a:srgbClr val="1F2937"/>
+                </a:solidFill>
+                <a:latin typeface="Aptos"/>
+              </a:rPr>
               <a:t>TickTick</a:t>
             </a:r>
           </a:p>
@@ -14683,6 +15762,12 @@
               </a:defRPr>
             </a:pPr>
             <a:r>
+              <a:rPr>
+                <a:solidFill>
+                  <a:srgbClr val="1F2937"/>
+                </a:solidFill>
+                <a:latin typeface="Aptos"/>
+              </a:rPr>
               <a:t>Wins on bundled value: tasks, calendar, habits, focus tools and strong annual pricing.</a:t>
             </a:r>
           </a:p>
@@ -14703,11 +15788,11 @@
             <a:avLst/>
           </a:prstGeom>
           <a:solidFill>
-            <a:srgbClr val="FFF7D6"/>
+            <a:srgbClr val="FFFDF9"/>
           </a:solidFill>
           <a:ln>
             <a:solidFill>
-              <a:srgbClr val="CA8A04"/>
+              <a:srgbClr val="D9D1C7"/>
             </a:solidFill>
           </a:ln>
         </p:spPr>
@@ -14749,7 +15834,7 @@
             <a:avLst/>
           </a:prstGeom>
           <a:solidFill>
-            <a:srgbClr val="CA8A04"/>
+            <a:srgbClr val="B65A34"/>
           </a:solidFill>
           <a:ln>
             <a:noFill/>
@@ -14809,6 +15894,12 @@
               </a:defRPr>
             </a:pPr>
             <a:r>
+              <a:rPr>
+                <a:solidFill>
+                  <a:srgbClr val="1F2937"/>
+                </a:solidFill>
+                <a:latin typeface="Aptos"/>
+              </a:rPr>
               <a:t>Any.do</a:t>
             </a:r>
           </a:p>
@@ -14845,6 +15936,12 @@
               </a:defRPr>
             </a:pPr>
             <a:r>
+              <a:rPr>
+                <a:solidFill>
+                  <a:srgbClr val="1F2937"/>
+                </a:solidFill>
+                <a:latin typeface="Aptos"/>
+              </a:rPr>
               <a:t>Wins on clearer shared-planning packaging through Family and Workspace flows.</a:t>
             </a:r>
           </a:p>
@@ -14865,11 +15962,11 @@
             <a:avLst/>
           </a:prstGeom>
           <a:solidFill>
-            <a:srgbClr val="FFF0E8"/>
+            <a:srgbClr val="FFFDF9"/>
           </a:solidFill>
           <a:ln>
             <a:solidFill>
-              <a:srgbClr val="F26B3A"/>
+              <a:srgbClr val="D9D1C7"/>
             </a:solidFill>
           </a:ln>
         </p:spPr>
@@ -14911,7 +16008,7 @@
             <a:avLst/>
           </a:prstGeom>
           <a:solidFill>
-            <a:srgbClr val="F26B3A"/>
+            <a:srgbClr val="B65A34"/>
           </a:solidFill>
           <a:ln>
             <a:noFill/>
@@ -14971,6 +16068,12 @@
               </a:defRPr>
             </a:pPr>
             <a:r>
+              <a:rPr>
+                <a:solidFill>
+                  <a:srgbClr val="1F2937"/>
+                </a:solidFill>
+                <a:latin typeface="Aptos"/>
+              </a:rPr>
               <a:t>Microsoft To Do</a:t>
             </a:r>
           </a:p>
@@ -15007,6 +16110,12 @@
               </a:defRPr>
             </a:pPr>
             <a:r>
+              <a:rPr>
+                <a:solidFill>
+                  <a:srgbClr val="1F2937"/>
+                </a:solidFill>
+                <a:latin typeface="Aptos"/>
+              </a:rPr>
               <a:t>Wins distribution through Outlook and the Microsoft ecosystem, not just paid UA.</a:t>
             </a:r>
           </a:p>
@@ -15043,6 +16152,12 @@
               </a:defRPr>
             </a:pPr>
             <a:r>
+              <a:rPr>
+                <a:solidFill>
+                  <a:srgbClr val="1F2937"/>
+                </a:solidFill>
+                <a:latin typeface="Aptos"/>
+              </a:rPr>
               <a:t>Lesson: TaskFlow does not need feature parity. It needs one sharper promise and fewer missing basics.</a:t>
             </a:r>
           </a:p>
@@ -15079,6 +16194,12 @@
               </a:defRPr>
             </a:pPr>
             <a:r>
+              <a:rPr>
+                <a:solidFill>
+                  <a:srgbClr val="667085"/>
+                </a:solidFill>
+                <a:latin typeface="Aptos"/>
+              </a:rPr>
               <a:t>Sources: Todoist, TickTick, Any.do and Microsoft To Do official pages + Google Play listings.</a:t>
             </a:r>
           </a:p>
@@ -15115,6 +16236,12 @@
               </a:defRPr>
             </a:pPr>
             <a:r>
+              <a:rPr>
+                <a:solidFill>
+                  <a:srgbClr val="667085"/>
+                </a:solidFill>
+                <a:latin typeface="Aptos"/>
+              </a:rPr>
               <a:t>7</a:t>
             </a:r>
           </a:p>
@@ -15134,7 +16261,7 @@
     <p:bg>
       <p:bgPr>
         <a:solidFill>
-          <a:srgbClr val="F7F3EE"/>
+          <a:srgbClr val="FBF8F3"/>
         </a:solidFill>
         <a:effectLst/>
       </p:bgPr>
@@ -15184,6 +16311,12 @@
               </a:defRPr>
             </a:pPr>
             <a:r>
+              <a:rPr>
+                <a:solidFill>
+                  <a:srgbClr val="1F2937"/>
+                </a:solidFill>
+                <a:latin typeface="Aptos"/>
+              </a:rPr>
               <a:t>Where TaskFlow still has room to win</a:t>
             </a:r>
           </a:p>
@@ -15204,7 +16337,7 @@
             <a:avLst/>
           </a:prstGeom>
           <a:solidFill>
-            <a:srgbClr val="F26B3A"/>
+            <a:srgbClr val="B65A34"/>
           </a:solidFill>
           <a:ln>
             <a:noFill/>
@@ -15248,11 +16381,11 @@
             <a:avLst/>
           </a:prstGeom>
           <a:solidFill>
-            <a:srgbClr val="E8F0FF"/>
+            <a:srgbClr val="F7EFE6"/>
           </a:solidFill>
           <a:ln>
             <a:solidFill>
-              <a:srgbClr val="2563EB"/>
+              <a:srgbClr val="B65A34"/>
             </a:solidFill>
           </a:ln>
         </p:spPr>
@@ -15294,7 +16427,7 @@
             <a:avLst/>
           </a:prstGeom>
           <a:solidFill>
-            <a:srgbClr val="2563EB"/>
+            <a:srgbClr val="B65A34"/>
           </a:solidFill>
           <a:ln>
             <a:noFill/>
@@ -15354,6 +16487,12 @@
               </a:defRPr>
             </a:pPr>
             <a:r>
+              <a:rPr>
+                <a:solidFill>
+                  <a:srgbClr val="1F2937"/>
+                </a:solidFill>
+                <a:latin typeface="Aptos"/>
+              </a:rPr>
               <a:t>1. Faster first value</a:t>
             </a:r>
           </a:p>
@@ -15390,6 +16529,12 @@
               </a:defRPr>
             </a:pPr>
             <a:r>
+              <a:rPr>
+                <a:solidFill>
+                  <a:srgbClr val="1F2937"/>
+                </a:solidFill>
+                <a:latin typeface="Aptos"/>
+              </a:rPr>
               <a:t>Onboarding, templates and calendar setup can make the product useful in the first session.</a:t>
             </a:r>
           </a:p>
@@ -15410,11 +16555,11 @@
             <a:avLst/>
           </a:prstGeom>
           <a:solidFill>
-            <a:srgbClr val="FFF7D6"/>
+            <a:srgbClr val="FFFDF9"/>
           </a:solidFill>
           <a:ln>
             <a:solidFill>
-              <a:srgbClr val="CA8A04"/>
+              <a:srgbClr val="D9D1C7"/>
             </a:solidFill>
           </a:ln>
         </p:spPr>
@@ -15456,7 +16601,7 @@
             <a:avLst/>
           </a:prstGeom>
           <a:solidFill>
-            <a:srgbClr val="CA8A04"/>
+            <a:srgbClr val="B65A34"/>
           </a:solidFill>
           <a:ln>
             <a:noFill/>
@@ -15516,6 +16661,12 @@
               </a:defRPr>
             </a:pPr>
             <a:r>
+              <a:rPr>
+                <a:solidFill>
+                  <a:srgbClr val="1F2937"/>
+                </a:solidFill>
+                <a:latin typeface="Aptos"/>
+              </a:rPr>
               <a:t>2. Better micro-collaboration</a:t>
             </a:r>
           </a:p>
@@ -15552,6 +16703,12 @@
               </a:defRPr>
             </a:pPr>
             <a:r>
+              <a:rPr>
+                <a:solidFill>
+                  <a:srgbClr val="1F2937"/>
+                </a:solidFill>
+                <a:latin typeface="Aptos"/>
+              </a:rPr>
               <a:t>The opening is 2-5 person planning, not complex team workflows.</a:t>
             </a:r>
           </a:p>
@@ -15572,11 +16729,11 @@
             <a:avLst/>
           </a:prstGeom>
           <a:solidFill>
-            <a:srgbClr val="FFF0E8"/>
+            <a:srgbClr val="FFFDF9"/>
           </a:solidFill>
           <a:ln>
             <a:solidFill>
-              <a:srgbClr val="F26B3A"/>
+              <a:srgbClr val="D9D1C7"/>
             </a:solidFill>
           </a:ln>
         </p:spPr>
@@ -15618,7 +16775,7 @@
             <a:avLst/>
           </a:prstGeom>
           <a:solidFill>
-            <a:srgbClr val="F26B3A"/>
+            <a:srgbClr val="B65A34"/>
           </a:solidFill>
           <a:ln>
             <a:noFill/>
@@ -15678,6 +16835,12 @@
               </a:defRPr>
             </a:pPr>
             <a:r>
+              <a:rPr>
+                <a:solidFill>
+                  <a:srgbClr val="1F2937"/>
+                </a:solidFill>
+                <a:latin typeface="Aptos"/>
+              </a:rPr>
               <a:t>3. Less paid dependence</a:t>
             </a:r>
           </a:p>
@@ -15714,6 +16877,12 @@
               </a:defRPr>
             </a:pPr>
             <a:r>
+              <a:rPr>
+                <a:solidFill>
+                  <a:srgbClr val="1F2937"/>
+                </a:solidFill>
+                <a:latin typeface="Aptos"/>
+              </a:rPr>
               <a:t>Competitors use templates, content, referrals and ecosystems. TaskFlow over-relies on paid social.</a:t>
             </a:r>
           </a:p>
@@ -15734,11 +16903,11 @@
             <a:avLst/>
           </a:prstGeom>
           <a:solidFill>
-            <a:srgbClr val="FEECEC"/>
+            <a:srgbClr val="FFFDF9"/>
           </a:solidFill>
           <a:ln>
             <a:solidFill>
-              <a:srgbClr val="B42318"/>
+              <a:srgbClr val="D9D1C7"/>
             </a:solidFill>
           </a:ln>
         </p:spPr>
@@ -15780,10 +16949,12 @@
             <a:avLst/>
           </a:prstGeom>
           <a:solidFill>
-            <a:srgbClr val="B42318"/>
+            <a:srgbClr val="F7EFE6"/>
           </a:solidFill>
           <a:ln>
-            <a:noFill/>
+            <a:solidFill>
+              <a:srgbClr val="B65A34"/>
+            </a:solidFill>
           </a:ln>
         </p:spPr>
         <p:style>
@@ -15840,6 +17011,12 @@
               </a:defRPr>
             </a:pPr>
             <a:r>
+              <a:rPr>
+                <a:solidFill>
+                  <a:srgbClr val="1F2937"/>
+                </a:solidFill>
+                <a:latin typeface="Aptos"/>
+              </a:rPr>
               <a:t>4. Product freshness</a:t>
             </a:r>
           </a:p>
@@ -15876,6 +17053,12 @@
               </a:defRPr>
             </a:pPr>
             <a:r>
+              <a:rPr>
+                <a:solidFill>
+                  <a:srgbClr val="1F2937"/>
+                </a:solidFill>
+                <a:latin typeface="Aptos"/>
+              </a:rPr>
               <a:t>Shipping visible basics matters. Reviews suggest users no longer trust the product to keep improving.</a:t>
             </a:r>
           </a:p>
@@ -15896,11 +17079,11 @@
             <a:avLst/>
           </a:prstGeom>
           <a:solidFill>
-            <a:srgbClr val="E9F8EE"/>
+            <a:srgbClr val="FFFDF9"/>
           </a:solidFill>
           <a:ln>
             <a:solidFill>
-              <a:srgbClr val="15803D"/>
+              <a:srgbClr val="D9D1C7"/>
             </a:solidFill>
           </a:ln>
         </p:spPr>
@@ -15942,7 +17125,7 @@
             <a:avLst/>
           </a:prstGeom>
           <a:solidFill>
-            <a:srgbClr val="15803D"/>
+            <a:srgbClr val="B65A34"/>
           </a:solidFill>
           <a:ln>
             <a:noFill/>
@@ -16002,6 +17185,12 @@
               </a:defRPr>
             </a:pPr>
             <a:r>
+              <a:rPr>
+                <a:solidFill>
+                  <a:srgbClr val="1F2937"/>
+                </a:solidFill>
+                <a:latin typeface="Aptos"/>
+              </a:rPr>
               <a:t>The growth thesis</a:t>
             </a:r>
           </a:p>
@@ -16038,6 +17227,12 @@
               </a:defRPr>
             </a:pPr>
             <a:r>
+              <a:rPr>
+                <a:solidFill>
+                  <a:srgbClr val="1F2937"/>
+                </a:solidFill>
+                <a:latin typeface="Aptos"/>
+              </a:rPr>
               <a:t>TaskFlow should not try to out-feature everyone. The opening is a cleaner calendar-first planner for solo professionals, freelancers and very small shared workflows.</a:t>
             </a:r>
           </a:p>
@@ -16074,6 +17269,12 @@
               </a:defRPr>
             </a:pPr>
             <a:r>
+              <a:rPr>
+                <a:solidFill>
+                  <a:srgbClr val="667085"/>
+                </a:solidFill>
+                <a:latin typeface="Aptos"/>
+              </a:rPr>
               <a:t>Sources: Competitor public pages and store listings; case prompt review themes.</a:t>
             </a:r>
           </a:p>
@@ -16110,6 +17311,12 @@
               </a:defRPr>
             </a:pPr>
             <a:r>
+              <a:rPr>
+                <a:solidFill>
+                  <a:srgbClr val="667085"/>
+                </a:solidFill>
+                <a:latin typeface="Aptos"/>
+              </a:rPr>
               <a:t>8</a:t>
             </a:r>
           </a:p>
@@ -16129,7 +17336,7 @@
     <p:bg>
       <p:bgPr>
         <a:solidFill>
-          <a:srgbClr val="F7F3EE"/>
+          <a:srgbClr val="FBF8F3"/>
         </a:solidFill>
         <a:effectLst/>
       </p:bgPr>
@@ -16179,6 +17386,12 @@
               </a:defRPr>
             </a:pPr>
             <a:r>
+              <a:rPr>
+                <a:solidFill>
+                  <a:srgbClr val="1F2937"/>
+                </a:solidFill>
+                <a:latin typeface="Aptos"/>
+              </a:rPr>
               <a:t>The strategic choice</a:t>
             </a:r>
           </a:p>
@@ -16199,7 +17412,7 @@
             <a:avLst/>
           </a:prstGeom>
           <a:solidFill>
-            <a:srgbClr val="F26B3A"/>
+            <a:srgbClr val="B65A34"/>
           </a:solidFill>
           <a:ln>
             <a:noFill/>
@@ -16243,11 +17456,11 @@
             <a:avLst/>
           </a:prstGeom>
           <a:solidFill>
-            <a:srgbClr val="E9F8EE"/>
+            <a:srgbClr val="FFFDF9"/>
           </a:solidFill>
           <a:ln>
             <a:solidFill>
-              <a:srgbClr val="15803D"/>
+              <a:srgbClr val="D9D1C7"/>
             </a:solidFill>
           </a:ln>
         </p:spPr>
@@ -16289,7 +17502,7 @@
             <a:avLst/>
           </a:prstGeom>
           <a:solidFill>
-            <a:srgbClr val="15803D"/>
+            <a:srgbClr val="B65A34"/>
           </a:solidFill>
           <a:ln>
             <a:noFill/>
@@ -16349,6 +17562,12 @@
               </a:defRPr>
             </a:pPr>
             <a:r>
+              <a:rPr>
+                <a:solidFill>
+                  <a:srgbClr val="1F2937"/>
+                </a:solidFill>
+                <a:latin typeface="Aptos"/>
+              </a:rPr>
               <a:t>Option A | Fix and narrow</a:t>
             </a:r>
           </a:p>
@@ -16385,6 +17604,12 @@
               </a:defRPr>
             </a:pPr>
             <a:r>
+              <a:rPr>
+                <a:solidFill>
+                  <a:srgbClr val="1F2937"/>
+                </a:solidFill>
+                <a:latin typeface="Aptos"/>
+              </a:rPr>
               <a:t>Why I would say yes</a:t>
             </a:r>
           </a:p>
@@ -16398,6 +17623,12 @@
               </a:defRPr>
             </a:pPr>
             <a:r>
+              <a:rPr>
+                <a:solidFill>
+                  <a:srgbClr val="1F2937"/>
+                </a:solidFill>
+                <a:latin typeface="Aptos"/>
+              </a:rPr>
               <a:t>Attacks the real leak, fits the current team, and can show progress inside 2-3 quarters.</a:t>
             </a:r>
           </a:p>
@@ -16421,6 +17652,12 @@
               </a:defRPr>
             </a:pPr>
             <a:r>
+              <a:rPr>
+                <a:solidFill>
+                  <a:srgbClr val="1F2937"/>
+                </a:solidFill>
+                <a:latin typeface="Aptos"/>
+              </a:rPr>
               <a:t>Main downside</a:t>
             </a:r>
           </a:p>
@@ -16434,6 +17671,12 @@
               </a:defRPr>
             </a:pPr>
             <a:r>
+              <a:rPr>
+                <a:solidFill>
+                  <a:srgbClr val="1F2937"/>
+                </a:solidFill>
+                <a:latin typeface="Aptos"/>
+              </a:rPr>
               <a:t>Requires discipline to stay narrow.</a:t>
             </a:r>
           </a:p>
@@ -16454,11 +17697,11 @@
             <a:avLst/>
           </a:prstGeom>
           <a:solidFill>
-            <a:srgbClr val="E8F0FF"/>
+            <a:srgbClr val="FFFDF9"/>
           </a:solidFill>
           <a:ln>
             <a:solidFill>
-              <a:srgbClr val="2563EB"/>
+              <a:srgbClr val="D9D1C7"/>
             </a:solidFill>
           </a:ln>
         </p:spPr>
@@ -16500,7 +17743,7 @@
             <a:avLst/>
           </a:prstGeom>
           <a:solidFill>
-            <a:srgbClr val="2563EB"/>
+            <a:srgbClr val="B65A34"/>
           </a:solidFill>
           <a:ln>
             <a:noFill/>
@@ -16560,6 +17803,12 @@
               </a:defRPr>
             </a:pPr>
             <a:r>
+              <a:rPr>
+                <a:solidFill>
+                  <a:srgbClr val="1F2937"/>
+                </a:solidFill>
+                <a:latin typeface="Aptos"/>
+              </a:rPr>
               <a:t>Option B | Full AI pivot</a:t>
             </a:r>
           </a:p>
@@ -16596,6 +17845,12 @@
               </a:defRPr>
             </a:pPr>
             <a:r>
+              <a:rPr>
+                <a:solidFill>
+                  <a:srgbClr val="1F2937"/>
+                </a:solidFill>
+                <a:latin typeface="Aptos"/>
+              </a:rPr>
               <a:t>Why I would hesitate</a:t>
             </a:r>
           </a:p>
@@ -16609,6 +17864,12 @@
               </a:defRPr>
             </a:pPr>
             <a:r>
+              <a:rPr>
+                <a:solidFill>
+                  <a:srgbClr val="1F2937"/>
+                </a:solidFill>
+                <a:latin typeface="Aptos"/>
+              </a:rPr>
               <a:t>Attractive theme, but it is a much bigger repositioning with higher product risk, stronger incumbents and extra cost.</a:t>
             </a:r>
           </a:p>
@@ -16632,6 +17893,12 @@
               </a:defRPr>
             </a:pPr>
             <a:r>
+              <a:rPr>
+                <a:solidFill>
+                  <a:srgbClr val="1F2937"/>
+                </a:solidFill>
+                <a:latin typeface="Aptos"/>
+              </a:rPr>
               <a:t>Main downside</a:t>
             </a:r>
           </a:p>
@@ -16645,6 +17912,12 @@
               </a:defRPr>
             </a:pPr>
             <a:r>
+              <a:rPr>
+                <a:solidFill>
+                  <a:srgbClr val="1F2937"/>
+                </a:solidFill>
+                <a:latin typeface="Aptos"/>
+              </a:rPr>
               <a:t>Too much uncertainty for the current runway.</a:t>
             </a:r>
           </a:p>
@@ -16665,11 +17938,11 @@
             <a:avLst/>
           </a:prstGeom>
           <a:solidFill>
-            <a:srgbClr val="FFF7D6"/>
+            <a:srgbClr val="FFFDF9"/>
           </a:solidFill>
           <a:ln>
             <a:solidFill>
-              <a:srgbClr val="CA8A04"/>
+              <a:srgbClr val="D9D1C7"/>
             </a:solidFill>
           </a:ln>
         </p:spPr>
@@ -16711,7 +17984,7 @@
             <a:avLst/>
           </a:prstGeom>
           <a:solidFill>
-            <a:srgbClr val="CA8A04"/>
+            <a:srgbClr val="B65A34"/>
           </a:solidFill>
           <a:ln>
             <a:noFill/>
@@ -16771,6 +18044,12 @@
               </a:defRPr>
             </a:pPr>
             <a:r>
+              <a:rPr>
+                <a:solidFill>
+                  <a:srgbClr val="1F2937"/>
+                </a:solidFill>
+                <a:latin typeface="Aptos"/>
+              </a:rPr>
               <a:t>Option C | Chase cheaper users</a:t>
             </a:r>
           </a:p>
@@ -16807,6 +18086,12 @@
               </a:defRPr>
             </a:pPr>
             <a:r>
+              <a:rPr>
+                <a:solidFill>
+                  <a:srgbClr val="1F2937"/>
+                </a:solidFill>
+                <a:latin typeface="Aptos"/>
+              </a:rPr>
               <a:t>Why I would say no for now</a:t>
             </a:r>
           </a:p>
@@ -16820,6 +18105,12 @@
               </a:defRPr>
             </a:pPr>
             <a:r>
+              <a:rPr>
+                <a:solidFill>
+                  <a:srgbClr val="1F2937"/>
+                </a:solidFill>
+                <a:latin typeface="Aptos"/>
+              </a:rPr>
               <a:t>It may improve install volume and headline CPI, but it does not solve retention and can weaken the revenue mix.</a:t>
             </a:r>
           </a:p>
@@ -16843,6 +18134,12 @@
               </a:defRPr>
             </a:pPr>
             <a:r>
+              <a:rPr>
+                <a:solidFill>
+                  <a:srgbClr val="1F2937"/>
+                </a:solidFill>
+                <a:latin typeface="Aptos"/>
+              </a:rPr>
               <a:t>Main downside</a:t>
             </a:r>
           </a:p>
@@ -16856,6 +18153,12 @@
               </a:defRPr>
             </a:pPr>
             <a:r>
+              <a:rPr>
+                <a:solidFill>
+                  <a:srgbClr val="1F2937"/>
+                </a:solidFill>
+                <a:latin typeface="Aptos"/>
+              </a:rPr>
               <a:t>Looks like growth without value.</a:t>
             </a:r>
           </a:p>
@@ -16876,11 +18179,11 @@
             <a:avLst/>
           </a:prstGeom>
           <a:solidFill>
-            <a:srgbClr val="FFF0E8"/>
+            <a:srgbClr val="F7EFE6"/>
           </a:solidFill>
           <a:ln>
             <a:solidFill>
-              <a:srgbClr val="F26B3A"/>
+              <a:srgbClr val="B65A34"/>
             </a:solidFill>
           </a:ln>
         </p:spPr>
@@ -16922,7 +18225,7 @@
             <a:avLst/>
           </a:prstGeom>
           <a:solidFill>
-            <a:srgbClr val="F26B3A"/>
+            <a:srgbClr val="B65A34"/>
           </a:solidFill>
           <a:ln>
             <a:noFill/>
@@ -16982,6 +18285,12 @@
               </a:defRPr>
             </a:pPr>
             <a:r>
+              <a:rPr>
+                <a:solidFill>
+                  <a:srgbClr val="1F2937"/>
+                </a:solidFill>
+                <a:latin typeface="Aptos"/>
+              </a:rPr>
               <a:t>Why I would pick A</a:t>
             </a:r>
           </a:p>
@@ -17018,6 +18327,12 @@
               </a:defRPr>
             </a:pPr>
             <a:r>
+              <a:rPr>
+                <a:solidFill>
+                  <a:srgbClr val="1F2937"/>
+                </a:solidFill>
+                <a:latin typeface="Aptos"/>
+              </a:rPr>
               <a:t>It attacks the real leak fastest, fits the 12-person team, and preserves the option to pivot later if the recovery stalls.</a:t>
             </a:r>
           </a:p>
@@ -17054,6 +18369,12 @@
               </a:defRPr>
             </a:pPr>
             <a:r>
+              <a:rPr>
+                <a:solidFill>
+                  <a:srgbClr val="667085"/>
+                </a:solidFill>
+                <a:latin typeface="Aptos"/>
+              </a:rPr>
               <a:t>Sources: Own strategic evaluation based on task brief, market data and competitor benchmark.</a:t>
             </a:r>
           </a:p>
@@ -17090,6 +18411,12 @@
               </a:defRPr>
             </a:pPr>
             <a:r>
+              <a:rPr>
+                <a:solidFill>
+                  <a:srgbClr val="667085"/>
+                </a:solidFill>
+                <a:latin typeface="Aptos"/>
+              </a:rPr>
               <a:t>9</a:t>
             </a:r>
           </a:p>

</xml_diff>

<commit_message>
Sync resaved presentation and PDF export
</commit_message>
<xml_diff>
--- a/deliverables/taskflow-case-presentation.pptx
+++ b/deliverables/taskflow-case-presentation.pptx
@@ -221,7 +221,7 @@
           <a:p>
             <a:fld id="{14A6344B-C0EF-4530-9BF6-D6F784C10354}" type="datetimeFigureOut">
               <a:rPr lang="en-US" smtClean="0"/>
-              <a:t>3/23/2026</a:t>
+              <a:t>4/8/2026</a:t>
             </a:fld>
             <a:endParaRPr lang="en-US"/>
           </a:p>
@@ -1853,7 +1853,7 @@
           <a:p>
             <a:fld id="{5BCAD085-E8A6-8845-BD4E-CB4CCA059FC4}" type="datetimeFigureOut">
               <a:rPr lang="en-US" smtClean="0"/>
-              <a:t>3/23/2026</a:t>
+              <a:t>4/8/2026</a:t>
             </a:fld>
             <a:endParaRPr lang="en-US"/>
           </a:p>
@@ -2021,7 +2021,7 @@
           <a:p>
             <a:fld id="{5BCAD085-E8A6-8845-BD4E-CB4CCA059FC4}" type="datetimeFigureOut">
               <a:rPr lang="en-US" smtClean="0"/>
-              <a:t>3/23/2026</a:t>
+              <a:t>4/8/2026</a:t>
             </a:fld>
             <a:endParaRPr lang="en-US"/>
           </a:p>
@@ -2199,7 +2199,7 @@
           <a:p>
             <a:fld id="{5BCAD085-E8A6-8845-BD4E-CB4CCA059FC4}" type="datetimeFigureOut">
               <a:rPr lang="en-US" smtClean="0"/>
-              <a:t>3/23/2026</a:t>
+              <a:t>4/8/2026</a:t>
             </a:fld>
             <a:endParaRPr lang="en-US"/>
           </a:p>
@@ -2367,7 +2367,7 @@
           <a:p>
             <a:fld id="{5BCAD085-E8A6-8845-BD4E-CB4CCA059FC4}" type="datetimeFigureOut">
               <a:rPr lang="en-US" smtClean="0"/>
-              <a:t>3/23/2026</a:t>
+              <a:t>4/8/2026</a:t>
             </a:fld>
             <a:endParaRPr lang="en-US"/>
           </a:p>
@@ -2612,7 +2612,7 @@
           <a:p>
             <a:fld id="{5BCAD085-E8A6-8845-BD4E-CB4CCA059FC4}" type="datetimeFigureOut">
               <a:rPr lang="en-US" smtClean="0"/>
-              <a:t>3/23/2026</a:t>
+              <a:t>4/8/2026</a:t>
             </a:fld>
             <a:endParaRPr lang="en-US"/>
           </a:p>
@@ -2897,7 +2897,7 @@
           <a:p>
             <a:fld id="{5BCAD085-E8A6-8845-BD4E-CB4CCA059FC4}" type="datetimeFigureOut">
               <a:rPr lang="en-US" smtClean="0"/>
-              <a:t>3/23/2026</a:t>
+              <a:t>4/8/2026</a:t>
             </a:fld>
             <a:endParaRPr lang="en-US"/>
           </a:p>
@@ -3316,7 +3316,7 @@
           <a:p>
             <a:fld id="{5BCAD085-E8A6-8845-BD4E-CB4CCA059FC4}" type="datetimeFigureOut">
               <a:rPr lang="en-US" smtClean="0"/>
-              <a:t>3/23/2026</a:t>
+              <a:t>4/8/2026</a:t>
             </a:fld>
             <a:endParaRPr lang="en-US"/>
           </a:p>
@@ -3433,7 +3433,7 @@
           <a:p>
             <a:fld id="{5BCAD085-E8A6-8845-BD4E-CB4CCA059FC4}" type="datetimeFigureOut">
               <a:rPr lang="en-US" smtClean="0"/>
-              <a:t>3/23/2026</a:t>
+              <a:t>4/8/2026</a:t>
             </a:fld>
             <a:endParaRPr lang="en-US"/>
           </a:p>
@@ -3528,7 +3528,7 @@
           <a:p>
             <a:fld id="{5BCAD085-E8A6-8845-BD4E-CB4CCA059FC4}" type="datetimeFigureOut">
               <a:rPr lang="en-US" smtClean="0"/>
-              <a:t>3/23/2026</a:t>
+              <a:t>4/8/2026</a:t>
             </a:fld>
             <a:endParaRPr lang="en-US"/>
           </a:p>
@@ -3803,7 +3803,7 @@
           <a:p>
             <a:fld id="{5BCAD085-E8A6-8845-BD4E-CB4CCA059FC4}" type="datetimeFigureOut">
               <a:rPr lang="en-US" smtClean="0"/>
-              <a:t>3/23/2026</a:t>
+              <a:t>4/8/2026</a:t>
             </a:fld>
             <a:endParaRPr lang="en-US"/>
           </a:p>
@@ -4055,7 +4055,7 @@
           <a:p>
             <a:fld id="{5BCAD085-E8A6-8845-BD4E-CB4CCA059FC4}" type="datetimeFigureOut">
               <a:rPr lang="en-US" smtClean="0"/>
-              <a:t>3/23/2026</a:t>
+              <a:t>4/8/2026</a:t>
             </a:fld>
             <a:endParaRPr lang="en-US"/>
           </a:p>
@@ -4266,7 +4266,7 @@
           <a:p>
             <a:fld id="{5BCAD085-E8A6-8845-BD4E-CB4CCA059FC4}" type="datetimeFigureOut">
               <a:rPr lang="en-US" smtClean="0"/>
-              <a:t>3/23/2026</a:t>
+              <a:t>4/8/2026</a:t>
             </a:fld>
             <a:endParaRPr lang="en-US"/>
           </a:p>
@@ -4689,7 +4689,7 @@
           <a:lstStyle/>
           <a:p>
             <a:pPr algn="ctr"/>
-            <a:endParaRPr/>
+            <a:endParaRPr dirty="0"/>
           </a:p>
         </p:txBody>
       </p:sp>
@@ -4856,7 +4856,7 @@
           <a:lstStyle/>
           <a:p>
             <a:r>
-              <a:rPr sz="1250" b="1">
+              <a:rPr sz="1250" b="1" dirty="0">
                 <a:solidFill>
                   <a:srgbClr val="1F2937"/>
                 </a:solidFill>
@@ -4896,7 +4896,7 @@
               </a:defRPr>
             </a:pPr>
             <a:r>
-              <a:rPr sz="1500" b="1">
+              <a:rPr sz="1500" b="1" dirty="0">
                 <a:solidFill>
                   <a:srgbClr val="1F2937"/>
                 </a:solidFill>
@@ -4907,7 +4907,7 @@
           </a:p>
           <a:p>
             <a:r>
-              <a:rPr sz="1500" b="1">
+              <a:rPr sz="1500" b="1" dirty="0">
                 <a:solidFill>
                   <a:srgbClr val="1F2937"/>
                 </a:solidFill>
@@ -5095,7 +5095,7 @@
         <p:spPr>
           <a:xfrm>
             <a:off x="9326880" y="914400"/>
-            <a:ext cx="2286000" cy="365760"/>
+            <a:ext cx="2286000" cy="443198"/>
           </a:xfrm>
           <a:prstGeom prst="rect">
             <a:avLst/>
@@ -5117,9 +5117,9 @@
               </a:defRPr>
             </a:pPr>
             <a:r>
-              <a:rPr>
-                <a:solidFill>
-                  <a:srgbClr val="1F2937"/>
+              <a:rPr dirty="0">
+                <a:solidFill>
+                  <a:schemeClr val="bg1"/>
                 </a:solidFill>
                 <a:latin typeface="Aptos"/>
               </a:rPr>
@@ -5137,7 +5137,7 @@
         <p:spPr>
           <a:xfrm>
             <a:off x="9144000" y="1234440"/>
-            <a:ext cx="2651760" cy="822960"/>
+            <a:ext cx="2651760" cy="597087"/>
           </a:xfrm>
           <a:prstGeom prst="rect">
             <a:avLst/>
@@ -5159,9 +5159,9 @@
               </a:defRPr>
             </a:pPr>
             <a:r>
-              <a:rPr>
-                <a:solidFill>
-                  <a:srgbClr val="1F2937"/>
+              <a:rPr dirty="0">
+                <a:solidFill>
+                  <a:schemeClr val="bg1"/>
                 </a:solidFill>
                 <a:latin typeface="Aptos"/>
               </a:rPr>
@@ -5201,7 +5201,7 @@
               </a:defRPr>
             </a:pPr>
             <a:r>
-              <a:rPr sz="1200">
+              <a:rPr sz="1200" dirty="0">
                 <a:solidFill>
                   <a:srgbClr val="FFFDF9"/>
                 </a:solidFill>
@@ -5212,18 +5212,18 @@
           </a:p>
           <a:p>
             <a:r>
-              <a:rPr sz="1200">
+              <a:rPr sz="1200" dirty="0">
                 <a:solidFill>
                   <a:srgbClr val="FFFDF9"/>
                 </a:solidFill>
                 <a:latin typeface="Aptos"/>
               </a:rPr>
-              <a:t>- redesigned deck</a:t>
-            </a:r>
-          </a:p>
-          <a:p>
-            <a:r>
-              <a:rPr sz="1200">
+              <a:t>- designed deck</a:t>
+            </a:r>
+          </a:p>
+          <a:p>
+            <a:r>
+              <a:rPr sz="1200" dirty="0">
                 <a:solidFill>
                   <a:srgbClr val="FFFDF9"/>
                 </a:solidFill>
@@ -5234,7 +5234,7 @@
           </a:p>
           <a:p>
             <a:r>
-              <a:rPr sz="1200">
+              <a:rPr sz="1200" dirty="0">
                 <a:solidFill>
                   <a:srgbClr val="FFFDF9"/>
                 </a:solidFill>
@@ -5245,7 +5245,7 @@
           </a:p>
           <a:p>
             <a:r>
-              <a:rPr sz="1200">
+              <a:rPr sz="1200" dirty="0">
                 <a:solidFill>
                   <a:srgbClr val="FFFDF9"/>
                 </a:solidFill>
@@ -5402,7 +5402,7 @@
         </p:nvSpPr>
         <p:spPr>
           <a:xfrm>
-            <a:off x="5577840" y="4754880"/>
+            <a:off x="6612484" y="5808797"/>
             <a:ext cx="2011680" cy="640080"/>
           </a:xfrm>
           <a:prstGeom prst="rect">
@@ -5436,6 +5436,7 @@
           <a:lstStyle/>
           <a:p>
             <a:pPr algn="ctr"/>
+            <a:endParaRPr/>
           </a:p>
         </p:txBody>
       </p:sp>
@@ -5447,7 +5448,7 @@
         </p:nvSpPr>
         <p:spPr>
           <a:xfrm>
-            <a:off x="5650992" y="4809744"/>
+            <a:off x="6775704" y="5918525"/>
             <a:ext cx="1865376" cy="530352"/>
           </a:xfrm>
           <a:prstGeom prst="rect">
@@ -5470,6 +5471,7 @@
               </a:defRPr>
             </a:pPr>
             <a:r>
+              <a:rPr dirty="0"/>
               <a:t>This is the sentence I would defend in the room.</a:t>
             </a:r>
           </a:p>
@@ -6700,7 +6702,7 @@
         </p:nvSpPr>
         <p:spPr>
           <a:xfrm>
-            <a:off x="658368" y="5303520"/>
+            <a:off x="658368" y="5102352"/>
             <a:ext cx="10972800" cy="384048"/>
           </a:xfrm>
           <a:prstGeom prst="rect">
@@ -6723,13 +6725,31 @@
               </a:defRPr>
             </a:pPr>
             <a:r>
-              <a:rPr sz="1200" b="1" i="1">
+              <a:rPr sz="1200" b="1" i="1" dirty="0">
                 <a:solidFill>
                   <a:srgbClr val="B65A34"/>
                 </a:solidFill>
                 <a:latin typeface="Georgia"/>
               </a:rPr>
-              <a:t>This is a sequencing plan, not a wishlist.</a:t>
+              <a:t>This is a sequencing plan, not a </a:t>
+            </a:r>
+            <a:r>
+              <a:rPr sz="1200" b="1" i="1" dirty="0" err="1">
+                <a:solidFill>
+                  <a:srgbClr val="B65A34"/>
+                </a:solidFill>
+                <a:latin typeface="Georgia"/>
+              </a:rPr>
+              <a:t>wishlist</a:t>
+            </a:r>
+            <a:r>
+              <a:rPr sz="1200" b="1" i="1" dirty="0">
+                <a:solidFill>
+                  <a:srgbClr val="B65A34"/>
+                </a:solidFill>
+                <a:latin typeface="Georgia"/>
+              </a:rPr>
+              <a:t>.</a:t>
             </a:r>
           </a:p>
         </p:txBody>
@@ -6860,6 +6880,7 @@
           <a:lstStyle/>
           <a:p>
             <a:pPr algn="ctr"/>
+            <a:endParaRPr/>
           </a:p>
         </p:txBody>
       </p:sp>
@@ -8120,7 +8141,7 @@
         </p:nvSpPr>
         <p:spPr>
           <a:xfrm>
-            <a:off x="658368" y="1024128"/>
+            <a:off x="640080" y="1148546"/>
             <a:ext cx="1005840" cy="73152"/>
           </a:xfrm>
           <a:prstGeom prst="roundRect">
@@ -8828,6 +8849,7 @@
           <a:lstStyle/>
           <a:p>
             <a:pPr algn="ctr"/>
+            <a:endParaRPr/>
           </a:p>
         </p:txBody>
       </p:sp>
@@ -8961,7 +8983,7 @@
         </p:nvSpPr>
         <p:spPr>
           <a:xfrm>
-            <a:off x="658368" y="1024128"/>
+            <a:off x="640080" y="1170432"/>
             <a:ext cx="1005840" cy="73152"/>
           </a:xfrm>
           <a:prstGeom prst="roundRect">
@@ -10167,7 +10189,7 @@
         <p:spPr>
           <a:xfrm>
             <a:off x="786384" y="1911096"/>
-            <a:ext cx="4855464" cy="3721608"/>
+            <a:ext cx="4855464" cy="2062103"/>
           </a:xfrm>
           <a:prstGeom prst="rect">
             <a:avLst/>
@@ -10181,7 +10203,7 @@
           <a:lstStyle/>
           <a:p>
             <a:r>
-              <a:rPr>
+              <a:rPr sz="1600" dirty="0">
                 <a:solidFill>
                   <a:srgbClr val="1F2937"/>
                 </a:solidFill>
@@ -10192,7 +10214,7 @@
           </a:p>
           <a:p>
             <a:r>
-              <a:rPr>
+              <a:rPr sz="1600" dirty="0">
                 <a:solidFill>
                   <a:srgbClr val="1F2937"/>
                 </a:solidFill>
@@ -10203,51 +10225,123 @@
           </a:p>
           <a:p>
             <a:r>
-              <a:rPr>
-                <a:solidFill>
-                  <a:srgbClr val="1F2937"/>
-                </a:solidFill>
-                <a:latin typeface="Aptos"/>
-              </a:rPr>
-              <a:t>3. Todoist template gallery</a:t>
-            </a:r>
-          </a:p>
-          <a:p>
-            <a:r>
-              <a:rPr>
-                <a:solidFill>
-                  <a:srgbClr val="1F2937"/>
-                </a:solidFill>
-                <a:latin typeface="Aptos"/>
-              </a:rPr>
-              <a:t>4. Todoist pricing update 2025</a:t>
-            </a:r>
-          </a:p>
-          <a:p>
-            <a:r>
-              <a:rPr>
-                <a:solidFill>
-                  <a:srgbClr val="1F2937"/>
-                </a:solidFill>
-                <a:latin typeface="Aptos"/>
-              </a:rPr>
-              <a:t>5. TickTick upgrade page</a:t>
-            </a:r>
-          </a:p>
-          <a:p>
-            <a:r>
-              <a:rPr>
-                <a:solidFill>
-                  <a:srgbClr val="1F2937"/>
-                </a:solidFill>
-                <a:latin typeface="Aptos"/>
-              </a:rPr>
-              <a:t>6. TickTick ambassador program</a:t>
-            </a:r>
-          </a:p>
-          <a:p>
-            <a:r>
-              <a:rPr>
+              <a:rPr sz="1600" dirty="0">
+                <a:solidFill>
+                  <a:srgbClr val="1F2937"/>
+                </a:solidFill>
+                <a:latin typeface="Aptos"/>
+              </a:rPr>
+              <a:t>3. </a:t>
+            </a:r>
+            <a:r>
+              <a:rPr sz="1600" dirty="0" err="1">
+                <a:solidFill>
+                  <a:srgbClr val="1F2937"/>
+                </a:solidFill>
+                <a:latin typeface="Aptos"/>
+              </a:rPr>
+              <a:t>Todoist</a:t>
+            </a:r>
+            <a:r>
+              <a:rPr sz="1600" dirty="0">
+                <a:solidFill>
+                  <a:srgbClr val="1F2937"/>
+                </a:solidFill>
+                <a:latin typeface="Aptos"/>
+              </a:rPr>
+              <a:t> template gallery</a:t>
+            </a:r>
+          </a:p>
+          <a:p>
+            <a:r>
+              <a:rPr sz="1600" dirty="0">
+                <a:solidFill>
+                  <a:srgbClr val="1F2937"/>
+                </a:solidFill>
+                <a:latin typeface="Aptos"/>
+              </a:rPr>
+              <a:t>4. </a:t>
+            </a:r>
+            <a:r>
+              <a:rPr sz="1600" dirty="0" err="1">
+                <a:solidFill>
+                  <a:srgbClr val="1F2937"/>
+                </a:solidFill>
+                <a:latin typeface="Aptos"/>
+              </a:rPr>
+              <a:t>Todoist</a:t>
+            </a:r>
+            <a:r>
+              <a:rPr sz="1600" dirty="0">
+                <a:solidFill>
+                  <a:srgbClr val="1F2937"/>
+                </a:solidFill>
+                <a:latin typeface="Aptos"/>
+              </a:rPr>
+              <a:t> pricing update 2025</a:t>
+            </a:r>
+          </a:p>
+          <a:p>
+            <a:r>
+              <a:rPr sz="1600" dirty="0">
+                <a:solidFill>
+                  <a:srgbClr val="1F2937"/>
+                </a:solidFill>
+                <a:latin typeface="Aptos"/>
+              </a:rPr>
+              <a:t>5. </a:t>
+            </a:r>
+            <a:r>
+              <a:rPr sz="1600" dirty="0" err="1">
+                <a:solidFill>
+                  <a:srgbClr val="1F2937"/>
+                </a:solidFill>
+                <a:latin typeface="Aptos"/>
+              </a:rPr>
+              <a:t>TickTick</a:t>
+            </a:r>
+            <a:r>
+              <a:rPr sz="1600" dirty="0">
+                <a:solidFill>
+                  <a:srgbClr val="1F2937"/>
+                </a:solidFill>
+                <a:latin typeface="Aptos"/>
+              </a:rPr>
+              <a:t> upgrade page</a:t>
+            </a:r>
+          </a:p>
+          <a:p>
+            <a:r>
+              <a:rPr sz="1600" dirty="0">
+                <a:solidFill>
+                  <a:srgbClr val="1F2937"/>
+                </a:solidFill>
+                <a:latin typeface="Aptos"/>
+              </a:rPr>
+              <a:t>6. </a:t>
+            </a:r>
+            <a:r>
+              <a:rPr sz="1600" dirty="0" err="1">
+                <a:solidFill>
+                  <a:srgbClr val="1F2937"/>
+                </a:solidFill>
+                <a:latin typeface="Aptos"/>
+              </a:rPr>
+              <a:t>TickTick</a:t>
+            </a:r>
+            <a:r>
+              <a:rPr sz="1600" dirty="0">
+                <a:solidFill>
+                  <a:srgbClr val="1F2937"/>
+                </a:solidFill>
+                <a:latin typeface="Aptos"/>
+              </a:rPr>
+              <a:t> ambassador program</a:t>
+            </a:r>
+          </a:p>
+          <a:p>
+            <a:r>
+              <a:rPr sz="1600" dirty="0">
                 <a:solidFill>
                   <a:srgbClr val="1F2937"/>
                 </a:solidFill>
@@ -10258,7 +10352,7 @@
           </a:p>
           <a:p>
             <a:r>
-              <a:rPr>
+              <a:rPr sz="1600" dirty="0">
                 <a:solidFill>
                   <a:srgbClr val="1F2937"/>
                 </a:solidFill>
@@ -10366,7 +10460,7 @@
         <p:spPr>
           <a:xfrm>
             <a:off x="6135624" y="1911096"/>
-            <a:ext cx="5358384" cy="2192908"/>
+            <a:ext cx="5358384" cy="2677656"/>
           </a:xfrm>
           <a:prstGeom prst="rect">
             <a:avLst/>
@@ -10380,91 +10474,219 @@
           <a:lstStyle/>
           <a:p>
             <a:r>
-              <a:rPr>
-                <a:solidFill>
-                  <a:srgbClr val="1F2937"/>
-                </a:solidFill>
-                <a:latin typeface="Aptos"/>
+              <a:rPr sz="1400" dirty="0">
+                <a:solidFill>
+                  <a:srgbClr val="1F2937"/>
+                </a:solidFill>
+                <a:latin typeface="Aptos"/>
+                <a:hlinkClick r:id="rId3"/>
               </a:rPr>
               <a:t>https://www.mordorintelligence.com/industry-reports/task-management-software-market</a:t>
             </a:r>
-          </a:p>
-          <a:p>
-            <a:r>
-              <a:rPr>
-                <a:solidFill>
-                  <a:srgbClr val="1F2937"/>
-                </a:solidFill>
-                <a:latin typeface="Aptos"/>
+            <a:r>
+              <a:rPr lang="uk-UA" sz="1400" dirty="0">
+                <a:solidFill>
+                  <a:srgbClr val="1F2937"/>
+                </a:solidFill>
+                <a:latin typeface="Aptos"/>
+              </a:rPr>
+              <a:t> </a:t>
+            </a:r>
+            <a:endParaRPr sz="1400" dirty="0">
+              <a:solidFill>
+                <a:srgbClr val="1F2937"/>
+              </a:solidFill>
+              <a:latin typeface="Aptos"/>
+            </a:endParaRPr>
+          </a:p>
+          <a:p>
+            <a:r>
+              <a:rPr sz="1400" dirty="0">
+                <a:solidFill>
+                  <a:srgbClr val="1F2937"/>
+                </a:solidFill>
+                <a:latin typeface="Aptos"/>
+                <a:hlinkClick r:id="rId4"/>
               </a:rPr>
               <a:t>https://techcrunch.com/2026/01/21/consumers-spent-more-on-mobile-apps-than-games-in-2025-driven-by-ai-app-adoption/</a:t>
             </a:r>
-          </a:p>
-          <a:p>
-            <a:r>
-              <a:rPr>
-                <a:solidFill>
-                  <a:srgbClr val="1F2937"/>
-                </a:solidFill>
-                <a:latin typeface="Aptos"/>
+            <a:r>
+              <a:rPr lang="uk-UA" sz="1400" dirty="0">
+                <a:solidFill>
+                  <a:srgbClr val="1F2937"/>
+                </a:solidFill>
+                <a:latin typeface="Aptos"/>
+              </a:rPr>
+              <a:t> </a:t>
+            </a:r>
+            <a:endParaRPr sz="1400" dirty="0">
+              <a:solidFill>
+                <a:srgbClr val="1F2937"/>
+              </a:solidFill>
+              <a:latin typeface="Aptos"/>
+            </a:endParaRPr>
+          </a:p>
+          <a:p>
+            <a:r>
+              <a:rPr sz="1400" dirty="0">
+                <a:solidFill>
+                  <a:srgbClr val="1F2937"/>
+                </a:solidFill>
+                <a:latin typeface="Aptos"/>
+                <a:hlinkClick r:id="rId5"/>
               </a:rPr>
               <a:t>https://www.todoist.com/templates/getting-things-done</a:t>
             </a:r>
-          </a:p>
-          <a:p>
-            <a:r>
-              <a:rPr>
-                <a:solidFill>
-                  <a:srgbClr val="1F2937"/>
-                </a:solidFill>
-                <a:latin typeface="Aptos"/>
+            <a:r>
+              <a:rPr lang="uk-UA" sz="1400" dirty="0">
+                <a:solidFill>
+                  <a:srgbClr val="1F2937"/>
+                </a:solidFill>
+                <a:latin typeface="Aptos"/>
+              </a:rPr>
+              <a:t> </a:t>
+            </a:r>
+            <a:endParaRPr sz="1400" dirty="0">
+              <a:solidFill>
+                <a:srgbClr val="1F2937"/>
+              </a:solidFill>
+              <a:latin typeface="Aptos"/>
+            </a:endParaRPr>
+          </a:p>
+          <a:p>
+            <a:r>
+              <a:rPr sz="1400" dirty="0">
+                <a:solidFill>
+                  <a:srgbClr val="1F2937"/>
+                </a:solidFill>
+                <a:latin typeface="Aptos"/>
+                <a:hlinkClick r:id="rId6"/>
               </a:rPr>
               <a:t>https://www.todoist.com/help/articles/todoist-pricing-and-plans-update-2025-everything-you-need-to-know-Tn6Pg1JKI</a:t>
             </a:r>
-          </a:p>
-          <a:p>
-            <a:r>
-              <a:rPr>
-                <a:solidFill>
-                  <a:srgbClr val="1F2937"/>
-                </a:solidFill>
-                <a:latin typeface="Aptos"/>
+            <a:r>
+              <a:rPr lang="uk-UA" sz="1400" dirty="0">
+                <a:solidFill>
+                  <a:srgbClr val="1F2937"/>
+                </a:solidFill>
+                <a:latin typeface="Aptos"/>
+              </a:rPr>
+              <a:t> </a:t>
+            </a:r>
+            <a:endParaRPr sz="1400" dirty="0">
+              <a:solidFill>
+                <a:srgbClr val="1F2937"/>
+              </a:solidFill>
+              <a:latin typeface="Aptos"/>
+            </a:endParaRPr>
+          </a:p>
+          <a:p>
+            <a:r>
+              <a:rPr sz="1400" dirty="0">
+                <a:solidFill>
+                  <a:srgbClr val="1F2937"/>
+                </a:solidFill>
+                <a:latin typeface="Aptos"/>
+                <a:hlinkClick r:id="rId7"/>
               </a:rPr>
               <a:t>https://ticktick.com/upgrade</a:t>
             </a:r>
-          </a:p>
-          <a:p>
-            <a:r>
-              <a:rPr>
-                <a:solidFill>
-                  <a:srgbClr val="1F2937"/>
-                </a:solidFill>
-                <a:latin typeface="Aptos"/>
+            <a:r>
+              <a:rPr lang="uk-UA" sz="1400" dirty="0">
+                <a:solidFill>
+                  <a:srgbClr val="1F2937"/>
+                </a:solidFill>
+                <a:latin typeface="Aptos"/>
+              </a:rPr>
+              <a:t> </a:t>
+            </a:r>
+            <a:endParaRPr sz="1400" dirty="0">
+              <a:solidFill>
+                <a:srgbClr val="1F2937"/>
+              </a:solidFill>
+              <a:latin typeface="Aptos"/>
+            </a:endParaRPr>
+          </a:p>
+          <a:p>
+            <a:r>
+              <a:rPr sz="1400" dirty="0">
+                <a:solidFill>
+                  <a:srgbClr val="1F2937"/>
+                </a:solidFill>
+                <a:latin typeface="Aptos"/>
+                <a:hlinkClick r:id="rId8"/>
               </a:rPr>
               <a:t>https://ticktick.com/ambassador_program</a:t>
             </a:r>
-          </a:p>
-          <a:p>
-            <a:r>
-              <a:rPr>
-                <a:solidFill>
-                  <a:srgbClr val="1F2937"/>
-                </a:solidFill>
-                <a:latin typeface="Aptos"/>
+            <a:r>
+              <a:rPr lang="uk-UA" sz="1400" dirty="0">
+                <a:solidFill>
+                  <a:srgbClr val="1F2937"/>
+                </a:solidFill>
+                <a:latin typeface="Aptos"/>
+              </a:rPr>
+              <a:t> </a:t>
+            </a:r>
+            <a:endParaRPr sz="1400" dirty="0">
+              <a:solidFill>
+                <a:srgbClr val="1F2937"/>
+              </a:solidFill>
+              <a:latin typeface="Aptos"/>
+            </a:endParaRPr>
+          </a:p>
+          <a:p>
+            <a:r>
+              <a:rPr sz="1400" dirty="0">
+                <a:solidFill>
+                  <a:srgbClr val="1F2937"/>
+                </a:solidFill>
+                <a:latin typeface="Aptos"/>
+                <a:hlinkClick r:id="rId9"/>
               </a:rPr>
               <a:t>https://www.any.do/pricing</a:t>
             </a:r>
-          </a:p>
-          <a:p>
-            <a:r>
-              <a:rPr>
-                <a:solidFill>
-                  <a:srgbClr val="1F2937"/>
-                </a:solidFill>
-                <a:latin typeface="Aptos"/>
+            <a:r>
+              <a:rPr lang="uk-UA" sz="1400" dirty="0">
+                <a:solidFill>
+                  <a:srgbClr val="1F2937"/>
+                </a:solidFill>
+                <a:latin typeface="Aptos"/>
+              </a:rPr>
+              <a:t> </a:t>
+            </a:r>
+            <a:endParaRPr sz="1400" dirty="0">
+              <a:solidFill>
+                <a:srgbClr val="1F2937"/>
+              </a:solidFill>
+              <a:latin typeface="Aptos"/>
+            </a:endParaRPr>
+          </a:p>
+          <a:p>
+            <a:r>
+              <a:rPr sz="1400" dirty="0">
+                <a:solidFill>
+                  <a:srgbClr val="1F2937"/>
+                </a:solidFill>
+                <a:latin typeface="Aptos"/>
+                <a:hlinkClick r:id="rId10"/>
               </a:rPr>
               <a:t>https://support.microsoft.com/en-us/office/using-microsoft-to-do-with-outlook-tasks-c7a0253d-b8cc-4054-b94b-c194e0e5308a</a:t>
             </a:r>
+            <a:r>
+              <a:rPr lang="uk-UA" sz="1400" dirty="0">
+                <a:solidFill>
+                  <a:srgbClr val="1F2937"/>
+                </a:solidFill>
+                <a:latin typeface="Aptos"/>
+              </a:rPr>
+              <a:t> </a:t>
+            </a:r>
+            <a:endParaRPr sz="1400" dirty="0">
+              <a:solidFill>
+                <a:srgbClr val="1F2937"/>
+              </a:solidFill>
+              <a:latin typeface="Aptos"/>
+            </a:endParaRPr>
           </a:p>
         </p:txBody>
       </p:sp>
@@ -10476,7 +10698,7 @@
         </p:nvSpPr>
         <p:spPr>
           <a:xfrm>
-            <a:off x="640080" y="5486400"/>
+            <a:off x="488748" y="5833872"/>
             <a:ext cx="10927080" cy="859536"/>
           </a:xfrm>
           <a:prstGeom prst="roundRect">
@@ -10522,8 +10744,8 @@
         </p:nvSpPr>
         <p:spPr>
           <a:xfrm>
-            <a:off x="640080" y="5486400"/>
-            <a:ext cx="73152" cy="685800"/>
+            <a:off x="640080" y="5825728"/>
+            <a:ext cx="82296" cy="648224"/>
           </a:xfrm>
           <a:prstGeom prst="rect">
             <a:avLst/>
@@ -10566,8 +10788,8 @@
         </p:nvSpPr>
         <p:spPr>
           <a:xfrm>
-            <a:off x="786383" y="5596128"/>
-            <a:ext cx="1416489" cy="923330"/>
+            <a:off x="801674" y="5874527"/>
+            <a:ext cx="2768084" cy="284693"/>
           </a:xfrm>
           <a:prstGeom prst="rect">
             <a:avLst/>
@@ -10587,13 +10809,13 @@
               </a:defRPr>
             </a:pPr>
             <a:r>
-              <a:rPr sz="1250" b="1">
-                <a:solidFill>
-                  <a:srgbClr val="1F2937"/>
-                </a:solidFill>
-                <a:latin typeface="Aptos"/>
-              </a:rPr>
-              <a:t>Why this version feels different</a:t>
+              <a:rPr lang="en-US" sz="1250" b="1">
+                <a:solidFill>
+                  <a:srgbClr val="1F2937"/>
+                </a:solidFill>
+                <a:latin typeface="Aptos"/>
+              </a:rPr>
+              <a:t>Why these sources matter</a:t>
             </a:r>
             <a:endParaRPr lang="en-US" dirty="0"/>
           </a:p>
@@ -10607,8 +10829,8 @@
         </p:nvSpPr>
         <p:spPr>
           <a:xfrm>
-            <a:off x="786384" y="5916168"/>
-            <a:ext cx="10707624" cy="738664"/>
+            <a:off x="786384" y="6168628"/>
+            <a:ext cx="10707624" cy="261610"/>
           </a:xfrm>
           <a:prstGeom prst="rect">
             <a:avLst/>
@@ -10630,14 +10852,38 @@
               </a:defRPr>
             </a:pPr>
             <a:r>
-              <a:rPr sz="1100">
-                <a:solidFill>
-                  <a:srgbClr val="1F2937"/>
-                </a:solidFill>
-                <a:latin typeface="Aptos"/>
-              </a:rPr>
-              <a:t>It is less about describing the problem and more about showing what I would do next, what numbers I would watch, and when I would refuse to scale.</a:t>
-            </a:r>
+              <a:rPr lang="en-US" sz="1100" dirty="0">
+                <a:solidFill>
+                  <a:srgbClr val="1F2937"/>
+                </a:solidFill>
+                <a:latin typeface="Aptos"/>
+              </a:rPr>
+              <a:t>Together, they show that the market is still healthy, competitors are raising the bar, and </a:t>
+            </a:r>
+            <a:r>
+              <a:rPr lang="en-US" sz="1100" dirty="0" err="1">
+                <a:solidFill>
+                  <a:srgbClr val="1F2937"/>
+                </a:solidFill>
+                <a:latin typeface="Aptos"/>
+              </a:rPr>
+              <a:t>TaskFlow’s</a:t>
+            </a:r>
+            <a:r>
+              <a:rPr lang="en-US" sz="1100" dirty="0">
+                <a:solidFill>
+                  <a:srgbClr val="1F2937"/>
+                </a:solidFill>
+                <a:latin typeface="Aptos"/>
+              </a:rPr>
+              <a:t> problem is execution and positioning — not category decline.</a:t>
+            </a:r>
+            <a:endParaRPr sz="1100" dirty="0">
+              <a:solidFill>
+                <a:srgbClr val="1F2937"/>
+              </a:solidFill>
+              <a:latin typeface="Aptos"/>
+            </a:endParaRPr>
           </a:p>
         </p:txBody>
       </p:sp>
@@ -10781,7 +11027,7 @@
               </a:defRPr>
             </a:pPr>
             <a:r>
-              <a:rPr sz="2500" b="1">
+              <a:rPr sz="2500" b="1" dirty="0">
                 <a:solidFill>
                   <a:srgbClr val="1F2937"/>
                 </a:solidFill>
@@ -10792,7 +11038,7 @@
           </a:p>
           <a:p>
             <a:r>
-              <a:rPr sz="2500" b="1">
+              <a:rPr sz="2500" b="1" dirty="0">
                 <a:solidFill>
                   <a:srgbClr val="1F2937"/>
                 </a:solidFill>
@@ -10811,8 +11057,8 @@
         </p:nvSpPr>
         <p:spPr>
           <a:xfrm>
-            <a:off x="658368" y="1024128"/>
-            <a:ext cx="1005840" cy="73152"/>
+            <a:off x="621793" y="1147572"/>
+            <a:ext cx="952484" cy="77724"/>
           </a:xfrm>
           <a:prstGeom prst="roundRect">
             <a:avLst/>
@@ -10855,7 +11101,7 @@
         </p:nvSpPr>
         <p:spPr>
           <a:xfrm>
-            <a:off x="640080" y="1143000"/>
+            <a:off x="640080" y="1184148"/>
             <a:ext cx="10515600" cy="411480"/>
           </a:xfrm>
           <a:prstGeom prst="rect">
@@ -10878,13 +11124,31 @@
               </a:defRPr>
             </a:pPr>
             <a:r>
-              <a:rPr sz="1200">
+              <a:rPr sz="1200" dirty="0">
                 <a:solidFill>
                   <a:srgbClr val="667085"/>
                 </a:solidFill>
                 <a:latin typeface="Aptos"/>
               </a:rPr>
-              <a:t>If I had to summarize the case in one line: TaskFlow stopped earning repeat usage.</a:t>
+              <a:t>If I had to summarize the case in one line: </a:t>
+            </a:r>
+            <a:r>
+              <a:rPr sz="1200" dirty="0" err="1">
+                <a:solidFill>
+                  <a:srgbClr val="667085"/>
+                </a:solidFill>
+                <a:latin typeface="Aptos"/>
+              </a:rPr>
+              <a:t>TaskFlow</a:t>
+            </a:r>
+            <a:r>
+              <a:rPr sz="1200" dirty="0">
+                <a:solidFill>
+                  <a:srgbClr val="667085"/>
+                </a:solidFill>
+                <a:latin typeface="Aptos"/>
+              </a:rPr>
+              <a:t> stopped earning repeat usage.</a:t>
             </a:r>
           </a:p>
         </p:txBody>
@@ -11753,6 +12017,7 @@
           <a:lstStyle/>
           <a:p>
             <a:pPr algn="ctr"/>
+            <a:endParaRPr/>
           </a:p>
         </p:txBody>
       </p:sp>
@@ -11764,8 +12029,8 @@
         </p:nvSpPr>
         <p:spPr>
           <a:xfrm>
-            <a:off x="8851392" y="5038344"/>
-            <a:ext cx="2139696" cy="621792"/>
+            <a:off x="8851392" y="4983480"/>
+            <a:ext cx="2286000" cy="769441"/>
           </a:xfrm>
           <a:prstGeom prst="rect">
             <a:avLst/>
@@ -11787,12 +12052,17 @@
               </a:defRPr>
             </a:pPr>
             <a:r>
-              <a:t>Less ?more features?.</a:t>
-            </a:r>
-            <a:br/>
-            <a:r>
-              <a:t>More ?why would I come back tomorrow??.</a:t>
-            </a:r>
+              <a:rPr lang="en-US" sz="1100" dirty="0"/>
+              <a:t>The real question is not “What else can we add?”</a:t>
+            </a:r>
+            <a:br>
+              <a:rPr lang="en-US" sz="1100" i="1" dirty="0"/>
+            </a:br>
+            <a:r>
+              <a:rPr lang="en-US" sz="1100" dirty="0"/>
+              <a:t>It is “Why would users come back tomorrow?”</a:t>
+            </a:r>
+            <a:endParaRPr dirty="0"/>
           </a:p>
         </p:txBody>
       </p:sp>
@@ -13736,6 +14006,7 @@
           <a:lstStyle/>
           <a:p>
             <a:pPr algn="ctr"/>
+            <a:endParaRPr/>
           </a:p>
         </p:txBody>
       </p:sp>
@@ -14802,6 +15073,7 @@
           <a:lstStyle/>
           <a:p>
             <a:pPr algn="ctr"/>
+            <a:endParaRPr/>
           </a:p>
         </p:txBody>
       </p:sp>
@@ -17786,7 +18058,7 @@
         </p:nvSpPr>
         <p:spPr>
           <a:xfrm>
-            <a:off x="8961120" y="4754880"/>
+            <a:off x="8951976" y="4879549"/>
             <a:ext cx="2194560" cy="713232"/>
           </a:xfrm>
           <a:prstGeom prst="rect">
@@ -17820,6 +18092,7 @@
           <a:lstStyle/>
           <a:p>
             <a:pPr algn="ctr"/>
+            <a:endParaRPr/>
           </a:p>
         </p:txBody>
       </p:sp>
@@ -17831,7 +18104,7 @@
         </p:nvSpPr>
         <p:spPr>
           <a:xfrm>
-            <a:off x="9034272" y="4809744"/>
+            <a:off x="9034272" y="4978908"/>
             <a:ext cx="2048256" cy="603504"/>
           </a:xfrm>
           <a:prstGeom prst="rect">
@@ -17953,7 +18226,7 @@
         </p:nvSpPr>
         <p:spPr>
           <a:xfrm>
-            <a:off x="658368" y="1024128"/>
+            <a:off x="658368" y="1117230"/>
             <a:ext cx="1005840" cy="73152"/>
           </a:xfrm>
           <a:prstGeom prst="roundRect">
@@ -18189,6 +18462,12 @@
                 <a:latin typeface="Segoe UI"/>
               </a:defRPr>
             </a:pPr>
+            <a:endParaRPr>
+              <a:solidFill>
+                <a:srgbClr val="1F2937"/>
+              </a:solidFill>
+              <a:latin typeface="Aptos"/>
+            </a:endParaRPr>
           </a:p>
           <a:p>
             <a:pPr>
@@ -18430,6 +18709,12 @@
                 <a:latin typeface="Segoe UI"/>
               </a:defRPr>
             </a:pPr>
+            <a:endParaRPr>
+              <a:solidFill>
+                <a:srgbClr val="1F2937"/>
+              </a:solidFill>
+              <a:latin typeface="Aptos"/>
+            </a:endParaRPr>
           </a:p>
           <a:p>
             <a:pPr>
@@ -18671,6 +18956,12 @@
                 <a:latin typeface="Segoe UI"/>
               </a:defRPr>
             </a:pPr>
+            <a:endParaRPr>
+              <a:solidFill>
+                <a:srgbClr val="1F2937"/>
+              </a:solidFill>
+              <a:latin typeface="Aptos"/>
+            </a:endParaRPr>
           </a:p>
           <a:p>
             <a:pPr>

</xml_diff>

<commit_message>
Add proof points and soften deck visuals
</commit_message>
<xml_diff>
--- a/deliverables/taskflow-case-presentation.pptx
+++ b/deliverables/taskflow-case-presentation.pptx
@@ -4651,6 +4651,135 @@
       </p:grpSpPr>
       <p:sp>
         <p:nvSpPr>
+          <p:cNvPr id="22" name="codex-bg-3"/>
+          <p:cNvSpPr/>
+          <p:nvPr/>
+        </p:nvSpPr>
+        <p:spPr>
+          <a:xfrm>
+            <a:off x="10195560" y="4526280"/>
+            <a:ext cx="1920240" cy="1325880"/>
+          </a:xfrm>
+          <a:prstGeom prst="ellipse">
+            <a:avLst/>
+          </a:prstGeom>
+          <a:solidFill>
+            <a:srgbClr val="E8E1D7"/>
+          </a:solidFill>
+          <a:ln>
+            <a:noFill/>
+          </a:ln>
+        </p:spPr>
+        <p:style>
+          <a:lnRef idx="1">
+            <a:schemeClr val="accent1"/>
+          </a:lnRef>
+          <a:fillRef idx="3">
+            <a:schemeClr val="accent1"/>
+          </a:fillRef>
+          <a:effectRef idx="2">
+            <a:schemeClr val="accent1"/>
+          </a:effectRef>
+          <a:fontRef idx="minor">
+            <a:schemeClr val="lt1"/>
+          </a:fontRef>
+        </p:style>
+        <p:txBody>
+          <a:bodyPr rtlCol="0" anchor="ctr"/>
+          <a:lstStyle/>
+          <a:p>
+            <a:pPr algn="ctr"/>
+          </a:p>
+        </p:txBody>
+      </p:sp>
+      <p:sp>
+        <p:nvSpPr>
+          <p:cNvPr id="21" name="codex-bg-2"/>
+          <p:cNvSpPr/>
+          <p:nvPr/>
+        </p:nvSpPr>
+        <p:spPr>
+          <a:xfrm>
+            <a:off x="9281160" y="-548640"/>
+            <a:ext cx="3886200" cy="2514600"/>
+          </a:xfrm>
+          <a:prstGeom prst="ellipse">
+            <a:avLst/>
+          </a:prstGeom>
+          <a:solidFill>
+            <a:srgbClr val="DCE6D7"/>
+          </a:solidFill>
+          <a:ln>
+            <a:noFill/>
+          </a:ln>
+        </p:spPr>
+        <p:style>
+          <a:lnRef idx="1">
+            <a:schemeClr val="accent1"/>
+          </a:lnRef>
+          <a:fillRef idx="3">
+            <a:schemeClr val="accent1"/>
+          </a:fillRef>
+          <a:effectRef idx="2">
+            <a:schemeClr val="accent1"/>
+          </a:effectRef>
+          <a:fontRef idx="minor">
+            <a:schemeClr val="lt1"/>
+          </a:fontRef>
+        </p:style>
+        <p:txBody>
+          <a:bodyPr rtlCol="0" anchor="ctr"/>
+          <a:lstStyle/>
+          <a:p>
+            <a:pPr algn="ctr"/>
+          </a:p>
+        </p:txBody>
+      </p:sp>
+      <p:sp>
+        <p:nvSpPr>
+          <p:cNvPr id="20" name="codex-bg-1"/>
+          <p:cNvSpPr/>
+          <p:nvPr/>
+        </p:nvSpPr>
+        <p:spPr>
+          <a:xfrm>
+            <a:off x="-868680" y="4754880"/>
+            <a:ext cx="4206240" cy="2743200"/>
+          </a:xfrm>
+          <a:prstGeom prst="ellipse">
+            <a:avLst/>
+          </a:prstGeom>
+          <a:solidFill>
+            <a:srgbClr val="F0D9CB"/>
+          </a:solidFill>
+          <a:ln>
+            <a:noFill/>
+          </a:ln>
+        </p:spPr>
+        <p:style>
+          <a:lnRef idx="1">
+            <a:schemeClr val="accent1"/>
+          </a:lnRef>
+          <a:fillRef idx="3">
+            <a:schemeClr val="accent1"/>
+          </a:fillRef>
+          <a:effectRef idx="2">
+            <a:schemeClr val="accent1"/>
+          </a:effectRef>
+          <a:fontRef idx="minor">
+            <a:schemeClr val="lt1"/>
+          </a:fontRef>
+        </p:style>
+        <p:txBody>
+          <a:bodyPr rtlCol="0" anchor="ctr"/>
+          <a:lstStyle/>
+          <a:p>
+            <a:pPr algn="ctr"/>
+          </a:p>
+        </p:txBody>
+      </p:sp>
+      <p:sp>
+        <p:nvSpPr>
           <p:cNvPr id="2" name="Rectangle 1"/>
           <p:cNvSpPr/>
           <p:nvPr/>
@@ -5512,6 +5641,135 @@
       </p:grpSpPr>
       <p:sp>
         <p:nvSpPr>
+          <p:cNvPr id="31" name="codex-bg-3"/>
+          <p:cNvSpPr/>
+          <p:nvPr/>
+        </p:nvSpPr>
+        <p:spPr>
+          <a:xfrm>
+            <a:off x="502920" y="5440680"/>
+            <a:ext cx="2011680" cy="1234440"/>
+          </a:xfrm>
+          <a:prstGeom prst="ellipse">
+            <a:avLst/>
+          </a:prstGeom>
+          <a:solidFill>
+            <a:srgbClr val="E7D0C3"/>
+          </a:solidFill>
+          <a:ln>
+            <a:noFill/>
+          </a:ln>
+        </p:spPr>
+        <p:style>
+          <a:lnRef idx="1">
+            <a:schemeClr val="accent1"/>
+          </a:lnRef>
+          <a:fillRef idx="3">
+            <a:schemeClr val="accent1"/>
+          </a:fillRef>
+          <a:effectRef idx="2">
+            <a:schemeClr val="accent1"/>
+          </a:effectRef>
+          <a:fontRef idx="minor">
+            <a:schemeClr val="lt1"/>
+          </a:fontRef>
+        </p:style>
+        <p:txBody>
+          <a:bodyPr rtlCol="0" anchor="ctr"/>
+          <a:lstStyle/>
+          <a:p>
+            <a:pPr algn="ctr"/>
+          </a:p>
+        </p:txBody>
+      </p:sp>
+      <p:sp>
+        <p:nvSpPr>
+          <p:cNvPr id="30" name="codex-bg-2"/>
+          <p:cNvSpPr/>
+          <p:nvPr/>
+        </p:nvSpPr>
+        <p:spPr>
+          <a:xfrm>
+            <a:off x="9006840" y="4434840"/>
+            <a:ext cx="4114800" cy="2697480"/>
+          </a:xfrm>
+          <a:prstGeom prst="ellipse">
+            <a:avLst/>
+          </a:prstGeom>
+          <a:solidFill>
+            <a:srgbClr val="D7E3E8"/>
+          </a:solidFill>
+          <a:ln>
+            <a:noFill/>
+          </a:ln>
+        </p:spPr>
+        <p:style>
+          <a:lnRef idx="1">
+            <a:schemeClr val="accent1"/>
+          </a:lnRef>
+          <a:fillRef idx="3">
+            <a:schemeClr val="accent1"/>
+          </a:fillRef>
+          <a:effectRef idx="2">
+            <a:schemeClr val="accent1"/>
+          </a:effectRef>
+          <a:fontRef idx="minor">
+            <a:schemeClr val="lt1"/>
+          </a:fontRef>
+        </p:style>
+        <p:txBody>
+          <a:bodyPr rtlCol="0" anchor="ctr"/>
+          <a:lstStyle/>
+          <a:p>
+            <a:pPr algn="ctr"/>
+          </a:p>
+        </p:txBody>
+      </p:sp>
+      <p:sp>
+        <p:nvSpPr>
+          <p:cNvPr id="29" name="codex-bg-1"/>
+          <p:cNvSpPr/>
+          <p:nvPr/>
+        </p:nvSpPr>
+        <p:spPr>
+          <a:xfrm>
+            <a:off x="-1051560" y="-777240"/>
+            <a:ext cx="3840480" cy="2606040"/>
+          </a:xfrm>
+          <a:prstGeom prst="ellipse">
+            <a:avLst/>
+          </a:prstGeom>
+          <a:solidFill>
+            <a:srgbClr val="EEE0D3"/>
+          </a:solidFill>
+          <a:ln>
+            <a:noFill/>
+          </a:ln>
+        </p:spPr>
+        <p:style>
+          <a:lnRef idx="1">
+            <a:schemeClr val="accent1"/>
+          </a:lnRef>
+          <a:fillRef idx="3">
+            <a:schemeClr val="accent1"/>
+          </a:fillRef>
+          <a:effectRef idx="2">
+            <a:schemeClr val="accent1"/>
+          </a:effectRef>
+          <a:fontRef idx="minor">
+            <a:schemeClr val="lt1"/>
+          </a:fontRef>
+        </p:style>
+        <p:txBody>
+          <a:bodyPr rtlCol="0" anchor="ctr"/>
+          <a:lstStyle/>
+          <a:p>
+            <a:pPr algn="ctr"/>
+          </a:p>
+        </p:txBody>
+      </p:sp>
+      <p:sp>
+        <p:nvSpPr>
           <p:cNvPr id="2" name="TextBox 1"/>
           <p:cNvSpPr txBox="1"/>
           <p:nvPr/>
@@ -6955,6 +7213,135 @@
       </p:grpSpPr>
       <p:sp>
         <p:nvSpPr>
+          <p:cNvPr id="25" name="codex-bg-3"/>
+          <p:cNvSpPr/>
+          <p:nvPr/>
+        </p:nvSpPr>
+        <p:spPr>
+          <a:xfrm>
+            <a:off x="10195560" y="4526280"/>
+            <a:ext cx="1920240" cy="1325880"/>
+          </a:xfrm>
+          <a:prstGeom prst="ellipse">
+            <a:avLst/>
+          </a:prstGeom>
+          <a:solidFill>
+            <a:srgbClr val="E8E1D7"/>
+          </a:solidFill>
+          <a:ln>
+            <a:noFill/>
+          </a:ln>
+        </p:spPr>
+        <p:style>
+          <a:lnRef idx="1">
+            <a:schemeClr val="accent1"/>
+          </a:lnRef>
+          <a:fillRef idx="3">
+            <a:schemeClr val="accent1"/>
+          </a:fillRef>
+          <a:effectRef idx="2">
+            <a:schemeClr val="accent1"/>
+          </a:effectRef>
+          <a:fontRef idx="minor">
+            <a:schemeClr val="lt1"/>
+          </a:fontRef>
+        </p:style>
+        <p:txBody>
+          <a:bodyPr rtlCol="0" anchor="ctr"/>
+          <a:lstStyle/>
+          <a:p>
+            <a:pPr algn="ctr"/>
+          </a:p>
+        </p:txBody>
+      </p:sp>
+      <p:sp>
+        <p:nvSpPr>
+          <p:cNvPr id="24" name="codex-bg-2"/>
+          <p:cNvSpPr/>
+          <p:nvPr/>
+        </p:nvSpPr>
+        <p:spPr>
+          <a:xfrm>
+            <a:off x="9281160" y="-548640"/>
+            <a:ext cx="3886200" cy="2514600"/>
+          </a:xfrm>
+          <a:prstGeom prst="ellipse">
+            <a:avLst/>
+          </a:prstGeom>
+          <a:solidFill>
+            <a:srgbClr val="DCE6D7"/>
+          </a:solidFill>
+          <a:ln>
+            <a:noFill/>
+          </a:ln>
+        </p:spPr>
+        <p:style>
+          <a:lnRef idx="1">
+            <a:schemeClr val="accent1"/>
+          </a:lnRef>
+          <a:fillRef idx="3">
+            <a:schemeClr val="accent1"/>
+          </a:fillRef>
+          <a:effectRef idx="2">
+            <a:schemeClr val="accent1"/>
+          </a:effectRef>
+          <a:fontRef idx="minor">
+            <a:schemeClr val="lt1"/>
+          </a:fontRef>
+        </p:style>
+        <p:txBody>
+          <a:bodyPr rtlCol="0" anchor="ctr"/>
+          <a:lstStyle/>
+          <a:p>
+            <a:pPr algn="ctr"/>
+          </a:p>
+        </p:txBody>
+      </p:sp>
+      <p:sp>
+        <p:nvSpPr>
+          <p:cNvPr id="23" name="codex-bg-1"/>
+          <p:cNvSpPr/>
+          <p:nvPr/>
+        </p:nvSpPr>
+        <p:spPr>
+          <a:xfrm>
+            <a:off x="-868680" y="4754880"/>
+            <a:ext cx="4206240" cy="2743200"/>
+          </a:xfrm>
+          <a:prstGeom prst="ellipse">
+            <a:avLst/>
+          </a:prstGeom>
+          <a:solidFill>
+            <a:srgbClr val="F0D9CB"/>
+          </a:solidFill>
+          <a:ln>
+            <a:noFill/>
+          </a:ln>
+        </p:spPr>
+        <p:style>
+          <a:lnRef idx="1">
+            <a:schemeClr val="accent1"/>
+          </a:lnRef>
+          <a:fillRef idx="3">
+            <a:schemeClr val="accent1"/>
+          </a:fillRef>
+          <a:effectRef idx="2">
+            <a:schemeClr val="accent1"/>
+          </a:effectRef>
+          <a:fontRef idx="minor">
+            <a:schemeClr val="lt1"/>
+          </a:fontRef>
+        </p:style>
+        <p:txBody>
+          <a:bodyPr rtlCol="0" anchor="ctr"/>
+          <a:lstStyle/>
+          <a:p>
+            <a:pPr algn="ctr"/>
+          </a:p>
+        </p:txBody>
+      </p:sp>
+      <p:sp>
+        <p:nvSpPr>
           <p:cNvPr id="2" name="TextBox 1"/>
           <p:cNvSpPr txBox="1"/>
           <p:nvPr/>
@@ -8093,6 +8480,135 @@
       </p:grpSpPr>
       <p:sp>
         <p:nvSpPr>
+          <p:cNvPr id="66" name="codex-bg-3"/>
+          <p:cNvSpPr/>
+          <p:nvPr/>
+        </p:nvSpPr>
+        <p:spPr>
+          <a:xfrm>
+            <a:off x="502920" y="5440680"/>
+            <a:ext cx="2011680" cy="1234440"/>
+          </a:xfrm>
+          <a:prstGeom prst="ellipse">
+            <a:avLst/>
+          </a:prstGeom>
+          <a:solidFill>
+            <a:srgbClr val="E7D0C3"/>
+          </a:solidFill>
+          <a:ln>
+            <a:noFill/>
+          </a:ln>
+        </p:spPr>
+        <p:style>
+          <a:lnRef idx="1">
+            <a:schemeClr val="accent1"/>
+          </a:lnRef>
+          <a:fillRef idx="3">
+            <a:schemeClr val="accent1"/>
+          </a:fillRef>
+          <a:effectRef idx="2">
+            <a:schemeClr val="accent1"/>
+          </a:effectRef>
+          <a:fontRef idx="minor">
+            <a:schemeClr val="lt1"/>
+          </a:fontRef>
+        </p:style>
+        <p:txBody>
+          <a:bodyPr rtlCol="0" anchor="ctr"/>
+          <a:lstStyle/>
+          <a:p>
+            <a:pPr algn="ctr"/>
+          </a:p>
+        </p:txBody>
+      </p:sp>
+      <p:sp>
+        <p:nvSpPr>
+          <p:cNvPr id="65" name="codex-bg-2"/>
+          <p:cNvSpPr/>
+          <p:nvPr/>
+        </p:nvSpPr>
+        <p:spPr>
+          <a:xfrm>
+            <a:off x="9006840" y="4434840"/>
+            <a:ext cx="4114800" cy="2697480"/>
+          </a:xfrm>
+          <a:prstGeom prst="ellipse">
+            <a:avLst/>
+          </a:prstGeom>
+          <a:solidFill>
+            <a:srgbClr val="D7E3E8"/>
+          </a:solidFill>
+          <a:ln>
+            <a:noFill/>
+          </a:ln>
+        </p:spPr>
+        <p:style>
+          <a:lnRef idx="1">
+            <a:schemeClr val="accent1"/>
+          </a:lnRef>
+          <a:fillRef idx="3">
+            <a:schemeClr val="accent1"/>
+          </a:fillRef>
+          <a:effectRef idx="2">
+            <a:schemeClr val="accent1"/>
+          </a:effectRef>
+          <a:fontRef idx="minor">
+            <a:schemeClr val="lt1"/>
+          </a:fontRef>
+        </p:style>
+        <p:txBody>
+          <a:bodyPr rtlCol="0" anchor="ctr"/>
+          <a:lstStyle/>
+          <a:p>
+            <a:pPr algn="ctr"/>
+          </a:p>
+        </p:txBody>
+      </p:sp>
+      <p:sp>
+        <p:nvSpPr>
+          <p:cNvPr id="64" name="codex-bg-1"/>
+          <p:cNvSpPr/>
+          <p:nvPr/>
+        </p:nvSpPr>
+        <p:spPr>
+          <a:xfrm>
+            <a:off x="-1051560" y="-777240"/>
+            <a:ext cx="3840480" cy="2606040"/>
+          </a:xfrm>
+          <a:prstGeom prst="ellipse">
+            <a:avLst/>
+          </a:prstGeom>
+          <a:solidFill>
+            <a:srgbClr val="EEE0D3"/>
+          </a:solidFill>
+          <a:ln>
+            <a:noFill/>
+          </a:ln>
+        </p:spPr>
+        <p:style>
+          <a:lnRef idx="1">
+            <a:schemeClr val="accent1"/>
+          </a:lnRef>
+          <a:fillRef idx="3">
+            <a:schemeClr val="accent1"/>
+          </a:fillRef>
+          <a:effectRef idx="2">
+            <a:schemeClr val="accent1"/>
+          </a:effectRef>
+          <a:fontRef idx="minor">
+            <a:schemeClr val="lt1"/>
+          </a:fontRef>
+        </p:style>
+        <p:txBody>
+          <a:bodyPr rtlCol="0" anchor="ctr"/>
+          <a:lstStyle/>
+          <a:p>
+            <a:pPr algn="ctr"/>
+          </a:p>
+        </p:txBody>
+      </p:sp>
+      <p:sp>
+        <p:nvSpPr>
           <p:cNvPr id="2" name="TextBox 1"/>
           <p:cNvSpPr txBox="1"/>
           <p:nvPr/>
@@ -8924,6 +9440,135 @@
       </p:grpSpPr>
       <p:sp>
         <p:nvSpPr>
+          <p:cNvPr id="28" name="codex-bg-3"/>
+          <p:cNvSpPr/>
+          <p:nvPr/>
+        </p:nvSpPr>
+        <p:spPr>
+          <a:xfrm>
+            <a:off x="10195560" y="4526280"/>
+            <a:ext cx="1920240" cy="1325880"/>
+          </a:xfrm>
+          <a:prstGeom prst="ellipse">
+            <a:avLst/>
+          </a:prstGeom>
+          <a:solidFill>
+            <a:srgbClr val="E8E1D7"/>
+          </a:solidFill>
+          <a:ln>
+            <a:noFill/>
+          </a:ln>
+        </p:spPr>
+        <p:style>
+          <a:lnRef idx="1">
+            <a:schemeClr val="accent1"/>
+          </a:lnRef>
+          <a:fillRef idx="3">
+            <a:schemeClr val="accent1"/>
+          </a:fillRef>
+          <a:effectRef idx="2">
+            <a:schemeClr val="accent1"/>
+          </a:effectRef>
+          <a:fontRef idx="minor">
+            <a:schemeClr val="lt1"/>
+          </a:fontRef>
+        </p:style>
+        <p:txBody>
+          <a:bodyPr rtlCol="0" anchor="ctr"/>
+          <a:lstStyle/>
+          <a:p>
+            <a:pPr algn="ctr"/>
+          </a:p>
+        </p:txBody>
+      </p:sp>
+      <p:sp>
+        <p:nvSpPr>
+          <p:cNvPr id="27" name="codex-bg-2"/>
+          <p:cNvSpPr/>
+          <p:nvPr/>
+        </p:nvSpPr>
+        <p:spPr>
+          <a:xfrm>
+            <a:off x="9281160" y="-548640"/>
+            <a:ext cx="3886200" cy="2514600"/>
+          </a:xfrm>
+          <a:prstGeom prst="ellipse">
+            <a:avLst/>
+          </a:prstGeom>
+          <a:solidFill>
+            <a:srgbClr val="DCE6D7"/>
+          </a:solidFill>
+          <a:ln>
+            <a:noFill/>
+          </a:ln>
+        </p:spPr>
+        <p:style>
+          <a:lnRef idx="1">
+            <a:schemeClr val="accent1"/>
+          </a:lnRef>
+          <a:fillRef idx="3">
+            <a:schemeClr val="accent1"/>
+          </a:fillRef>
+          <a:effectRef idx="2">
+            <a:schemeClr val="accent1"/>
+          </a:effectRef>
+          <a:fontRef idx="minor">
+            <a:schemeClr val="lt1"/>
+          </a:fontRef>
+        </p:style>
+        <p:txBody>
+          <a:bodyPr rtlCol="0" anchor="ctr"/>
+          <a:lstStyle/>
+          <a:p>
+            <a:pPr algn="ctr"/>
+          </a:p>
+        </p:txBody>
+      </p:sp>
+      <p:sp>
+        <p:nvSpPr>
+          <p:cNvPr id="26" name="codex-bg-1"/>
+          <p:cNvSpPr/>
+          <p:nvPr/>
+        </p:nvSpPr>
+        <p:spPr>
+          <a:xfrm>
+            <a:off x="-868680" y="4754880"/>
+            <a:ext cx="4206240" cy="2743200"/>
+          </a:xfrm>
+          <a:prstGeom prst="ellipse">
+            <a:avLst/>
+          </a:prstGeom>
+          <a:solidFill>
+            <a:srgbClr val="F0D9CB"/>
+          </a:solidFill>
+          <a:ln>
+            <a:noFill/>
+          </a:ln>
+        </p:spPr>
+        <p:style>
+          <a:lnRef idx="1">
+            <a:schemeClr val="accent1"/>
+          </a:lnRef>
+          <a:fillRef idx="3">
+            <a:schemeClr val="accent1"/>
+          </a:fillRef>
+          <a:effectRef idx="2">
+            <a:schemeClr val="accent1"/>
+          </a:effectRef>
+          <a:fontRef idx="minor">
+            <a:schemeClr val="lt1"/>
+          </a:fontRef>
+        </p:style>
+        <p:txBody>
+          <a:bodyPr rtlCol="0" anchor="ctr"/>
+          <a:lstStyle/>
+          <a:p>
+            <a:pPr algn="ctr"/>
+          </a:p>
+        </p:txBody>
+      </p:sp>
+      <p:sp>
+        <p:nvSpPr>
           <p:cNvPr id="2" name="TextBox 1"/>
           <p:cNvSpPr txBox="1"/>
           <p:nvPr/>
@@ -10008,6 +10653,135 @@
       </p:grpSpPr>
       <p:sp>
         <p:nvSpPr>
+          <p:cNvPr id="18" name="codex-bg-3"/>
+          <p:cNvSpPr/>
+          <p:nvPr/>
+        </p:nvSpPr>
+        <p:spPr>
+          <a:xfrm>
+            <a:off x="502920" y="5440680"/>
+            <a:ext cx="2011680" cy="1234440"/>
+          </a:xfrm>
+          <a:prstGeom prst="ellipse">
+            <a:avLst/>
+          </a:prstGeom>
+          <a:solidFill>
+            <a:srgbClr val="E7D0C3"/>
+          </a:solidFill>
+          <a:ln>
+            <a:noFill/>
+          </a:ln>
+        </p:spPr>
+        <p:style>
+          <a:lnRef idx="1">
+            <a:schemeClr val="accent1"/>
+          </a:lnRef>
+          <a:fillRef idx="3">
+            <a:schemeClr val="accent1"/>
+          </a:fillRef>
+          <a:effectRef idx="2">
+            <a:schemeClr val="accent1"/>
+          </a:effectRef>
+          <a:fontRef idx="minor">
+            <a:schemeClr val="lt1"/>
+          </a:fontRef>
+        </p:style>
+        <p:txBody>
+          <a:bodyPr rtlCol="0" anchor="ctr"/>
+          <a:lstStyle/>
+          <a:p>
+            <a:pPr algn="ctr"/>
+          </a:p>
+        </p:txBody>
+      </p:sp>
+      <p:sp>
+        <p:nvSpPr>
+          <p:cNvPr id="17" name="codex-bg-2"/>
+          <p:cNvSpPr/>
+          <p:nvPr/>
+        </p:nvSpPr>
+        <p:spPr>
+          <a:xfrm>
+            <a:off x="9006840" y="4434840"/>
+            <a:ext cx="4114800" cy="2697480"/>
+          </a:xfrm>
+          <a:prstGeom prst="ellipse">
+            <a:avLst/>
+          </a:prstGeom>
+          <a:solidFill>
+            <a:srgbClr val="D7E3E8"/>
+          </a:solidFill>
+          <a:ln>
+            <a:noFill/>
+          </a:ln>
+        </p:spPr>
+        <p:style>
+          <a:lnRef idx="1">
+            <a:schemeClr val="accent1"/>
+          </a:lnRef>
+          <a:fillRef idx="3">
+            <a:schemeClr val="accent1"/>
+          </a:fillRef>
+          <a:effectRef idx="2">
+            <a:schemeClr val="accent1"/>
+          </a:effectRef>
+          <a:fontRef idx="minor">
+            <a:schemeClr val="lt1"/>
+          </a:fontRef>
+        </p:style>
+        <p:txBody>
+          <a:bodyPr rtlCol="0" anchor="ctr"/>
+          <a:lstStyle/>
+          <a:p>
+            <a:pPr algn="ctr"/>
+          </a:p>
+        </p:txBody>
+      </p:sp>
+      <p:sp>
+        <p:nvSpPr>
+          <p:cNvPr id="16" name="codex-bg-1"/>
+          <p:cNvSpPr/>
+          <p:nvPr/>
+        </p:nvSpPr>
+        <p:spPr>
+          <a:xfrm>
+            <a:off x="-1051560" y="-777240"/>
+            <a:ext cx="3840480" cy="2606040"/>
+          </a:xfrm>
+          <a:prstGeom prst="ellipse">
+            <a:avLst/>
+          </a:prstGeom>
+          <a:solidFill>
+            <a:srgbClr val="EEE0D3"/>
+          </a:solidFill>
+          <a:ln>
+            <a:noFill/>
+          </a:ln>
+        </p:spPr>
+        <p:style>
+          <a:lnRef idx="1">
+            <a:schemeClr val="accent1"/>
+          </a:lnRef>
+          <a:fillRef idx="3">
+            <a:schemeClr val="accent1"/>
+          </a:fillRef>
+          <a:effectRef idx="2">
+            <a:schemeClr val="accent1"/>
+          </a:effectRef>
+          <a:fontRef idx="minor">
+            <a:schemeClr val="lt1"/>
+          </a:fontRef>
+        </p:style>
+        <p:txBody>
+          <a:bodyPr rtlCol="0" anchor="ctr"/>
+          <a:lstStyle/>
+          <a:p>
+            <a:pPr algn="ctr"/>
+          </a:p>
+        </p:txBody>
+      </p:sp>
+      <p:sp>
+        <p:nvSpPr>
           <p:cNvPr id="2" name="TextBox 1"/>
           <p:cNvSpPr txBox="1"/>
           <p:nvPr/>
@@ -10998,6 +11772,135 @@
       </p:grpSpPr>
       <p:sp>
         <p:nvSpPr>
+          <p:cNvPr id="28" name="codex-bg-3"/>
+          <p:cNvSpPr/>
+          <p:nvPr/>
+        </p:nvSpPr>
+        <p:spPr>
+          <a:xfrm>
+            <a:off x="502920" y="5440680"/>
+            <a:ext cx="2011680" cy="1234440"/>
+          </a:xfrm>
+          <a:prstGeom prst="ellipse">
+            <a:avLst/>
+          </a:prstGeom>
+          <a:solidFill>
+            <a:srgbClr val="E7D0C3"/>
+          </a:solidFill>
+          <a:ln>
+            <a:noFill/>
+          </a:ln>
+        </p:spPr>
+        <p:style>
+          <a:lnRef idx="1">
+            <a:schemeClr val="accent1"/>
+          </a:lnRef>
+          <a:fillRef idx="3">
+            <a:schemeClr val="accent1"/>
+          </a:fillRef>
+          <a:effectRef idx="2">
+            <a:schemeClr val="accent1"/>
+          </a:effectRef>
+          <a:fontRef idx="minor">
+            <a:schemeClr val="lt1"/>
+          </a:fontRef>
+        </p:style>
+        <p:txBody>
+          <a:bodyPr rtlCol="0" anchor="ctr"/>
+          <a:lstStyle/>
+          <a:p>
+            <a:pPr algn="ctr"/>
+          </a:p>
+        </p:txBody>
+      </p:sp>
+      <p:sp>
+        <p:nvSpPr>
+          <p:cNvPr id="27" name="codex-bg-2"/>
+          <p:cNvSpPr/>
+          <p:nvPr/>
+        </p:nvSpPr>
+        <p:spPr>
+          <a:xfrm>
+            <a:off x="9006840" y="4434840"/>
+            <a:ext cx="4114800" cy="2697480"/>
+          </a:xfrm>
+          <a:prstGeom prst="ellipse">
+            <a:avLst/>
+          </a:prstGeom>
+          <a:solidFill>
+            <a:srgbClr val="D7E3E8"/>
+          </a:solidFill>
+          <a:ln>
+            <a:noFill/>
+          </a:ln>
+        </p:spPr>
+        <p:style>
+          <a:lnRef idx="1">
+            <a:schemeClr val="accent1"/>
+          </a:lnRef>
+          <a:fillRef idx="3">
+            <a:schemeClr val="accent1"/>
+          </a:fillRef>
+          <a:effectRef idx="2">
+            <a:schemeClr val="accent1"/>
+          </a:effectRef>
+          <a:fontRef idx="minor">
+            <a:schemeClr val="lt1"/>
+          </a:fontRef>
+        </p:style>
+        <p:txBody>
+          <a:bodyPr rtlCol="0" anchor="ctr"/>
+          <a:lstStyle/>
+          <a:p>
+            <a:pPr algn="ctr"/>
+          </a:p>
+        </p:txBody>
+      </p:sp>
+      <p:sp>
+        <p:nvSpPr>
+          <p:cNvPr id="26" name="codex-bg-1"/>
+          <p:cNvSpPr/>
+          <p:nvPr/>
+        </p:nvSpPr>
+        <p:spPr>
+          <a:xfrm>
+            <a:off x="-1051560" y="-777240"/>
+            <a:ext cx="3840480" cy="2606040"/>
+          </a:xfrm>
+          <a:prstGeom prst="ellipse">
+            <a:avLst/>
+          </a:prstGeom>
+          <a:solidFill>
+            <a:srgbClr val="EEE0D3"/>
+          </a:solidFill>
+          <a:ln>
+            <a:noFill/>
+          </a:ln>
+        </p:spPr>
+        <p:style>
+          <a:lnRef idx="1">
+            <a:schemeClr val="accent1"/>
+          </a:lnRef>
+          <a:fillRef idx="3">
+            <a:schemeClr val="accent1"/>
+          </a:fillRef>
+          <a:effectRef idx="2">
+            <a:schemeClr val="accent1"/>
+          </a:effectRef>
+          <a:fontRef idx="minor">
+            <a:schemeClr val="lt1"/>
+          </a:fontRef>
+        </p:style>
+        <p:txBody>
+          <a:bodyPr rtlCol="0" anchor="ctr"/>
+          <a:lstStyle/>
+          <a:p>
+            <a:pPr algn="ctr"/>
+          </a:p>
+        </p:txBody>
+      </p:sp>
+      <p:sp>
+        <p:nvSpPr>
           <p:cNvPr id="2" name="TextBox 1"/>
           <p:cNvSpPr txBox="1"/>
           <p:nvPr/>
@@ -12101,6 +13004,135 @@
       </p:grpSpPr>
       <p:sp>
         <p:nvSpPr>
+          <p:cNvPr id="25" name="codex-bg-3"/>
+          <p:cNvSpPr/>
+          <p:nvPr/>
+        </p:nvSpPr>
+        <p:spPr>
+          <a:xfrm>
+            <a:off x="10195560" y="4526280"/>
+            <a:ext cx="1920240" cy="1325880"/>
+          </a:xfrm>
+          <a:prstGeom prst="ellipse">
+            <a:avLst/>
+          </a:prstGeom>
+          <a:solidFill>
+            <a:srgbClr val="E8E1D7"/>
+          </a:solidFill>
+          <a:ln>
+            <a:noFill/>
+          </a:ln>
+        </p:spPr>
+        <p:style>
+          <a:lnRef idx="1">
+            <a:schemeClr val="accent1"/>
+          </a:lnRef>
+          <a:fillRef idx="3">
+            <a:schemeClr val="accent1"/>
+          </a:fillRef>
+          <a:effectRef idx="2">
+            <a:schemeClr val="accent1"/>
+          </a:effectRef>
+          <a:fontRef idx="minor">
+            <a:schemeClr val="lt1"/>
+          </a:fontRef>
+        </p:style>
+        <p:txBody>
+          <a:bodyPr rtlCol="0" anchor="ctr"/>
+          <a:lstStyle/>
+          <a:p>
+            <a:pPr algn="ctr"/>
+          </a:p>
+        </p:txBody>
+      </p:sp>
+      <p:sp>
+        <p:nvSpPr>
+          <p:cNvPr id="24" name="codex-bg-2"/>
+          <p:cNvSpPr/>
+          <p:nvPr/>
+        </p:nvSpPr>
+        <p:spPr>
+          <a:xfrm>
+            <a:off x="9281160" y="-548640"/>
+            <a:ext cx="3886200" cy="2514600"/>
+          </a:xfrm>
+          <a:prstGeom prst="ellipse">
+            <a:avLst/>
+          </a:prstGeom>
+          <a:solidFill>
+            <a:srgbClr val="DCE6D7"/>
+          </a:solidFill>
+          <a:ln>
+            <a:noFill/>
+          </a:ln>
+        </p:spPr>
+        <p:style>
+          <a:lnRef idx="1">
+            <a:schemeClr val="accent1"/>
+          </a:lnRef>
+          <a:fillRef idx="3">
+            <a:schemeClr val="accent1"/>
+          </a:fillRef>
+          <a:effectRef idx="2">
+            <a:schemeClr val="accent1"/>
+          </a:effectRef>
+          <a:fontRef idx="minor">
+            <a:schemeClr val="lt1"/>
+          </a:fontRef>
+        </p:style>
+        <p:txBody>
+          <a:bodyPr rtlCol="0" anchor="ctr"/>
+          <a:lstStyle/>
+          <a:p>
+            <a:pPr algn="ctr"/>
+          </a:p>
+        </p:txBody>
+      </p:sp>
+      <p:sp>
+        <p:nvSpPr>
+          <p:cNvPr id="23" name="codex-bg-1"/>
+          <p:cNvSpPr/>
+          <p:nvPr/>
+        </p:nvSpPr>
+        <p:spPr>
+          <a:xfrm>
+            <a:off x="-868680" y="4754880"/>
+            <a:ext cx="4206240" cy="2743200"/>
+          </a:xfrm>
+          <a:prstGeom prst="ellipse">
+            <a:avLst/>
+          </a:prstGeom>
+          <a:solidFill>
+            <a:srgbClr val="F0D9CB"/>
+          </a:solidFill>
+          <a:ln>
+            <a:noFill/>
+          </a:ln>
+        </p:spPr>
+        <p:style>
+          <a:lnRef idx="1">
+            <a:schemeClr val="accent1"/>
+          </a:lnRef>
+          <a:fillRef idx="3">
+            <a:schemeClr val="accent1"/>
+          </a:fillRef>
+          <a:effectRef idx="2">
+            <a:schemeClr val="accent1"/>
+          </a:effectRef>
+          <a:fontRef idx="minor">
+            <a:schemeClr val="lt1"/>
+          </a:fontRef>
+        </p:style>
+        <p:txBody>
+          <a:bodyPr rtlCol="0" anchor="ctr"/>
+          <a:lstStyle/>
+          <a:p>
+            <a:pPr algn="ctr"/>
+          </a:p>
+        </p:txBody>
+      </p:sp>
+      <p:sp>
+        <p:nvSpPr>
           <p:cNvPr id="2" name="TextBox 1"/>
           <p:cNvSpPr txBox="1"/>
           <p:nvPr/>
@@ -13100,6 +14132,135 @@
       </p:grpSpPr>
       <p:sp>
         <p:nvSpPr>
+          <p:cNvPr id="26" name="codex-bg-3"/>
+          <p:cNvSpPr/>
+          <p:nvPr/>
+        </p:nvSpPr>
+        <p:spPr>
+          <a:xfrm>
+            <a:off x="502920" y="5440680"/>
+            <a:ext cx="2011680" cy="1234440"/>
+          </a:xfrm>
+          <a:prstGeom prst="ellipse">
+            <a:avLst/>
+          </a:prstGeom>
+          <a:solidFill>
+            <a:srgbClr val="E7D0C3"/>
+          </a:solidFill>
+          <a:ln>
+            <a:noFill/>
+          </a:ln>
+        </p:spPr>
+        <p:style>
+          <a:lnRef idx="1">
+            <a:schemeClr val="accent1"/>
+          </a:lnRef>
+          <a:fillRef idx="3">
+            <a:schemeClr val="accent1"/>
+          </a:fillRef>
+          <a:effectRef idx="2">
+            <a:schemeClr val="accent1"/>
+          </a:effectRef>
+          <a:fontRef idx="minor">
+            <a:schemeClr val="lt1"/>
+          </a:fontRef>
+        </p:style>
+        <p:txBody>
+          <a:bodyPr rtlCol="0" anchor="ctr"/>
+          <a:lstStyle/>
+          <a:p>
+            <a:pPr algn="ctr"/>
+          </a:p>
+        </p:txBody>
+      </p:sp>
+      <p:sp>
+        <p:nvSpPr>
+          <p:cNvPr id="25" name="codex-bg-2"/>
+          <p:cNvSpPr/>
+          <p:nvPr/>
+        </p:nvSpPr>
+        <p:spPr>
+          <a:xfrm>
+            <a:off x="9006840" y="4434840"/>
+            <a:ext cx="4114800" cy="2697480"/>
+          </a:xfrm>
+          <a:prstGeom prst="ellipse">
+            <a:avLst/>
+          </a:prstGeom>
+          <a:solidFill>
+            <a:srgbClr val="D7E3E8"/>
+          </a:solidFill>
+          <a:ln>
+            <a:noFill/>
+          </a:ln>
+        </p:spPr>
+        <p:style>
+          <a:lnRef idx="1">
+            <a:schemeClr val="accent1"/>
+          </a:lnRef>
+          <a:fillRef idx="3">
+            <a:schemeClr val="accent1"/>
+          </a:fillRef>
+          <a:effectRef idx="2">
+            <a:schemeClr val="accent1"/>
+          </a:effectRef>
+          <a:fontRef idx="minor">
+            <a:schemeClr val="lt1"/>
+          </a:fontRef>
+        </p:style>
+        <p:txBody>
+          <a:bodyPr rtlCol="0" anchor="ctr"/>
+          <a:lstStyle/>
+          <a:p>
+            <a:pPr algn="ctr"/>
+          </a:p>
+        </p:txBody>
+      </p:sp>
+      <p:sp>
+        <p:nvSpPr>
+          <p:cNvPr id="24" name="codex-bg-1"/>
+          <p:cNvSpPr/>
+          <p:nvPr/>
+        </p:nvSpPr>
+        <p:spPr>
+          <a:xfrm>
+            <a:off x="-1051560" y="-777240"/>
+            <a:ext cx="3840480" cy="2606040"/>
+          </a:xfrm>
+          <a:prstGeom prst="ellipse">
+            <a:avLst/>
+          </a:prstGeom>
+          <a:solidFill>
+            <a:srgbClr val="EEE0D3"/>
+          </a:solidFill>
+          <a:ln>
+            <a:noFill/>
+          </a:ln>
+        </p:spPr>
+        <p:style>
+          <a:lnRef idx="1">
+            <a:schemeClr val="accent1"/>
+          </a:lnRef>
+          <a:fillRef idx="3">
+            <a:schemeClr val="accent1"/>
+          </a:fillRef>
+          <a:effectRef idx="2">
+            <a:schemeClr val="accent1"/>
+          </a:effectRef>
+          <a:fontRef idx="minor">
+            <a:schemeClr val="lt1"/>
+          </a:fontRef>
+        </p:style>
+        <p:txBody>
+          <a:bodyPr rtlCol="0" anchor="ctr"/>
+          <a:lstStyle/>
+          <a:p>
+            <a:pPr algn="ctr"/>
+          </a:p>
+        </p:txBody>
+      </p:sp>
+      <p:sp>
+        <p:nvSpPr>
           <p:cNvPr id="2" name="TextBox 1"/>
           <p:cNvSpPr txBox="1"/>
           <p:nvPr/>
@@ -14081,6 +15242,135 @@
       </p:grpSpPr>
       <p:sp>
         <p:nvSpPr>
+          <p:cNvPr id="28" name="codex-bg-3"/>
+          <p:cNvSpPr/>
+          <p:nvPr/>
+        </p:nvSpPr>
+        <p:spPr>
+          <a:xfrm>
+            <a:off x="10195560" y="4526280"/>
+            <a:ext cx="1920240" cy="1325880"/>
+          </a:xfrm>
+          <a:prstGeom prst="ellipse">
+            <a:avLst/>
+          </a:prstGeom>
+          <a:solidFill>
+            <a:srgbClr val="E8E1D7"/>
+          </a:solidFill>
+          <a:ln>
+            <a:noFill/>
+          </a:ln>
+        </p:spPr>
+        <p:style>
+          <a:lnRef idx="1">
+            <a:schemeClr val="accent1"/>
+          </a:lnRef>
+          <a:fillRef idx="3">
+            <a:schemeClr val="accent1"/>
+          </a:fillRef>
+          <a:effectRef idx="2">
+            <a:schemeClr val="accent1"/>
+          </a:effectRef>
+          <a:fontRef idx="minor">
+            <a:schemeClr val="lt1"/>
+          </a:fontRef>
+        </p:style>
+        <p:txBody>
+          <a:bodyPr rtlCol="0" anchor="ctr"/>
+          <a:lstStyle/>
+          <a:p>
+            <a:pPr algn="ctr"/>
+          </a:p>
+        </p:txBody>
+      </p:sp>
+      <p:sp>
+        <p:nvSpPr>
+          <p:cNvPr id="27" name="codex-bg-2"/>
+          <p:cNvSpPr/>
+          <p:nvPr/>
+        </p:nvSpPr>
+        <p:spPr>
+          <a:xfrm>
+            <a:off x="9281160" y="-548640"/>
+            <a:ext cx="3886200" cy="2514600"/>
+          </a:xfrm>
+          <a:prstGeom prst="ellipse">
+            <a:avLst/>
+          </a:prstGeom>
+          <a:solidFill>
+            <a:srgbClr val="DCE6D7"/>
+          </a:solidFill>
+          <a:ln>
+            <a:noFill/>
+          </a:ln>
+        </p:spPr>
+        <p:style>
+          <a:lnRef idx="1">
+            <a:schemeClr val="accent1"/>
+          </a:lnRef>
+          <a:fillRef idx="3">
+            <a:schemeClr val="accent1"/>
+          </a:fillRef>
+          <a:effectRef idx="2">
+            <a:schemeClr val="accent1"/>
+          </a:effectRef>
+          <a:fontRef idx="minor">
+            <a:schemeClr val="lt1"/>
+          </a:fontRef>
+        </p:style>
+        <p:txBody>
+          <a:bodyPr rtlCol="0" anchor="ctr"/>
+          <a:lstStyle/>
+          <a:p>
+            <a:pPr algn="ctr"/>
+          </a:p>
+        </p:txBody>
+      </p:sp>
+      <p:sp>
+        <p:nvSpPr>
+          <p:cNvPr id="26" name="codex-bg-1"/>
+          <p:cNvSpPr/>
+          <p:nvPr/>
+        </p:nvSpPr>
+        <p:spPr>
+          <a:xfrm>
+            <a:off x="-868680" y="4754880"/>
+            <a:ext cx="4206240" cy="2743200"/>
+          </a:xfrm>
+          <a:prstGeom prst="ellipse">
+            <a:avLst/>
+          </a:prstGeom>
+          <a:solidFill>
+            <a:srgbClr val="F0D9CB"/>
+          </a:solidFill>
+          <a:ln>
+            <a:noFill/>
+          </a:ln>
+        </p:spPr>
+        <p:style>
+          <a:lnRef idx="1">
+            <a:schemeClr val="accent1"/>
+          </a:lnRef>
+          <a:fillRef idx="3">
+            <a:schemeClr val="accent1"/>
+          </a:fillRef>
+          <a:effectRef idx="2">
+            <a:schemeClr val="accent1"/>
+          </a:effectRef>
+          <a:fontRef idx="minor">
+            <a:schemeClr val="lt1"/>
+          </a:fontRef>
+        </p:style>
+        <p:txBody>
+          <a:bodyPr rtlCol="0" anchor="ctr"/>
+          <a:lstStyle/>
+          <a:p>
+            <a:pPr algn="ctr"/>
+          </a:p>
+        </p:txBody>
+      </p:sp>
+      <p:sp>
+        <p:nvSpPr>
           <p:cNvPr id="2" name="TextBox 1"/>
           <p:cNvSpPr txBox="1"/>
           <p:nvPr/>
@@ -15148,6 +16438,135 @@
       </p:grpSpPr>
       <p:sp>
         <p:nvSpPr>
+          <p:cNvPr id="21" name="codex-bg-3"/>
+          <p:cNvSpPr/>
+          <p:nvPr/>
+        </p:nvSpPr>
+        <p:spPr>
+          <a:xfrm>
+            <a:off x="502920" y="5440680"/>
+            <a:ext cx="2011680" cy="1234440"/>
+          </a:xfrm>
+          <a:prstGeom prst="ellipse">
+            <a:avLst/>
+          </a:prstGeom>
+          <a:solidFill>
+            <a:srgbClr val="E7D0C3"/>
+          </a:solidFill>
+          <a:ln>
+            <a:noFill/>
+          </a:ln>
+        </p:spPr>
+        <p:style>
+          <a:lnRef idx="1">
+            <a:schemeClr val="accent1"/>
+          </a:lnRef>
+          <a:fillRef idx="3">
+            <a:schemeClr val="accent1"/>
+          </a:fillRef>
+          <a:effectRef idx="2">
+            <a:schemeClr val="accent1"/>
+          </a:effectRef>
+          <a:fontRef idx="minor">
+            <a:schemeClr val="lt1"/>
+          </a:fontRef>
+        </p:style>
+        <p:txBody>
+          <a:bodyPr rtlCol="0" anchor="ctr"/>
+          <a:lstStyle/>
+          <a:p>
+            <a:pPr algn="ctr"/>
+          </a:p>
+        </p:txBody>
+      </p:sp>
+      <p:sp>
+        <p:nvSpPr>
+          <p:cNvPr id="20" name="codex-bg-2"/>
+          <p:cNvSpPr/>
+          <p:nvPr/>
+        </p:nvSpPr>
+        <p:spPr>
+          <a:xfrm>
+            <a:off x="9006840" y="4434840"/>
+            <a:ext cx="4114800" cy="2697480"/>
+          </a:xfrm>
+          <a:prstGeom prst="ellipse">
+            <a:avLst/>
+          </a:prstGeom>
+          <a:solidFill>
+            <a:srgbClr val="D7E3E8"/>
+          </a:solidFill>
+          <a:ln>
+            <a:noFill/>
+          </a:ln>
+        </p:spPr>
+        <p:style>
+          <a:lnRef idx="1">
+            <a:schemeClr val="accent1"/>
+          </a:lnRef>
+          <a:fillRef idx="3">
+            <a:schemeClr val="accent1"/>
+          </a:fillRef>
+          <a:effectRef idx="2">
+            <a:schemeClr val="accent1"/>
+          </a:effectRef>
+          <a:fontRef idx="minor">
+            <a:schemeClr val="lt1"/>
+          </a:fontRef>
+        </p:style>
+        <p:txBody>
+          <a:bodyPr rtlCol="0" anchor="ctr"/>
+          <a:lstStyle/>
+          <a:p>
+            <a:pPr algn="ctr"/>
+          </a:p>
+        </p:txBody>
+      </p:sp>
+      <p:sp>
+        <p:nvSpPr>
+          <p:cNvPr id="19" name="codex-bg-1"/>
+          <p:cNvSpPr/>
+          <p:nvPr/>
+        </p:nvSpPr>
+        <p:spPr>
+          <a:xfrm>
+            <a:off x="-1051560" y="-777240"/>
+            <a:ext cx="3840480" cy="2606040"/>
+          </a:xfrm>
+          <a:prstGeom prst="ellipse">
+            <a:avLst/>
+          </a:prstGeom>
+          <a:solidFill>
+            <a:srgbClr val="EEE0D3"/>
+          </a:solidFill>
+          <a:ln>
+            <a:noFill/>
+          </a:ln>
+        </p:spPr>
+        <p:style>
+          <a:lnRef idx="1">
+            <a:schemeClr val="accent1"/>
+          </a:lnRef>
+          <a:fillRef idx="3">
+            <a:schemeClr val="accent1"/>
+          </a:fillRef>
+          <a:effectRef idx="2">
+            <a:schemeClr val="accent1"/>
+          </a:effectRef>
+          <a:fontRef idx="minor">
+            <a:schemeClr val="lt1"/>
+          </a:fontRef>
+        </p:style>
+        <p:txBody>
+          <a:bodyPr rtlCol="0" anchor="ctr"/>
+          <a:lstStyle/>
+          <a:p>
+            <a:pPr algn="ctr"/>
+          </a:p>
+        </p:txBody>
+      </p:sp>
+      <p:sp>
+        <p:nvSpPr>
           <p:cNvPr id="2" name="TextBox 1"/>
           <p:cNvSpPr txBox="1"/>
           <p:nvPr/>
@@ -15897,6 +17316,135 @@
       </p:grpSpPr>
       <p:sp>
         <p:nvSpPr>
+          <p:cNvPr id="29" name="codex-bg-3"/>
+          <p:cNvSpPr/>
+          <p:nvPr/>
+        </p:nvSpPr>
+        <p:spPr>
+          <a:xfrm>
+            <a:off x="10195560" y="4526280"/>
+            <a:ext cx="1920240" cy="1325880"/>
+          </a:xfrm>
+          <a:prstGeom prst="ellipse">
+            <a:avLst/>
+          </a:prstGeom>
+          <a:solidFill>
+            <a:srgbClr val="E8E1D7"/>
+          </a:solidFill>
+          <a:ln>
+            <a:noFill/>
+          </a:ln>
+        </p:spPr>
+        <p:style>
+          <a:lnRef idx="1">
+            <a:schemeClr val="accent1"/>
+          </a:lnRef>
+          <a:fillRef idx="3">
+            <a:schemeClr val="accent1"/>
+          </a:fillRef>
+          <a:effectRef idx="2">
+            <a:schemeClr val="accent1"/>
+          </a:effectRef>
+          <a:fontRef idx="minor">
+            <a:schemeClr val="lt1"/>
+          </a:fontRef>
+        </p:style>
+        <p:txBody>
+          <a:bodyPr rtlCol="0" anchor="ctr"/>
+          <a:lstStyle/>
+          <a:p>
+            <a:pPr algn="ctr"/>
+          </a:p>
+        </p:txBody>
+      </p:sp>
+      <p:sp>
+        <p:nvSpPr>
+          <p:cNvPr id="28" name="codex-bg-2"/>
+          <p:cNvSpPr/>
+          <p:nvPr/>
+        </p:nvSpPr>
+        <p:spPr>
+          <a:xfrm>
+            <a:off x="9281160" y="-548640"/>
+            <a:ext cx="3886200" cy="2514600"/>
+          </a:xfrm>
+          <a:prstGeom prst="ellipse">
+            <a:avLst/>
+          </a:prstGeom>
+          <a:solidFill>
+            <a:srgbClr val="DCE6D7"/>
+          </a:solidFill>
+          <a:ln>
+            <a:noFill/>
+          </a:ln>
+        </p:spPr>
+        <p:style>
+          <a:lnRef idx="1">
+            <a:schemeClr val="accent1"/>
+          </a:lnRef>
+          <a:fillRef idx="3">
+            <a:schemeClr val="accent1"/>
+          </a:fillRef>
+          <a:effectRef idx="2">
+            <a:schemeClr val="accent1"/>
+          </a:effectRef>
+          <a:fontRef idx="minor">
+            <a:schemeClr val="lt1"/>
+          </a:fontRef>
+        </p:style>
+        <p:txBody>
+          <a:bodyPr rtlCol="0" anchor="ctr"/>
+          <a:lstStyle/>
+          <a:p>
+            <a:pPr algn="ctr"/>
+          </a:p>
+        </p:txBody>
+      </p:sp>
+      <p:sp>
+        <p:nvSpPr>
+          <p:cNvPr id="27" name="codex-bg-1"/>
+          <p:cNvSpPr/>
+          <p:nvPr/>
+        </p:nvSpPr>
+        <p:spPr>
+          <a:xfrm>
+            <a:off x="-868680" y="4754880"/>
+            <a:ext cx="4206240" cy="2743200"/>
+          </a:xfrm>
+          <a:prstGeom prst="ellipse">
+            <a:avLst/>
+          </a:prstGeom>
+          <a:solidFill>
+            <a:srgbClr val="F0D9CB"/>
+          </a:solidFill>
+          <a:ln>
+            <a:noFill/>
+          </a:ln>
+        </p:spPr>
+        <p:style>
+          <a:lnRef idx="1">
+            <a:schemeClr val="accent1"/>
+          </a:lnRef>
+          <a:fillRef idx="3">
+            <a:schemeClr val="accent1"/>
+          </a:fillRef>
+          <a:effectRef idx="2">
+            <a:schemeClr val="accent1"/>
+          </a:effectRef>
+          <a:fontRef idx="minor">
+            <a:schemeClr val="lt1"/>
+          </a:fontRef>
+        </p:style>
+        <p:txBody>
+          <a:bodyPr rtlCol="0" anchor="ctr"/>
+          <a:lstStyle/>
+          <a:p>
+            <a:pPr algn="ctr"/>
+          </a:p>
+        </p:txBody>
+      </p:sp>
+      <p:sp>
+        <p:nvSpPr>
           <p:cNvPr id="2" name="TextBox 1"/>
           <p:cNvSpPr txBox="1"/>
           <p:nvPr/>
@@ -15996,11 +17544,11 @@
             <a:avLst/>
           </a:prstGeom>
           <a:solidFill>
-            <a:srgbClr val="FFFDF9"/>
+            <a:srgbClr val="FCF4EE"/>
           </a:solidFill>
-          <a:ln>
+          <a:ln w="15240">
             <a:solidFill>
-              <a:srgbClr val="D9D1C7"/>
+              <a:srgbClr val="D9C7BA"/>
             </a:solidFill>
           </a:ln>
         </p:spPr>
@@ -16042,7 +17590,7 @@
             <a:avLst/>
           </a:prstGeom>
           <a:solidFill>
-            <a:srgbClr val="B65A34"/>
+            <a:srgbClr val="C46A43"/>
           </a:solidFill>
           <a:ln>
             <a:noFill/>
@@ -16121,8 +17669,8 @@
         </p:nvSpPr>
         <p:spPr>
           <a:xfrm>
-            <a:off x="786384" y="1984248"/>
-            <a:ext cx="1837944" cy="3995928"/>
+            <a:off x="786384" y="2304288"/>
+            <a:ext cx="1837943" cy="3675887"/>
           </a:xfrm>
           <a:prstGeom prst="rect">
             <a:avLst/>
@@ -16136,21 +17684,15 @@
           <a:lstStyle/>
           <a:p>
             <a:pPr>
-              <a:defRPr sz="1050">
-                <a:solidFill>
-                  <a:srgbClr val="1F2937"/>
-                </a:solidFill>
-                <a:latin typeface="Segoe UI"/>
+              <a:defRPr sz="1350">
+                <a:solidFill>
+                  <a:srgbClr val="273243"/>
+                </a:solidFill>
+                <a:latin typeface="Aptos"/>
               </a:defRPr>
             </a:pPr>
             <a:r>
-              <a:rPr>
-                <a:solidFill>
-                  <a:srgbClr val="1F2937"/>
-                </a:solidFill>
-                <a:latin typeface="Aptos"/>
-              </a:rPr>
-              <a:t>Generic promise, weak collaboration, no offline mode, stale UX, too much paid dependence.</a:t>
+              <a:t>Broad promise, weak collaboration, no offline mode, and a product that feels less fresh than the category leaders.</a:t>
             </a:r>
           </a:p>
         </p:txBody>
@@ -16170,11 +17712,11 @@
             <a:avLst/>
           </a:prstGeom>
           <a:solidFill>
-            <a:srgbClr val="FFFDF9"/>
+            <a:srgbClr val="FFFDFC"/>
           </a:solidFill>
-          <a:ln>
+          <a:ln w="15240">
             <a:solidFill>
-              <a:srgbClr val="D9D1C7"/>
+              <a:srgbClr val="D8CDC3"/>
             </a:solidFill>
           </a:ln>
         </p:spPr>
@@ -16216,7 +17758,7 @@
             <a:avLst/>
           </a:prstGeom>
           <a:solidFill>
-            <a:srgbClr val="B65A34"/>
+            <a:srgbClr val="B86A4A"/>
           </a:solidFill>
           <a:ln>
             <a:noFill/>
@@ -16295,8 +17837,8 @@
         </p:nvSpPr>
         <p:spPr>
           <a:xfrm>
-            <a:off x="3072384" y="1984248"/>
-            <a:ext cx="3758183" cy="1527048"/>
+            <a:off x="3072384" y="2322576"/>
+            <a:ext cx="3758184" cy="1124712"/>
           </a:xfrm>
           <a:prstGeom prst="rect">
             <a:avLst/>
@@ -16310,21 +17852,15 @@
           <a:lstStyle/>
           <a:p>
             <a:pPr>
-              <a:defRPr sz="1050">
-                <a:solidFill>
-                  <a:srgbClr val="1F2937"/>
-                </a:solidFill>
-                <a:latin typeface="Segoe UI"/>
+              <a:defRPr sz="1350">
+                <a:solidFill>
+                  <a:srgbClr val="273243"/>
+                </a:solidFill>
+                <a:latin typeface="Aptos"/>
               </a:defRPr>
             </a:pPr>
             <a:r>
-              <a:rPr>
-                <a:solidFill>
-                  <a:srgbClr val="1F2937"/>
-                </a:solidFill>
-                <a:latin typeface="Aptos"/>
-              </a:rPr>
-              <a:t>Wins on templates, content and integrations. It feels easier to start for a concrete job to be done.</a:t>
+              <a:t>Templates, integrations and content make it easier to discover and easier to start with a clear job to be done.</a:t>
             </a:r>
           </a:p>
         </p:txBody>
@@ -16344,11 +17880,11 @@
             <a:avLst/>
           </a:prstGeom>
           <a:solidFill>
-            <a:srgbClr val="FFFDF9"/>
+            <a:srgbClr val="FCFCF8"/>
           </a:solidFill>
-          <a:ln>
+          <a:ln w="15240">
             <a:solidFill>
-              <a:srgbClr val="D9D1C7"/>
+              <a:srgbClr val="D8D4C7"/>
             </a:solidFill>
           </a:ln>
         </p:spPr>
@@ -16390,7 +17926,7 @@
             <a:avLst/>
           </a:prstGeom>
           <a:solidFill>
-            <a:srgbClr val="B65A34"/>
+            <a:srgbClr val="788B63"/>
           </a:solidFill>
           <a:ln>
             <a:noFill/>
@@ -16469,8 +18005,8 @@
         </p:nvSpPr>
         <p:spPr>
           <a:xfrm>
-            <a:off x="7278624" y="1984248"/>
-            <a:ext cx="3758183" cy="1527048"/>
+            <a:off x="7278624" y="2322576"/>
+            <a:ext cx="3758184" cy="1124712"/>
           </a:xfrm>
           <a:prstGeom prst="rect">
             <a:avLst/>
@@ -16484,21 +18020,15 @@
           <a:lstStyle/>
           <a:p>
             <a:pPr>
-              <a:defRPr sz="1050">
-                <a:solidFill>
-                  <a:srgbClr val="1F2937"/>
-                </a:solidFill>
-                <a:latin typeface="Segoe UI"/>
+              <a:defRPr sz="1350">
+                <a:solidFill>
+                  <a:srgbClr val="273243"/>
+                </a:solidFill>
+                <a:latin typeface="Aptos"/>
               </a:defRPr>
             </a:pPr>
             <a:r>
-              <a:rPr>
-                <a:solidFill>
-                  <a:srgbClr val="1F2937"/>
-                </a:solidFill>
-                <a:latin typeface="Aptos"/>
-              </a:rPr>
-              <a:t>Wins on bundled value: tasks, calendar, habits, focus tools and strong annual pricing.</a:t>
+              <a:t>Bundled value feels stronger: tasks, calendar, habits and focus tools under attractive annual pricing.</a:t>
             </a:r>
           </a:p>
         </p:txBody>
@@ -16518,11 +18048,11 @@
             <a:avLst/>
           </a:prstGeom>
           <a:solidFill>
-            <a:srgbClr val="FFFDF9"/>
+            <a:srgbClr val="FFFDFB"/>
           </a:solidFill>
-          <a:ln>
+          <a:ln w="15240">
             <a:solidFill>
-              <a:srgbClr val="D9D1C7"/>
+              <a:srgbClr val="DCCFC3"/>
             </a:solidFill>
           </a:ln>
         </p:spPr>
@@ -16564,7 +18094,7 @@
             <a:avLst/>
           </a:prstGeom>
           <a:solidFill>
-            <a:srgbClr val="B65A34"/>
+            <a:srgbClr val="C98C54"/>
           </a:solidFill>
           <a:ln>
             <a:noFill/>
@@ -16643,8 +18173,8 @@
         </p:nvSpPr>
         <p:spPr>
           <a:xfrm>
-            <a:off x="3072384" y="4224528"/>
-            <a:ext cx="3758183" cy="1298448"/>
+            <a:off x="3072384" y="4535424"/>
+            <a:ext cx="3758184" cy="868680"/>
           </a:xfrm>
           <a:prstGeom prst="rect">
             <a:avLst/>
@@ -16658,21 +18188,15 @@
           <a:lstStyle/>
           <a:p>
             <a:pPr>
-              <a:defRPr sz="1050">
-                <a:solidFill>
-                  <a:srgbClr val="1F2937"/>
-                </a:solidFill>
-                <a:latin typeface="Segoe UI"/>
+              <a:defRPr sz="1350">
+                <a:solidFill>
+                  <a:srgbClr val="273243"/>
+                </a:solidFill>
+                <a:latin typeface="Aptos"/>
               </a:defRPr>
             </a:pPr>
             <a:r>
-              <a:rPr>
-                <a:solidFill>
-                  <a:srgbClr val="1F2937"/>
-                </a:solidFill>
-                <a:latin typeface="Aptos"/>
-              </a:rPr>
-              <a:t>Wins on clearer shared-planning packaging through Family and Workspace flows.</a:t>
+              <a:t>Shared planning is packaged more clearly through Family and Workspace flows, not generic collaboration language.</a:t>
             </a:r>
           </a:p>
         </p:txBody>
@@ -16692,11 +18216,11 @@
             <a:avLst/>
           </a:prstGeom>
           <a:solidFill>
-            <a:srgbClr val="FFFDF9"/>
+            <a:srgbClr val="FCFDFF"/>
           </a:solidFill>
-          <a:ln>
+          <a:ln w="15240">
             <a:solidFill>
-              <a:srgbClr val="D9D1C7"/>
+              <a:srgbClr val="CED7E2"/>
             </a:solidFill>
           </a:ln>
         </p:spPr>
@@ -16738,7 +18262,7 @@
             <a:avLst/>
           </a:prstGeom>
           <a:solidFill>
-            <a:srgbClr val="B65A34"/>
+            <a:srgbClr val="6E88A8"/>
           </a:solidFill>
           <a:ln>
             <a:noFill/>
@@ -16817,8 +18341,8 @@
         </p:nvSpPr>
         <p:spPr>
           <a:xfrm>
-            <a:off x="7278624" y="4224528"/>
-            <a:ext cx="3758183" cy="1298448"/>
+            <a:off x="7278624" y="4535424"/>
+            <a:ext cx="3758184" cy="868680"/>
           </a:xfrm>
           <a:prstGeom prst="rect">
             <a:avLst/>
@@ -16832,22 +18356,61 @@
           <a:lstStyle/>
           <a:p>
             <a:pPr>
-              <a:defRPr sz="1050">
-                <a:solidFill>
-                  <a:srgbClr val="1F2937"/>
-                </a:solidFill>
-                <a:latin typeface="Segoe UI"/>
+              <a:defRPr sz="1350">
+                <a:solidFill>
+                  <a:srgbClr val="273243"/>
+                </a:solidFill>
+                <a:latin typeface="Aptos"/>
               </a:defRPr>
             </a:pPr>
             <a:r>
-              <a:rPr>
-                <a:solidFill>
-                  <a:srgbClr val="1F2937"/>
-                </a:solidFill>
-                <a:latin typeface="Aptos"/>
-              </a:rPr>
-              <a:t>Wins distribution through Outlook and the Microsoft ecosystem, not just paid UA.</a:t>
-            </a:r>
+              <a:t>Distribution comes from the ecosystem itself through Outlook and Microsoft, not rebuilt every month in paid UA.</a:t>
+            </a:r>
+          </a:p>
+        </p:txBody>
+      </p:sp>
+      <p:sp>
+        <p:nvSpPr>
+          <p:cNvPr id="36" name="codex-s7-lesson-band"/>
+          <p:cNvSpPr/>
+          <p:nvPr/>
+        </p:nvSpPr>
+        <p:spPr>
+          <a:xfrm>
+            <a:off x="658368" y="5916168"/>
+            <a:ext cx="10972800" cy="475488"/>
+          </a:xfrm>
+          <a:prstGeom prst="roundRect">
+            <a:avLst/>
+          </a:prstGeom>
+          <a:solidFill>
+            <a:srgbClr val="F4E8DE"/>
+          </a:solidFill>
+          <a:ln w="10160">
+            <a:solidFill>
+              <a:srgbClr val="E5D4C5"/>
+            </a:solidFill>
+          </a:ln>
+        </p:spPr>
+        <p:style>
+          <a:lnRef idx="1">
+            <a:schemeClr val="accent1"/>
+          </a:lnRef>
+          <a:fillRef idx="3">
+            <a:schemeClr val="accent1"/>
+          </a:fillRef>
+          <a:effectRef idx="2">
+            <a:schemeClr val="accent1"/>
+          </a:effectRef>
+          <a:fontRef idx="minor">
+            <a:schemeClr val="lt1"/>
+          </a:fontRef>
+        </p:style>
+        <p:txBody>
+          <a:bodyPr rtlCol="0" anchor="ctr"/>
+          <a:lstStyle/>
+          <a:p>
+            <a:pPr algn="ctr"/>
           </a:p>
         </p:txBody>
       </p:sp>
@@ -16873,22 +18436,16 @@
           </a:bodyPr>
           <a:lstStyle/>
           <a:p>
-            <a:pPr algn="l">
-              <a:defRPr sz="950" b="0">
-                <a:solidFill>
-                  <a:srgbClr val="6B7280"/>
-                </a:solidFill>
-                <a:latin typeface="Segoe UI"/>
+            <a:pPr>
+              <a:defRPr sz="1600" b="1">
+                <a:solidFill>
+                  <a:srgbClr val="2F3441"/>
+                </a:solidFill>
+                <a:latin typeface="Aptos"/>
               </a:defRPr>
             </a:pPr>
             <a:r>
-              <a:rPr sz="1150" b="1" i="1">
-                <a:solidFill>
-                  <a:srgbClr val="B65A34"/>
-                </a:solidFill>
-                <a:latin typeface="Georgia"/>
-              </a:rPr>
-              <a:t>The practical lesson: TaskFlow needs a sharper promise, not a longer feature list.</a:t>
+              <a:t>The gap is not just features. Stronger players are easier to trust, easier to discover, and easier to return to.</a:t>
             </a:r>
           </a:p>
         </p:txBody>
@@ -16916,21 +18473,15 @@
           <a:lstStyle/>
           <a:p>
             <a:pPr>
-              <a:defRPr sz="800">
-                <a:solidFill>
-                  <a:srgbClr val="6B7280"/>
-                </a:solidFill>
-                <a:latin typeface="Segoe UI"/>
+              <a:defRPr sz="850">
+                <a:solidFill>
+                  <a:srgbClr val="6E7783"/>
+                </a:solidFill>
+                <a:latin typeface="Aptos"/>
               </a:defRPr>
             </a:pPr>
             <a:r>
-              <a:rPr>
-                <a:solidFill>
-                  <a:srgbClr val="1F2937"/>
-                </a:solidFill>
-                <a:latin typeface="Aptos"/>
-              </a:rPr>
-              <a:t>Sources: Todoist, TickTick, Any.do and Microsoft To Do official pages + Google Play listings.</a:t>
+              <a:t>Sources: Case data for TaskFlow; Google Play public ratings/review counts; competitor official pages.</a:t>
             </a:r>
           </a:p>
         </p:txBody>
@@ -16973,6 +18524,222 @@
                 <a:latin typeface="Aptos"/>
               </a:rPr>
               <a:t>7</a:t>
+            </a:r>
+          </a:p>
+        </p:txBody>
+      </p:sp>
+      <p:sp>
+        <p:nvSpPr>
+          <p:cNvPr id="30" name="codex-s7-metric-taskflow"/>
+          <p:cNvSpPr txBox="1"/>
+          <p:nvPr/>
+        </p:nvSpPr>
+        <p:spPr>
+          <a:xfrm>
+            <a:off x="786384" y="1975104"/>
+            <a:ext cx="1847088" cy="256032"/>
+          </a:xfrm>
+          <a:prstGeom prst="rect">
+            <a:avLst/>
+          </a:prstGeom>
+          <a:noFill/>
+        </p:spPr>
+        <p:txBody>
+          <a:bodyPr wrap="square" lIns="0" rIns="0">
+            <a:spAutoFit/>
+          </a:bodyPr>
+          <a:lstStyle/>
+          <a:p>
+            <a:pPr>
+              <a:defRPr sz="1150" b="1">
+                <a:solidFill>
+                  <a:srgbClr val="C46A43"/>
+                </a:solidFill>
+                <a:latin typeface="Aptos"/>
+              </a:defRPr>
+            </a:pPr>
+            <a:r>
+              <a:t>4.2 rating | 105k MAU | 62% Meta mix</a:t>
+            </a:r>
+          </a:p>
+        </p:txBody>
+      </p:sp>
+      <p:sp>
+        <p:nvSpPr>
+          <p:cNvPr id="31" name="codex-s7-metric-todoist"/>
+          <p:cNvSpPr txBox="1"/>
+          <p:nvPr/>
+        </p:nvSpPr>
+        <p:spPr>
+          <a:xfrm>
+            <a:off x="3072384" y="1965960"/>
+            <a:ext cx="3758184" cy="256032"/>
+          </a:xfrm>
+          <a:prstGeom prst="rect">
+            <a:avLst/>
+          </a:prstGeom>
+          <a:noFill/>
+        </p:spPr>
+        <p:txBody>
+          <a:bodyPr wrap="square" lIns="0" rIns="0">
+            <a:spAutoFit/>
+          </a:bodyPr>
+          <a:lstStyle/>
+          <a:p>
+            <a:pPr>
+              <a:defRPr sz="1150" b="1">
+                <a:solidFill>
+                  <a:srgbClr val="B86A4A"/>
+                </a:solidFill>
+                <a:latin typeface="Aptos"/>
+              </a:defRPr>
+            </a:pPr>
+            <a:r>
+              <a:t>4.6 rating | 297k reviews | 10M+ downloads</a:t>
+            </a:r>
+          </a:p>
+        </p:txBody>
+      </p:sp>
+      <p:sp>
+        <p:nvSpPr>
+          <p:cNvPr id="32" name="codex-s7-metric-ticktick"/>
+          <p:cNvSpPr txBox="1"/>
+          <p:nvPr/>
+        </p:nvSpPr>
+        <p:spPr>
+          <a:xfrm>
+            <a:off x="7278624" y="1965960"/>
+            <a:ext cx="3758184" cy="256032"/>
+          </a:xfrm>
+          <a:prstGeom prst="rect">
+            <a:avLst/>
+          </a:prstGeom>
+          <a:noFill/>
+        </p:spPr>
+        <p:txBody>
+          <a:bodyPr wrap="square" lIns="0" rIns="0">
+            <a:spAutoFit/>
+          </a:bodyPr>
+          <a:lstStyle/>
+          <a:p>
+            <a:pPr>
+              <a:defRPr sz="1150" b="1">
+                <a:solidFill>
+                  <a:srgbClr val="788B63"/>
+                </a:solidFill>
+                <a:latin typeface="Aptos"/>
+              </a:defRPr>
+            </a:pPr>
+            <a:r>
+              <a:t>4.6 rating | 157k reviews | 5M+ downloads</a:t>
+            </a:r>
+          </a:p>
+        </p:txBody>
+      </p:sp>
+      <p:sp>
+        <p:nvSpPr>
+          <p:cNvPr id="33" name="codex-s7-metric-anydo"/>
+          <p:cNvSpPr txBox="1"/>
+          <p:nvPr/>
+        </p:nvSpPr>
+        <p:spPr>
+          <a:xfrm>
+            <a:off x="3072384" y="4197096"/>
+            <a:ext cx="3758184" cy="256032"/>
+          </a:xfrm>
+          <a:prstGeom prst="rect">
+            <a:avLst/>
+          </a:prstGeom>
+          <a:noFill/>
+        </p:spPr>
+        <p:txBody>
+          <a:bodyPr wrap="square" lIns="0" rIns="0">
+            <a:spAutoFit/>
+          </a:bodyPr>
+          <a:lstStyle/>
+          <a:p>
+            <a:pPr>
+              <a:defRPr sz="1150" b="1">
+                <a:solidFill>
+                  <a:srgbClr val="C98C54"/>
+                </a:solidFill>
+                <a:latin typeface="Aptos"/>
+              </a:defRPr>
+            </a:pPr>
+            <a:r>
+              <a:t>4.4 rating | 503k reviews | 10M+ downloads</a:t>
+            </a:r>
+          </a:p>
+        </p:txBody>
+      </p:sp>
+      <p:sp>
+        <p:nvSpPr>
+          <p:cNvPr id="34" name="codex-s7-metric-ms"/>
+          <p:cNvSpPr txBox="1"/>
+          <p:nvPr/>
+        </p:nvSpPr>
+        <p:spPr>
+          <a:xfrm>
+            <a:off x="7278624" y="4197096"/>
+            <a:ext cx="3758184" cy="256032"/>
+          </a:xfrm>
+          <a:prstGeom prst="rect">
+            <a:avLst/>
+          </a:prstGeom>
+          <a:noFill/>
+        </p:spPr>
+        <p:txBody>
+          <a:bodyPr wrap="square" lIns="0" rIns="0">
+            <a:spAutoFit/>
+          </a:bodyPr>
+          <a:lstStyle/>
+          <a:p>
+            <a:pPr>
+              <a:defRPr sz="1150" b="1">
+                <a:solidFill>
+                  <a:srgbClr val="6E88A8"/>
+                </a:solidFill>
+                <a:latin typeface="Aptos"/>
+              </a:defRPr>
+            </a:pPr>
+            <a:r>
+              <a:t>4.6 rating | 468k reviews | 10M+ downloads</a:t>
+            </a:r>
+          </a:p>
+        </p:txBody>
+      </p:sp>
+      <p:sp>
+        <p:nvSpPr>
+          <p:cNvPr id="35" name="codex-s7-kicker"/>
+          <p:cNvSpPr txBox="1"/>
+          <p:nvPr/>
+        </p:nvSpPr>
+        <p:spPr>
+          <a:xfrm>
+            <a:off x="795528" y="1069848"/>
+            <a:ext cx="3474720" cy="201168"/>
+          </a:xfrm>
+          <a:prstGeom prst="rect">
+            <a:avLst/>
+          </a:prstGeom>
+          <a:noFill/>
+        </p:spPr>
+        <p:txBody>
+          <a:bodyPr wrap="none">
+            <a:spAutoFit/>
+          </a:bodyPr>
+          <a:lstStyle/>
+          <a:p>
+            <a:pPr>
+              <a:defRPr sz="1100" i="1">
+                <a:solidFill>
+                  <a:srgbClr val="9E6A56"/>
+                </a:solidFill>
+                <a:latin typeface="Aptos"/>
+              </a:defRPr>
+            </a:pPr>
+            <a:r>
+              <a:t>Public proof points, not just category reputation.</a:t>
             </a:r>
           </a:p>
         </p:txBody>
@@ -17012,6 +18779,135 @@
       </p:grpSpPr>
       <p:sp>
         <p:nvSpPr>
+          <p:cNvPr id="30" name="codex-bg-3"/>
+          <p:cNvSpPr/>
+          <p:nvPr/>
+        </p:nvSpPr>
+        <p:spPr>
+          <a:xfrm>
+            <a:off x="502920" y="5440680"/>
+            <a:ext cx="2011680" cy="1234440"/>
+          </a:xfrm>
+          <a:prstGeom prst="ellipse">
+            <a:avLst/>
+          </a:prstGeom>
+          <a:solidFill>
+            <a:srgbClr val="E7D0C3"/>
+          </a:solidFill>
+          <a:ln>
+            <a:noFill/>
+          </a:ln>
+        </p:spPr>
+        <p:style>
+          <a:lnRef idx="1">
+            <a:schemeClr val="accent1"/>
+          </a:lnRef>
+          <a:fillRef idx="3">
+            <a:schemeClr val="accent1"/>
+          </a:fillRef>
+          <a:effectRef idx="2">
+            <a:schemeClr val="accent1"/>
+          </a:effectRef>
+          <a:fontRef idx="minor">
+            <a:schemeClr val="lt1"/>
+          </a:fontRef>
+        </p:style>
+        <p:txBody>
+          <a:bodyPr rtlCol="0" anchor="ctr"/>
+          <a:lstStyle/>
+          <a:p>
+            <a:pPr algn="ctr"/>
+          </a:p>
+        </p:txBody>
+      </p:sp>
+      <p:sp>
+        <p:nvSpPr>
+          <p:cNvPr id="29" name="codex-bg-2"/>
+          <p:cNvSpPr/>
+          <p:nvPr/>
+        </p:nvSpPr>
+        <p:spPr>
+          <a:xfrm>
+            <a:off x="9006840" y="4434840"/>
+            <a:ext cx="4114800" cy="2697480"/>
+          </a:xfrm>
+          <a:prstGeom prst="ellipse">
+            <a:avLst/>
+          </a:prstGeom>
+          <a:solidFill>
+            <a:srgbClr val="D7E3E8"/>
+          </a:solidFill>
+          <a:ln>
+            <a:noFill/>
+          </a:ln>
+        </p:spPr>
+        <p:style>
+          <a:lnRef idx="1">
+            <a:schemeClr val="accent1"/>
+          </a:lnRef>
+          <a:fillRef idx="3">
+            <a:schemeClr val="accent1"/>
+          </a:fillRef>
+          <a:effectRef idx="2">
+            <a:schemeClr val="accent1"/>
+          </a:effectRef>
+          <a:fontRef idx="minor">
+            <a:schemeClr val="lt1"/>
+          </a:fontRef>
+        </p:style>
+        <p:txBody>
+          <a:bodyPr rtlCol="0" anchor="ctr"/>
+          <a:lstStyle/>
+          <a:p>
+            <a:pPr algn="ctr"/>
+          </a:p>
+        </p:txBody>
+      </p:sp>
+      <p:sp>
+        <p:nvSpPr>
+          <p:cNvPr id="28" name="codex-bg-1"/>
+          <p:cNvSpPr/>
+          <p:nvPr/>
+        </p:nvSpPr>
+        <p:spPr>
+          <a:xfrm>
+            <a:off x="-1051560" y="-777240"/>
+            <a:ext cx="3840480" cy="2606040"/>
+          </a:xfrm>
+          <a:prstGeom prst="ellipse">
+            <a:avLst/>
+          </a:prstGeom>
+          <a:solidFill>
+            <a:srgbClr val="EEE0D3"/>
+          </a:solidFill>
+          <a:ln>
+            <a:noFill/>
+          </a:ln>
+        </p:spPr>
+        <p:style>
+          <a:lnRef idx="1">
+            <a:schemeClr val="accent1"/>
+          </a:lnRef>
+          <a:fillRef idx="3">
+            <a:schemeClr val="accent1"/>
+          </a:fillRef>
+          <a:effectRef idx="2">
+            <a:schemeClr val="accent1"/>
+          </a:effectRef>
+          <a:fontRef idx="minor">
+            <a:schemeClr val="lt1"/>
+          </a:fontRef>
+        </p:style>
+        <p:txBody>
+          <a:bodyPr rtlCol="0" anchor="ctr"/>
+          <a:lstStyle/>
+          <a:p>
+            <a:pPr algn="ctr"/>
+          </a:p>
+        </p:txBody>
+      </p:sp>
+      <p:sp>
+        <p:nvSpPr>
           <p:cNvPr id="2" name="TextBox 1"/>
           <p:cNvSpPr txBox="1"/>
           <p:nvPr/>
@@ -18165,6 +20061,135 @@
           <a:chExt cx="0" cy="0"/>
         </a:xfrm>
       </p:grpSpPr>
+      <p:sp>
+        <p:nvSpPr>
+          <p:cNvPr id="24" name="codex-bg-3"/>
+          <p:cNvSpPr/>
+          <p:nvPr/>
+        </p:nvSpPr>
+        <p:spPr>
+          <a:xfrm>
+            <a:off x="10195560" y="4526280"/>
+            <a:ext cx="1920240" cy="1325880"/>
+          </a:xfrm>
+          <a:prstGeom prst="ellipse">
+            <a:avLst/>
+          </a:prstGeom>
+          <a:solidFill>
+            <a:srgbClr val="E8E1D7"/>
+          </a:solidFill>
+          <a:ln>
+            <a:noFill/>
+          </a:ln>
+        </p:spPr>
+        <p:style>
+          <a:lnRef idx="1">
+            <a:schemeClr val="accent1"/>
+          </a:lnRef>
+          <a:fillRef idx="3">
+            <a:schemeClr val="accent1"/>
+          </a:fillRef>
+          <a:effectRef idx="2">
+            <a:schemeClr val="accent1"/>
+          </a:effectRef>
+          <a:fontRef idx="minor">
+            <a:schemeClr val="lt1"/>
+          </a:fontRef>
+        </p:style>
+        <p:txBody>
+          <a:bodyPr rtlCol="0" anchor="ctr"/>
+          <a:lstStyle/>
+          <a:p>
+            <a:pPr algn="ctr"/>
+          </a:p>
+        </p:txBody>
+      </p:sp>
+      <p:sp>
+        <p:nvSpPr>
+          <p:cNvPr id="23" name="codex-bg-2"/>
+          <p:cNvSpPr/>
+          <p:nvPr/>
+        </p:nvSpPr>
+        <p:spPr>
+          <a:xfrm>
+            <a:off x="9281160" y="-548640"/>
+            <a:ext cx="3886200" cy="2514600"/>
+          </a:xfrm>
+          <a:prstGeom prst="ellipse">
+            <a:avLst/>
+          </a:prstGeom>
+          <a:solidFill>
+            <a:srgbClr val="DCE6D7"/>
+          </a:solidFill>
+          <a:ln>
+            <a:noFill/>
+          </a:ln>
+        </p:spPr>
+        <p:style>
+          <a:lnRef idx="1">
+            <a:schemeClr val="accent1"/>
+          </a:lnRef>
+          <a:fillRef idx="3">
+            <a:schemeClr val="accent1"/>
+          </a:fillRef>
+          <a:effectRef idx="2">
+            <a:schemeClr val="accent1"/>
+          </a:effectRef>
+          <a:fontRef idx="minor">
+            <a:schemeClr val="lt1"/>
+          </a:fontRef>
+        </p:style>
+        <p:txBody>
+          <a:bodyPr rtlCol="0" anchor="ctr"/>
+          <a:lstStyle/>
+          <a:p>
+            <a:pPr algn="ctr"/>
+          </a:p>
+        </p:txBody>
+      </p:sp>
+      <p:sp>
+        <p:nvSpPr>
+          <p:cNvPr id="22" name="codex-bg-1"/>
+          <p:cNvSpPr/>
+          <p:nvPr/>
+        </p:nvSpPr>
+        <p:spPr>
+          <a:xfrm>
+            <a:off x="-868680" y="4754880"/>
+            <a:ext cx="4206240" cy="2743200"/>
+          </a:xfrm>
+          <a:prstGeom prst="ellipse">
+            <a:avLst/>
+          </a:prstGeom>
+          <a:solidFill>
+            <a:srgbClr val="F0D9CB"/>
+          </a:solidFill>
+          <a:ln>
+            <a:noFill/>
+          </a:ln>
+        </p:spPr>
+        <p:style>
+          <a:lnRef idx="1">
+            <a:schemeClr val="accent1"/>
+          </a:lnRef>
+          <a:fillRef idx="3">
+            <a:schemeClr val="accent1"/>
+          </a:fillRef>
+          <a:effectRef idx="2">
+            <a:schemeClr val="accent1"/>
+          </a:effectRef>
+          <a:fontRef idx="minor">
+            <a:schemeClr val="lt1"/>
+          </a:fontRef>
+        </p:style>
+        <p:txBody>
+          <a:bodyPr rtlCol="0" anchor="ctr"/>
+          <a:lstStyle/>
+          <a:p>
+            <a:pPr algn="ctr"/>
+          </a:p>
+        </p:txBody>
+      </p:sp>
       <p:sp>
         <p:nvSpPr>
           <p:cNvPr id="2" name="TextBox 1"/>

</xml_diff>